<commit_message>
docs: update README, advisor titles, and target building references across all documents
- README.md v2.3: rebuilt repository contents table, added 9 completed items to
  Phase 0 status, updated advisor titles and building references
- Advisor titles updated in all EN and JP docs: Joi Ito → President, Chiba
  Institute of Technology; Ray Ozzie → Executive Chair, Blues
- Takuo Dome and San Poisson added to advisory board (README, introduction A4)
- Target building updated from "closed Mitsue Elementary School" to Taiken
  Koryukan (Phase 1) + old factory (Phase 2) in README, founding charter, WBS (EN/JP)
- Version bumps and last-modified dates updated on all edited documents

Co-Authored-By: Claude Sonnet 4.6 <noreply@anthropic.com>
</commit_message>
<xml_diff>
--- a/Mitsue Project Presentation - 日本語.pptx
+++ b/Mitsue Project Presentation - 日本語.pptx
@@ -44,7 +44,7 @@
       </p:grpSpPr>
       <p:sp>
         <p:nvSpPr>
-          <p:cNvPr id="457895979" name="PlaceHolder 1"/>
+          <p:cNvPr id="1984016748" name="PlaceHolder 1"/>
           <p:cNvSpPr>
             <a:spLocks noGrp="1"/>
           </p:cNvSpPr>
@@ -93,7 +93,7 @@
       </p:sp>
       <p:sp>
         <p:nvSpPr>
-          <p:cNvPr id="1250640412" name="PlaceHolder 2"/>
+          <p:cNvPr id="243059693" name="PlaceHolder 2"/>
           <p:cNvSpPr>
             <a:spLocks noGrp="1"/>
           </p:cNvSpPr>
@@ -143,7 +143,7 @@
       </p:sp>
       <p:sp>
         <p:nvSpPr>
-          <p:cNvPr id="1923071723" name="PlaceHolder 3"/>
+          <p:cNvPr id="1557685788" name="PlaceHolder 3"/>
           <p:cNvSpPr>
             <a:spLocks noGrp="1"/>
           </p:cNvSpPr>
@@ -193,7 +193,7 @@
       </p:sp>
       <p:sp>
         <p:nvSpPr>
-          <p:cNvPr id="1353806655" name="PlaceHolder 4"/>
+          <p:cNvPr id="1757483935" name="PlaceHolder 4"/>
           <p:cNvSpPr>
             <a:spLocks noGrp="1"/>
           </p:cNvSpPr>
@@ -254,7 +254,7 @@
       </p:sp>
       <p:sp>
         <p:nvSpPr>
-          <p:cNvPr id="1251591897" name="PlaceHolder 5"/>
+          <p:cNvPr id="1511882554" name="PlaceHolder 5"/>
           <p:cNvSpPr>
             <a:spLocks noGrp="1"/>
           </p:cNvSpPr>
@@ -315,7 +315,7 @@
       </p:sp>
       <p:sp>
         <p:nvSpPr>
-          <p:cNvPr id="1338976285" name="PlaceHolder 6"/>
+          <p:cNvPr id="632998193" name="PlaceHolder 6"/>
           <p:cNvSpPr>
             <a:spLocks noGrp="1"/>
           </p:cNvSpPr>
@@ -399,7 +399,7 @@
       </p:grpSpPr>
       <p:sp>
         <p:nvSpPr>
-          <p:cNvPr id="1546211730" name="PlaceHolder 1"/>
+          <p:cNvPr id="1554986029" name="PlaceHolder 1"/>
           <p:cNvSpPr>
             <a:spLocks noGrp="1"/>
           </p:cNvSpPr>
@@ -422,7 +422,7 @@
       </p:sp>
       <p:sp>
         <p:nvSpPr>
-          <p:cNvPr id="1507511342" name="PlaceHolder 2"/>
+          <p:cNvPr id="456348786" name="PlaceHolder 2"/>
           <p:cNvSpPr>
             <a:spLocks noGrp="1"/>
           </p:cNvSpPr>
@@ -529,7 +529,7 @@
       </p:sp>
       <p:sp>
         <p:nvSpPr>
-          <p:cNvPr id="1341822082" name="PlaceHolder 3"/>
+          <p:cNvPr id="2040580538" name="PlaceHolder 3"/>
           <p:cNvSpPr>
             <a:spLocks noGrp="1"/>
           </p:cNvSpPr>
@@ -623,7 +623,7 @@
       </p:grpSpPr>
       <p:sp>
         <p:nvSpPr>
-          <p:cNvPr id="2093946235" name="PlaceHolder 1"/>
+          <p:cNvPr id="673343773" name="PlaceHolder 1"/>
           <p:cNvSpPr>
             <a:spLocks noGrp="1"/>
           </p:cNvSpPr>
@@ -646,7 +646,7 @@
       </p:sp>
       <p:sp>
         <p:nvSpPr>
-          <p:cNvPr id="415300725" name="PlaceHolder 2"/>
+          <p:cNvPr id="578370398" name="PlaceHolder 2"/>
           <p:cNvSpPr>
             <a:spLocks noGrp="1"/>
           </p:cNvSpPr>
@@ -753,7 +753,7 @@
       </p:sp>
       <p:sp>
         <p:nvSpPr>
-          <p:cNvPr id="2091397099" name="PlaceHolder 3"/>
+          <p:cNvPr id="2136005613" name="PlaceHolder 3"/>
           <p:cNvSpPr>
             <a:spLocks noGrp="1"/>
           </p:cNvSpPr>
@@ -847,7 +847,7 @@
       </p:grpSpPr>
       <p:sp>
         <p:nvSpPr>
-          <p:cNvPr id="194611002" name="PlaceHolder 1"/>
+          <p:cNvPr id="170707273" name="PlaceHolder 1"/>
           <p:cNvSpPr>
             <a:spLocks noGrp="1"/>
           </p:cNvSpPr>
@@ -870,7 +870,7 @@
       </p:sp>
       <p:sp>
         <p:nvSpPr>
-          <p:cNvPr id="791698350" name="PlaceHolder 2"/>
+          <p:cNvPr id="280938527" name="PlaceHolder 2"/>
           <p:cNvSpPr>
             <a:spLocks noGrp="1"/>
           </p:cNvSpPr>
@@ -959,7 +959,7 @@
       </p:sp>
       <p:sp>
         <p:nvSpPr>
-          <p:cNvPr id="1806326610" name="PlaceHolder 3"/>
+          <p:cNvPr id="1797017230" name="PlaceHolder 3"/>
           <p:cNvSpPr>
             <a:spLocks noGrp="1"/>
           </p:cNvSpPr>
@@ -1053,7 +1053,7 @@
       </p:grpSpPr>
       <p:sp>
         <p:nvSpPr>
-          <p:cNvPr id="607185346" name="PlaceHolder 1"/>
+          <p:cNvPr id="1035022814" name="PlaceHolder 1"/>
           <p:cNvSpPr>
             <a:spLocks noGrp="1"/>
           </p:cNvSpPr>
@@ -1076,7 +1076,7 @@
       </p:sp>
       <p:sp>
         <p:nvSpPr>
-          <p:cNvPr id="1096739650" name="PlaceHolder 2"/>
+          <p:cNvPr id="1947790174" name="PlaceHolder 2"/>
           <p:cNvSpPr>
             <a:spLocks noGrp="1"/>
           </p:cNvSpPr>
@@ -1147,7 +1147,7 @@
       </p:sp>
       <p:sp>
         <p:nvSpPr>
-          <p:cNvPr id="1361176902" name="PlaceHolder 3"/>
+          <p:cNvPr id="1890271484" name="PlaceHolder 3"/>
           <p:cNvSpPr>
             <a:spLocks noGrp="1"/>
           </p:cNvSpPr>
@@ -1241,7 +1241,7 @@
       </p:grpSpPr>
       <p:sp>
         <p:nvSpPr>
-          <p:cNvPr id="630108819" name="PlaceHolder 1"/>
+          <p:cNvPr id="917833158" name="PlaceHolder 1"/>
           <p:cNvSpPr>
             <a:spLocks noGrp="1"/>
           </p:cNvSpPr>
@@ -1264,7 +1264,7 @@
       </p:sp>
       <p:sp>
         <p:nvSpPr>
-          <p:cNvPr id="404869994" name="PlaceHolder 2"/>
+          <p:cNvPr id="1980219772" name="PlaceHolder 2"/>
           <p:cNvSpPr>
             <a:spLocks noGrp="1"/>
           </p:cNvSpPr>
@@ -1353,7 +1353,7 @@
       </p:sp>
       <p:sp>
         <p:nvSpPr>
-          <p:cNvPr id="1490511789" name="PlaceHolder 3"/>
+          <p:cNvPr id="1720375532" name="PlaceHolder 3"/>
           <p:cNvSpPr>
             <a:spLocks noGrp="1"/>
           </p:cNvSpPr>
@@ -1447,7 +1447,7 @@
       </p:grpSpPr>
       <p:sp>
         <p:nvSpPr>
-          <p:cNvPr id="1863198948" name="PlaceHolder 1"/>
+          <p:cNvPr id="1884438349" name="PlaceHolder 1"/>
           <p:cNvSpPr>
             <a:spLocks noGrp="1"/>
           </p:cNvSpPr>
@@ -1470,7 +1470,7 @@
       </p:sp>
       <p:sp>
         <p:nvSpPr>
-          <p:cNvPr id="623723054" name="PlaceHolder 2"/>
+          <p:cNvPr id="2030860969" name="PlaceHolder 2"/>
           <p:cNvSpPr>
             <a:spLocks noGrp="1"/>
           </p:cNvSpPr>
@@ -1559,7 +1559,7 @@
       </p:sp>
       <p:sp>
         <p:nvSpPr>
-          <p:cNvPr id="1813297557" name="PlaceHolder 3"/>
+          <p:cNvPr id="1206361882" name="PlaceHolder 3"/>
           <p:cNvSpPr>
             <a:spLocks noGrp="1"/>
           </p:cNvSpPr>
@@ -1653,7 +1653,7 @@
       </p:grpSpPr>
       <p:sp>
         <p:nvSpPr>
-          <p:cNvPr id="1416210985" name="PlaceHolder 1"/>
+          <p:cNvPr id="1939423540" name="PlaceHolder 1"/>
           <p:cNvSpPr>
             <a:spLocks noGrp="1"/>
           </p:cNvSpPr>
@@ -1676,7 +1676,7 @@
       </p:sp>
       <p:sp>
         <p:nvSpPr>
-          <p:cNvPr id="1585121518" name="PlaceHolder 2"/>
+          <p:cNvPr id="784595610" name="PlaceHolder 2"/>
           <p:cNvSpPr>
             <a:spLocks noGrp="1"/>
           </p:cNvSpPr>
@@ -1783,7 +1783,7 @@
       </p:sp>
       <p:sp>
         <p:nvSpPr>
-          <p:cNvPr id="1726058632" name="PlaceHolder 3"/>
+          <p:cNvPr id="1664553095" name="PlaceHolder 3"/>
           <p:cNvSpPr>
             <a:spLocks noGrp="1"/>
           </p:cNvSpPr>
@@ -1877,7 +1877,7 @@
       </p:grpSpPr>
       <p:sp>
         <p:nvSpPr>
-          <p:cNvPr id="1595045455" name="PlaceHolder 1"/>
+          <p:cNvPr id="743013847" name="PlaceHolder 1"/>
           <p:cNvSpPr>
             <a:spLocks noGrp="1"/>
           </p:cNvSpPr>
@@ -1900,7 +1900,7 @@
       </p:sp>
       <p:sp>
         <p:nvSpPr>
-          <p:cNvPr id="543997953" name="PlaceHolder 2"/>
+          <p:cNvPr id="1022070280" name="PlaceHolder 2"/>
           <p:cNvSpPr>
             <a:spLocks noGrp="1"/>
           </p:cNvSpPr>
@@ -1971,7 +1971,7 @@
       </p:sp>
       <p:sp>
         <p:nvSpPr>
-          <p:cNvPr id="715078193" name="PlaceHolder 3"/>
+          <p:cNvPr id="2050211378" name="PlaceHolder 3"/>
           <p:cNvSpPr>
             <a:spLocks noGrp="1"/>
           </p:cNvSpPr>
@@ -2065,7 +2065,7 @@
       </p:grpSpPr>
       <p:sp>
         <p:nvSpPr>
-          <p:cNvPr id="619446542" name="PlaceHolder 1"/>
+          <p:cNvPr id="499738986" name="PlaceHolder 1"/>
           <p:cNvSpPr>
             <a:spLocks noGrp="1"/>
           </p:cNvSpPr>
@@ -2088,7 +2088,7 @@
       </p:sp>
       <p:sp>
         <p:nvSpPr>
-          <p:cNvPr id="428833503" name="PlaceHolder 2"/>
+          <p:cNvPr id="926470640" name="PlaceHolder 2"/>
           <p:cNvSpPr>
             <a:spLocks noGrp="1"/>
           </p:cNvSpPr>
@@ -2159,7 +2159,7 @@
       </p:sp>
       <p:sp>
         <p:nvSpPr>
-          <p:cNvPr id="391701800" name="PlaceHolder 3"/>
+          <p:cNvPr id="1607321736" name="PlaceHolder 3"/>
           <p:cNvSpPr>
             <a:spLocks noGrp="1"/>
           </p:cNvSpPr>
@@ -2253,7 +2253,7 @@
       </p:grpSpPr>
       <p:sp>
         <p:nvSpPr>
-          <p:cNvPr id="1068828616" name="PlaceHolder 1"/>
+          <p:cNvPr id="382480533" name="PlaceHolder 1"/>
           <p:cNvSpPr>
             <a:spLocks noGrp="1"/>
           </p:cNvSpPr>
@@ -2276,7 +2276,7 @@
       </p:sp>
       <p:sp>
         <p:nvSpPr>
-          <p:cNvPr id="648929935" name="PlaceHolder 2"/>
+          <p:cNvPr id="487546572" name="PlaceHolder 2"/>
           <p:cNvSpPr>
             <a:spLocks noGrp="1"/>
           </p:cNvSpPr>
@@ -2347,7 +2347,7 @@
       </p:sp>
       <p:sp>
         <p:nvSpPr>
-          <p:cNvPr id="715818888" name="PlaceHolder 3"/>
+          <p:cNvPr id="175632044" name="PlaceHolder 3"/>
           <p:cNvSpPr>
             <a:spLocks noGrp="1"/>
           </p:cNvSpPr>
@@ -2441,7 +2441,7 @@
       </p:grpSpPr>
       <p:sp>
         <p:nvSpPr>
-          <p:cNvPr id="2031471005" name="PlaceHolder 1"/>
+          <p:cNvPr id="2019753983" name="PlaceHolder 1"/>
           <p:cNvSpPr>
             <a:spLocks noGrp="1"/>
           </p:cNvSpPr>
@@ -2464,7 +2464,7 @@
       </p:sp>
       <p:sp>
         <p:nvSpPr>
-          <p:cNvPr id="1049683567" name="PlaceHolder 2"/>
+          <p:cNvPr id="761745741" name="PlaceHolder 2"/>
           <p:cNvSpPr>
             <a:spLocks noGrp="1"/>
           </p:cNvSpPr>
@@ -2589,7 +2589,7 @@
       </p:sp>
       <p:sp>
         <p:nvSpPr>
-          <p:cNvPr id="69184448" name="PlaceHolder 3"/>
+          <p:cNvPr id="1255446650" name="PlaceHolder 3"/>
           <p:cNvSpPr>
             <a:spLocks noGrp="1"/>
           </p:cNvSpPr>
@@ -2715,7 +2715,7 @@
       </p:grpSpPr>
       <p:sp>
         <p:nvSpPr>
-          <p:cNvPr id="1702597993" name="PlaceHolder 1"/>
+          <p:cNvPr id="1668680052" name="PlaceHolder 1"/>
           <p:cNvSpPr>
             <a:spLocks noGrp="1"/>
           </p:cNvSpPr>
@@ -2785,7 +2785,7 @@
       </p:sp>
       <p:sp>
         <p:nvSpPr>
-          <p:cNvPr id="1100979602" name="PlaceHolder 2"/>
+          <p:cNvPr id="567106208" name="PlaceHolder 2"/>
           <p:cNvSpPr>
             <a:spLocks noGrp="1"/>
           </p:cNvSpPr>
@@ -3171,7 +3171,7 @@
       </p:grpSpPr>
       <p:sp>
         <p:nvSpPr>
-          <p:cNvPr id="1114983152" name="Shape 0"/>
+          <p:cNvPr id="180468769" name="Shape 0"/>
           <p:cNvSpPr/>
           <p:nvPr/>
         </p:nvSpPr>
@@ -3215,7 +3215,7 @@
       </p:sp>
       <p:sp>
         <p:nvSpPr>
-          <p:cNvPr id="1338360476" name="Text 1"/>
+          <p:cNvPr id="1578858755" name="Text 1"/>
           <p:cNvSpPr/>
           <p:nvPr/>
         </p:nvSpPr>
@@ -3273,7 +3273,7 @@
       </p:sp>
       <p:sp>
         <p:nvSpPr>
-          <p:cNvPr id="1166316595" name="Text 2"/>
+          <p:cNvPr id="2055955169" name="Text 2"/>
           <p:cNvSpPr/>
           <p:nvPr/>
         </p:nvSpPr>
@@ -3331,7 +3331,7 @@
       </p:sp>
       <p:sp>
         <p:nvSpPr>
-          <p:cNvPr id="1829318694" name="Text 3"/>
+          <p:cNvPr id="1209946151" name="Text 3"/>
           <p:cNvSpPr/>
           <p:nvPr/>
         </p:nvSpPr>
@@ -3469,7 +3469,7 @@
       </p:sp>
       <p:sp>
         <p:nvSpPr>
-          <p:cNvPr id="1616275716" name="Text 4"/>
+          <p:cNvPr id="494028716" name="Text 4"/>
           <p:cNvSpPr/>
           <p:nvPr/>
         </p:nvSpPr>
@@ -3547,7 +3547,7 @@
       </p:sp>
       <p:sp>
         <p:nvSpPr>
-          <p:cNvPr id="1615772733" name="Text 5"/>
+          <p:cNvPr id="577999181" name="Text 5"/>
           <p:cNvSpPr/>
           <p:nvPr/>
         </p:nvSpPr>
@@ -3615,7 +3615,7 @@
       </p:sp>
       <p:sp>
         <p:nvSpPr>
-          <p:cNvPr id="1137463042" name="Text 6"/>
+          <p:cNvPr id="959661343" name="Text 6"/>
           <p:cNvSpPr/>
           <p:nvPr/>
         </p:nvSpPr>
@@ -3673,7 +3673,7 @@
       </p:sp>
       <p:pic>
         <p:nvPicPr>
-          <p:cNvPr id="590128803" name="Image 0" descr="preencoded.png"/>
+          <p:cNvPr id="1762927954" name="Image 0" descr="preencoded.png"/>
           <p:cNvPicPr/>
           <p:nvPr/>
         </p:nvPicPr>
@@ -3697,7 +3697,7 @@
       </p:pic>
       <p:sp>
         <p:nvSpPr>
-          <p:cNvPr id="1894087861" name="Text 7"/>
+          <p:cNvPr id="1117949284" name="Text 7"/>
           <p:cNvSpPr/>
           <p:nvPr/>
         </p:nvSpPr>
@@ -3755,7 +3755,7 @@
       </p:sp>
       <p:sp>
         <p:nvSpPr>
-          <p:cNvPr id="860661591" name="Text 8"/>
+          <p:cNvPr id="422234812" name="Text 8"/>
           <p:cNvSpPr/>
           <p:nvPr/>
         </p:nvSpPr>
@@ -3883,7 +3883,7 @@
       </p:grpSpPr>
       <p:sp>
         <p:nvSpPr>
-          <p:cNvPr id="602931399" name="Shape 0"/>
+          <p:cNvPr id="1185013351" name="Shape 0"/>
           <p:cNvSpPr/>
           <p:nvPr/>
         </p:nvSpPr>
@@ -3927,7 +3927,7 @@
       </p:sp>
       <p:sp>
         <p:nvSpPr>
-          <p:cNvPr id="1355343031" name="Text 1"/>
+          <p:cNvPr id="1851910007" name="Text 1"/>
           <p:cNvSpPr/>
           <p:nvPr/>
         </p:nvSpPr>
@@ -3985,7 +3985,7 @@
       </p:sp>
       <p:sp>
         <p:nvSpPr>
-          <p:cNvPr id="520612443" name="Text 2"/>
+          <p:cNvPr id="1899381255" name="Text 2"/>
           <p:cNvSpPr/>
           <p:nvPr/>
         </p:nvSpPr>
@@ -4043,7 +4043,7 @@
       </p:sp>
       <p:sp>
         <p:nvSpPr>
-          <p:cNvPr id="598344753" name="Text 3"/>
+          <p:cNvPr id="867870880" name="Text 3"/>
           <p:cNvSpPr/>
           <p:nvPr/>
         </p:nvSpPr>
@@ -4111,7 +4111,7 @@
       </p:sp>
       <p:sp>
         <p:nvSpPr>
-          <p:cNvPr id="2145863713" name="Text 4"/>
+          <p:cNvPr id="1153889480" name="Text 4"/>
           <p:cNvSpPr/>
           <p:nvPr/>
         </p:nvSpPr>
@@ -4189,7 +4189,7 @@
       </p:sp>
       <p:sp>
         <p:nvSpPr>
-          <p:cNvPr id="353728527" name="Text 5"/>
+          <p:cNvPr id="2013467932" name="Text 5"/>
           <p:cNvSpPr/>
           <p:nvPr/>
         </p:nvSpPr>
@@ -4247,7 +4247,7 @@
       </p:sp>
       <p:sp>
         <p:nvSpPr>
-          <p:cNvPr id="25090788" name="Shape 6"/>
+          <p:cNvPr id="1806686517" name="Shape 6"/>
           <p:cNvSpPr/>
           <p:nvPr/>
         </p:nvSpPr>
@@ -4294,7 +4294,7 @@
       </p:sp>
       <p:sp>
         <p:nvSpPr>
-          <p:cNvPr id="1056979894" name="Text 7"/>
+          <p:cNvPr id="1674045760" name="Text 7"/>
           <p:cNvSpPr/>
           <p:nvPr/>
         </p:nvSpPr>
@@ -4402,7 +4402,7 @@
       </p:sp>
       <p:sp>
         <p:nvSpPr>
-          <p:cNvPr id="658807705" name="Text 8"/>
+          <p:cNvPr id="534567469" name="Text 8"/>
           <p:cNvSpPr/>
           <p:nvPr/>
         </p:nvSpPr>
@@ -4460,7 +4460,7 @@
       </p:sp>
       <p:sp>
         <p:nvSpPr>
-          <p:cNvPr id="1927826300" name="Text 9"/>
+          <p:cNvPr id="1761464432" name="Text 9"/>
           <p:cNvSpPr/>
           <p:nvPr/>
         </p:nvSpPr>
@@ -4568,7 +4568,7 @@
       </p:sp>
       <p:sp>
         <p:nvSpPr>
-          <p:cNvPr id="109951074" name="Shape 10"/>
+          <p:cNvPr id="184452923" name="Shape 10"/>
           <p:cNvSpPr/>
           <p:nvPr/>
         </p:nvSpPr>
@@ -4615,7 +4615,7 @@
       </p:sp>
       <p:sp>
         <p:nvSpPr>
-          <p:cNvPr id="371839531" name="Text 11"/>
+          <p:cNvPr id="362364170" name="Text 11"/>
           <p:cNvSpPr/>
           <p:nvPr/>
         </p:nvSpPr>
@@ -4693,7 +4693,7 @@
       </p:sp>
       <p:sp>
         <p:nvSpPr>
-          <p:cNvPr id="1302360033" name="Text 12"/>
+          <p:cNvPr id="1296923714" name="Text 12"/>
           <p:cNvSpPr/>
           <p:nvPr/>
         </p:nvSpPr>
@@ -4751,7 +4751,7 @@
       </p:sp>
       <p:sp>
         <p:nvSpPr>
-          <p:cNvPr id="4475474" name="Text 13"/>
+          <p:cNvPr id="536484483" name="Text 13"/>
           <p:cNvSpPr/>
           <p:nvPr/>
         </p:nvSpPr>
@@ -4849,7 +4849,7 @@
       </p:sp>
       <p:sp>
         <p:nvSpPr>
-          <p:cNvPr id="397618652" name="Shape 14"/>
+          <p:cNvPr id="441293122" name="Shape 14"/>
           <p:cNvSpPr/>
           <p:nvPr/>
         </p:nvSpPr>
@@ -4896,7 +4896,7 @@
       </p:sp>
       <p:sp>
         <p:nvSpPr>
-          <p:cNvPr id="189078918" name="Text 15"/>
+          <p:cNvPr id="1652543409" name="Text 15"/>
           <p:cNvSpPr/>
           <p:nvPr/>
         </p:nvSpPr>
@@ -4974,7 +4974,7 @@
       </p:sp>
       <p:sp>
         <p:nvSpPr>
-          <p:cNvPr id="576189169" name="Text 16"/>
+          <p:cNvPr id="808601144" name="Text 16"/>
           <p:cNvSpPr/>
           <p:nvPr/>
         </p:nvSpPr>
@@ -5032,7 +5032,7 @@
       </p:sp>
       <p:sp>
         <p:nvSpPr>
-          <p:cNvPr id="134674030" name="Text 17"/>
+          <p:cNvPr id="979030967" name="Text 17"/>
           <p:cNvSpPr/>
           <p:nvPr/>
         </p:nvSpPr>
@@ -5130,7 +5130,7 @@
       </p:sp>
       <p:sp>
         <p:nvSpPr>
-          <p:cNvPr id="1566629873" name="Shape 18"/>
+          <p:cNvPr id="1986714328" name="Shape 18"/>
           <p:cNvSpPr/>
           <p:nvPr/>
         </p:nvSpPr>
@@ -5177,7 +5177,7 @@
       </p:sp>
       <p:sp>
         <p:nvSpPr>
-          <p:cNvPr id="740057734" name="Text 19"/>
+          <p:cNvPr id="1173544945" name="Text 19"/>
           <p:cNvSpPr/>
           <p:nvPr/>
         </p:nvSpPr>
@@ -5255,7 +5255,7 @@
       </p:sp>
       <p:sp>
         <p:nvSpPr>
-          <p:cNvPr id="280501470" name="Text 20"/>
+          <p:cNvPr id="1071614961" name="Text 20"/>
           <p:cNvSpPr/>
           <p:nvPr/>
         </p:nvSpPr>
@@ -5313,7 +5313,7 @@
       </p:sp>
       <p:sp>
         <p:nvSpPr>
-          <p:cNvPr id="984929041" name="Text 21"/>
+          <p:cNvPr id="781680087" name="Text 21"/>
           <p:cNvSpPr/>
           <p:nvPr/>
         </p:nvSpPr>
@@ -5411,7 +5411,7 @@
       </p:sp>
       <p:sp>
         <p:nvSpPr>
-          <p:cNvPr id="1759085978" name="Shape 22"/>
+          <p:cNvPr id="1654679972" name="Shape 22"/>
           <p:cNvSpPr/>
           <p:nvPr/>
         </p:nvSpPr>
@@ -5458,7 +5458,7 @@
       </p:sp>
       <p:sp>
         <p:nvSpPr>
-          <p:cNvPr id="1741291315" name="Text 23"/>
+          <p:cNvPr id="1230001426" name="Text 23"/>
           <p:cNvSpPr/>
           <p:nvPr/>
         </p:nvSpPr>
@@ -5536,7 +5536,7 @@
       </p:sp>
       <p:sp>
         <p:nvSpPr>
-          <p:cNvPr id="594232064" name="Text 24"/>
+          <p:cNvPr id="977668301" name="Text 24"/>
           <p:cNvSpPr/>
           <p:nvPr/>
         </p:nvSpPr>
@@ -5594,7 +5594,7 @@
       </p:sp>
       <p:sp>
         <p:nvSpPr>
-          <p:cNvPr id="598711395" name="Text 25"/>
+          <p:cNvPr id="669569318" name="Text 25"/>
           <p:cNvSpPr/>
           <p:nvPr/>
         </p:nvSpPr>
@@ -5662,7 +5662,7 @@
       </p:sp>
       <p:sp>
         <p:nvSpPr>
-          <p:cNvPr id="117405453" name="Text 26"/>
+          <p:cNvPr id="582723230" name="Text 26"/>
           <p:cNvSpPr/>
           <p:nvPr/>
         </p:nvSpPr>
@@ -5720,7 +5720,7 @@
       </p:sp>
       <p:sp>
         <p:nvSpPr>
-          <p:cNvPr id="38530211" name="Text 27"/>
+          <p:cNvPr id="1101145990" name="Text 27"/>
           <p:cNvSpPr/>
           <p:nvPr/>
         </p:nvSpPr>
@@ -5778,7 +5778,7 @@
       </p:sp>
       <p:sp>
         <p:nvSpPr>
-          <p:cNvPr id="18843854" name="Text 28"/>
+          <p:cNvPr id="824156514" name="Text 28"/>
           <p:cNvSpPr/>
           <p:nvPr/>
         </p:nvSpPr>
@@ -5836,7 +5836,7 @@
       </p:sp>
       <p:sp>
         <p:nvSpPr>
-          <p:cNvPr id="1735019952" name="Text 29"/>
+          <p:cNvPr id="450233577" name="Text 29"/>
           <p:cNvSpPr/>
           <p:nvPr/>
         </p:nvSpPr>
@@ -5904,7 +5904,7 @@
       </p:sp>
       <p:sp>
         <p:nvSpPr>
-          <p:cNvPr id="1385207230" name="Text 30"/>
+          <p:cNvPr id="1857653523" name="Text 30"/>
           <p:cNvSpPr/>
           <p:nvPr/>
         </p:nvSpPr>
@@ -5992,7 +5992,7 @@
       </p:sp>
       <p:sp>
         <p:nvSpPr>
-          <p:cNvPr id="753257034" name="Shape 31"/>
+          <p:cNvPr id="1378467758" name="Shape 31"/>
           <p:cNvSpPr/>
           <p:nvPr/>
         </p:nvSpPr>
@@ -6036,7 +6036,7 @@
       </p:sp>
       <p:sp>
         <p:nvSpPr>
-          <p:cNvPr id="1170643972" name="Text 32"/>
+          <p:cNvPr id="797772166" name="Text 32"/>
           <p:cNvSpPr/>
           <p:nvPr/>
         </p:nvSpPr>
@@ -6094,7 +6094,7 @@
       </p:sp>
       <p:sp>
         <p:nvSpPr>
-          <p:cNvPr id="1830268800" name="Text 33"/>
+          <p:cNvPr id="859510481" name="Text 33"/>
           <p:cNvSpPr/>
           <p:nvPr/>
         </p:nvSpPr>
@@ -6152,7 +6152,7 @@
       </p:sp>
       <p:sp>
         <p:nvSpPr>
-          <p:cNvPr id="1515221859" name="Text 34"/>
+          <p:cNvPr id="877994061" name="Text 34"/>
           <p:cNvSpPr/>
           <p:nvPr/>
         </p:nvSpPr>
@@ -6220,7 +6220,7 @@
       </p:sp>
       <p:sp>
         <p:nvSpPr>
-          <p:cNvPr id="938782007" name="Text 35"/>
+          <p:cNvPr id="518527857" name="Text 35"/>
           <p:cNvSpPr/>
           <p:nvPr/>
         </p:nvSpPr>
@@ -6288,7 +6288,7 @@
       </p:sp>
       <p:sp>
         <p:nvSpPr>
-          <p:cNvPr id="633125606" name="Shape 36"/>
+          <p:cNvPr id="1601131354" name="Shape 36"/>
           <p:cNvSpPr/>
           <p:nvPr/>
         </p:nvSpPr>
@@ -6334,7 +6334,7 @@
       </p:sp>
       <p:sp>
         <p:nvSpPr>
-          <p:cNvPr id="178922995" name="Text 37"/>
+          <p:cNvPr id="26245991" name="Text 37"/>
           <p:cNvSpPr/>
           <p:nvPr/>
         </p:nvSpPr>
@@ -6392,7 +6392,7 @@
       </p:sp>
       <p:sp>
         <p:nvSpPr>
-          <p:cNvPr id="2060427522" name="Text 38"/>
+          <p:cNvPr id="1065509177" name="Text 38"/>
           <p:cNvSpPr/>
           <p:nvPr/>
         </p:nvSpPr>
@@ -6450,7 +6450,7 @@
       </p:sp>
       <p:sp>
         <p:nvSpPr>
-          <p:cNvPr id="2122944757" name="Text 39"/>
+          <p:cNvPr id="1802967265" name="Text 39"/>
           <p:cNvSpPr/>
           <p:nvPr/>
         </p:nvSpPr>
@@ -6508,7 +6508,7 @@
       </p:sp>
       <p:sp>
         <p:nvSpPr>
-          <p:cNvPr id="1618677262" name="Text 40"/>
+          <p:cNvPr id="865381162" name="Text 40"/>
           <p:cNvSpPr/>
           <p:nvPr/>
         </p:nvSpPr>
@@ -6566,7 +6566,7 @@
       </p:sp>
       <p:sp>
         <p:nvSpPr>
-          <p:cNvPr id="1795346382" name="Shape 41"/>
+          <p:cNvPr id="69135626" name="Shape 41"/>
           <p:cNvSpPr/>
           <p:nvPr/>
         </p:nvSpPr>
@@ -6612,7 +6612,7 @@
       </p:sp>
       <p:sp>
         <p:nvSpPr>
-          <p:cNvPr id="914927580" name="Text 42"/>
+          <p:cNvPr id="505197927" name="Text 42"/>
           <p:cNvSpPr/>
           <p:nvPr/>
         </p:nvSpPr>
@@ -6670,7 +6670,7 @@
       </p:sp>
       <p:sp>
         <p:nvSpPr>
-          <p:cNvPr id="185816314" name="Text 43"/>
+          <p:cNvPr id="1311654165" name="Text 43"/>
           <p:cNvSpPr/>
           <p:nvPr/>
         </p:nvSpPr>
@@ -6728,7 +6728,7 @@
       </p:sp>
       <p:sp>
         <p:nvSpPr>
-          <p:cNvPr id="914236075" name="Text 44"/>
+          <p:cNvPr id="1587564302" name="Text 44"/>
           <p:cNvSpPr/>
           <p:nvPr/>
         </p:nvSpPr>
@@ -6786,7 +6786,7 @@
       </p:sp>
       <p:sp>
         <p:nvSpPr>
-          <p:cNvPr id="961719973" name="Text 45"/>
+          <p:cNvPr id="1221098830" name="Text 45"/>
           <p:cNvSpPr/>
           <p:nvPr/>
         </p:nvSpPr>
@@ -6844,7 +6844,7 @@
       </p:sp>
       <p:sp>
         <p:nvSpPr>
-          <p:cNvPr id="354354628" name="Shape 46"/>
+          <p:cNvPr id="1824423458" name="Shape 46"/>
           <p:cNvSpPr/>
           <p:nvPr/>
         </p:nvSpPr>
@@ -6890,7 +6890,7 @@
       </p:sp>
       <p:sp>
         <p:nvSpPr>
-          <p:cNvPr id="757915759" name="Text 47"/>
+          <p:cNvPr id="1432050020" name="Text 47"/>
           <p:cNvSpPr/>
           <p:nvPr/>
         </p:nvSpPr>
@@ -6948,7 +6948,7 @@
       </p:sp>
       <p:sp>
         <p:nvSpPr>
-          <p:cNvPr id="1747216241" name="Text 48"/>
+          <p:cNvPr id="82765174" name="Text 48"/>
           <p:cNvSpPr/>
           <p:nvPr/>
         </p:nvSpPr>
@@ -7006,7 +7006,7 @@
       </p:sp>
       <p:sp>
         <p:nvSpPr>
-          <p:cNvPr id="1580099329" name="Text 49"/>
+          <p:cNvPr id="468307804" name="Text 49"/>
           <p:cNvSpPr/>
           <p:nvPr/>
         </p:nvSpPr>
@@ -7064,7 +7064,7 @@
       </p:sp>
       <p:sp>
         <p:nvSpPr>
-          <p:cNvPr id="605896452" name="Text 50"/>
+          <p:cNvPr id="368082271" name="Text 50"/>
           <p:cNvSpPr/>
           <p:nvPr/>
         </p:nvSpPr>
@@ -7122,7 +7122,7 @@
       </p:sp>
       <p:sp>
         <p:nvSpPr>
-          <p:cNvPr id="1870678036" name="Shape 51"/>
+          <p:cNvPr id="1954503106" name="Shape 51"/>
           <p:cNvSpPr/>
           <p:nvPr/>
         </p:nvSpPr>
@@ -7168,7 +7168,7 @@
       </p:sp>
       <p:sp>
         <p:nvSpPr>
-          <p:cNvPr id="1080319304" name="Text 52"/>
+          <p:cNvPr id="1347963579" name="Text 52"/>
           <p:cNvSpPr/>
           <p:nvPr/>
         </p:nvSpPr>
@@ -7226,7 +7226,7 @@
       </p:sp>
       <p:sp>
         <p:nvSpPr>
-          <p:cNvPr id="206791058" name="Text 53"/>
+          <p:cNvPr id="1685112853" name="Text 53"/>
           <p:cNvSpPr/>
           <p:nvPr/>
         </p:nvSpPr>
@@ -7284,7 +7284,7 @@
       </p:sp>
       <p:sp>
         <p:nvSpPr>
-          <p:cNvPr id="2020097308" name="Text 54"/>
+          <p:cNvPr id="1097430547" name="Text 54"/>
           <p:cNvSpPr/>
           <p:nvPr/>
         </p:nvSpPr>
@@ -7342,7 +7342,7 @@
       </p:sp>
       <p:sp>
         <p:nvSpPr>
-          <p:cNvPr id="115520974" name="Text 55"/>
+          <p:cNvPr id="567800838" name="Text 55"/>
           <p:cNvSpPr/>
           <p:nvPr/>
         </p:nvSpPr>
@@ -7400,7 +7400,7 @@
       </p:sp>
       <p:sp>
         <p:nvSpPr>
-          <p:cNvPr id="1938839073" name="Shape 56"/>
+          <p:cNvPr id="2051952188" name="Shape 56"/>
           <p:cNvSpPr/>
           <p:nvPr/>
         </p:nvSpPr>
@@ -7446,7 +7446,7 @@
       </p:sp>
       <p:sp>
         <p:nvSpPr>
-          <p:cNvPr id="2068805811" name="Text 57"/>
+          <p:cNvPr id="1270960934" name="Text 57"/>
           <p:cNvSpPr/>
           <p:nvPr/>
         </p:nvSpPr>
@@ -7504,7 +7504,7 @@
       </p:sp>
       <p:sp>
         <p:nvSpPr>
-          <p:cNvPr id="183750742" name="Text 58"/>
+          <p:cNvPr id="1904521594" name="Text 58"/>
           <p:cNvSpPr/>
           <p:nvPr/>
         </p:nvSpPr>
@@ -7562,7 +7562,7 @@
       </p:sp>
       <p:sp>
         <p:nvSpPr>
-          <p:cNvPr id="218609816" name="Text 59"/>
+          <p:cNvPr id="1732031448" name="Text 59"/>
           <p:cNvSpPr/>
           <p:nvPr/>
         </p:nvSpPr>
@@ -7620,7 +7620,7 @@
       </p:sp>
       <p:sp>
         <p:nvSpPr>
-          <p:cNvPr id="373514426" name="Text 60"/>
+          <p:cNvPr id="396652228" name="Text 60"/>
           <p:cNvSpPr/>
           <p:nvPr/>
         </p:nvSpPr>
@@ -7678,7 +7678,7 @@
       </p:sp>
       <p:sp>
         <p:nvSpPr>
-          <p:cNvPr id="1283252366" name="Text 61"/>
+          <p:cNvPr id="670530255" name="Text 61"/>
           <p:cNvSpPr/>
           <p:nvPr/>
         </p:nvSpPr>
@@ -7736,7 +7736,7 @@
       </p:sp>
       <p:sp>
         <p:nvSpPr>
-          <p:cNvPr id="787996338" name="Text 62"/>
+          <p:cNvPr id="1828981111" name="Text 62"/>
           <p:cNvSpPr/>
           <p:nvPr/>
         </p:nvSpPr>
@@ -7794,7 +7794,7 @@
       </p:sp>
       <p:sp>
         <p:nvSpPr>
-          <p:cNvPr id="1875392541" name="Text 63"/>
+          <p:cNvPr id="1917590070" name="Text 63"/>
           <p:cNvSpPr/>
           <p:nvPr/>
         </p:nvSpPr>
@@ -7852,7 +7852,7 @@
       </p:sp>
       <p:sp>
         <p:nvSpPr>
-          <p:cNvPr id="614228131" name="Text 64"/>
+          <p:cNvPr id="234721288" name="Text 64"/>
           <p:cNvSpPr/>
           <p:nvPr/>
         </p:nvSpPr>
@@ -7910,7 +7910,7 @@
       </p:sp>
       <p:sp>
         <p:nvSpPr>
-          <p:cNvPr id="1418397296" name="Text 65"/>
+          <p:cNvPr id="1984801389" name="Text 65"/>
           <p:cNvSpPr/>
           <p:nvPr/>
         </p:nvSpPr>
@@ -7968,7 +7968,7 @@
       </p:sp>
       <p:sp>
         <p:nvSpPr>
-          <p:cNvPr id="991397585" name="Text 66"/>
+          <p:cNvPr id="238222921" name="Text 66"/>
           <p:cNvSpPr/>
           <p:nvPr/>
         </p:nvSpPr>
@@ -8036,7 +8036,7 @@
       </p:sp>
       <p:sp>
         <p:nvSpPr>
-          <p:cNvPr id="136234461" name="Text 67"/>
+          <p:cNvPr id="744578612" name="Text 67"/>
           <p:cNvSpPr/>
           <p:nvPr/>
         </p:nvSpPr>
@@ -8104,7 +8104,7 @@
       </p:sp>
       <p:sp>
         <p:nvSpPr>
-          <p:cNvPr id="844769765" name="Text 68"/>
+          <p:cNvPr id="1252689118" name="Text 68"/>
           <p:cNvSpPr/>
           <p:nvPr/>
         </p:nvSpPr>
@@ -8172,7 +8172,7 @@
       </p:sp>
       <p:sp>
         <p:nvSpPr>
-          <p:cNvPr id="2135952324" name="Text 69"/>
+          <p:cNvPr id="857552825" name="Text 69"/>
           <p:cNvSpPr/>
           <p:nvPr/>
         </p:nvSpPr>
@@ -8240,7 +8240,7 @@
       </p:sp>
       <p:sp>
         <p:nvSpPr>
-          <p:cNvPr id="686963746" name="Text 70"/>
+          <p:cNvPr id="1286620205" name="Text 70"/>
           <p:cNvSpPr/>
           <p:nvPr/>
         </p:nvSpPr>
@@ -8308,7 +8308,7 @@
       </p:sp>
       <p:sp>
         <p:nvSpPr>
-          <p:cNvPr id="1981281984" name="Text 71"/>
+          <p:cNvPr id="1295364420" name="Text 71"/>
           <p:cNvSpPr/>
           <p:nvPr/>
         </p:nvSpPr>
@@ -8376,7 +8376,7 @@
       </p:sp>
       <p:sp>
         <p:nvSpPr>
-          <p:cNvPr id="373729794" name="Text 72"/>
+          <p:cNvPr id="1041594252" name="Text 72"/>
           <p:cNvSpPr/>
           <p:nvPr/>
         </p:nvSpPr>
@@ -8434,7 +8434,7 @@
       </p:sp>
       <p:sp>
         <p:nvSpPr>
-          <p:cNvPr id="506437043" name="Text 73"/>
+          <p:cNvPr id="227403528" name="Text 73"/>
           <p:cNvSpPr/>
           <p:nvPr/>
         </p:nvSpPr>
@@ -8562,7 +8562,7 @@
       </p:grpSpPr>
       <p:sp>
         <p:nvSpPr>
-          <p:cNvPr id="1020730786" name="Shape 0"/>
+          <p:cNvPr id="1363361727" name="Shape 0"/>
           <p:cNvSpPr/>
           <p:nvPr/>
         </p:nvSpPr>
@@ -8606,7 +8606,7 @@
       </p:sp>
       <p:sp>
         <p:nvSpPr>
-          <p:cNvPr id="1152284194" name="Text 1"/>
+          <p:cNvPr id="1804561236" name="Text 1"/>
           <p:cNvSpPr/>
           <p:nvPr/>
         </p:nvSpPr>
@@ -8664,7 +8664,7 @@
       </p:sp>
       <p:sp>
         <p:nvSpPr>
-          <p:cNvPr id="1185072173" name="Text 2"/>
+          <p:cNvPr id="2093606075" name="Text 2"/>
           <p:cNvSpPr/>
           <p:nvPr/>
         </p:nvSpPr>
@@ -8724,7 +8724,7 @@
       </p:sp>
       <p:sp>
         <p:nvSpPr>
-          <p:cNvPr id="2116109233" name="Text 3"/>
+          <p:cNvPr id="1875839617" name="Text 3"/>
           <p:cNvSpPr/>
           <p:nvPr/>
         </p:nvSpPr>
@@ -8796,7 +8796,7 @@
       </p:sp>
       <p:sp>
         <p:nvSpPr>
-          <p:cNvPr id="1855203197" name="Text 4"/>
+          <p:cNvPr id="956143411" name="Text 4"/>
           <p:cNvSpPr/>
           <p:nvPr/>
         </p:nvSpPr>
@@ -8856,7 +8856,7 @@
       </p:sp>
       <p:sp>
         <p:nvSpPr>
-          <p:cNvPr id="1288836413" name="Text 5"/>
+          <p:cNvPr id="2056113774" name="Text 5"/>
           <p:cNvSpPr/>
           <p:nvPr/>
         </p:nvSpPr>
@@ -8924,7 +8924,7 @@
       </p:sp>
       <p:sp>
         <p:nvSpPr>
-          <p:cNvPr id="949056244" name="Text 6"/>
+          <p:cNvPr id="1020169287" name="Text 6"/>
           <p:cNvSpPr/>
           <p:nvPr/>
         </p:nvSpPr>
@@ -8984,7 +8984,7 @@
       </p:sp>
       <p:sp>
         <p:nvSpPr>
-          <p:cNvPr id="252996244" name="Text 7"/>
+          <p:cNvPr id="2058981427" name="Text 7"/>
           <p:cNvSpPr/>
           <p:nvPr/>
         </p:nvSpPr>
@@ -9193,7 +9193,7 @@
       </p:sp>
       <p:sp>
         <p:nvSpPr>
-          <p:cNvPr id="186031958" name="Shape 8"/>
+          <p:cNvPr id="140279313" name="Shape 8"/>
           <p:cNvSpPr/>
           <p:nvPr/>
         </p:nvSpPr>
@@ -9239,7 +9239,7 @@
       </p:sp>
       <p:sp>
         <p:nvSpPr>
-          <p:cNvPr id="403504544" name="Shape 9"/>
+          <p:cNvPr id="424909196" name="Shape 9"/>
           <p:cNvSpPr/>
           <p:nvPr/>
         </p:nvSpPr>
@@ -9283,7 +9283,7 @@
       </p:sp>
       <p:pic>
         <p:nvPicPr>
-          <p:cNvPr id="216991283" name="Image 0" descr="preencoded.png"/>
+          <p:cNvPr id="186279102" name="Image 0" descr="preencoded.png"/>
           <p:cNvPicPr/>
           <p:nvPr/>
         </p:nvPicPr>
@@ -9307,7 +9307,7 @@
       </p:pic>
       <p:sp>
         <p:nvSpPr>
-          <p:cNvPr id="9737617" name="Text 10"/>
+          <p:cNvPr id="345375620" name="Text 10"/>
           <p:cNvSpPr/>
           <p:nvPr/>
         </p:nvSpPr>
@@ -9379,7 +9379,7 @@
       </p:sp>
       <p:sp>
         <p:nvSpPr>
-          <p:cNvPr id="208139398" name="Text 11"/>
+          <p:cNvPr id="1310707761" name="Text 11"/>
           <p:cNvSpPr/>
           <p:nvPr/>
         </p:nvSpPr>
@@ -9437,7 +9437,7 @@
       </p:sp>
       <p:sp>
         <p:nvSpPr>
-          <p:cNvPr id="170840289" name="Text 12"/>
+          <p:cNvPr id="270990650" name="Text 12"/>
           <p:cNvSpPr/>
           <p:nvPr/>
         </p:nvSpPr>
@@ -9497,7 +9497,7 @@
       </p:sp>
       <p:sp>
         <p:nvSpPr>
-          <p:cNvPr id="1556098738" name="Text 13"/>
+          <p:cNvPr id="1960314238" name="Text 13"/>
           <p:cNvSpPr/>
           <p:nvPr/>
         </p:nvSpPr>
@@ -9557,7 +9557,7 @@
       </p:sp>
       <p:sp>
         <p:nvSpPr>
-          <p:cNvPr id="1516715348" name="Shape 14"/>
+          <p:cNvPr id="695265078" name="Shape 14"/>
           <p:cNvSpPr/>
           <p:nvPr/>
         </p:nvSpPr>
@@ -9603,7 +9603,7 @@
       </p:sp>
       <p:sp>
         <p:nvSpPr>
-          <p:cNvPr id="1565590522" name="Text 15"/>
+          <p:cNvPr id="988702377" name="Text 15"/>
           <p:cNvSpPr/>
           <p:nvPr/>
         </p:nvSpPr>
@@ -9663,7 +9663,7 @@
       </p:sp>
       <p:sp>
         <p:nvSpPr>
-          <p:cNvPr id="1180919286" name="Text 16"/>
+          <p:cNvPr id="1047279317" name="Text 16"/>
           <p:cNvSpPr/>
           <p:nvPr/>
         </p:nvSpPr>
@@ -9721,7 +9721,7 @@
       </p:sp>
       <p:sp>
         <p:nvSpPr>
-          <p:cNvPr id="2506863" name="Text 17"/>
+          <p:cNvPr id="61226153" name="Text 17"/>
           <p:cNvSpPr/>
           <p:nvPr/>
         </p:nvSpPr>
@@ -9793,7 +9793,7 @@
       </p:sp>
       <p:sp>
         <p:nvSpPr>
-          <p:cNvPr id="1446522552" name="Text 18"/>
+          <p:cNvPr id="387965395" name="Text 18"/>
           <p:cNvSpPr/>
           <p:nvPr/>
         </p:nvSpPr>
@@ -9853,7 +9853,7 @@
       </p:sp>
       <p:sp>
         <p:nvSpPr>
-          <p:cNvPr id="758286961" name="Text 19"/>
+          <p:cNvPr id="442094370" name="Text 19"/>
           <p:cNvSpPr/>
           <p:nvPr/>
         </p:nvSpPr>
@@ -9965,7 +9965,7 @@
       </p:grpSpPr>
       <p:sp>
         <p:nvSpPr>
-          <p:cNvPr id="1362966370" name="Shape 0"/>
+          <p:cNvPr id="801055863" name="Shape 0"/>
           <p:cNvSpPr/>
           <p:nvPr/>
         </p:nvSpPr>
@@ -10009,7 +10009,7 @@
       </p:sp>
       <p:sp>
         <p:nvSpPr>
-          <p:cNvPr id="1085829317" name="Text 1"/>
+          <p:cNvPr id="308361682" name="Text 1"/>
           <p:cNvSpPr/>
           <p:nvPr/>
         </p:nvSpPr>
@@ -10067,7 +10067,7 @@
       </p:sp>
       <p:sp>
         <p:nvSpPr>
-          <p:cNvPr id="974331782" name="Text 2"/>
+          <p:cNvPr id="297969335" name="Text 2"/>
           <p:cNvSpPr/>
           <p:nvPr/>
         </p:nvSpPr>
@@ -10125,7 +10125,7 @@
       </p:sp>
       <p:sp>
         <p:nvSpPr>
-          <p:cNvPr id="1588084993" name="Text 3"/>
+          <p:cNvPr id="2010151477" name="Text 3"/>
           <p:cNvSpPr/>
           <p:nvPr/>
         </p:nvSpPr>
@@ -10193,7 +10193,7 @@
       </p:sp>
       <p:sp>
         <p:nvSpPr>
-          <p:cNvPr id="1650312415" name="Text 4"/>
+          <p:cNvPr id="244169868" name="Text 4"/>
           <p:cNvSpPr/>
           <p:nvPr/>
         </p:nvSpPr>
@@ -10271,7 +10271,7 @@
       </p:sp>
       <p:sp>
         <p:nvSpPr>
-          <p:cNvPr id="345530276" name="Text 5"/>
+          <p:cNvPr id="788411843" name="Text 5"/>
           <p:cNvSpPr/>
           <p:nvPr/>
         </p:nvSpPr>
@@ -10349,7 +10349,7 @@
       </p:sp>
       <p:sp>
         <p:nvSpPr>
-          <p:cNvPr id="1252408367" name="Text 6"/>
+          <p:cNvPr id="775914539" name="Text 6"/>
           <p:cNvSpPr/>
           <p:nvPr/>
         </p:nvSpPr>
@@ -10407,7 +10407,7 @@
       </p:sp>
       <p:sp>
         <p:nvSpPr>
-          <p:cNvPr id="2011083202" name="Text 7"/>
+          <p:cNvPr id="1653163411" name="Text 7"/>
           <p:cNvSpPr/>
           <p:nvPr/>
         </p:nvSpPr>
@@ -10465,7 +10465,7 @@
       </p:sp>
       <p:sp>
         <p:nvSpPr>
-          <p:cNvPr id="2081631008" name="Shape 8"/>
+          <p:cNvPr id="317303089" name="Shape 8"/>
           <p:cNvSpPr/>
           <p:nvPr/>
         </p:nvSpPr>
@@ -10512,7 +10512,7 @@
       </p:sp>
       <p:sp>
         <p:nvSpPr>
-          <p:cNvPr id="1548147217" name="Text 9"/>
+          <p:cNvPr id="265956819" name="Text 9"/>
           <p:cNvSpPr/>
           <p:nvPr/>
         </p:nvSpPr>
@@ -10570,7 +10570,7 @@
       </p:sp>
       <p:sp>
         <p:nvSpPr>
-          <p:cNvPr id="1415653186" name="Text 10"/>
+          <p:cNvPr id="986627749" name="Text 10"/>
           <p:cNvSpPr/>
           <p:nvPr/>
         </p:nvSpPr>
@@ -10628,7 +10628,7 @@
       </p:sp>
       <p:sp>
         <p:nvSpPr>
-          <p:cNvPr id="429487519" name="Shape 11"/>
+          <p:cNvPr id="708337715" name="Shape 11"/>
           <p:cNvSpPr/>
           <p:nvPr/>
         </p:nvSpPr>
@@ -10674,7 +10674,7 @@
       </p:sp>
       <p:sp>
         <p:nvSpPr>
-          <p:cNvPr id="1653798128" name="Text 12"/>
+          <p:cNvPr id="692945212" name="Text 12"/>
           <p:cNvSpPr/>
           <p:nvPr/>
         </p:nvSpPr>
@@ -10732,7 +10732,7 @@
       </p:sp>
       <p:sp>
         <p:nvSpPr>
-          <p:cNvPr id="1182602763" name="Text 13"/>
+          <p:cNvPr id="43940090" name="Text 13"/>
           <p:cNvSpPr/>
           <p:nvPr/>
         </p:nvSpPr>
@@ -10790,7 +10790,7 @@
       </p:sp>
       <p:sp>
         <p:nvSpPr>
-          <p:cNvPr id="632391059" name="Text 14"/>
+          <p:cNvPr id="717297674" name="Text 14"/>
           <p:cNvSpPr/>
           <p:nvPr/>
         </p:nvSpPr>
@@ -10848,7 +10848,7 @@
       </p:sp>
       <p:sp>
         <p:nvSpPr>
-          <p:cNvPr id="485172923" name="Text 15"/>
+          <p:cNvPr id="1768625702" name="Text 15"/>
           <p:cNvSpPr/>
           <p:nvPr/>
         </p:nvSpPr>
@@ -10906,7 +10906,7 @@
       </p:sp>
       <p:sp>
         <p:nvSpPr>
-          <p:cNvPr id="1021557903" name="Text 16"/>
+          <p:cNvPr id="1064310721" name="Text 16"/>
           <p:cNvSpPr/>
           <p:nvPr/>
         </p:nvSpPr>
@@ -10964,7 +10964,7 @@
       </p:sp>
       <p:sp>
         <p:nvSpPr>
-          <p:cNvPr id="1822293559" name="Text 17"/>
+          <p:cNvPr id="1808257630" name="Text 17"/>
           <p:cNvSpPr/>
           <p:nvPr/>
         </p:nvSpPr>
@@ -11022,7 +11022,7 @@
       </p:sp>
       <p:sp>
         <p:nvSpPr>
-          <p:cNvPr id="1953198876" name="Text 18"/>
+          <p:cNvPr id="1375396778" name="Text 18"/>
           <p:cNvSpPr/>
           <p:nvPr/>
         </p:nvSpPr>
@@ -11080,7 +11080,7 @@
       </p:sp>
       <p:sp>
         <p:nvSpPr>
-          <p:cNvPr id="862101145" name="Text 19"/>
+          <p:cNvPr id="659549375" name="Text 19"/>
           <p:cNvSpPr/>
           <p:nvPr/>
         </p:nvSpPr>
@@ -11148,7 +11148,7 @@
       </p:sp>
       <p:sp>
         <p:nvSpPr>
-          <p:cNvPr id="864256938" name="Text 20"/>
+          <p:cNvPr id="1268852456" name="Text 20"/>
           <p:cNvSpPr/>
           <p:nvPr/>
         </p:nvSpPr>
@@ -11206,7 +11206,7 @@
       </p:sp>
       <p:sp>
         <p:nvSpPr>
-          <p:cNvPr id="702935062" name="Text 21"/>
+          <p:cNvPr id="2018612453" name="Text 21"/>
           <p:cNvSpPr/>
           <p:nvPr/>
         </p:nvSpPr>
@@ -11264,7 +11264,7 @@
       </p:sp>
       <p:sp>
         <p:nvSpPr>
-          <p:cNvPr id="1262809202" name="Text 22"/>
+          <p:cNvPr id="305058050" name="Text 22"/>
           <p:cNvSpPr/>
           <p:nvPr/>
         </p:nvSpPr>
@@ -11362,7 +11362,7 @@
       </p:grpSpPr>
       <p:sp>
         <p:nvSpPr>
-          <p:cNvPr id="667784983" name="Shape 0"/>
+          <p:cNvPr id="16358296" name="Shape 0"/>
           <p:cNvSpPr/>
           <p:nvPr/>
         </p:nvSpPr>
@@ -11406,7 +11406,7 @@
       </p:sp>
       <p:sp>
         <p:nvSpPr>
-          <p:cNvPr id="497291212" name="Text 1"/>
+          <p:cNvPr id="875366155" name="Text 1"/>
           <p:cNvSpPr/>
           <p:nvPr/>
         </p:nvSpPr>
@@ -11464,7 +11464,7 @@
       </p:sp>
       <p:sp>
         <p:nvSpPr>
-          <p:cNvPr id="1385081152" name="Text 2"/>
+          <p:cNvPr id="1218646270" name="Text 2"/>
           <p:cNvSpPr/>
           <p:nvPr/>
         </p:nvSpPr>
@@ -11522,7 +11522,7 @@
       </p:sp>
       <p:sp>
         <p:nvSpPr>
-          <p:cNvPr id="762792254" name="Text 3"/>
+          <p:cNvPr id="1479463539" name="Text 3"/>
           <p:cNvSpPr/>
           <p:nvPr/>
         </p:nvSpPr>
@@ -11590,7 +11590,7 @@
       </p:sp>
       <p:sp>
         <p:nvSpPr>
-          <p:cNvPr id="1905676503" name="Text 4"/>
+          <p:cNvPr id="1689369904" name="Text 4"/>
           <p:cNvSpPr/>
           <p:nvPr/>
         </p:nvSpPr>
@@ -11658,7 +11658,7 @@
       </p:sp>
       <p:sp>
         <p:nvSpPr>
-          <p:cNvPr id="1234607199" name="Text 5"/>
+          <p:cNvPr id="640873274" name="Text 5"/>
           <p:cNvSpPr/>
           <p:nvPr/>
         </p:nvSpPr>
@@ -11716,7 +11716,7 @@
       </p:sp>
       <p:sp>
         <p:nvSpPr>
-          <p:cNvPr id="568192181" name="Shape 6"/>
+          <p:cNvPr id="1310945598" name="Shape 6"/>
           <p:cNvSpPr/>
           <p:nvPr/>
         </p:nvSpPr>
@@ -11760,7 +11760,7 @@
       </p:sp>
       <p:sp>
         <p:nvSpPr>
-          <p:cNvPr id="277083871" name="Text 7"/>
+          <p:cNvPr id="1661877146" name="Text 7"/>
           <p:cNvSpPr/>
           <p:nvPr/>
         </p:nvSpPr>
@@ -11828,7 +11828,7 @@
       </p:sp>
       <p:pic>
         <p:nvPicPr>
-          <p:cNvPr id="1074602087" name="Image 0" descr="preencoded.png"/>
+          <p:cNvPr id="2108897886" name="Image 0" descr="preencoded.png"/>
           <p:cNvPicPr/>
           <p:nvPr/>
         </p:nvPicPr>
@@ -11852,7 +11852,7 @@
       </p:pic>
       <p:sp>
         <p:nvSpPr>
-          <p:cNvPr id="21044135" name="Text 8"/>
+          <p:cNvPr id="12378667" name="Text 8"/>
           <p:cNvSpPr/>
           <p:nvPr/>
         </p:nvSpPr>
@@ -11920,7 +11920,7 @@
       </p:sp>
       <p:sp>
         <p:nvSpPr>
-          <p:cNvPr id="1507391438" name="Text 9"/>
+          <p:cNvPr id="1735605357" name="Text 9"/>
           <p:cNvSpPr/>
           <p:nvPr/>
         </p:nvSpPr>
@@ -12018,7 +12018,7 @@
       </p:sp>
       <p:sp>
         <p:nvSpPr>
-          <p:cNvPr id="851933813" name="Shape 10"/>
+          <p:cNvPr id="1106480146" name="Shape 10"/>
           <p:cNvSpPr/>
           <p:nvPr/>
         </p:nvSpPr>
@@ -12062,7 +12062,7 @@
       </p:sp>
       <p:sp>
         <p:nvSpPr>
-          <p:cNvPr id="1422994988" name="Text 11"/>
+          <p:cNvPr id="632307893" name="Text 11"/>
           <p:cNvSpPr/>
           <p:nvPr/>
         </p:nvSpPr>
@@ -12130,7 +12130,7 @@
       </p:sp>
       <p:pic>
         <p:nvPicPr>
-          <p:cNvPr id="1891595990" name="Image 1" descr="preencoded.png"/>
+          <p:cNvPr id="2130669908" name="Image 1" descr="preencoded.png"/>
           <p:cNvPicPr/>
           <p:nvPr/>
         </p:nvPicPr>
@@ -12154,7 +12154,7 @@
       </p:pic>
       <p:sp>
         <p:nvSpPr>
-          <p:cNvPr id="1823310150" name="Text 12"/>
+          <p:cNvPr id="682829359" name="Text 12"/>
           <p:cNvSpPr/>
           <p:nvPr/>
         </p:nvSpPr>
@@ -12212,7 +12212,7 @@
       </p:sp>
       <p:sp>
         <p:nvSpPr>
-          <p:cNvPr id="1214771887" name="Text 13"/>
+          <p:cNvPr id="1464668794" name="Text 13"/>
           <p:cNvSpPr/>
           <p:nvPr/>
         </p:nvSpPr>
@@ -12270,7 +12270,7 @@
       </p:sp>
       <p:sp>
         <p:nvSpPr>
-          <p:cNvPr id="1258697149" name="Shape 14"/>
+          <p:cNvPr id="200633281" name="Shape 14"/>
           <p:cNvSpPr/>
           <p:nvPr/>
         </p:nvSpPr>
@@ -12314,7 +12314,7 @@
       </p:sp>
       <p:sp>
         <p:nvSpPr>
-          <p:cNvPr id="560021494" name="Text 15"/>
+          <p:cNvPr id="665886233" name="Text 15"/>
           <p:cNvSpPr/>
           <p:nvPr/>
         </p:nvSpPr>
@@ -12382,7 +12382,7 @@
       </p:sp>
       <p:pic>
         <p:nvPicPr>
-          <p:cNvPr id="2091452114" name="Image 2" descr="preencoded.png"/>
+          <p:cNvPr id="1730017557" name="Image 2" descr="preencoded.png"/>
           <p:cNvPicPr/>
           <p:nvPr/>
         </p:nvPicPr>
@@ -12406,7 +12406,7 @@
       </p:pic>
       <p:sp>
         <p:nvSpPr>
-          <p:cNvPr id="2088444737" name="Text 16"/>
+          <p:cNvPr id="549118815" name="Text 16"/>
           <p:cNvSpPr/>
           <p:nvPr/>
         </p:nvSpPr>
@@ -12464,7 +12464,7 @@
       </p:sp>
       <p:sp>
         <p:nvSpPr>
-          <p:cNvPr id="954120650" name="Text 17"/>
+          <p:cNvPr id="33396407" name="Text 17"/>
           <p:cNvSpPr/>
           <p:nvPr/>
         </p:nvSpPr>
@@ -12522,7 +12522,7 @@
       </p:sp>
       <p:sp>
         <p:nvSpPr>
-          <p:cNvPr id="1074951067" name="Shape 18"/>
+          <p:cNvPr id="791142763" name="Shape 18"/>
           <p:cNvSpPr/>
           <p:nvPr/>
         </p:nvSpPr>
@@ -12566,7 +12566,7 @@
       </p:sp>
       <p:sp>
         <p:nvSpPr>
-          <p:cNvPr id="1461846709" name="Text 19"/>
+          <p:cNvPr id="10576095" name="Text 19"/>
           <p:cNvSpPr/>
           <p:nvPr/>
         </p:nvSpPr>
@@ -12634,7 +12634,7 @@
       </p:sp>
       <p:pic>
         <p:nvPicPr>
-          <p:cNvPr id="1104531516" name="Image 3" descr="preencoded.png"/>
+          <p:cNvPr id="1677899825" name="Image 3" descr="preencoded.png"/>
           <p:cNvPicPr/>
           <p:nvPr/>
         </p:nvPicPr>
@@ -12658,7 +12658,7 @@
       </p:pic>
       <p:sp>
         <p:nvSpPr>
-          <p:cNvPr id="1310706669" name="Text 20"/>
+          <p:cNvPr id="1565767776" name="Text 20"/>
           <p:cNvSpPr/>
           <p:nvPr/>
         </p:nvSpPr>
@@ -12716,7 +12716,7 @@
       </p:sp>
       <p:sp>
         <p:nvSpPr>
-          <p:cNvPr id="271210511" name="Text 21"/>
+          <p:cNvPr id="14171434" name="Text 21"/>
           <p:cNvSpPr/>
           <p:nvPr/>
         </p:nvSpPr>
@@ -12774,7 +12774,7 @@
       </p:sp>
       <p:sp>
         <p:nvSpPr>
-          <p:cNvPr id="62074419" name="Text 22"/>
+          <p:cNvPr id="1325743325" name="Text 22"/>
           <p:cNvSpPr/>
           <p:nvPr/>
         </p:nvSpPr>
@@ -12832,7 +12832,7 @@
       </p:sp>
       <p:sp>
         <p:nvSpPr>
-          <p:cNvPr id="1730691820" name="Text 23"/>
+          <p:cNvPr id="2065924173" name="Text 23"/>
           <p:cNvSpPr/>
           <p:nvPr/>
         </p:nvSpPr>
@@ -12950,7 +12950,7 @@
       </p:grpSpPr>
       <p:sp>
         <p:nvSpPr>
-          <p:cNvPr id="1447991443" name="Shape 0"/>
+          <p:cNvPr id="457530692" name="Shape 0"/>
           <p:cNvSpPr/>
           <p:nvPr/>
         </p:nvSpPr>
@@ -12994,7 +12994,7 @@
       </p:sp>
       <p:sp>
         <p:nvSpPr>
-          <p:cNvPr id="1148640568" name="Text 1"/>
+          <p:cNvPr id="2025306043" name="Text 1"/>
           <p:cNvSpPr/>
           <p:nvPr/>
         </p:nvSpPr>
@@ -13052,7 +13052,7 @@
       </p:sp>
       <p:sp>
         <p:nvSpPr>
-          <p:cNvPr id="1388535726" name="Text 2"/>
+          <p:cNvPr id="1831036218" name="Text 2"/>
           <p:cNvSpPr/>
           <p:nvPr/>
         </p:nvSpPr>
@@ -13112,7 +13112,7 @@
       </p:sp>
       <p:sp>
         <p:nvSpPr>
-          <p:cNvPr id="1015909365" name="Text 3"/>
+          <p:cNvPr id="735061245" name="Text 3"/>
           <p:cNvSpPr/>
           <p:nvPr/>
         </p:nvSpPr>
@@ -13184,7 +13184,7 @@
       </p:sp>
       <p:sp>
         <p:nvSpPr>
-          <p:cNvPr id="2017292284" name="Text 4"/>
+          <p:cNvPr id="784848287" name="Text 4"/>
           <p:cNvSpPr/>
           <p:nvPr/>
         </p:nvSpPr>
@@ -13268,7 +13268,7 @@
       </p:sp>
       <p:sp>
         <p:nvSpPr>
-          <p:cNvPr id="1731483783" name="Text 5"/>
+          <p:cNvPr id="2062703620" name="Text 5"/>
           <p:cNvSpPr/>
           <p:nvPr/>
         </p:nvSpPr>
@@ -13336,7 +13336,7 @@
       </p:sp>
       <p:sp>
         <p:nvSpPr>
-          <p:cNvPr id="1671923071" name="Text 6"/>
+          <p:cNvPr id="442284818" name="Text 6"/>
           <p:cNvSpPr/>
           <p:nvPr/>
         </p:nvSpPr>
@@ -13396,7 +13396,7 @@
       </p:sp>
       <p:sp>
         <p:nvSpPr>
-          <p:cNvPr id="1481661197" name="Text 7"/>
+          <p:cNvPr id="899358655" name="Text 7"/>
           <p:cNvSpPr/>
           <p:nvPr/>
         </p:nvSpPr>
@@ -13456,7 +13456,7 @@
       </p:sp>
       <p:sp>
         <p:nvSpPr>
-          <p:cNvPr id="1070592720" name="Text 8"/>
+          <p:cNvPr id="442115796" name="Text 8"/>
           <p:cNvSpPr/>
           <p:nvPr/>
         </p:nvSpPr>
@@ -13514,7 +13514,7 @@
       </p:sp>
       <p:sp>
         <p:nvSpPr>
-          <p:cNvPr id="1462385276" name="Text 9"/>
+          <p:cNvPr id="1129638251" name="Text 9"/>
           <p:cNvSpPr/>
           <p:nvPr/>
         </p:nvSpPr>
@@ -13574,7 +13574,7 @@
       </p:sp>
       <p:sp>
         <p:nvSpPr>
-          <p:cNvPr id="1429464473" name="Text 10"/>
+          <p:cNvPr id="2053545696" name="Text 10"/>
           <p:cNvSpPr/>
           <p:nvPr/>
         </p:nvSpPr>
@@ -13634,7 +13634,7 @@
       </p:sp>
       <p:sp>
         <p:nvSpPr>
-          <p:cNvPr id="1863363936" name="Text 11"/>
+          <p:cNvPr id="2051978858" name="Text 11"/>
           <p:cNvSpPr/>
           <p:nvPr/>
         </p:nvSpPr>
@@ -13702,7 +13702,7 @@
       </p:sp>
       <p:sp>
         <p:nvSpPr>
-          <p:cNvPr id="998178793" name="Text 12"/>
+          <p:cNvPr id="2064577421" name="Text 12"/>
           <p:cNvSpPr/>
           <p:nvPr/>
         </p:nvSpPr>
@@ -13858,7 +13858,7 @@
       </p:sp>
       <p:sp>
         <p:nvSpPr>
-          <p:cNvPr id="541482316" name="Text 13"/>
+          <p:cNvPr id="1773606277" name="Text 13"/>
           <p:cNvSpPr/>
           <p:nvPr/>
         </p:nvSpPr>
@@ -13918,7 +13918,7 @@
       </p:sp>
       <p:sp>
         <p:nvSpPr>
-          <p:cNvPr id="1003767296" name="Text 14"/>
+          <p:cNvPr id="935863754" name="Text 14"/>
           <p:cNvSpPr/>
           <p:nvPr/>
         </p:nvSpPr>
@@ -13976,7 +13976,7 @@
       </p:sp>
       <p:sp>
         <p:nvSpPr>
-          <p:cNvPr id="1726907736" name="Text 15"/>
+          <p:cNvPr id="675725398" name="Text 15"/>
           <p:cNvSpPr/>
           <p:nvPr/>
         </p:nvSpPr>
@@ -14036,7 +14036,7 @@
       </p:sp>
       <p:sp>
         <p:nvSpPr>
-          <p:cNvPr id="1590854606" name="Text 16"/>
+          <p:cNvPr id="1932084279" name="Text 16"/>
           <p:cNvSpPr/>
           <p:nvPr/>
         </p:nvSpPr>
@@ -14096,7 +14096,7 @@
       </p:sp>
       <p:sp>
         <p:nvSpPr>
-          <p:cNvPr id="417908144" name="Text 17"/>
+          <p:cNvPr id="1256618040" name="Text 17"/>
           <p:cNvSpPr/>
           <p:nvPr/>
         </p:nvSpPr>
@@ -14196,7 +14196,7 @@
       </p:grpSpPr>
       <p:sp>
         <p:nvSpPr>
-          <p:cNvPr id="1927567861" name="Shape 0"/>
+          <p:cNvPr id="376830770" name="Shape 0"/>
           <p:cNvSpPr/>
           <p:nvPr/>
         </p:nvSpPr>
@@ -14240,7 +14240,7 @@
       </p:sp>
       <p:sp>
         <p:nvSpPr>
-          <p:cNvPr id="471662461" name="Text 1"/>
+          <p:cNvPr id="405566513" name="Text 1"/>
           <p:cNvSpPr/>
           <p:nvPr/>
         </p:nvSpPr>
@@ -14298,7 +14298,7 @@
       </p:sp>
       <p:sp>
         <p:nvSpPr>
-          <p:cNvPr id="1390584295" name="Text 2"/>
+          <p:cNvPr id="867132601" name="Text 2"/>
           <p:cNvSpPr/>
           <p:nvPr/>
         </p:nvSpPr>
@@ -14356,7 +14356,7 @@
       </p:sp>
       <p:sp>
         <p:nvSpPr>
-          <p:cNvPr id="521024144" name="Text 3"/>
+          <p:cNvPr id="1747979929" name="Text 3"/>
           <p:cNvSpPr/>
           <p:nvPr/>
         </p:nvSpPr>
@@ -14424,7 +14424,7 @@
       </p:sp>
       <p:sp>
         <p:nvSpPr>
-          <p:cNvPr id="1509139451" name="Text 4"/>
+          <p:cNvPr id="506766536" name="Text 4"/>
           <p:cNvSpPr/>
           <p:nvPr/>
         </p:nvSpPr>
@@ -14492,7 +14492,7 @@
       </p:sp>
       <p:sp>
         <p:nvSpPr>
-          <p:cNvPr id="1665261052" name="Text 5"/>
+          <p:cNvPr id="648188832" name="Text 5"/>
           <p:cNvSpPr/>
           <p:nvPr/>
         </p:nvSpPr>
@@ -14610,7 +14610,7 @@
       </p:sp>
       <p:sp>
         <p:nvSpPr>
-          <p:cNvPr id="679604795" name="Text 6"/>
+          <p:cNvPr id="1587952672" name="Text 6"/>
           <p:cNvSpPr/>
           <p:nvPr/>
         </p:nvSpPr>
@@ -14668,7 +14668,7 @@
       </p:sp>
       <p:sp>
         <p:nvSpPr>
-          <p:cNvPr id="1773920334" name="Text 7"/>
+          <p:cNvPr id="906301324" name="Text 7"/>
           <p:cNvSpPr/>
           <p:nvPr/>
         </p:nvSpPr>
@@ -14726,7 +14726,7 @@
       </p:sp>
       <p:sp>
         <p:nvSpPr>
-          <p:cNvPr id="1692583266" name="Shape 8"/>
+          <p:cNvPr id="1090286914" name="Shape 8"/>
           <p:cNvSpPr/>
           <p:nvPr/>
         </p:nvSpPr>
@@ -14772,7 +14772,7 @@
       </p:sp>
       <p:sp>
         <p:nvSpPr>
-          <p:cNvPr id="1851988100" name="Text 9"/>
+          <p:cNvPr id="260949673" name="Text 9"/>
           <p:cNvSpPr/>
           <p:nvPr/>
         </p:nvSpPr>
@@ -14830,7 +14830,7 @@
       </p:sp>
       <p:sp>
         <p:nvSpPr>
-          <p:cNvPr id="927098632" name="Text 10"/>
+          <p:cNvPr id="1303587515" name="Text 10"/>
           <p:cNvSpPr/>
           <p:nvPr/>
         </p:nvSpPr>
@@ -14888,7 +14888,7 @@
       </p:sp>
       <p:sp>
         <p:nvSpPr>
-          <p:cNvPr id="1661214024" name="Text 11"/>
+          <p:cNvPr id="1405833468" name="Text 11"/>
           <p:cNvSpPr/>
           <p:nvPr/>
         </p:nvSpPr>
@@ -14946,7 +14946,7 @@
       </p:sp>
       <p:sp>
         <p:nvSpPr>
-          <p:cNvPr id="1203954453" name="Text 12"/>
+          <p:cNvPr id="1118053606" name="Text 12"/>
           <p:cNvSpPr/>
           <p:nvPr/>
         </p:nvSpPr>
@@ -15004,7 +15004,7 @@
       </p:sp>
       <p:sp>
         <p:nvSpPr>
-          <p:cNvPr id="1525312755" name="Text 13"/>
+          <p:cNvPr id="2106063731" name="Text 13"/>
           <p:cNvSpPr/>
           <p:nvPr/>
         </p:nvSpPr>
@@ -15062,7 +15062,7 @@
       </p:sp>
       <p:sp>
         <p:nvSpPr>
-          <p:cNvPr id="546030908" name="Text 14"/>
+          <p:cNvPr id="498361137" name="Text 14"/>
           <p:cNvSpPr/>
           <p:nvPr/>
         </p:nvSpPr>
@@ -15120,7 +15120,7 @@
       </p:sp>
       <p:sp>
         <p:nvSpPr>
-          <p:cNvPr id="1023554347" name="Shape 15"/>
+          <p:cNvPr id="1820932082" name="Shape 15"/>
           <p:cNvSpPr/>
           <p:nvPr/>
         </p:nvSpPr>
@@ -15167,7 +15167,7 @@
       </p:sp>
       <p:sp>
         <p:nvSpPr>
-          <p:cNvPr id="249990931" name="Text 16"/>
+          <p:cNvPr id="1015306620" name="Text 16"/>
           <p:cNvSpPr/>
           <p:nvPr/>
         </p:nvSpPr>
@@ -15245,7 +15245,7 @@
       </p:sp>
       <p:pic>
         <p:nvPicPr>
-          <p:cNvPr id="1985904654" name="Image 0" descr="preencoded.png"/>
+          <p:cNvPr id="503440574" name="Image 0" descr="preencoded.png"/>
           <p:cNvPicPr/>
           <p:nvPr/>
         </p:nvPicPr>
@@ -15269,7 +15269,7 @@
       </p:pic>
       <p:sp>
         <p:nvSpPr>
-          <p:cNvPr id="1510152782" name="Text 17"/>
+          <p:cNvPr id="705011173" name="Text 17"/>
           <p:cNvSpPr/>
           <p:nvPr/>
         </p:nvSpPr>
@@ -15327,7 +15327,7 @@
       </p:sp>
       <p:sp>
         <p:nvSpPr>
-          <p:cNvPr id="1239641058" name="Shape 18"/>
+          <p:cNvPr id="171785448" name="Shape 18"/>
           <p:cNvSpPr/>
           <p:nvPr/>
         </p:nvSpPr>
@@ -15374,7 +15374,7 @@
       </p:sp>
       <p:sp>
         <p:nvSpPr>
-          <p:cNvPr id="358841682" name="Text 19"/>
+          <p:cNvPr id="544127312" name="Text 19"/>
           <p:cNvSpPr/>
           <p:nvPr/>
         </p:nvSpPr>
@@ -15452,7 +15452,7 @@
       </p:sp>
       <p:pic>
         <p:nvPicPr>
-          <p:cNvPr id="1761062874" name="Image 1" descr="preencoded.png"/>
+          <p:cNvPr id="555593218" name="Image 1" descr="preencoded.png"/>
           <p:cNvPicPr/>
           <p:nvPr/>
         </p:nvPicPr>
@@ -15476,7 +15476,7 @@
       </p:pic>
       <p:sp>
         <p:nvSpPr>
-          <p:cNvPr id="491831094" name="Text 20"/>
+          <p:cNvPr id="1136569274" name="Text 20"/>
           <p:cNvSpPr/>
           <p:nvPr/>
         </p:nvSpPr>
@@ -15534,7 +15534,7 @@
       </p:sp>
       <p:sp>
         <p:nvSpPr>
-          <p:cNvPr id="1121299510" name="Text 21"/>
+          <p:cNvPr id="384048609" name="Text 21"/>
           <p:cNvSpPr/>
           <p:nvPr/>
         </p:nvSpPr>
@@ -15592,7 +15592,7 @@
       </p:sp>
       <p:sp>
         <p:nvSpPr>
-          <p:cNvPr id="934417979" name="Text 22"/>
+          <p:cNvPr id="907591184" name="Text 22"/>
           <p:cNvSpPr/>
           <p:nvPr/>
         </p:nvSpPr>
@@ -15730,7 +15730,7 @@
       </p:grpSpPr>
       <p:sp>
         <p:nvSpPr>
-          <p:cNvPr id="1752289921" name="Shape 0"/>
+          <p:cNvPr id="1455134663" name="Shape 0"/>
           <p:cNvSpPr/>
           <p:nvPr/>
         </p:nvSpPr>
@@ -15774,7 +15774,7 @@
       </p:sp>
       <p:sp>
         <p:nvSpPr>
-          <p:cNvPr id="722541618" name="Text 1"/>
+          <p:cNvPr id="1794342229" name="Text 1"/>
           <p:cNvSpPr/>
           <p:nvPr/>
         </p:nvSpPr>
@@ -15832,7 +15832,7 @@
       </p:sp>
       <p:sp>
         <p:nvSpPr>
-          <p:cNvPr id="734494260" name="Text 2"/>
+          <p:cNvPr id="725415191" name="Text 2"/>
           <p:cNvSpPr/>
           <p:nvPr/>
         </p:nvSpPr>
@@ -15890,7 +15890,7 @@
       </p:sp>
       <p:sp>
         <p:nvSpPr>
-          <p:cNvPr id="657144234" name="Text 3"/>
+          <p:cNvPr id="649015260" name="Text 3"/>
           <p:cNvSpPr/>
           <p:nvPr/>
         </p:nvSpPr>
@@ -15968,7 +15968,7 @@
       </p:sp>
       <p:sp>
         <p:nvSpPr>
-          <p:cNvPr id="1642498097" name="Text 4"/>
+          <p:cNvPr id="525908390" name="Text 4"/>
           <p:cNvSpPr/>
           <p:nvPr/>
         </p:nvSpPr>
@@ -16046,7 +16046,7 @@
       </p:sp>
       <p:sp>
         <p:nvSpPr>
-          <p:cNvPr id="2038666556" name="Text 5"/>
+          <p:cNvPr id="362321185" name="Text 5"/>
           <p:cNvSpPr/>
           <p:nvPr/>
         </p:nvSpPr>
@@ -16124,7 +16124,7 @@
       </p:sp>
       <p:sp>
         <p:nvSpPr>
-          <p:cNvPr id="856735210" name="Shape 6"/>
+          <p:cNvPr id="2101199333" name="Shape 6"/>
           <p:cNvSpPr/>
           <p:nvPr/>
         </p:nvSpPr>
@@ -16171,7 +16171,7 @@
       </p:sp>
       <p:pic>
         <p:nvPicPr>
-          <p:cNvPr id="2107808057" name="Image 0" descr="preencoded.png"/>
+          <p:cNvPr id="1339350575" name="Image 0" descr="preencoded.png"/>
           <p:cNvPicPr/>
           <p:nvPr/>
         </p:nvPicPr>
@@ -16195,7 +16195,7 @@
       </p:pic>
       <p:sp>
         <p:nvSpPr>
-          <p:cNvPr id="898334055" name="Text 7"/>
+          <p:cNvPr id="1013212979" name="Text 7"/>
           <p:cNvSpPr/>
           <p:nvPr/>
         </p:nvSpPr>
@@ -16253,7 +16253,7 @@
       </p:sp>
       <p:sp>
         <p:nvSpPr>
-          <p:cNvPr id="1066567989" name="Text 8"/>
+          <p:cNvPr id="1096581599" name="Text 8"/>
           <p:cNvSpPr/>
           <p:nvPr/>
         </p:nvSpPr>
@@ -16411,7 +16411,7 @@
       </p:grpSpPr>
       <p:sp>
         <p:nvSpPr>
-          <p:cNvPr id="814542079" name="Shape 0"/>
+          <p:cNvPr id="2048356476" name="Shape 0"/>
           <p:cNvSpPr/>
           <p:nvPr/>
         </p:nvSpPr>
@@ -16455,7 +16455,7 @@
       </p:sp>
       <p:sp>
         <p:nvSpPr>
-          <p:cNvPr id="272960998" name="Text 1"/>
+          <p:cNvPr id="497280334" name="Text 1"/>
           <p:cNvSpPr/>
           <p:nvPr/>
         </p:nvSpPr>
@@ -16513,7 +16513,7 @@
       </p:sp>
       <p:sp>
         <p:nvSpPr>
-          <p:cNvPr id="208000128" name="Text 2"/>
+          <p:cNvPr id="1617864630" name="Text 2"/>
           <p:cNvSpPr/>
           <p:nvPr/>
         </p:nvSpPr>
@@ -16571,7 +16571,7 @@
       </p:sp>
       <p:sp>
         <p:nvSpPr>
-          <p:cNvPr id="604683873" name="Text 3"/>
+          <p:cNvPr id="899904238" name="Text 3"/>
           <p:cNvSpPr/>
           <p:nvPr/>
         </p:nvSpPr>
@@ -16639,7 +16639,7 @@
       </p:sp>
       <p:sp>
         <p:nvSpPr>
-          <p:cNvPr id="1545462154" name="Text 4"/>
+          <p:cNvPr id="208919990" name="Text 4"/>
           <p:cNvSpPr/>
           <p:nvPr/>
         </p:nvSpPr>
@@ -16707,14 +16707,96 @@
       </p:sp>
       <p:sp>
         <p:nvSpPr>
-          <p:cNvPr id="743709474" name="Text 5"/>
-          <p:cNvSpPr/>
-          <p:nvPr/>
-        </p:nvSpPr>
-        <p:spPr bwMode="auto">
-          <a:xfrm>
-            <a:off x="1047600" y="3607920"/>
-            <a:ext cx="7009920" cy="1357920"/>
+          <p:cNvPr id="1857490926" name="Text 5"/>
+          <p:cNvSpPr/>
+          <p:nvPr/>
+        </p:nvSpPr>
+        <p:spPr bwMode="auto">
+          <a:xfrm flipH="0" flipV="0">
+            <a:off x="1047599" y="3452812"/>
+            <a:ext cx="7009920" cy="1940424"/>
+          </a:xfrm>
+          <a:prstGeom prst="rect">
+            <a:avLst/>
+          </a:prstGeom>
+          <a:noFill/>
+          <a:ln w="0">
+            <a:noFill/>
+          </a:ln>
+        </p:spPr>
+        <p:style>
+          <a:lnRef idx="0"/>
+          <a:fillRef idx="0"/>
+          <a:effectRef idx="0"/>
+          <a:fontRef idx="minor"/>
+        </p:style>
+        <p:txBody>
+          <a:bodyPr vertOverflow="overflow" horzOverflow="overflow" vert="horz" wrap="square" lIns="25560" tIns="25560" rIns="25560" bIns="25560" numCol="1" spcCol="0" rtlCol="0" fromWordArt="0" anchor="t" anchorCtr="0" forceAA="0" upright="0" compatLnSpc="0">
+            <a:normAutofit fontScale="90000" lnSpcReduction="2000"/>
+          </a:bodyPr>
+          <a:p>
+            <a:pPr>
+              <a:defRPr/>
+            </a:pPr>
+            <a:r>
+              <a:rPr lang="zh-CN" sz="1900" b="0" i="0" u="none" strike="noStrike" cap="none" spc="0">
+                <a:solidFill>
+                  <a:srgbClr val="1F2A24"/>
+                </a:solidFill>
+                <a:latin typeface="Noto Sans JP"/>
+                <a:ea typeface="Noto Sans JP"/>
+                <a:cs typeface="Noto Sans JP"/>
+              </a:rPr>
+              <a:t>"地域の中心に立つデータセンター。"</a:t>
+            </a:r>
+            <a:endParaRPr lang="zh-CN" sz="1900" b="0" i="0" u="none" strike="noStrike" cap="none" spc="0">
+              <a:solidFill>
+                <a:srgbClr val="1F2A24"/>
+              </a:solidFill>
+              <a:latin typeface="Noto Sans JP"/>
+              <a:cs typeface="Noto Sans JP"/>
+            </a:endParaRPr>
+          </a:p>
+          <a:p>
+            <a:pPr defTabSz="914400">
+              <a:lnSpc>
+                <a:spcPct val="165000"/>
+              </a:lnSpc>
+              <a:tabLst>
+                <a:tab pos="0" algn="l"/>
+              </a:tabLst>
+              <a:defRPr/>
+            </a:pPr>
+            <a:r>
+              <a:rPr lang="zh-CN" sz="1900" b="0" i="0" u="none" strike="noStrike" cap="none" spc="0">
+                <a:solidFill>
+                  <a:srgbClr val="1F2A24"/>
+                </a:solidFill>
+                <a:latin typeface="Noto Sans JP"/>
+                <a:ea typeface="Noto Sans JP"/>
+                <a:cs typeface="Noto Sans JP"/>
+              </a:rPr>
+              <a:t>"御杖体験交流館（活用可能な地域の空き交流施設）を、エネルギー効率の高い小規模エッジ計算施設として活用。フェーズ2では村内の空き工場へ拡張します。100%地域の再生可能エネルギーで稼働します。"</a:t>
+            </a:r>
+            <a:endParaRPr lang="en-US" sz="2100" b="0" u="none" strike="noStrike">
+              <a:solidFill>
+                <a:srgbClr val="000000"/>
+              </a:solidFill>
+              <a:latin typeface="Arial"/>
+            </a:endParaRPr>
+          </a:p>
+        </p:txBody>
+      </p:sp>
+      <p:sp>
+        <p:nvSpPr>
+          <p:cNvPr id="790506815" name="Text 6"/>
+          <p:cNvSpPr/>
+          <p:nvPr/>
+        </p:nvSpPr>
+        <p:spPr bwMode="auto">
+          <a:xfrm>
+            <a:off x="1047600" y="5194800"/>
+            <a:ext cx="7009920" cy="2238120"/>
           </a:xfrm>
           <a:prstGeom prst="rect">
             <a:avLst/>
@@ -16752,27 +16834,7 @@
                 <a:latin typeface="Noto Sans JP"/>
                 <a:ea typeface="Noto Sans JP"/>
               </a:rPr>
-              <a:t>御杖小学校の旧校舎（2021年に中学校と統合・移転）を、エネルギー効率の高い小規模エッジ計算施設として再利用。</a:t>
-            </a:r>
-            <a:r>
-              <a:rPr lang="en-US" sz="2100" b="0" u="none" strike="noStrike">
-                <a:solidFill>
-                  <a:srgbClr val="1F2A24"/>
-                </a:solidFill>
-                <a:latin typeface="Noto Sans JP"/>
-                <a:ea typeface="Noto Sans JP"/>
-              </a:rPr>
-              <a:t>100%</a:t>
-            </a:r>
-            <a:r>
-              <a:rPr lang="zh-CN" sz="2100" b="0" u="none" strike="noStrike">
-                <a:solidFill>
-                  <a:srgbClr val="1F2A24"/>
-                </a:solidFill>
-                <a:latin typeface="Noto Sans JP"/>
-                <a:ea typeface="Noto Sans JP"/>
-              </a:rPr>
-              <a:t>地域の再生可能エネルギーで稼働します。</a:t>
+              <a:t>ハイパースケールではなく、説明責任を果たせる規模に。村が所有し、監査し、何をしているかを説明できる規模。排熱は温室や公共施設の暖房に再利用。設計図はオープンライセンスで公開し、他の人口減少自治体でも複製できるようにします。</a:t>
             </a:r>
             <a:endParaRPr lang="en-US" sz="2100" b="0" u="none" strike="noStrike">
               <a:solidFill>
@@ -16785,65 +16847,7 @@
       </p:sp>
       <p:sp>
         <p:nvSpPr>
-          <p:cNvPr id="855695302" name="Text 6"/>
-          <p:cNvSpPr/>
-          <p:nvPr/>
-        </p:nvSpPr>
-        <p:spPr bwMode="auto">
-          <a:xfrm>
-            <a:off x="1047600" y="5194800"/>
-            <a:ext cx="7009920" cy="2238120"/>
-          </a:xfrm>
-          <a:prstGeom prst="rect">
-            <a:avLst/>
-          </a:prstGeom>
-          <a:noFill/>
-          <a:ln w="0">
-            <a:noFill/>
-          </a:ln>
-        </p:spPr>
-        <p:style>
-          <a:lnRef idx="0"/>
-          <a:fillRef idx="0"/>
-          <a:effectRef idx="0"/>
-          <a:fontRef idx="minor"/>
-        </p:style>
-        <p:txBody>
-          <a:bodyPr lIns="25560" tIns="25560" rIns="25560" bIns="25560" anchor="t">
-            <a:normAutofit fontScale="92500"/>
-          </a:bodyPr>
-          <a:p>
-            <a:pPr defTabSz="914400">
-              <a:lnSpc>
-                <a:spcPct val="165000"/>
-              </a:lnSpc>
-              <a:tabLst>
-                <a:tab pos="0" algn="l"/>
-              </a:tabLst>
-              <a:defRPr/>
-            </a:pPr>
-            <a:r>
-              <a:rPr lang="zh-CN" sz="2100" b="0" u="none" strike="noStrike">
-                <a:solidFill>
-                  <a:srgbClr val="1F2A24"/>
-                </a:solidFill>
-                <a:latin typeface="Noto Sans JP"/>
-                <a:ea typeface="Noto Sans JP"/>
-              </a:rPr>
-              <a:t>ハイパースケールではなく、説明責任を果たせる規模に。村が所有し、監査し、何をしているかを説明できる規模。排熱は温室や公共施設の暖房に再利用。設計図はオープンライセンスで公開し、他の人口減少自治体でも複製できるようにします。</a:t>
-            </a:r>
-            <a:endParaRPr lang="en-US" sz="2100" b="0" u="none" strike="noStrike">
-              <a:solidFill>
-                <a:srgbClr val="000000"/>
-              </a:solidFill>
-              <a:latin typeface="Arial"/>
-            </a:endParaRPr>
-          </a:p>
-        </p:txBody>
-      </p:sp>
-      <p:sp>
-        <p:nvSpPr>
-          <p:cNvPr id="1658612895" name="Shape 7"/>
+          <p:cNvPr id="2107274469" name="Shape 7"/>
           <p:cNvSpPr/>
           <p:nvPr/>
         </p:nvSpPr>
@@ -16889,7 +16893,7 @@
       </p:sp>
       <p:sp>
         <p:nvSpPr>
-          <p:cNvPr id="9198225" name="Text 8"/>
+          <p:cNvPr id="1511241397" name="Text 8"/>
           <p:cNvSpPr/>
           <p:nvPr/>
         </p:nvSpPr>
@@ -16947,7 +16951,7 @@
       </p:sp>
       <p:sp>
         <p:nvSpPr>
-          <p:cNvPr id="1859320609" name="Text 9"/>
+          <p:cNvPr id="885585109" name="Text 9"/>
           <p:cNvSpPr/>
           <p:nvPr/>
         </p:nvSpPr>
@@ -17005,7 +17009,7 @@
       </p:sp>
       <p:sp>
         <p:nvSpPr>
-          <p:cNvPr id="1278736415" name="Text 10"/>
+          <p:cNvPr id="243308595" name="Text 10"/>
           <p:cNvSpPr/>
           <p:nvPr/>
         </p:nvSpPr>
@@ -17063,7 +17067,7 @@
       </p:sp>
       <p:sp>
         <p:nvSpPr>
-          <p:cNvPr id="1365892601" name="Text 11"/>
+          <p:cNvPr id="22889132" name="Text 11"/>
           <p:cNvSpPr/>
           <p:nvPr/>
         </p:nvSpPr>
@@ -17131,7 +17135,7 @@
       </p:sp>
       <p:sp>
         <p:nvSpPr>
-          <p:cNvPr id="693906034" name="Text 12"/>
+          <p:cNvPr id="1566627860" name="Text 12"/>
           <p:cNvSpPr/>
           <p:nvPr/>
         </p:nvSpPr>
@@ -17189,7 +17193,7 @@
       </p:sp>
       <p:sp>
         <p:nvSpPr>
-          <p:cNvPr id="509347566" name="Text 13"/>
+          <p:cNvPr id="1950995619" name="Text 13"/>
           <p:cNvSpPr/>
           <p:nvPr/>
         </p:nvSpPr>
@@ -17247,7 +17251,7 @@
       </p:sp>
       <p:sp>
         <p:nvSpPr>
-          <p:cNvPr id="771084134" name="Shape 14"/>
+          <p:cNvPr id="871341328" name="Shape 14"/>
           <p:cNvSpPr/>
           <p:nvPr/>
         </p:nvSpPr>
@@ -17294,7 +17298,7 @@
       </p:sp>
       <p:sp>
         <p:nvSpPr>
-          <p:cNvPr id="494849378" name="Text 15"/>
+          <p:cNvPr id="1689388071" name="Text 15"/>
           <p:cNvSpPr/>
           <p:nvPr/>
         </p:nvSpPr>
@@ -17354,7 +17358,7 @@
       </p:sp>
       <p:pic>
         <p:nvPicPr>
-          <p:cNvPr id="922405130" name="Image 0" descr="preencoded.png"/>
+          <p:cNvPr id="424698534" name="Image 0" descr="preencoded.png"/>
           <p:cNvPicPr/>
           <p:nvPr/>
         </p:nvPicPr>
@@ -17378,7 +17382,7 @@
       </p:pic>
       <p:sp>
         <p:nvSpPr>
-          <p:cNvPr id="320546180" name="Text 16"/>
+          <p:cNvPr id="914017339" name="Text 16"/>
           <p:cNvSpPr/>
           <p:nvPr/>
         </p:nvSpPr>
@@ -17436,7 +17440,7 @@
       </p:sp>
       <p:sp>
         <p:nvSpPr>
-          <p:cNvPr id="1213576094" name="Text 17"/>
+          <p:cNvPr id="860260467" name="Text 17"/>
           <p:cNvSpPr/>
           <p:nvPr/>
         </p:nvSpPr>
@@ -17594,7 +17598,7 @@
       </p:grpSpPr>
       <p:sp>
         <p:nvSpPr>
-          <p:cNvPr id="907225975" name="Shape 0"/>
+          <p:cNvPr id="576507102" name="Shape 0"/>
           <p:cNvSpPr/>
           <p:nvPr/>
         </p:nvSpPr>
@@ -17638,7 +17642,7 @@
       </p:sp>
       <p:sp>
         <p:nvSpPr>
-          <p:cNvPr id="572102458" name="Text 1"/>
+          <p:cNvPr id="1915541970" name="Text 1"/>
           <p:cNvSpPr/>
           <p:nvPr/>
         </p:nvSpPr>
@@ -17696,7 +17700,7 @@
       </p:sp>
       <p:sp>
         <p:nvSpPr>
-          <p:cNvPr id="1156941153" name="Text 2"/>
+          <p:cNvPr id="609599192" name="Text 2"/>
           <p:cNvSpPr/>
           <p:nvPr/>
         </p:nvSpPr>
@@ -17756,7 +17760,7 @@
       </p:sp>
       <p:sp>
         <p:nvSpPr>
-          <p:cNvPr id="1252889715" name="Text 3"/>
+          <p:cNvPr id="101138698" name="Text 3"/>
           <p:cNvSpPr/>
           <p:nvPr/>
         </p:nvSpPr>
@@ -17828,7 +17832,7 @@
       </p:sp>
       <p:sp>
         <p:nvSpPr>
-          <p:cNvPr id="441197527" name="Text 4"/>
+          <p:cNvPr id="1878100107" name="Text 4"/>
           <p:cNvSpPr/>
           <p:nvPr/>
         </p:nvSpPr>
@@ -17896,7 +17900,7 @@
       </p:sp>
       <p:sp>
         <p:nvSpPr>
-          <p:cNvPr id="1635514771" name="Text 5"/>
+          <p:cNvPr id="1268904596" name="Text 5"/>
           <p:cNvSpPr/>
           <p:nvPr/>
         </p:nvSpPr>
@@ -17956,7 +17960,7 @@
       </p:sp>
       <p:sp>
         <p:nvSpPr>
-          <p:cNvPr id="1764328356" name="Shape 6"/>
+          <p:cNvPr id="719346191" name="Shape 6"/>
           <p:cNvSpPr/>
           <p:nvPr/>
         </p:nvSpPr>
@@ -18000,7 +18004,7 @@
       </p:sp>
       <p:sp>
         <p:nvSpPr>
-          <p:cNvPr id="1460591417" name="Text 7"/>
+          <p:cNvPr id="1884192920" name="Text 7"/>
           <p:cNvSpPr/>
           <p:nvPr/>
         </p:nvSpPr>
@@ -18060,7 +18064,7 @@
       </p:sp>
       <p:sp>
         <p:nvSpPr>
-          <p:cNvPr id="1811167511" name="Text 8"/>
+          <p:cNvPr id="1057550619" name="Text 8"/>
           <p:cNvSpPr/>
           <p:nvPr/>
         </p:nvSpPr>
@@ -18246,7 +18250,7 @@
       </p:sp>
       <p:sp>
         <p:nvSpPr>
-          <p:cNvPr id="1629306780" name="Shape 9"/>
+          <p:cNvPr id="557885163" name="Shape 9"/>
           <p:cNvSpPr/>
           <p:nvPr/>
         </p:nvSpPr>
@@ -18290,7 +18294,7 @@
       </p:sp>
       <p:sp>
         <p:nvSpPr>
-          <p:cNvPr id="98946355" name="Text 10"/>
+          <p:cNvPr id="804926757" name="Text 10"/>
           <p:cNvSpPr/>
           <p:nvPr/>
         </p:nvSpPr>
@@ -18350,7 +18354,7 @@
       </p:sp>
       <p:sp>
         <p:nvSpPr>
-          <p:cNvPr id="1142512474" name="Text 11"/>
+          <p:cNvPr id="1086110919" name="Text 11"/>
           <p:cNvSpPr/>
           <p:nvPr/>
         </p:nvSpPr>
@@ -18526,7 +18530,7 @@
       </p:sp>
       <p:sp>
         <p:nvSpPr>
-          <p:cNvPr id="136388029" name="Shape 12"/>
+          <p:cNvPr id="144038349" name="Shape 12"/>
           <p:cNvSpPr/>
           <p:nvPr/>
         </p:nvSpPr>
@@ -18570,7 +18574,7 @@
       </p:sp>
       <p:sp>
         <p:nvSpPr>
-          <p:cNvPr id="409338042" name="Text 13"/>
+          <p:cNvPr id="620596687" name="Text 13"/>
           <p:cNvSpPr/>
           <p:nvPr/>
         </p:nvSpPr>
@@ -18630,7 +18634,7 @@
       </p:sp>
       <p:sp>
         <p:nvSpPr>
-          <p:cNvPr id="1325076478" name="Text 14"/>
+          <p:cNvPr id="1226263714" name="Text 14"/>
           <p:cNvSpPr/>
           <p:nvPr/>
         </p:nvSpPr>
@@ -18806,7 +18810,7 @@
       </p:sp>
       <p:sp>
         <p:nvSpPr>
-          <p:cNvPr id="980888862" name="Text 15"/>
+          <p:cNvPr id="1825288368" name="Text 15"/>
           <p:cNvSpPr/>
           <p:nvPr/>
         </p:nvSpPr>
@@ -18866,7 +18870,7 @@
       </p:sp>
       <p:sp>
         <p:nvSpPr>
-          <p:cNvPr id="1410735263" name="Text 16"/>
+          <p:cNvPr id="1740805273" name="Text 16"/>
           <p:cNvSpPr/>
           <p:nvPr/>
         </p:nvSpPr>
@@ -19014,7 +19018,7 @@
       </p:grpSpPr>
       <p:sp>
         <p:nvSpPr>
-          <p:cNvPr id="1582404040" name="Shape 0"/>
+          <p:cNvPr id="1758143046" name="Shape 0"/>
           <p:cNvSpPr/>
           <p:nvPr/>
         </p:nvSpPr>
@@ -19058,7 +19062,7 @@
       </p:sp>
       <p:sp>
         <p:nvSpPr>
-          <p:cNvPr id="1666607059" name="Text 1"/>
+          <p:cNvPr id="2077290380" name="Text 1"/>
           <p:cNvSpPr/>
           <p:nvPr/>
         </p:nvSpPr>
@@ -19116,7 +19120,7 @@
       </p:sp>
       <p:sp>
         <p:nvSpPr>
-          <p:cNvPr id="1980489206" name="Text 2"/>
+          <p:cNvPr id="547814934" name="Text 2"/>
           <p:cNvSpPr/>
           <p:nvPr/>
         </p:nvSpPr>
@@ -19174,7 +19178,7 @@
       </p:sp>
       <p:sp>
         <p:nvSpPr>
-          <p:cNvPr id="2038040653" name="Text 3"/>
+          <p:cNvPr id="1379526926" name="Text 3"/>
           <p:cNvSpPr/>
           <p:nvPr/>
         </p:nvSpPr>
@@ -19282,7 +19286,7 @@
       </p:sp>
       <p:sp>
         <p:nvSpPr>
-          <p:cNvPr id="826763121" name="Text 4"/>
+          <p:cNvPr id="1559642411" name="Text 4"/>
           <p:cNvSpPr/>
           <p:nvPr/>
         </p:nvSpPr>
@@ -19380,7 +19384,7 @@
       </p:sp>
       <p:sp>
         <p:nvSpPr>
-          <p:cNvPr id="1287681068" name="Text 5"/>
+          <p:cNvPr id="1964139600" name="Text 5"/>
           <p:cNvSpPr/>
           <p:nvPr/>
         </p:nvSpPr>
@@ -19458,7 +19462,7 @@
       </p:sp>
       <p:sp>
         <p:nvSpPr>
-          <p:cNvPr id="1583031485" name="Text 6"/>
+          <p:cNvPr id="785425816" name="Text 6"/>
           <p:cNvSpPr/>
           <p:nvPr/>
         </p:nvSpPr>
@@ -19556,7 +19560,7 @@
       </p:sp>
       <p:sp>
         <p:nvSpPr>
-          <p:cNvPr id="1918341467" name="Shape 7"/>
+          <p:cNvPr id="594998918" name="Shape 7"/>
           <p:cNvSpPr/>
           <p:nvPr/>
         </p:nvSpPr>
@@ -19602,7 +19606,7 @@
       </p:sp>
       <p:sp>
         <p:nvSpPr>
-          <p:cNvPr id="1245760708" name="Text 8"/>
+          <p:cNvPr id="1063329633" name="Text 8"/>
           <p:cNvSpPr/>
           <p:nvPr/>
         </p:nvSpPr>
@@ -19660,7 +19664,7 @@
       </p:sp>
       <p:sp>
         <p:nvSpPr>
-          <p:cNvPr id="2049965251" name="Text 9"/>
+          <p:cNvPr id="371148390" name="Text 9"/>
           <p:cNvSpPr/>
           <p:nvPr/>
         </p:nvSpPr>
@@ -19718,7 +19722,7 @@
       </p:sp>
       <p:sp>
         <p:nvSpPr>
-          <p:cNvPr id="1652903205" name="Text 10"/>
+          <p:cNvPr id="1723462849" name="Text 10"/>
           <p:cNvSpPr/>
           <p:nvPr/>
         </p:nvSpPr>
@@ -19796,7 +19800,7 @@
       </p:sp>
       <p:sp>
         <p:nvSpPr>
-          <p:cNvPr id="2001424592" name="Text 11"/>
+          <p:cNvPr id="1960020873" name="Text 11"/>
           <p:cNvSpPr/>
           <p:nvPr/>
         </p:nvSpPr>
@@ -19854,7 +19858,7 @@
       </p:sp>
       <p:sp>
         <p:nvSpPr>
-          <p:cNvPr id="1809685589" name="Text 12"/>
+          <p:cNvPr id="1018719017" name="Text 12"/>
           <p:cNvSpPr/>
           <p:nvPr/>
         </p:nvSpPr>
@@ -19960,7 +19964,7 @@
       </p:sp>
       <p:sp>
         <p:nvSpPr>
-          <p:cNvPr id="1480703846" name="Shape 13"/>
+          <p:cNvPr id="24693780" name="Shape 13"/>
           <p:cNvSpPr/>
           <p:nvPr/>
         </p:nvSpPr>
@@ -20007,7 +20011,7 @@
       </p:sp>
       <p:sp>
         <p:nvSpPr>
-          <p:cNvPr id="869198799" name="Text 14"/>
+          <p:cNvPr id="56391103" name="Text 14"/>
           <p:cNvSpPr/>
           <p:nvPr/>
         </p:nvSpPr>
@@ -20065,7 +20069,7 @@
       </p:sp>
       <p:sp>
         <p:nvSpPr>
-          <p:cNvPr id="695915192" name="Text 15"/>
+          <p:cNvPr id="88658421" name="Text 15"/>
           <p:cNvSpPr/>
           <p:nvPr/>
         </p:nvSpPr>
@@ -20336,7 +20340,7 @@
       </p:sp>
       <p:sp>
         <p:nvSpPr>
-          <p:cNvPr id="1651140794" name="Shape 16"/>
+          <p:cNvPr id="231876704" name="Shape 16"/>
           <p:cNvSpPr/>
           <p:nvPr/>
         </p:nvSpPr>
@@ -20383,7 +20387,7 @@
       </p:sp>
       <p:sp>
         <p:nvSpPr>
-          <p:cNvPr id="1796594786" name="Text 17"/>
+          <p:cNvPr id="1057190693" name="Text 17"/>
           <p:cNvSpPr/>
           <p:nvPr/>
         </p:nvSpPr>
@@ -20441,7 +20445,7 @@
       </p:sp>
       <p:sp>
         <p:nvSpPr>
-          <p:cNvPr id="1741094396" name="Text 18"/>
+          <p:cNvPr id="264466579" name="Text 18"/>
           <p:cNvSpPr/>
           <p:nvPr/>
         </p:nvSpPr>
@@ -20600,7 +20604,7 @@
       </p:sp>
       <p:sp>
         <p:nvSpPr>
-          <p:cNvPr id="869021379" name="Shape 19"/>
+          <p:cNvPr id="1131098155" name="Shape 19"/>
           <p:cNvSpPr/>
           <p:nvPr/>
         </p:nvSpPr>
@@ -20647,7 +20651,7 @@
       </p:sp>
       <p:sp>
         <p:nvSpPr>
-          <p:cNvPr id="74906442" name="Text 20"/>
+          <p:cNvPr id="336462265" name="Text 20"/>
           <p:cNvSpPr/>
           <p:nvPr/>
         </p:nvSpPr>
@@ -20725,7 +20729,7 @@
       </p:sp>
       <p:sp>
         <p:nvSpPr>
-          <p:cNvPr id="220377815" name="Text 21"/>
+          <p:cNvPr id="1523828494" name="Text 21"/>
           <p:cNvSpPr/>
           <p:nvPr/>
         </p:nvSpPr>
@@ -20904,7 +20908,7 @@
       </p:sp>
       <p:sp>
         <p:nvSpPr>
-          <p:cNvPr id="2013945238" name="Text 22"/>
+          <p:cNvPr id="1555567358" name="Text 22"/>
           <p:cNvSpPr/>
           <p:nvPr/>
         </p:nvSpPr>
@@ -20962,7 +20966,7 @@
       </p:sp>
       <p:sp>
         <p:nvSpPr>
-          <p:cNvPr id="1841661214" name="Text 23"/>
+          <p:cNvPr id="1057804698" name="Text 23"/>
           <p:cNvSpPr/>
           <p:nvPr/>
         </p:nvSpPr>
@@ -21100,7 +21104,7 @@
       </p:sp>
       <p:sp>
         <p:nvSpPr>
-          <p:cNvPr id="111827772" name="Text 11"/>
+          <p:cNvPr id="1466648479" name="Text 11"/>
           <p:cNvSpPr/>
           <p:nvPr/>
         </p:nvSpPr>
@@ -21158,7 +21162,7 @@
       </p:sp>
       <p:sp>
         <p:nvSpPr>
-          <p:cNvPr id="85596193" name="Text 12"/>
+          <p:cNvPr id="1181559285" name="Text 12"/>
           <p:cNvSpPr/>
           <p:nvPr/>
         </p:nvSpPr>

</xml_diff>

<commit_message>
docs: restore Option A label in implementation plan, add extra docs and presentations
- Restore accidentally deleted 一般社団法人 heading in mitsue_implementation_plan.md
- Add A3 Gantt Chart PDF, Fututani-san Village Hall photo, and three SEA/PEIA research docs
- Update HEARTBEAT.md (remove stale code fence)
- Update presentation files (JP + PDF)

Co-Authored-By: Claude Sonnet 4.6 <noreply@anthropic.com>
</commit_message>
<xml_diff>
--- a/Mitsue Project Presentation - 日本語.pptx
+++ b/Mitsue Project Presentation - 日本語.pptx
@@ -44,7 +44,7 @@
       </p:grpSpPr>
       <p:sp>
         <p:nvSpPr>
-          <p:cNvPr id="1984016748" name="PlaceHolder 1"/>
+          <p:cNvPr id="294604861" name="PlaceHolder 1"/>
           <p:cNvSpPr>
             <a:spLocks noGrp="1"/>
           </p:cNvSpPr>
@@ -93,7 +93,7 @@
       </p:sp>
       <p:sp>
         <p:nvSpPr>
-          <p:cNvPr id="243059693" name="PlaceHolder 2"/>
+          <p:cNvPr id="564233237" name="PlaceHolder 2"/>
           <p:cNvSpPr>
             <a:spLocks noGrp="1"/>
           </p:cNvSpPr>
@@ -143,7 +143,7 @@
       </p:sp>
       <p:sp>
         <p:nvSpPr>
-          <p:cNvPr id="1557685788" name="PlaceHolder 3"/>
+          <p:cNvPr id="477663182" name="PlaceHolder 3"/>
           <p:cNvSpPr>
             <a:spLocks noGrp="1"/>
           </p:cNvSpPr>
@@ -193,7 +193,7 @@
       </p:sp>
       <p:sp>
         <p:nvSpPr>
-          <p:cNvPr id="1757483935" name="PlaceHolder 4"/>
+          <p:cNvPr id="437754593" name="PlaceHolder 4"/>
           <p:cNvSpPr>
             <a:spLocks noGrp="1"/>
           </p:cNvSpPr>
@@ -254,7 +254,7 @@
       </p:sp>
       <p:sp>
         <p:nvSpPr>
-          <p:cNvPr id="1511882554" name="PlaceHolder 5"/>
+          <p:cNvPr id="99097040" name="PlaceHolder 5"/>
           <p:cNvSpPr>
             <a:spLocks noGrp="1"/>
           </p:cNvSpPr>
@@ -315,7 +315,7 @@
       </p:sp>
       <p:sp>
         <p:nvSpPr>
-          <p:cNvPr id="632998193" name="PlaceHolder 6"/>
+          <p:cNvPr id="11205150" name="PlaceHolder 6"/>
           <p:cNvSpPr>
             <a:spLocks noGrp="1"/>
           </p:cNvSpPr>
@@ -399,7 +399,7 @@
       </p:grpSpPr>
       <p:sp>
         <p:nvSpPr>
-          <p:cNvPr id="1554986029" name="PlaceHolder 1"/>
+          <p:cNvPr id="1644009152" name="PlaceHolder 1"/>
           <p:cNvSpPr>
             <a:spLocks noGrp="1"/>
           </p:cNvSpPr>
@@ -422,7 +422,7 @@
       </p:sp>
       <p:sp>
         <p:nvSpPr>
-          <p:cNvPr id="456348786" name="PlaceHolder 2"/>
+          <p:cNvPr id="1351841254" name="PlaceHolder 2"/>
           <p:cNvSpPr>
             <a:spLocks noGrp="1"/>
           </p:cNvSpPr>
@@ -529,7 +529,7 @@
       </p:sp>
       <p:sp>
         <p:nvSpPr>
-          <p:cNvPr id="2040580538" name="PlaceHolder 3"/>
+          <p:cNvPr id="33546514" name="PlaceHolder 3"/>
           <p:cNvSpPr>
             <a:spLocks noGrp="1"/>
           </p:cNvSpPr>
@@ -623,7 +623,7 @@
       </p:grpSpPr>
       <p:sp>
         <p:nvSpPr>
-          <p:cNvPr id="673343773" name="PlaceHolder 1"/>
+          <p:cNvPr id="518145258" name="PlaceHolder 1"/>
           <p:cNvSpPr>
             <a:spLocks noGrp="1"/>
           </p:cNvSpPr>
@@ -646,7 +646,7 @@
       </p:sp>
       <p:sp>
         <p:nvSpPr>
-          <p:cNvPr id="578370398" name="PlaceHolder 2"/>
+          <p:cNvPr id="84616943" name="PlaceHolder 2"/>
           <p:cNvSpPr>
             <a:spLocks noGrp="1"/>
           </p:cNvSpPr>
@@ -753,7 +753,7 @@
       </p:sp>
       <p:sp>
         <p:nvSpPr>
-          <p:cNvPr id="2136005613" name="PlaceHolder 3"/>
+          <p:cNvPr id="901081253" name="PlaceHolder 3"/>
           <p:cNvSpPr>
             <a:spLocks noGrp="1"/>
           </p:cNvSpPr>
@@ -847,7 +847,7 @@
       </p:grpSpPr>
       <p:sp>
         <p:nvSpPr>
-          <p:cNvPr id="170707273" name="PlaceHolder 1"/>
+          <p:cNvPr id="2000092283" name="PlaceHolder 1"/>
           <p:cNvSpPr>
             <a:spLocks noGrp="1"/>
           </p:cNvSpPr>
@@ -870,7 +870,7 @@
       </p:sp>
       <p:sp>
         <p:nvSpPr>
-          <p:cNvPr id="280938527" name="PlaceHolder 2"/>
+          <p:cNvPr id="1441880656" name="PlaceHolder 2"/>
           <p:cNvSpPr>
             <a:spLocks noGrp="1"/>
           </p:cNvSpPr>
@@ -959,7 +959,7 @@
       </p:sp>
       <p:sp>
         <p:nvSpPr>
-          <p:cNvPr id="1797017230" name="PlaceHolder 3"/>
+          <p:cNvPr id="421292214" name="PlaceHolder 3"/>
           <p:cNvSpPr>
             <a:spLocks noGrp="1"/>
           </p:cNvSpPr>
@@ -1053,7 +1053,7 @@
       </p:grpSpPr>
       <p:sp>
         <p:nvSpPr>
-          <p:cNvPr id="1035022814" name="PlaceHolder 1"/>
+          <p:cNvPr id="1675644118" name="PlaceHolder 1"/>
           <p:cNvSpPr>
             <a:spLocks noGrp="1"/>
           </p:cNvSpPr>
@@ -1076,7 +1076,7 @@
       </p:sp>
       <p:sp>
         <p:nvSpPr>
-          <p:cNvPr id="1947790174" name="PlaceHolder 2"/>
+          <p:cNvPr id="1612828889" name="PlaceHolder 2"/>
           <p:cNvSpPr>
             <a:spLocks noGrp="1"/>
           </p:cNvSpPr>
@@ -1147,7 +1147,7 @@
       </p:sp>
       <p:sp>
         <p:nvSpPr>
-          <p:cNvPr id="1890271484" name="PlaceHolder 3"/>
+          <p:cNvPr id="1142676710" name="PlaceHolder 3"/>
           <p:cNvSpPr>
             <a:spLocks noGrp="1"/>
           </p:cNvSpPr>
@@ -1241,7 +1241,7 @@
       </p:grpSpPr>
       <p:sp>
         <p:nvSpPr>
-          <p:cNvPr id="917833158" name="PlaceHolder 1"/>
+          <p:cNvPr id="456172479" name="PlaceHolder 1"/>
           <p:cNvSpPr>
             <a:spLocks noGrp="1"/>
           </p:cNvSpPr>
@@ -1264,7 +1264,7 @@
       </p:sp>
       <p:sp>
         <p:nvSpPr>
-          <p:cNvPr id="1980219772" name="PlaceHolder 2"/>
+          <p:cNvPr id="1437364269" name="PlaceHolder 2"/>
           <p:cNvSpPr>
             <a:spLocks noGrp="1"/>
           </p:cNvSpPr>
@@ -1353,7 +1353,7 @@
       </p:sp>
       <p:sp>
         <p:nvSpPr>
-          <p:cNvPr id="1720375532" name="PlaceHolder 3"/>
+          <p:cNvPr id="1602422303" name="PlaceHolder 3"/>
           <p:cNvSpPr>
             <a:spLocks noGrp="1"/>
           </p:cNvSpPr>
@@ -1447,7 +1447,7 @@
       </p:grpSpPr>
       <p:sp>
         <p:nvSpPr>
-          <p:cNvPr id="1884438349" name="PlaceHolder 1"/>
+          <p:cNvPr id="322539848" name="PlaceHolder 1"/>
           <p:cNvSpPr>
             <a:spLocks noGrp="1"/>
           </p:cNvSpPr>
@@ -1470,7 +1470,7 @@
       </p:sp>
       <p:sp>
         <p:nvSpPr>
-          <p:cNvPr id="2030860969" name="PlaceHolder 2"/>
+          <p:cNvPr id="1396194268" name="PlaceHolder 2"/>
           <p:cNvSpPr>
             <a:spLocks noGrp="1"/>
           </p:cNvSpPr>
@@ -1559,7 +1559,7 @@
       </p:sp>
       <p:sp>
         <p:nvSpPr>
-          <p:cNvPr id="1206361882" name="PlaceHolder 3"/>
+          <p:cNvPr id="378677349" name="PlaceHolder 3"/>
           <p:cNvSpPr>
             <a:spLocks noGrp="1"/>
           </p:cNvSpPr>
@@ -1653,7 +1653,7 @@
       </p:grpSpPr>
       <p:sp>
         <p:nvSpPr>
-          <p:cNvPr id="1939423540" name="PlaceHolder 1"/>
+          <p:cNvPr id="1739135960" name="PlaceHolder 1"/>
           <p:cNvSpPr>
             <a:spLocks noGrp="1"/>
           </p:cNvSpPr>
@@ -1676,7 +1676,7 @@
       </p:sp>
       <p:sp>
         <p:nvSpPr>
-          <p:cNvPr id="784595610" name="PlaceHolder 2"/>
+          <p:cNvPr id="2060867458" name="PlaceHolder 2"/>
           <p:cNvSpPr>
             <a:spLocks noGrp="1"/>
           </p:cNvSpPr>
@@ -1783,7 +1783,7 @@
       </p:sp>
       <p:sp>
         <p:nvSpPr>
-          <p:cNvPr id="1664553095" name="PlaceHolder 3"/>
+          <p:cNvPr id="970390403" name="PlaceHolder 3"/>
           <p:cNvSpPr>
             <a:spLocks noGrp="1"/>
           </p:cNvSpPr>
@@ -1877,7 +1877,7 @@
       </p:grpSpPr>
       <p:sp>
         <p:nvSpPr>
-          <p:cNvPr id="743013847" name="PlaceHolder 1"/>
+          <p:cNvPr id="1256436520" name="PlaceHolder 1"/>
           <p:cNvSpPr>
             <a:spLocks noGrp="1"/>
           </p:cNvSpPr>
@@ -1900,7 +1900,7 @@
       </p:sp>
       <p:sp>
         <p:nvSpPr>
-          <p:cNvPr id="1022070280" name="PlaceHolder 2"/>
+          <p:cNvPr id="2083170079" name="PlaceHolder 2"/>
           <p:cNvSpPr>
             <a:spLocks noGrp="1"/>
           </p:cNvSpPr>
@@ -1971,7 +1971,7 @@
       </p:sp>
       <p:sp>
         <p:nvSpPr>
-          <p:cNvPr id="2050211378" name="PlaceHolder 3"/>
+          <p:cNvPr id="72588911" name="PlaceHolder 3"/>
           <p:cNvSpPr>
             <a:spLocks noGrp="1"/>
           </p:cNvSpPr>
@@ -2065,7 +2065,7 @@
       </p:grpSpPr>
       <p:sp>
         <p:nvSpPr>
-          <p:cNvPr id="499738986" name="PlaceHolder 1"/>
+          <p:cNvPr id="1502679641" name="PlaceHolder 1"/>
           <p:cNvSpPr>
             <a:spLocks noGrp="1"/>
           </p:cNvSpPr>
@@ -2088,7 +2088,7 @@
       </p:sp>
       <p:sp>
         <p:nvSpPr>
-          <p:cNvPr id="926470640" name="PlaceHolder 2"/>
+          <p:cNvPr id="745449383" name="PlaceHolder 2"/>
           <p:cNvSpPr>
             <a:spLocks noGrp="1"/>
           </p:cNvSpPr>
@@ -2159,7 +2159,7 @@
       </p:sp>
       <p:sp>
         <p:nvSpPr>
-          <p:cNvPr id="1607321736" name="PlaceHolder 3"/>
+          <p:cNvPr id="1755066038" name="PlaceHolder 3"/>
           <p:cNvSpPr>
             <a:spLocks noGrp="1"/>
           </p:cNvSpPr>
@@ -2253,7 +2253,7 @@
       </p:grpSpPr>
       <p:sp>
         <p:nvSpPr>
-          <p:cNvPr id="382480533" name="PlaceHolder 1"/>
+          <p:cNvPr id="1706231782" name="PlaceHolder 1"/>
           <p:cNvSpPr>
             <a:spLocks noGrp="1"/>
           </p:cNvSpPr>
@@ -2276,7 +2276,7 @@
       </p:sp>
       <p:sp>
         <p:nvSpPr>
-          <p:cNvPr id="487546572" name="PlaceHolder 2"/>
+          <p:cNvPr id="1719961001" name="PlaceHolder 2"/>
           <p:cNvSpPr>
             <a:spLocks noGrp="1"/>
           </p:cNvSpPr>
@@ -2347,7 +2347,7 @@
       </p:sp>
       <p:sp>
         <p:nvSpPr>
-          <p:cNvPr id="175632044" name="PlaceHolder 3"/>
+          <p:cNvPr id="111054837" name="PlaceHolder 3"/>
           <p:cNvSpPr>
             <a:spLocks noGrp="1"/>
           </p:cNvSpPr>
@@ -2441,7 +2441,7 @@
       </p:grpSpPr>
       <p:sp>
         <p:nvSpPr>
-          <p:cNvPr id="2019753983" name="PlaceHolder 1"/>
+          <p:cNvPr id="1127562183" name="PlaceHolder 1"/>
           <p:cNvSpPr>
             <a:spLocks noGrp="1"/>
           </p:cNvSpPr>
@@ -2464,7 +2464,7 @@
       </p:sp>
       <p:sp>
         <p:nvSpPr>
-          <p:cNvPr id="761745741" name="PlaceHolder 2"/>
+          <p:cNvPr id="564359513" name="PlaceHolder 2"/>
           <p:cNvSpPr>
             <a:spLocks noGrp="1"/>
           </p:cNvSpPr>
@@ -2589,7 +2589,7 @@
       </p:sp>
       <p:sp>
         <p:nvSpPr>
-          <p:cNvPr id="1255446650" name="PlaceHolder 3"/>
+          <p:cNvPr id="386954311" name="PlaceHolder 3"/>
           <p:cNvSpPr>
             <a:spLocks noGrp="1"/>
           </p:cNvSpPr>
@@ -2715,7 +2715,7 @@
       </p:grpSpPr>
       <p:sp>
         <p:nvSpPr>
-          <p:cNvPr id="1668680052" name="PlaceHolder 1"/>
+          <p:cNvPr id="92704070" name="PlaceHolder 1"/>
           <p:cNvSpPr>
             <a:spLocks noGrp="1"/>
           </p:cNvSpPr>
@@ -2785,7 +2785,7 @@
       </p:sp>
       <p:sp>
         <p:nvSpPr>
-          <p:cNvPr id="567106208" name="PlaceHolder 2"/>
+          <p:cNvPr id="1761809761" name="PlaceHolder 2"/>
           <p:cNvSpPr>
             <a:spLocks noGrp="1"/>
           </p:cNvSpPr>
@@ -3171,7 +3171,7 @@
       </p:grpSpPr>
       <p:sp>
         <p:nvSpPr>
-          <p:cNvPr id="180468769" name="Shape 0"/>
+          <p:cNvPr id="1621578403" name="Shape 0"/>
           <p:cNvSpPr/>
           <p:nvPr/>
         </p:nvSpPr>
@@ -3215,7 +3215,7 @@
       </p:sp>
       <p:sp>
         <p:nvSpPr>
-          <p:cNvPr id="1578858755" name="Text 1"/>
+          <p:cNvPr id="1721350262" name="Text 1"/>
           <p:cNvSpPr/>
           <p:nvPr/>
         </p:nvSpPr>
@@ -3273,7 +3273,7 @@
       </p:sp>
       <p:sp>
         <p:nvSpPr>
-          <p:cNvPr id="2055955169" name="Text 2"/>
+          <p:cNvPr id="1812411050" name="Text 2"/>
           <p:cNvSpPr/>
           <p:nvPr/>
         </p:nvSpPr>
@@ -3331,7 +3331,7 @@
       </p:sp>
       <p:sp>
         <p:nvSpPr>
-          <p:cNvPr id="1209946151" name="Text 3"/>
+          <p:cNvPr id="982168404" name="Text 3"/>
           <p:cNvSpPr/>
           <p:nvPr/>
         </p:nvSpPr>
@@ -3469,7 +3469,7 @@
       </p:sp>
       <p:sp>
         <p:nvSpPr>
-          <p:cNvPr id="494028716" name="Text 4"/>
+          <p:cNvPr id="1089769332" name="Text 4"/>
           <p:cNvSpPr/>
           <p:nvPr/>
         </p:nvSpPr>
@@ -3547,7 +3547,7 @@
       </p:sp>
       <p:sp>
         <p:nvSpPr>
-          <p:cNvPr id="577999181" name="Text 5"/>
+          <p:cNvPr id="339785271" name="Text 5"/>
           <p:cNvSpPr/>
           <p:nvPr/>
         </p:nvSpPr>
@@ -3615,7 +3615,7 @@
       </p:sp>
       <p:sp>
         <p:nvSpPr>
-          <p:cNvPr id="959661343" name="Text 6"/>
+          <p:cNvPr id="1238795058" name="Text 6"/>
           <p:cNvSpPr/>
           <p:nvPr/>
         </p:nvSpPr>
@@ -3673,7 +3673,7 @@
       </p:sp>
       <p:pic>
         <p:nvPicPr>
-          <p:cNvPr id="1762927954" name="Image 0" descr="preencoded.png"/>
+          <p:cNvPr id="115836495" name="Image 0" descr="preencoded.png"/>
           <p:cNvPicPr/>
           <p:nvPr/>
         </p:nvPicPr>
@@ -3697,7 +3697,7 @@
       </p:pic>
       <p:sp>
         <p:nvSpPr>
-          <p:cNvPr id="1117949284" name="Text 7"/>
+          <p:cNvPr id="1171554852" name="Text 7"/>
           <p:cNvSpPr/>
           <p:nvPr/>
         </p:nvSpPr>
@@ -3755,7 +3755,7 @@
       </p:sp>
       <p:sp>
         <p:nvSpPr>
-          <p:cNvPr id="422234812" name="Text 8"/>
+          <p:cNvPr id="896286411" name="Text 8"/>
           <p:cNvSpPr/>
           <p:nvPr/>
         </p:nvSpPr>
@@ -3883,7 +3883,7 @@
       </p:grpSpPr>
       <p:sp>
         <p:nvSpPr>
-          <p:cNvPr id="1185013351" name="Shape 0"/>
+          <p:cNvPr id="1168522280" name="Shape 0"/>
           <p:cNvSpPr/>
           <p:nvPr/>
         </p:nvSpPr>
@@ -3927,7 +3927,7 @@
       </p:sp>
       <p:sp>
         <p:nvSpPr>
-          <p:cNvPr id="1851910007" name="Text 1"/>
+          <p:cNvPr id="1956532926" name="Text 1"/>
           <p:cNvSpPr/>
           <p:nvPr/>
         </p:nvSpPr>
@@ -3985,7 +3985,7 @@
       </p:sp>
       <p:sp>
         <p:nvSpPr>
-          <p:cNvPr id="1899381255" name="Text 2"/>
+          <p:cNvPr id="847783222" name="Text 2"/>
           <p:cNvSpPr/>
           <p:nvPr/>
         </p:nvSpPr>
@@ -4043,7 +4043,7 @@
       </p:sp>
       <p:sp>
         <p:nvSpPr>
-          <p:cNvPr id="867870880" name="Text 3"/>
+          <p:cNvPr id="992690375" name="Text 3"/>
           <p:cNvSpPr/>
           <p:nvPr/>
         </p:nvSpPr>
@@ -4111,7 +4111,7 @@
       </p:sp>
       <p:sp>
         <p:nvSpPr>
-          <p:cNvPr id="1153889480" name="Text 4"/>
+          <p:cNvPr id="930047618" name="Text 4"/>
           <p:cNvSpPr/>
           <p:nvPr/>
         </p:nvSpPr>
@@ -4189,7 +4189,7 @@
       </p:sp>
       <p:sp>
         <p:nvSpPr>
-          <p:cNvPr id="2013467932" name="Text 5"/>
+          <p:cNvPr id="871699349" name="Text 5"/>
           <p:cNvSpPr/>
           <p:nvPr/>
         </p:nvSpPr>
@@ -4247,7 +4247,7 @@
       </p:sp>
       <p:sp>
         <p:nvSpPr>
-          <p:cNvPr id="1806686517" name="Shape 6"/>
+          <p:cNvPr id="269950831" name="Shape 6"/>
           <p:cNvSpPr/>
           <p:nvPr/>
         </p:nvSpPr>
@@ -4294,7 +4294,7 @@
       </p:sp>
       <p:sp>
         <p:nvSpPr>
-          <p:cNvPr id="1674045760" name="Text 7"/>
+          <p:cNvPr id="739628669" name="Text 7"/>
           <p:cNvSpPr/>
           <p:nvPr/>
         </p:nvSpPr>
@@ -4402,7 +4402,7 @@
       </p:sp>
       <p:sp>
         <p:nvSpPr>
-          <p:cNvPr id="534567469" name="Text 8"/>
+          <p:cNvPr id="2120340319" name="Text 8"/>
           <p:cNvSpPr/>
           <p:nvPr/>
         </p:nvSpPr>
@@ -4460,7 +4460,7 @@
       </p:sp>
       <p:sp>
         <p:nvSpPr>
-          <p:cNvPr id="1761464432" name="Text 9"/>
+          <p:cNvPr id="569172326" name="Text 9"/>
           <p:cNvSpPr/>
           <p:nvPr/>
         </p:nvSpPr>
@@ -4568,7 +4568,7 @@
       </p:sp>
       <p:sp>
         <p:nvSpPr>
-          <p:cNvPr id="184452923" name="Shape 10"/>
+          <p:cNvPr id="1452356530" name="Shape 10"/>
           <p:cNvSpPr/>
           <p:nvPr/>
         </p:nvSpPr>
@@ -4615,7 +4615,7 @@
       </p:sp>
       <p:sp>
         <p:nvSpPr>
-          <p:cNvPr id="362364170" name="Text 11"/>
+          <p:cNvPr id="1756266922" name="Text 11"/>
           <p:cNvSpPr/>
           <p:nvPr/>
         </p:nvSpPr>
@@ -4693,7 +4693,7 @@
       </p:sp>
       <p:sp>
         <p:nvSpPr>
-          <p:cNvPr id="1296923714" name="Text 12"/>
+          <p:cNvPr id="1201799498" name="Text 12"/>
           <p:cNvSpPr/>
           <p:nvPr/>
         </p:nvSpPr>
@@ -4751,7 +4751,7 @@
       </p:sp>
       <p:sp>
         <p:nvSpPr>
-          <p:cNvPr id="536484483" name="Text 13"/>
+          <p:cNvPr id="932686163" name="Text 13"/>
           <p:cNvSpPr/>
           <p:nvPr/>
         </p:nvSpPr>
@@ -4849,7 +4849,7 @@
       </p:sp>
       <p:sp>
         <p:nvSpPr>
-          <p:cNvPr id="441293122" name="Shape 14"/>
+          <p:cNvPr id="1702947435" name="Shape 14"/>
           <p:cNvSpPr/>
           <p:nvPr/>
         </p:nvSpPr>
@@ -4896,7 +4896,7 @@
       </p:sp>
       <p:sp>
         <p:nvSpPr>
-          <p:cNvPr id="1652543409" name="Text 15"/>
+          <p:cNvPr id="513126716" name="Text 15"/>
           <p:cNvSpPr/>
           <p:nvPr/>
         </p:nvSpPr>
@@ -4974,7 +4974,7 @@
       </p:sp>
       <p:sp>
         <p:nvSpPr>
-          <p:cNvPr id="808601144" name="Text 16"/>
+          <p:cNvPr id="1416626192" name="Text 16"/>
           <p:cNvSpPr/>
           <p:nvPr/>
         </p:nvSpPr>
@@ -5032,7 +5032,7 @@
       </p:sp>
       <p:sp>
         <p:nvSpPr>
-          <p:cNvPr id="979030967" name="Text 17"/>
+          <p:cNvPr id="1025559051" name="Text 17"/>
           <p:cNvSpPr/>
           <p:nvPr/>
         </p:nvSpPr>
@@ -5130,7 +5130,7 @@
       </p:sp>
       <p:sp>
         <p:nvSpPr>
-          <p:cNvPr id="1986714328" name="Shape 18"/>
+          <p:cNvPr id="1216885097" name="Shape 18"/>
           <p:cNvSpPr/>
           <p:nvPr/>
         </p:nvSpPr>
@@ -5177,7 +5177,7 @@
       </p:sp>
       <p:sp>
         <p:nvSpPr>
-          <p:cNvPr id="1173544945" name="Text 19"/>
+          <p:cNvPr id="2114946139" name="Text 19"/>
           <p:cNvSpPr/>
           <p:nvPr/>
         </p:nvSpPr>
@@ -5255,7 +5255,7 @@
       </p:sp>
       <p:sp>
         <p:nvSpPr>
-          <p:cNvPr id="1071614961" name="Text 20"/>
+          <p:cNvPr id="642712425" name="Text 20"/>
           <p:cNvSpPr/>
           <p:nvPr/>
         </p:nvSpPr>
@@ -5313,7 +5313,7 @@
       </p:sp>
       <p:sp>
         <p:nvSpPr>
-          <p:cNvPr id="781680087" name="Text 21"/>
+          <p:cNvPr id="331462764" name="Text 21"/>
           <p:cNvSpPr/>
           <p:nvPr/>
         </p:nvSpPr>
@@ -5411,7 +5411,7 @@
       </p:sp>
       <p:sp>
         <p:nvSpPr>
-          <p:cNvPr id="1654679972" name="Shape 22"/>
+          <p:cNvPr id="2076120625" name="Shape 22"/>
           <p:cNvSpPr/>
           <p:nvPr/>
         </p:nvSpPr>
@@ -5458,7 +5458,7 @@
       </p:sp>
       <p:sp>
         <p:nvSpPr>
-          <p:cNvPr id="1230001426" name="Text 23"/>
+          <p:cNvPr id="326732685" name="Text 23"/>
           <p:cNvSpPr/>
           <p:nvPr/>
         </p:nvSpPr>
@@ -5536,7 +5536,7 @@
       </p:sp>
       <p:sp>
         <p:nvSpPr>
-          <p:cNvPr id="977668301" name="Text 24"/>
+          <p:cNvPr id="1682596808" name="Text 24"/>
           <p:cNvSpPr/>
           <p:nvPr/>
         </p:nvSpPr>
@@ -5594,7 +5594,7 @@
       </p:sp>
       <p:sp>
         <p:nvSpPr>
-          <p:cNvPr id="669569318" name="Text 25"/>
+          <p:cNvPr id="1689171855" name="Text 25"/>
           <p:cNvSpPr/>
           <p:nvPr/>
         </p:nvSpPr>
@@ -5662,7 +5662,7 @@
       </p:sp>
       <p:sp>
         <p:nvSpPr>
-          <p:cNvPr id="582723230" name="Text 26"/>
+          <p:cNvPr id="448649583" name="Text 26"/>
           <p:cNvSpPr/>
           <p:nvPr/>
         </p:nvSpPr>
@@ -5720,7 +5720,7 @@
       </p:sp>
       <p:sp>
         <p:nvSpPr>
-          <p:cNvPr id="1101145990" name="Text 27"/>
+          <p:cNvPr id="1284850120" name="Text 27"/>
           <p:cNvSpPr/>
           <p:nvPr/>
         </p:nvSpPr>
@@ -5778,7 +5778,7 @@
       </p:sp>
       <p:sp>
         <p:nvSpPr>
-          <p:cNvPr id="824156514" name="Text 28"/>
+          <p:cNvPr id="441838751" name="Text 28"/>
           <p:cNvSpPr/>
           <p:nvPr/>
         </p:nvSpPr>
@@ -5836,7 +5836,7 @@
       </p:sp>
       <p:sp>
         <p:nvSpPr>
-          <p:cNvPr id="450233577" name="Text 29"/>
+          <p:cNvPr id="1024005534" name="Text 29"/>
           <p:cNvSpPr/>
           <p:nvPr/>
         </p:nvSpPr>
@@ -5904,7 +5904,7 @@
       </p:sp>
       <p:sp>
         <p:nvSpPr>
-          <p:cNvPr id="1857653523" name="Text 30"/>
+          <p:cNvPr id="1455515365" name="Text 30"/>
           <p:cNvSpPr/>
           <p:nvPr/>
         </p:nvSpPr>
@@ -5992,7 +5992,7 @@
       </p:sp>
       <p:sp>
         <p:nvSpPr>
-          <p:cNvPr id="1378467758" name="Shape 31"/>
+          <p:cNvPr id="739741437" name="Shape 31"/>
           <p:cNvSpPr/>
           <p:nvPr/>
         </p:nvSpPr>
@@ -6036,7 +6036,7 @@
       </p:sp>
       <p:sp>
         <p:nvSpPr>
-          <p:cNvPr id="797772166" name="Text 32"/>
+          <p:cNvPr id="1731245722" name="Text 32"/>
           <p:cNvSpPr/>
           <p:nvPr/>
         </p:nvSpPr>
@@ -6094,7 +6094,7 @@
       </p:sp>
       <p:sp>
         <p:nvSpPr>
-          <p:cNvPr id="859510481" name="Text 33"/>
+          <p:cNvPr id="1750879334" name="Text 33"/>
           <p:cNvSpPr/>
           <p:nvPr/>
         </p:nvSpPr>
@@ -6152,7 +6152,7 @@
       </p:sp>
       <p:sp>
         <p:nvSpPr>
-          <p:cNvPr id="877994061" name="Text 34"/>
+          <p:cNvPr id="1736926084" name="Text 34"/>
           <p:cNvSpPr/>
           <p:nvPr/>
         </p:nvSpPr>
@@ -6220,7 +6220,7 @@
       </p:sp>
       <p:sp>
         <p:nvSpPr>
-          <p:cNvPr id="518527857" name="Text 35"/>
+          <p:cNvPr id="973696983" name="Text 35"/>
           <p:cNvSpPr/>
           <p:nvPr/>
         </p:nvSpPr>
@@ -6288,7 +6288,7 @@
       </p:sp>
       <p:sp>
         <p:nvSpPr>
-          <p:cNvPr id="1601131354" name="Shape 36"/>
+          <p:cNvPr id="110159385" name="Shape 36"/>
           <p:cNvSpPr/>
           <p:nvPr/>
         </p:nvSpPr>
@@ -6334,7 +6334,7 @@
       </p:sp>
       <p:sp>
         <p:nvSpPr>
-          <p:cNvPr id="26245991" name="Text 37"/>
+          <p:cNvPr id="1379994335" name="Text 37"/>
           <p:cNvSpPr/>
           <p:nvPr/>
         </p:nvSpPr>
@@ -6392,7 +6392,7 @@
       </p:sp>
       <p:sp>
         <p:nvSpPr>
-          <p:cNvPr id="1065509177" name="Text 38"/>
+          <p:cNvPr id="901924047" name="Text 38"/>
           <p:cNvSpPr/>
           <p:nvPr/>
         </p:nvSpPr>
@@ -6450,7 +6450,7 @@
       </p:sp>
       <p:sp>
         <p:nvSpPr>
-          <p:cNvPr id="1802967265" name="Text 39"/>
+          <p:cNvPr id="1388925597" name="Text 39"/>
           <p:cNvSpPr/>
           <p:nvPr/>
         </p:nvSpPr>
@@ -6508,7 +6508,7 @@
       </p:sp>
       <p:sp>
         <p:nvSpPr>
-          <p:cNvPr id="865381162" name="Text 40"/>
+          <p:cNvPr id="1350152330" name="Text 40"/>
           <p:cNvSpPr/>
           <p:nvPr/>
         </p:nvSpPr>
@@ -6566,7 +6566,7 @@
       </p:sp>
       <p:sp>
         <p:nvSpPr>
-          <p:cNvPr id="69135626" name="Shape 41"/>
+          <p:cNvPr id="1855788583" name="Shape 41"/>
           <p:cNvSpPr/>
           <p:nvPr/>
         </p:nvSpPr>
@@ -6612,7 +6612,7 @@
       </p:sp>
       <p:sp>
         <p:nvSpPr>
-          <p:cNvPr id="505197927" name="Text 42"/>
+          <p:cNvPr id="178675538" name="Text 42"/>
           <p:cNvSpPr/>
           <p:nvPr/>
         </p:nvSpPr>
@@ -6670,7 +6670,7 @@
       </p:sp>
       <p:sp>
         <p:nvSpPr>
-          <p:cNvPr id="1311654165" name="Text 43"/>
+          <p:cNvPr id="903588724" name="Text 43"/>
           <p:cNvSpPr/>
           <p:nvPr/>
         </p:nvSpPr>
@@ -6728,7 +6728,7 @@
       </p:sp>
       <p:sp>
         <p:nvSpPr>
-          <p:cNvPr id="1587564302" name="Text 44"/>
+          <p:cNvPr id="763527347" name="Text 44"/>
           <p:cNvSpPr/>
           <p:nvPr/>
         </p:nvSpPr>
@@ -6786,7 +6786,7 @@
       </p:sp>
       <p:sp>
         <p:nvSpPr>
-          <p:cNvPr id="1221098830" name="Text 45"/>
+          <p:cNvPr id="985522155" name="Text 45"/>
           <p:cNvSpPr/>
           <p:nvPr/>
         </p:nvSpPr>
@@ -6844,7 +6844,7 @@
       </p:sp>
       <p:sp>
         <p:nvSpPr>
-          <p:cNvPr id="1824423458" name="Shape 46"/>
+          <p:cNvPr id="839946929" name="Shape 46"/>
           <p:cNvSpPr/>
           <p:nvPr/>
         </p:nvSpPr>
@@ -6890,7 +6890,7 @@
       </p:sp>
       <p:sp>
         <p:nvSpPr>
-          <p:cNvPr id="1432050020" name="Text 47"/>
+          <p:cNvPr id="1016362202" name="Text 47"/>
           <p:cNvSpPr/>
           <p:nvPr/>
         </p:nvSpPr>
@@ -6948,7 +6948,7 @@
       </p:sp>
       <p:sp>
         <p:nvSpPr>
-          <p:cNvPr id="82765174" name="Text 48"/>
+          <p:cNvPr id="1799256594" name="Text 48"/>
           <p:cNvSpPr/>
           <p:nvPr/>
         </p:nvSpPr>
@@ -7006,7 +7006,7 @@
       </p:sp>
       <p:sp>
         <p:nvSpPr>
-          <p:cNvPr id="468307804" name="Text 49"/>
+          <p:cNvPr id="1208826639" name="Text 49"/>
           <p:cNvSpPr/>
           <p:nvPr/>
         </p:nvSpPr>
@@ -7064,7 +7064,7 @@
       </p:sp>
       <p:sp>
         <p:nvSpPr>
-          <p:cNvPr id="368082271" name="Text 50"/>
+          <p:cNvPr id="515625587" name="Text 50"/>
           <p:cNvSpPr/>
           <p:nvPr/>
         </p:nvSpPr>
@@ -7122,7 +7122,7 @@
       </p:sp>
       <p:sp>
         <p:nvSpPr>
-          <p:cNvPr id="1954503106" name="Shape 51"/>
+          <p:cNvPr id="978389807" name="Shape 51"/>
           <p:cNvSpPr/>
           <p:nvPr/>
         </p:nvSpPr>
@@ -7168,7 +7168,7 @@
       </p:sp>
       <p:sp>
         <p:nvSpPr>
-          <p:cNvPr id="1347963579" name="Text 52"/>
+          <p:cNvPr id="685024993" name="Text 52"/>
           <p:cNvSpPr/>
           <p:nvPr/>
         </p:nvSpPr>
@@ -7226,7 +7226,7 @@
       </p:sp>
       <p:sp>
         <p:nvSpPr>
-          <p:cNvPr id="1685112853" name="Text 53"/>
+          <p:cNvPr id="2018820869" name="Text 53"/>
           <p:cNvSpPr/>
           <p:nvPr/>
         </p:nvSpPr>
@@ -7284,7 +7284,7 @@
       </p:sp>
       <p:sp>
         <p:nvSpPr>
-          <p:cNvPr id="1097430547" name="Text 54"/>
+          <p:cNvPr id="922336134" name="Text 54"/>
           <p:cNvSpPr/>
           <p:nvPr/>
         </p:nvSpPr>
@@ -7342,7 +7342,7 @@
       </p:sp>
       <p:sp>
         <p:nvSpPr>
-          <p:cNvPr id="567800838" name="Text 55"/>
+          <p:cNvPr id="998811619" name="Text 55"/>
           <p:cNvSpPr/>
           <p:nvPr/>
         </p:nvSpPr>
@@ -7400,7 +7400,7 @@
       </p:sp>
       <p:sp>
         <p:nvSpPr>
-          <p:cNvPr id="2051952188" name="Shape 56"/>
+          <p:cNvPr id="54790400" name="Shape 56"/>
           <p:cNvSpPr/>
           <p:nvPr/>
         </p:nvSpPr>
@@ -7446,7 +7446,7 @@
       </p:sp>
       <p:sp>
         <p:nvSpPr>
-          <p:cNvPr id="1270960934" name="Text 57"/>
+          <p:cNvPr id="1713836872" name="Text 57"/>
           <p:cNvSpPr/>
           <p:nvPr/>
         </p:nvSpPr>
@@ -7504,7 +7504,7 @@
       </p:sp>
       <p:sp>
         <p:nvSpPr>
-          <p:cNvPr id="1904521594" name="Text 58"/>
+          <p:cNvPr id="341303249" name="Text 58"/>
           <p:cNvSpPr/>
           <p:nvPr/>
         </p:nvSpPr>
@@ -7562,7 +7562,7 @@
       </p:sp>
       <p:sp>
         <p:nvSpPr>
-          <p:cNvPr id="1732031448" name="Text 59"/>
+          <p:cNvPr id="1762383823" name="Text 59"/>
           <p:cNvSpPr/>
           <p:nvPr/>
         </p:nvSpPr>
@@ -7620,7 +7620,7 @@
       </p:sp>
       <p:sp>
         <p:nvSpPr>
-          <p:cNvPr id="396652228" name="Text 60"/>
+          <p:cNvPr id="181491160" name="Text 60"/>
           <p:cNvSpPr/>
           <p:nvPr/>
         </p:nvSpPr>
@@ -7678,7 +7678,7 @@
       </p:sp>
       <p:sp>
         <p:nvSpPr>
-          <p:cNvPr id="670530255" name="Text 61"/>
+          <p:cNvPr id="1852344475" name="Text 61"/>
           <p:cNvSpPr/>
           <p:nvPr/>
         </p:nvSpPr>
@@ -7736,7 +7736,7 @@
       </p:sp>
       <p:sp>
         <p:nvSpPr>
-          <p:cNvPr id="1828981111" name="Text 62"/>
+          <p:cNvPr id="784009581" name="Text 62"/>
           <p:cNvSpPr/>
           <p:nvPr/>
         </p:nvSpPr>
@@ -7794,7 +7794,7 @@
       </p:sp>
       <p:sp>
         <p:nvSpPr>
-          <p:cNvPr id="1917590070" name="Text 63"/>
+          <p:cNvPr id="41677004" name="Text 63"/>
           <p:cNvSpPr/>
           <p:nvPr/>
         </p:nvSpPr>
@@ -7852,7 +7852,7 @@
       </p:sp>
       <p:sp>
         <p:nvSpPr>
-          <p:cNvPr id="234721288" name="Text 64"/>
+          <p:cNvPr id="1893354768" name="Text 64"/>
           <p:cNvSpPr/>
           <p:nvPr/>
         </p:nvSpPr>
@@ -7910,7 +7910,7 @@
       </p:sp>
       <p:sp>
         <p:nvSpPr>
-          <p:cNvPr id="1984801389" name="Text 65"/>
+          <p:cNvPr id="1145831762" name="Text 65"/>
           <p:cNvSpPr/>
           <p:nvPr/>
         </p:nvSpPr>
@@ -7968,7 +7968,7 @@
       </p:sp>
       <p:sp>
         <p:nvSpPr>
-          <p:cNvPr id="238222921" name="Text 66"/>
+          <p:cNvPr id="1449669377" name="Text 66"/>
           <p:cNvSpPr/>
           <p:nvPr/>
         </p:nvSpPr>
@@ -8036,7 +8036,7 @@
       </p:sp>
       <p:sp>
         <p:nvSpPr>
-          <p:cNvPr id="744578612" name="Text 67"/>
+          <p:cNvPr id="413677408" name="Text 67"/>
           <p:cNvSpPr/>
           <p:nvPr/>
         </p:nvSpPr>
@@ -8104,7 +8104,7 @@
       </p:sp>
       <p:sp>
         <p:nvSpPr>
-          <p:cNvPr id="1252689118" name="Text 68"/>
+          <p:cNvPr id="631411145" name="Text 68"/>
           <p:cNvSpPr/>
           <p:nvPr/>
         </p:nvSpPr>
@@ -8172,7 +8172,7 @@
       </p:sp>
       <p:sp>
         <p:nvSpPr>
-          <p:cNvPr id="857552825" name="Text 69"/>
+          <p:cNvPr id="960034234" name="Text 69"/>
           <p:cNvSpPr/>
           <p:nvPr/>
         </p:nvSpPr>
@@ -8240,7 +8240,7 @@
       </p:sp>
       <p:sp>
         <p:nvSpPr>
-          <p:cNvPr id="1286620205" name="Text 70"/>
+          <p:cNvPr id="1070260513" name="Text 70"/>
           <p:cNvSpPr/>
           <p:nvPr/>
         </p:nvSpPr>
@@ -8308,7 +8308,7 @@
       </p:sp>
       <p:sp>
         <p:nvSpPr>
-          <p:cNvPr id="1295364420" name="Text 71"/>
+          <p:cNvPr id="1957294692" name="Text 71"/>
           <p:cNvSpPr/>
           <p:nvPr/>
         </p:nvSpPr>
@@ -8376,7 +8376,7 @@
       </p:sp>
       <p:sp>
         <p:nvSpPr>
-          <p:cNvPr id="1041594252" name="Text 72"/>
+          <p:cNvPr id="1289630489" name="Text 72"/>
           <p:cNvSpPr/>
           <p:nvPr/>
         </p:nvSpPr>
@@ -8434,7 +8434,7 @@
       </p:sp>
       <p:sp>
         <p:nvSpPr>
-          <p:cNvPr id="227403528" name="Text 73"/>
+          <p:cNvPr id="745567176" name="Text 73"/>
           <p:cNvSpPr/>
           <p:nvPr/>
         </p:nvSpPr>
@@ -8562,7 +8562,7 @@
       </p:grpSpPr>
       <p:sp>
         <p:nvSpPr>
-          <p:cNvPr id="1363361727" name="Shape 0"/>
+          <p:cNvPr id="1485813197" name="Shape 0"/>
           <p:cNvSpPr/>
           <p:nvPr/>
         </p:nvSpPr>
@@ -8606,7 +8606,7 @@
       </p:sp>
       <p:sp>
         <p:nvSpPr>
-          <p:cNvPr id="1804561236" name="Text 1"/>
+          <p:cNvPr id="126183597" name="Text 1"/>
           <p:cNvSpPr/>
           <p:nvPr/>
         </p:nvSpPr>
@@ -8664,7 +8664,7 @@
       </p:sp>
       <p:sp>
         <p:nvSpPr>
-          <p:cNvPr id="2093606075" name="Text 2"/>
+          <p:cNvPr id="491116623" name="Text 2"/>
           <p:cNvSpPr/>
           <p:nvPr/>
         </p:nvSpPr>
@@ -8724,7 +8724,7 @@
       </p:sp>
       <p:sp>
         <p:nvSpPr>
-          <p:cNvPr id="1875839617" name="Text 3"/>
+          <p:cNvPr id="2038090585" name="Text 3"/>
           <p:cNvSpPr/>
           <p:nvPr/>
         </p:nvSpPr>
@@ -8796,7 +8796,7 @@
       </p:sp>
       <p:sp>
         <p:nvSpPr>
-          <p:cNvPr id="956143411" name="Text 4"/>
+          <p:cNvPr id="859157660" name="Text 4"/>
           <p:cNvSpPr/>
           <p:nvPr/>
         </p:nvSpPr>
@@ -8856,7 +8856,7 @@
       </p:sp>
       <p:sp>
         <p:nvSpPr>
-          <p:cNvPr id="2056113774" name="Text 5"/>
+          <p:cNvPr id="1712679557" name="Text 5"/>
           <p:cNvSpPr/>
           <p:nvPr/>
         </p:nvSpPr>
@@ -8924,7 +8924,7 @@
       </p:sp>
       <p:sp>
         <p:nvSpPr>
-          <p:cNvPr id="1020169287" name="Text 6"/>
+          <p:cNvPr id="1882789491" name="Text 6"/>
           <p:cNvSpPr/>
           <p:nvPr/>
         </p:nvSpPr>
@@ -8984,7 +8984,7 @@
       </p:sp>
       <p:sp>
         <p:nvSpPr>
-          <p:cNvPr id="2058981427" name="Text 7"/>
+          <p:cNvPr id="1046136931" name="Text 7"/>
           <p:cNvSpPr/>
           <p:nvPr/>
         </p:nvSpPr>
@@ -9193,7 +9193,7 @@
       </p:sp>
       <p:sp>
         <p:nvSpPr>
-          <p:cNvPr id="140279313" name="Shape 8"/>
+          <p:cNvPr id="763766825" name="Shape 8"/>
           <p:cNvSpPr/>
           <p:nvPr/>
         </p:nvSpPr>
@@ -9239,7 +9239,7 @@
       </p:sp>
       <p:sp>
         <p:nvSpPr>
-          <p:cNvPr id="424909196" name="Shape 9"/>
+          <p:cNvPr id="122209668" name="Shape 9"/>
           <p:cNvSpPr/>
           <p:nvPr/>
         </p:nvSpPr>
@@ -9283,7 +9283,7 @@
       </p:sp>
       <p:pic>
         <p:nvPicPr>
-          <p:cNvPr id="186279102" name="Image 0" descr="preencoded.png"/>
+          <p:cNvPr id="1086079359" name="Image 0" descr="preencoded.png"/>
           <p:cNvPicPr/>
           <p:nvPr/>
         </p:nvPicPr>
@@ -9307,7 +9307,7 @@
       </p:pic>
       <p:sp>
         <p:nvSpPr>
-          <p:cNvPr id="345375620" name="Text 10"/>
+          <p:cNvPr id="502199151" name="Text 10"/>
           <p:cNvSpPr/>
           <p:nvPr/>
         </p:nvSpPr>
@@ -9379,7 +9379,7 @@
       </p:sp>
       <p:sp>
         <p:nvSpPr>
-          <p:cNvPr id="1310707761" name="Text 11"/>
+          <p:cNvPr id="1871879999" name="Text 11"/>
           <p:cNvSpPr/>
           <p:nvPr/>
         </p:nvSpPr>
@@ -9437,7 +9437,7 @@
       </p:sp>
       <p:sp>
         <p:nvSpPr>
-          <p:cNvPr id="270990650" name="Text 12"/>
+          <p:cNvPr id="1344086185" name="Text 12"/>
           <p:cNvSpPr/>
           <p:nvPr/>
         </p:nvSpPr>
@@ -9497,7 +9497,7 @@
       </p:sp>
       <p:sp>
         <p:nvSpPr>
-          <p:cNvPr id="1960314238" name="Text 13"/>
+          <p:cNvPr id="234159831" name="Text 13"/>
           <p:cNvSpPr/>
           <p:nvPr/>
         </p:nvSpPr>
@@ -9557,7 +9557,7 @@
       </p:sp>
       <p:sp>
         <p:nvSpPr>
-          <p:cNvPr id="695265078" name="Shape 14"/>
+          <p:cNvPr id="1254156152" name="Shape 14"/>
           <p:cNvSpPr/>
           <p:nvPr/>
         </p:nvSpPr>
@@ -9603,7 +9603,7 @@
       </p:sp>
       <p:sp>
         <p:nvSpPr>
-          <p:cNvPr id="988702377" name="Text 15"/>
+          <p:cNvPr id="722196524" name="Text 15"/>
           <p:cNvSpPr/>
           <p:nvPr/>
         </p:nvSpPr>
@@ -9663,7 +9663,7 @@
       </p:sp>
       <p:sp>
         <p:nvSpPr>
-          <p:cNvPr id="1047279317" name="Text 16"/>
+          <p:cNvPr id="1711504522" name="Text 16"/>
           <p:cNvSpPr/>
           <p:nvPr/>
         </p:nvSpPr>
@@ -9721,7 +9721,7 @@
       </p:sp>
       <p:sp>
         <p:nvSpPr>
-          <p:cNvPr id="61226153" name="Text 17"/>
+          <p:cNvPr id="1233636420" name="Text 17"/>
           <p:cNvSpPr/>
           <p:nvPr/>
         </p:nvSpPr>
@@ -9793,7 +9793,7 @@
       </p:sp>
       <p:sp>
         <p:nvSpPr>
-          <p:cNvPr id="387965395" name="Text 18"/>
+          <p:cNvPr id="189316891" name="Text 18"/>
           <p:cNvSpPr/>
           <p:nvPr/>
         </p:nvSpPr>
@@ -9853,7 +9853,7 @@
       </p:sp>
       <p:sp>
         <p:nvSpPr>
-          <p:cNvPr id="442094370" name="Text 19"/>
+          <p:cNvPr id="1627025328" name="Text 19"/>
           <p:cNvSpPr/>
           <p:nvPr/>
         </p:nvSpPr>
@@ -9965,7 +9965,7 @@
       </p:grpSpPr>
       <p:sp>
         <p:nvSpPr>
-          <p:cNvPr id="801055863" name="Shape 0"/>
+          <p:cNvPr id="1827540468" name="Shape 0"/>
           <p:cNvSpPr/>
           <p:nvPr/>
         </p:nvSpPr>
@@ -10009,7 +10009,7 @@
       </p:sp>
       <p:sp>
         <p:nvSpPr>
-          <p:cNvPr id="308361682" name="Text 1"/>
+          <p:cNvPr id="1740670500" name="Text 1"/>
           <p:cNvSpPr/>
           <p:nvPr/>
         </p:nvSpPr>
@@ -10067,7 +10067,7 @@
       </p:sp>
       <p:sp>
         <p:nvSpPr>
-          <p:cNvPr id="297969335" name="Text 2"/>
+          <p:cNvPr id="433017871" name="Text 2"/>
           <p:cNvSpPr/>
           <p:nvPr/>
         </p:nvSpPr>
@@ -10125,7 +10125,7 @@
       </p:sp>
       <p:sp>
         <p:nvSpPr>
-          <p:cNvPr id="2010151477" name="Text 3"/>
+          <p:cNvPr id="326968851" name="Text 3"/>
           <p:cNvSpPr/>
           <p:nvPr/>
         </p:nvSpPr>
@@ -10193,7 +10193,7 @@
       </p:sp>
       <p:sp>
         <p:nvSpPr>
-          <p:cNvPr id="244169868" name="Text 4"/>
+          <p:cNvPr id="700605793" name="Text 4"/>
           <p:cNvSpPr/>
           <p:nvPr/>
         </p:nvSpPr>
@@ -10271,7 +10271,7 @@
       </p:sp>
       <p:sp>
         <p:nvSpPr>
-          <p:cNvPr id="788411843" name="Text 5"/>
+          <p:cNvPr id="583191558" name="Text 5"/>
           <p:cNvSpPr/>
           <p:nvPr/>
         </p:nvSpPr>
@@ -10295,102 +10295,102 @@
           <a:fontRef idx="minor"/>
         </p:style>
         <p:txBody>
+          <a:bodyPr vertOverflow="overflow" horzOverflow="overflow" vert="horz" wrap="square" lIns="25560" tIns="25560" rIns="25560" bIns="25560" numCol="1" spcCol="0" rtlCol="0" fromWordArt="0" anchor="t" anchorCtr="0" forceAA="0" upright="0" compatLnSpc="0">
+            <a:normAutofit fontScale="50000" lnSpcReduction="10000"/>
+          </a:bodyPr>
+          <a:p>
+            <a:pPr defTabSz="914400">
+              <a:lnSpc>
+                <a:spcPct val="117000"/>
+              </a:lnSpc>
+              <a:tabLst>
+                <a:tab pos="0" algn="l"/>
+              </a:tabLst>
+              <a:defRPr/>
+            </a:pPr>
+            <a:r>
+              <a:rPr lang="zh-CN" sz="11000" b="1" u="none" strike="noStrike" spc="-28">
+                <a:solidFill>
+                  <a:srgbClr val="1F2A24"/>
+                </a:solidFill>
+                <a:latin typeface="Noto Serif JP"/>
+                <a:ea typeface="Noto Serif JP"/>
+              </a:rPr>
+              <a:t>空き校舎がひとつ。 </a:t>
+            </a:r>
+            <a:r>
+              <a:rPr lang="zh-CN" sz="11000" b="1" u="none" strike="noStrike" spc="-28">
+                <a:solidFill>
+                  <a:srgbClr val="C4663A"/>
+                </a:solidFill>
+                <a:latin typeface="Noto Serif JP"/>
+                <a:ea typeface="Noto Serif JP"/>
+              </a:rPr>
+              <a:t>疲れた森林がひとつ。 </a:t>
+            </a:r>
+            <a:r>
+              <a:rPr lang="zh-CN" sz="11000" b="1" u="none" strike="noStrike" spc="-28">
+                <a:solidFill>
+                  <a:srgbClr val="1F2A24"/>
+                </a:solidFill>
+                <a:latin typeface="Noto Serif JP"/>
+                <a:ea typeface="Noto Serif JP"/>
+              </a:rPr>
+              <a:t>短いアイデアのリストがひとつ。</a:t>
+            </a:r>
+            <a:endParaRPr lang="en-US" sz="5850" b="0" u="none" strike="noStrike">
+              <a:solidFill>
+                <a:srgbClr val="000000"/>
+              </a:solidFill>
+              <a:latin typeface="Arial"/>
+            </a:endParaRPr>
+          </a:p>
+        </p:txBody>
+      </p:sp>
+      <p:sp>
+        <p:nvSpPr>
+          <p:cNvPr id="1068698757" name="Text 6"/>
+          <p:cNvSpPr/>
+          <p:nvPr/>
+        </p:nvSpPr>
+        <p:spPr bwMode="auto">
+          <a:xfrm>
+            <a:off x="1047600" y="6284880"/>
+            <a:ext cx="7009920" cy="1797840"/>
+          </a:xfrm>
+          <a:prstGeom prst="rect">
+            <a:avLst/>
+          </a:prstGeom>
+          <a:noFill/>
+          <a:ln w="0">
+            <a:noFill/>
+          </a:ln>
+        </p:spPr>
+        <p:style>
+          <a:lnRef idx="0"/>
+          <a:fillRef idx="0"/>
+          <a:effectRef idx="0"/>
+          <a:fontRef idx="minor"/>
+        </p:style>
+        <p:txBody>
           <a:bodyPr lIns="25560" tIns="25560" rIns="25560" bIns="25560" anchor="t">
             <a:normAutofit/>
           </a:bodyPr>
           <a:p>
             <a:pPr defTabSz="914400">
               <a:lnSpc>
-                <a:spcPct val="117000"/>
-              </a:lnSpc>
-              <a:tabLst>
-                <a:tab pos="0" algn="l"/>
-              </a:tabLst>
-              <a:defRPr/>
-            </a:pPr>
-            <a:r>
-              <a:rPr lang="zh-CN" sz="5850" b="1" u="none" strike="noStrike" spc="-28">
+                <a:spcPct val="165000"/>
+              </a:lnSpc>
+              <a:tabLst>
+                <a:tab pos="0" algn="l"/>
+              </a:tabLst>
+              <a:defRPr/>
+            </a:pPr>
+            <a:r>
+              <a:rPr lang="zh-CN" sz="2100" b="0" u="none" strike="noStrike">
                 <a:solidFill>
                   <a:srgbClr val="1F2A24"/>
                 </a:solidFill>
-                <a:latin typeface="Noto Serif JP"/>
-                <a:ea typeface="Noto Serif JP"/>
-              </a:rPr>
-              <a:t>空き校舎がひとつ。 </a:t>
-            </a:r>
-            <a:r>
-              <a:rPr lang="zh-CN" sz="5850" b="1" u="none" strike="noStrike" spc="-28">
-                <a:solidFill>
-                  <a:srgbClr val="C4663A"/>
-                </a:solidFill>
-                <a:latin typeface="Noto Serif JP"/>
-                <a:ea typeface="Noto Serif JP"/>
-              </a:rPr>
-              <a:t>疲れた森林がひとつ。 </a:t>
-            </a:r>
-            <a:r>
-              <a:rPr lang="zh-CN" sz="5850" b="1" u="none" strike="noStrike" spc="-28">
-                <a:solidFill>
-                  <a:srgbClr val="1F2A24"/>
-                </a:solidFill>
-                <a:latin typeface="Noto Serif JP"/>
-                <a:ea typeface="Noto Serif JP"/>
-              </a:rPr>
-              <a:t>短いアイデアのリストがひとつ。</a:t>
-            </a:r>
-            <a:endParaRPr lang="en-US" sz="5850" b="0" u="none" strike="noStrike">
-              <a:solidFill>
-                <a:srgbClr val="000000"/>
-              </a:solidFill>
-              <a:latin typeface="Arial"/>
-            </a:endParaRPr>
-          </a:p>
-        </p:txBody>
-      </p:sp>
-      <p:sp>
-        <p:nvSpPr>
-          <p:cNvPr id="775914539" name="Text 6"/>
-          <p:cNvSpPr/>
-          <p:nvPr/>
-        </p:nvSpPr>
-        <p:spPr bwMode="auto">
-          <a:xfrm>
-            <a:off x="1047600" y="6284880"/>
-            <a:ext cx="7009920" cy="1797840"/>
-          </a:xfrm>
-          <a:prstGeom prst="rect">
-            <a:avLst/>
-          </a:prstGeom>
-          <a:noFill/>
-          <a:ln w="0">
-            <a:noFill/>
-          </a:ln>
-        </p:spPr>
-        <p:style>
-          <a:lnRef idx="0"/>
-          <a:fillRef idx="0"/>
-          <a:effectRef idx="0"/>
-          <a:fontRef idx="minor"/>
-        </p:style>
-        <p:txBody>
-          <a:bodyPr lIns="25560" tIns="25560" rIns="25560" bIns="25560" anchor="t">
-            <a:normAutofit/>
-          </a:bodyPr>
-          <a:p>
-            <a:pPr defTabSz="914400">
-              <a:lnSpc>
-                <a:spcPct val="165000"/>
-              </a:lnSpc>
-              <a:tabLst>
-                <a:tab pos="0" algn="l"/>
-              </a:tabLst>
-              <a:defRPr/>
-            </a:pPr>
-            <a:r>
-              <a:rPr lang="zh-CN" sz="2100" b="0" u="none" strike="noStrike">
-                <a:solidFill>
-                  <a:srgbClr val="1F2A24"/>
-                </a:solidFill>
                 <a:latin typeface="Noto Sans JP"/>
                 <a:ea typeface="Noto Sans JP"/>
               </a:rPr>
@@ -10407,7 +10407,7 @@
       </p:sp>
       <p:sp>
         <p:nvSpPr>
-          <p:cNvPr id="1653163411" name="Text 7"/>
+          <p:cNvPr id="639770386" name="Text 7"/>
           <p:cNvSpPr/>
           <p:nvPr/>
         </p:nvSpPr>
@@ -10465,7 +10465,7 @@
       </p:sp>
       <p:sp>
         <p:nvSpPr>
-          <p:cNvPr id="317303089" name="Shape 8"/>
+          <p:cNvPr id="696573992" name="Shape 8"/>
           <p:cNvSpPr/>
           <p:nvPr/>
         </p:nvSpPr>
@@ -10512,7 +10512,7 @@
       </p:sp>
       <p:sp>
         <p:nvSpPr>
-          <p:cNvPr id="265956819" name="Text 9"/>
+          <p:cNvPr id="2122322110" name="Text 9"/>
           <p:cNvSpPr/>
           <p:nvPr/>
         </p:nvSpPr>
@@ -10570,7 +10570,7 @@
       </p:sp>
       <p:sp>
         <p:nvSpPr>
-          <p:cNvPr id="986627749" name="Text 10"/>
+          <p:cNvPr id="258385052" name="Text 10"/>
           <p:cNvSpPr/>
           <p:nvPr/>
         </p:nvSpPr>
@@ -10628,7 +10628,7 @@
       </p:sp>
       <p:sp>
         <p:nvSpPr>
-          <p:cNvPr id="708337715" name="Shape 11"/>
+          <p:cNvPr id="1943101733" name="Shape 11"/>
           <p:cNvSpPr/>
           <p:nvPr/>
         </p:nvSpPr>
@@ -10674,7 +10674,7 @@
       </p:sp>
       <p:sp>
         <p:nvSpPr>
-          <p:cNvPr id="692945212" name="Text 12"/>
+          <p:cNvPr id="1000951783" name="Text 12"/>
           <p:cNvSpPr/>
           <p:nvPr/>
         </p:nvSpPr>
@@ -10732,7 +10732,7 @@
       </p:sp>
       <p:sp>
         <p:nvSpPr>
-          <p:cNvPr id="43940090" name="Text 13"/>
+          <p:cNvPr id="979017131" name="Text 13"/>
           <p:cNvSpPr/>
           <p:nvPr/>
         </p:nvSpPr>
@@ -10790,7 +10790,7 @@
       </p:sp>
       <p:sp>
         <p:nvSpPr>
-          <p:cNvPr id="717297674" name="Text 14"/>
+          <p:cNvPr id="1021000704" name="Text 14"/>
           <p:cNvSpPr/>
           <p:nvPr/>
         </p:nvSpPr>
@@ -10848,7 +10848,7 @@
       </p:sp>
       <p:sp>
         <p:nvSpPr>
-          <p:cNvPr id="1768625702" name="Text 15"/>
+          <p:cNvPr id="1703776994" name="Text 15"/>
           <p:cNvSpPr/>
           <p:nvPr/>
         </p:nvSpPr>
@@ -10906,7 +10906,7 @@
       </p:sp>
       <p:sp>
         <p:nvSpPr>
-          <p:cNvPr id="1064310721" name="Text 16"/>
+          <p:cNvPr id="1569192084" name="Text 16"/>
           <p:cNvSpPr/>
           <p:nvPr/>
         </p:nvSpPr>
@@ -10964,7 +10964,7 @@
       </p:sp>
       <p:sp>
         <p:nvSpPr>
-          <p:cNvPr id="1808257630" name="Text 17"/>
+          <p:cNvPr id="780382702" name="Text 17"/>
           <p:cNvSpPr/>
           <p:nvPr/>
         </p:nvSpPr>
@@ -11022,7 +11022,7 @@
       </p:sp>
       <p:sp>
         <p:nvSpPr>
-          <p:cNvPr id="1375396778" name="Text 18"/>
+          <p:cNvPr id="1471515198" name="Text 18"/>
           <p:cNvSpPr/>
           <p:nvPr/>
         </p:nvSpPr>
@@ -11080,7 +11080,7 @@
       </p:sp>
       <p:sp>
         <p:nvSpPr>
-          <p:cNvPr id="659549375" name="Text 19"/>
+          <p:cNvPr id="1062625837" name="Text 19"/>
           <p:cNvSpPr/>
           <p:nvPr/>
         </p:nvSpPr>
@@ -11148,7 +11148,7 @@
       </p:sp>
       <p:sp>
         <p:nvSpPr>
-          <p:cNvPr id="1268852456" name="Text 20"/>
+          <p:cNvPr id="613488834" name="Text 20"/>
           <p:cNvSpPr/>
           <p:nvPr/>
         </p:nvSpPr>
@@ -11206,7 +11206,7 @@
       </p:sp>
       <p:sp>
         <p:nvSpPr>
-          <p:cNvPr id="2018612453" name="Text 21"/>
+          <p:cNvPr id="1960415673" name="Text 21"/>
           <p:cNvSpPr/>
           <p:nvPr/>
         </p:nvSpPr>
@@ -11264,7 +11264,7 @@
       </p:sp>
       <p:sp>
         <p:nvSpPr>
-          <p:cNvPr id="305058050" name="Text 22"/>
+          <p:cNvPr id="1679633539" name="Text 22"/>
           <p:cNvSpPr/>
           <p:nvPr/>
         </p:nvSpPr>
@@ -11362,7 +11362,7 @@
       </p:grpSpPr>
       <p:sp>
         <p:nvSpPr>
-          <p:cNvPr id="16358296" name="Shape 0"/>
+          <p:cNvPr id="417168171" name="Shape 0"/>
           <p:cNvSpPr/>
           <p:nvPr/>
         </p:nvSpPr>
@@ -11406,7 +11406,7 @@
       </p:sp>
       <p:sp>
         <p:nvSpPr>
-          <p:cNvPr id="875366155" name="Text 1"/>
+          <p:cNvPr id="424393670" name="Text 1"/>
           <p:cNvSpPr/>
           <p:nvPr/>
         </p:nvSpPr>
@@ -11464,7 +11464,7 @@
       </p:sp>
       <p:sp>
         <p:nvSpPr>
-          <p:cNvPr id="1218646270" name="Text 2"/>
+          <p:cNvPr id="1329309250" name="Text 2"/>
           <p:cNvSpPr/>
           <p:nvPr/>
         </p:nvSpPr>
@@ -11522,7 +11522,7 @@
       </p:sp>
       <p:sp>
         <p:nvSpPr>
-          <p:cNvPr id="1479463539" name="Text 3"/>
+          <p:cNvPr id="954057615" name="Text 3"/>
           <p:cNvSpPr/>
           <p:nvPr/>
         </p:nvSpPr>
@@ -11590,7 +11590,7 @@
       </p:sp>
       <p:sp>
         <p:nvSpPr>
-          <p:cNvPr id="1689369904" name="Text 4"/>
+          <p:cNvPr id="902210945" name="Text 4"/>
           <p:cNvSpPr/>
           <p:nvPr/>
         </p:nvSpPr>
@@ -11658,7 +11658,7 @@
       </p:sp>
       <p:sp>
         <p:nvSpPr>
-          <p:cNvPr id="640873274" name="Text 5"/>
+          <p:cNvPr id="780894899" name="Text 5"/>
           <p:cNvSpPr/>
           <p:nvPr/>
         </p:nvSpPr>
@@ -11716,7 +11716,7 @@
       </p:sp>
       <p:sp>
         <p:nvSpPr>
-          <p:cNvPr id="1310945598" name="Shape 6"/>
+          <p:cNvPr id="809733056" name="Shape 6"/>
           <p:cNvSpPr/>
           <p:nvPr/>
         </p:nvSpPr>
@@ -11760,7 +11760,7 @@
       </p:sp>
       <p:sp>
         <p:nvSpPr>
-          <p:cNvPr id="1661877146" name="Text 7"/>
+          <p:cNvPr id="1801038945" name="Text 7"/>
           <p:cNvSpPr/>
           <p:nvPr/>
         </p:nvSpPr>
@@ -11828,7 +11828,7 @@
       </p:sp>
       <p:pic>
         <p:nvPicPr>
-          <p:cNvPr id="2108897886" name="Image 0" descr="preencoded.png"/>
+          <p:cNvPr id="495873561" name="Image 0" descr="preencoded.png"/>
           <p:cNvPicPr/>
           <p:nvPr/>
         </p:nvPicPr>
@@ -11852,7 +11852,7 @@
       </p:pic>
       <p:sp>
         <p:nvSpPr>
-          <p:cNvPr id="12378667" name="Text 8"/>
+          <p:cNvPr id="2042120519" name="Text 8"/>
           <p:cNvSpPr/>
           <p:nvPr/>
         </p:nvSpPr>
@@ -11920,7 +11920,7 @@
       </p:sp>
       <p:sp>
         <p:nvSpPr>
-          <p:cNvPr id="1735605357" name="Text 9"/>
+          <p:cNvPr id="1816951347" name="Text 9"/>
           <p:cNvSpPr/>
           <p:nvPr/>
         </p:nvSpPr>
@@ -12018,7 +12018,7 @@
       </p:sp>
       <p:sp>
         <p:nvSpPr>
-          <p:cNvPr id="1106480146" name="Shape 10"/>
+          <p:cNvPr id="507023777" name="Shape 10"/>
           <p:cNvSpPr/>
           <p:nvPr/>
         </p:nvSpPr>
@@ -12062,7 +12062,7 @@
       </p:sp>
       <p:sp>
         <p:nvSpPr>
-          <p:cNvPr id="632307893" name="Text 11"/>
+          <p:cNvPr id="1031941457" name="Text 11"/>
           <p:cNvSpPr/>
           <p:nvPr/>
         </p:nvSpPr>
@@ -12130,7 +12130,7 @@
       </p:sp>
       <p:pic>
         <p:nvPicPr>
-          <p:cNvPr id="2130669908" name="Image 1" descr="preencoded.png"/>
+          <p:cNvPr id="756740304" name="Image 1" descr="preencoded.png"/>
           <p:cNvPicPr/>
           <p:nvPr/>
         </p:nvPicPr>
@@ -12154,7 +12154,7 @@
       </p:pic>
       <p:sp>
         <p:nvSpPr>
-          <p:cNvPr id="682829359" name="Text 12"/>
+          <p:cNvPr id="2070446161" name="Text 12"/>
           <p:cNvSpPr/>
           <p:nvPr/>
         </p:nvSpPr>
@@ -12212,7 +12212,7 @@
       </p:sp>
       <p:sp>
         <p:nvSpPr>
-          <p:cNvPr id="1464668794" name="Text 13"/>
+          <p:cNvPr id="2128951686" name="Text 13"/>
           <p:cNvSpPr/>
           <p:nvPr/>
         </p:nvSpPr>
@@ -12270,7 +12270,7 @@
       </p:sp>
       <p:sp>
         <p:nvSpPr>
-          <p:cNvPr id="200633281" name="Shape 14"/>
+          <p:cNvPr id="1101007532" name="Shape 14"/>
           <p:cNvSpPr/>
           <p:nvPr/>
         </p:nvSpPr>
@@ -12314,7 +12314,7 @@
       </p:sp>
       <p:sp>
         <p:nvSpPr>
-          <p:cNvPr id="665886233" name="Text 15"/>
+          <p:cNvPr id="43513260" name="Text 15"/>
           <p:cNvSpPr/>
           <p:nvPr/>
         </p:nvSpPr>
@@ -12382,7 +12382,7 @@
       </p:sp>
       <p:pic>
         <p:nvPicPr>
-          <p:cNvPr id="1730017557" name="Image 2" descr="preencoded.png"/>
+          <p:cNvPr id="1966734930" name="Image 2" descr="preencoded.png"/>
           <p:cNvPicPr/>
           <p:nvPr/>
         </p:nvPicPr>
@@ -12406,7 +12406,7 @@
       </p:pic>
       <p:sp>
         <p:nvSpPr>
-          <p:cNvPr id="549118815" name="Text 16"/>
+          <p:cNvPr id="1863705255" name="Text 16"/>
           <p:cNvSpPr/>
           <p:nvPr/>
         </p:nvSpPr>
@@ -12464,7 +12464,7 @@
       </p:sp>
       <p:sp>
         <p:nvSpPr>
-          <p:cNvPr id="33396407" name="Text 17"/>
+          <p:cNvPr id="497457230" name="Text 17"/>
           <p:cNvSpPr/>
           <p:nvPr/>
         </p:nvSpPr>
@@ -12522,7 +12522,7 @@
       </p:sp>
       <p:sp>
         <p:nvSpPr>
-          <p:cNvPr id="791142763" name="Shape 18"/>
+          <p:cNvPr id="749563276" name="Shape 18"/>
           <p:cNvSpPr/>
           <p:nvPr/>
         </p:nvSpPr>
@@ -12566,7 +12566,7 @@
       </p:sp>
       <p:sp>
         <p:nvSpPr>
-          <p:cNvPr id="10576095" name="Text 19"/>
+          <p:cNvPr id="266867855" name="Text 19"/>
           <p:cNvSpPr/>
           <p:nvPr/>
         </p:nvSpPr>
@@ -12634,7 +12634,7 @@
       </p:sp>
       <p:pic>
         <p:nvPicPr>
-          <p:cNvPr id="1677899825" name="Image 3" descr="preencoded.png"/>
+          <p:cNvPr id="2123372896" name="Image 3" descr="preencoded.png"/>
           <p:cNvPicPr/>
           <p:nvPr/>
         </p:nvPicPr>
@@ -12658,7 +12658,7 @@
       </p:pic>
       <p:sp>
         <p:nvSpPr>
-          <p:cNvPr id="1565767776" name="Text 20"/>
+          <p:cNvPr id="2032484805" name="Text 20"/>
           <p:cNvSpPr/>
           <p:nvPr/>
         </p:nvSpPr>
@@ -12716,7 +12716,7 @@
       </p:sp>
       <p:sp>
         <p:nvSpPr>
-          <p:cNvPr id="14171434" name="Text 21"/>
+          <p:cNvPr id="1065262737" name="Text 21"/>
           <p:cNvSpPr/>
           <p:nvPr/>
         </p:nvSpPr>
@@ -12774,7 +12774,7 @@
       </p:sp>
       <p:sp>
         <p:nvSpPr>
-          <p:cNvPr id="1325743325" name="Text 22"/>
+          <p:cNvPr id="2016434406" name="Text 22"/>
           <p:cNvSpPr/>
           <p:nvPr/>
         </p:nvSpPr>
@@ -12832,7 +12832,7 @@
       </p:sp>
       <p:sp>
         <p:nvSpPr>
-          <p:cNvPr id="2065924173" name="Text 23"/>
+          <p:cNvPr id="1905953678" name="Text 23"/>
           <p:cNvSpPr/>
           <p:nvPr/>
         </p:nvSpPr>
@@ -12950,7 +12950,7 @@
       </p:grpSpPr>
       <p:sp>
         <p:nvSpPr>
-          <p:cNvPr id="457530692" name="Shape 0"/>
+          <p:cNvPr id="1475801700" name="Shape 0"/>
           <p:cNvSpPr/>
           <p:nvPr/>
         </p:nvSpPr>
@@ -12994,7 +12994,7 @@
       </p:sp>
       <p:sp>
         <p:nvSpPr>
-          <p:cNvPr id="2025306043" name="Text 1"/>
+          <p:cNvPr id="608051111" name="Text 1"/>
           <p:cNvSpPr/>
           <p:nvPr/>
         </p:nvSpPr>
@@ -13052,7 +13052,7 @@
       </p:sp>
       <p:sp>
         <p:nvSpPr>
-          <p:cNvPr id="1831036218" name="Text 2"/>
+          <p:cNvPr id="2084527036" name="Text 2"/>
           <p:cNvSpPr/>
           <p:nvPr/>
         </p:nvSpPr>
@@ -13112,7 +13112,7 @@
       </p:sp>
       <p:sp>
         <p:nvSpPr>
-          <p:cNvPr id="735061245" name="Text 3"/>
+          <p:cNvPr id="295629945" name="Text 3"/>
           <p:cNvSpPr/>
           <p:nvPr/>
         </p:nvSpPr>
@@ -13184,7 +13184,7 @@
       </p:sp>
       <p:sp>
         <p:nvSpPr>
-          <p:cNvPr id="784848287" name="Text 4"/>
+          <p:cNvPr id="1847968381" name="Text 4"/>
           <p:cNvSpPr/>
           <p:nvPr/>
         </p:nvSpPr>
@@ -13268,13 +13268,13 @@
       </p:sp>
       <p:sp>
         <p:nvSpPr>
-          <p:cNvPr id="2062703620" name="Text 5"/>
-          <p:cNvSpPr/>
-          <p:nvPr/>
-        </p:nvSpPr>
-        <p:spPr bwMode="auto">
-          <a:xfrm>
-            <a:off x="1047600" y="2021040"/>
+          <p:cNvPr id="790161197" name="Text 5"/>
+          <p:cNvSpPr/>
+          <p:nvPr/>
+        </p:nvSpPr>
+        <p:spPr bwMode="auto">
+          <a:xfrm>
+            <a:off x="1047600" y="2383560"/>
             <a:ext cx="15513480" cy="3078000"/>
           </a:xfrm>
           <a:prstGeom prst="rect">
@@ -13292,8 +13292,8 @@
           <a:fontRef idx="minor"/>
         </p:style>
         <p:txBody>
-          <a:bodyPr lIns="25560" tIns="25560" rIns="25560" bIns="25560" anchor="t">
-            <a:normAutofit fontScale="92500"/>
+          <a:bodyPr vertOverflow="overflow" horzOverflow="overflow" vert="horz" wrap="square" lIns="25560" tIns="25560" rIns="25560" bIns="25560" numCol="1" spcCol="0" rtlCol="0" fromWordArt="0" anchor="t" anchorCtr="0" forceAA="0" upright="0" compatLnSpc="0">
+            <a:normAutofit/>
           </a:bodyPr>
           <a:p>
             <a:pPr defTabSz="914400">
@@ -13306,7 +13306,7 @@
               <a:defRPr/>
             </a:pPr>
             <a:r>
-              <a:rPr lang="zh-CN" sz="11400" b="1" u="none" strike="noStrike" spc="-57">
+              <a:rPr lang="zh-CN" sz="8000" b="1" u="none" strike="noStrike" spc="-57">
                 <a:solidFill>
                   <a:srgbClr val="F3ECE0"/>
                 </a:solidFill>
@@ -13316,7 +13316,7 @@
               <a:t>森林。電力。 計算。</a:t>
             </a:r>
             <a:r>
-              <a:rPr lang="zh-CN" sz="11400" b="1" u="none" strike="noStrike" spc="-57">
+              <a:rPr lang="zh-CN" sz="8000" b="1" u="none" strike="noStrike" spc="-57">
                 <a:solidFill>
                   <a:srgbClr val="F3B486"/>
                 </a:solidFill>
@@ -13336,13 +13336,13 @@
       </p:sp>
       <p:sp>
         <p:nvSpPr>
-          <p:cNvPr id="442284818" name="Text 6"/>
-          <p:cNvSpPr/>
-          <p:nvPr/>
-        </p:nvSpPr>
-        <p:spPr bwMode="auto">
-          <a:xfrm>
-            <a:off x="1047600" y="5461560"/>
+          <p:cNvPr id="544780188" name="Text 6"/>
+          <p:cNvSpPr/>
+          <p:nvPr/>
+        </p:nvSpPr>
+        <p:spPr bwMode="auto">
+          <a:xfrm>
+            <a:off x="1047600" y="4052653"/>
             <a:ext cx="16678079" cy="485280"/>
           </a:xfrm>
           <a:prstGeom prst="rect">
@@ -13396,13 +13396,13 @@
       </p:sp>
       <p:sp>
         <p:nvSpPr>
-          <p:cNvPr id="899358655" name="Text 7"/>
-          <p:cNvSpPr/>
-          <p:nvPr/>
-        </p:nvSpPr>
-        <p:spPr bwMode="auto">
-          <a:xfrm>
-            <a:off x="1047600" y="6576120"/>
+          <p:cNvPr id="1985837495" name="Text 7"/>
+          <p:cNvSpPr/>
+          <p:nvPr/>
+        </p:nvSpPr>
+        <p:spPr bwMode="auto">
+          <a:xfrm>
+            <a:off x="972359" y="5646060"/>
             <a:ext cx="5166720" cy="371160"/>
           </a:xfrm>
           <a:prstGeom prst="rect">
@@ -13456,13 +13456,13 @@
       </p:sp>
       <p:sp>
         <p:nvSpPr>
-          <p:cNvPr id="442115796" name="Text 8"/>
-          <p:cNvSpPr/>
-          <p:nvPr/>
-        </p:nvSpPr>
-        <p:spPr bwMode="auto">
-          <a:xfrm>
-            <a:off x="1047600" y="6985800"/>
+          <p:cNvPr id="1951952415" name="Text 8"/>
+          <p:cNvSpPr/>
+          <p:nvPr/>
+        </p:nvSpPr>
+        <p:spPr bwMode="auto">
+          <a:xfrm>
+            <a:off x="972359" y="6055740"/>
             <a:ext cx="5166720" cy="607320"/>
           </a:xfrm>
           <a:prstGeom prst="rect">
@@ -13514,13 +13514,13 @@
       </p:sp>
       <p:sp>
         <p:nvSpPr>
-          <p:cNvPr id="1129638251" name="Text 9"/>
-          <p:cNvSpPr/>
-          <p:nvPr/>
-        </p:nvSpPr>
-        <p:spPr bwMode="auto">
-          <a:xfrm>
-            <a:off x="1047600" y="7688520"/>
+          <p:cNvPr id="936654664" name="Text 9"/>
+          <p:cNvSpPr/>
+          <p:nvPr/>
+        </p:nvSpPr>
+        <p:spPr bwMode="auto">
+          <a:xfrm>
+            <a:off x="972359" y="6758460"/>
             <a:ext cx="5166720" cy="792000"/>
           </a:xfrm>
           <a:prstGeom prst="rect">
@@ -13574,13 +13574,13 @@
       </p:sp>
       <p:sp>
         <p:nvSpPr>
-          <p:cNvPr id="2053545696" name="Text 10"/>
-          <p:cNvSpPr/>
-          <p:nvPr/>
-        </p:nvSpPr>
-        <p:spPr bwMode="auto">
-          <a:xfrm>
-            <a:off x="6635880" y="6576120"/>
+          <p:cNvPr id="550911995" name="Text 10"/>
+          <p:cNvSpPr/>
+          <p:nvPr/>
+        </p:nvSpPr>
+        <p:spPr bwMode="auto">
+          <a:xfrm>
+            <a:off x="6560639" y="5646060"/>
             <a:ext cx="5166720" cy="371160"/>
           </a:xfrm>
           <a:prstGeom prst="rect">
@@ -13634,13 +13634,13 @@
       </p:sp>
       <p:sp>
         <p:nvSpPr>
-          <p:cNvPr id="2051978858" name="Text 11"/>
-          <p:cNvSpPr/>
-          <p:nvPr/>
-        </p:nvSpPr>
-        <p:spPr bwMode="auto">
-          <a:xfrm>
-            <a:off x="6635880" y="6985800"/>
+          <p:cNvPr id="301830645" name="Text 11"/>
+          <p:cNvSpPr/>
+          <p:nvPr/>
+        </p:nvSpPr>
+        <p:spPr bwMode="auto">
+          <a:xfrm>
+            <a:off x="6560639" y="6055740"/>
             <a:ext cx="5166720" cy="607320"/>
           </a:xfrm>
           <a:prstGeom prst="rect">
@@ -13702,13 +13702,13 @@
       </p:sp>
       <p:sp>
         <p:nvSpPr>
-          <p:cNvPr id="2064577421" name="Text 12"/>
-          <p:cNvSpPr/>
-          <p:nvPr/>
-        </p:nvSpPr>
-        <p:spPr bwMode="auto">
-          <a:xfrm>
-            <a:off x="6635880" y="7688520"/>
+          <p:cNvPr id="935103193" name="Text 12"/>
+          <p:cNvSpPr/>
+          <p:nvPr/>
+        </p:nvSpPr>
+        <p:spPr bwMode="auto">
+          <a:xfrm>
+            <a:off x="6560639" y="6758460"/>
             <a:ext cx="5166720" cy="792000"/>
           </a:xfrm>
           <a:prstGeom prst="rect">
@@ -13858,13 +13858,13 @@
       </p:sp>
       <p:sp>
         <p:nvSpPr>
-          <p:cNvPr id="1773606277" name="Text 13"/>
-          <p:cNvSpPr/>
-          <p:nvPr/>
-        </p:nvSpPr>
-        <p:spPr bwMode="auto">
-          <a:xfrm>
-            <a:off x="12223800" y="6576120"/>
+          <p:cNvPr id="1486320110" name="Text 13"/>
+          <p:cNvSpPr/>
+          <p:nvPr/>
+        </p:nvSpPr>
+        <p:spPr bwMode="auto">
+          <a:xfrm>
+            <a:off x="12148560" y="5646060"/>
             <a:ext cx="5166720" cy="371160"/>
           </a:xfrm>
           <a:prstGeom prst="rect">
@@ -13918,13 +13918,13 @@
       </p:sp>
       <p:sp>
         <p:nvSpPr>
-          <p:cNvPr id="935863754" name="Text 14"/>
-          <p:cNvSpPr/>
-          <p:nvPr/>
-        </p:nvSpPr>
-        <p:spPr bwMode="auto">
-          <a:xfrm>
-            <a:off x="12223800" y="6985800"/>
+          <p:cNvPr id="334830274" name="Text 14"/>
+          <p:cNvSpPr/>
+          <p:nvPr/>
+        </p:nvSpPr>
+        <p:spPr bwMode="auto">
+          <a:xfrm>
+            <a:off x="12148560" y="6055740"/>
             <a:ext cx="5166720" cy="1176840"/>
           </a:xfrm>
           <a:prstGeom prst="rect">
@@ -13976,13 +13976,13 @@
       </p:sp>
       <p:sp>
         <p:nvSpPr>
-          <p:cNvPr id="675725398" name="Text 15"/>
-          <p:cNvSpPr/>
-          <p:nvPr/>
-        </p:nvSpPr>
-        <p:spPr bwMode="auto">
-          <a:xfrm>
-            <a:off x="12223800" y="7718039"/>
+          <p:cNvPr id="1688969194" name="Text 15"/>
+          <p:cNvSpPr/>
+          <p:nvPr/>
+        </p:nvSpPr>
+        <p:spPr bwMode="auto">
+          <a:xfrm>
+            <a:off x="12148560" y="6787978"/>
             <a:ext cx="5166720" cy="415080"/>
           </a:xfrm>
           <a:prstGeom prst="rect">
@@ -14036,7 +14036,7 @@
       </p:sp>
       <p:sp>
         <p:nvSpPr>
-          <p:cNvPr id="1932084279" name="Text 16"/>
+          <p:cNvPr id="201891272" name="Text 16"/>
           <p:cNvSpPr/>
           <p:nvPr/>
         </p:nvSpPr>
@@ -14096,13 +14096,13 @@
       </p:sp>
       <p:sp>
         <p:nvSpPr>
-          <p:cNvPr id="1256618040" name="Text 17"/>
-          <p:cNvSpPr/>
-          <p:nvPr/>
-        </p:nvSpPr>
-        <p:spPr bwMode="auto">
-          <a:xfrm>
-            <a:off x="12229200" y="8219520"/>
+          <p:cNvPr id="2107547592" name="Text 17"/>
+          <p:cNvSpPr/>
+          <p:nvPr/>
+        </p:nvSpPr>
+        <p:spPr bwMode="auto">
+          <a:xfrm>
+            <a:off x="12153959" y="7289460"/>
             <a:ext cx="5383440" cy="371160"/>
           </a:xfrm>
           <a:prstGeom prst="rect">
@@ -14196,7 +14196,7 @@
       </p:grpSpPr>
       <p:sp>
         <p:nvSpPr>
-          <p:cNvPr id="376830770" name="Shape 0"/>
+          <p:cNvPr id="981710343" name="Shape 0"/>
           <p:cNvSpPr/>
           <p:nvPr/>
         </p:nvSpPr>
@@ -14240,7 +14240,7 @@
       </p:sp>
       <p:sp>
         <p:nvSpPr>
-          <p:cNvPr id="405566513" name="Text 1"/>
+          <p:cNvPr id="368715291" name="Text 1"/>
           <p:cNvSpPr/>
           <p:nvPr/>
         </p:nvSpPr>
@@ -14298,7 +14298,7 @@
       </p:sp>
       <p:sp>
         <p:nvSpPr>
-          <p:cNvPr id="867132601" name="Text 2"/>
+          <p:cNvPr id="1012480395" name="Text 2"/>
           <p:cNvSpPr/>
           <p:nvPr/>
         </p:nvSpPr>
@@ -14356,7 +14356,7 @@
       </p:sp>
       <p:sp>
         <p:nvSpPr>
-          <p:cNvPr id="1747979929" name="Text 3"/>
+          <p:cNvPr id="258905470" name="Text 3"/>
           <p:cNvSpPr/>
           <p:nvPr/>
         </p:nvSpPr>
@@ -14424,7 +14424,7 @@
       </p:sp>
       <p:sp>
         <p:nvSpPr>
-          <p:cNvPr id="506766536" name="Text 4"/>
+          <p:cNvPr id="1054583620" name="Text 4"/>
           <p:cNvSpPr/>
           <p:nvPr/>
         </p:nvSpPr>
@@ -14492,7 +14492,7 @@
       </p:sp>
       <p:sp>
         <p:nvSpPr>
-          <p:cNvPr id="648188832" name="Text 5"/>
+          <p:cNvPr id="1959366808" name="Text 5"/>
           <p:cNvSpPr/>
           <p:nvPr/>
         </p:nvSpPr>
@@ -14610,7 +14610,7 @@
       </p:sp>
       <p:sp>
         <p:nvSpPr>
-          <p:cNvPr id="1587952672" name="Text 6"/>
+          <p:cNvPr id="622638716" name="Text 6"/>
           <p:cNvSpPr/>
           <p:nvPr/>
         </p:nvSpPr>
@@ -14668,7 +14668,7 @@
       </p:sp>
       <p:sp>
         <p:nvSpPr>
-          <p:cNvPr id="906301324" name="Text 7"/>
+          <p:cNvPr id="1507952935" name="Text 7"/>
           <p:cNvSpPr/>
           <p:nvPr/>
         </p:nvSpPr>
@@ -14726,7 +14726,7 @@
       </p:sp>
       <p:sp>
         <p:nvSpPr>
-          <p:cNvPr id="1090286914" name="Shape 8"/>
+          <p:cNvPr id="2117137047" name="Shape 8"/>
           <p:cNvSpPr/>
           <p:nvPr/>
         </p:nvSpPr>
@@ -14772,7 +14772,7 @@
       </p:sp>
       <p:sp>
         <p:nvSpPr>
-          <p:cNvPr id="260949673" name="Text 9"/>
+          <p:cNvPr id="365943872" name="Text 9"/>
           <p:cNvSpPr/>
           <p:nvPr/>
         </p:nvSpPr>
@@ -14830,7 +14830,7 @@
       </p:sp>
       <p:sp>
         <p:nvSpPr>
-          <p:cNvPr id="1303587515" name="Text 10"/>
+          <p:cNvPr id="762558139" name="Text 10"/>
           <p:cNvSpPr/>
           <p:nvPr/>
         </p:nvSpPr>
@@ -14888,7 +14888,7 @@
       </p:sp>
       <p:sp>
         <p:nvSpPr>
-          <p:cNvPr id="1405833468" name="Text 11"/>
+          <p:cNvPr id="1300366708" name="Text 11"/>
           <p:cNvSpPr/>
           <p:nvPr/>
         </p:nvSpPr>
@@ -14946,7 +14946,7 @@
       </p:sp>
       <p:sp>
         <p:nvSpPr>
-          <p:cNvPr id="1118053606" name="Text 12"/>
+          <p:cNvPr id="1408805184" name="Text 12"/>
           <p:cNvSpPr/>
           <p:nvPr/>
         </p:nvSpPr>
@@ -15004,7 +15004,7 @@
       </p:sp>
       <p:sp>
         <p:nvSpPr>
-          <p:cNvPr id="2106063731" name="Text 13"/>
+          <p:cNvPr id="1391449506" name="Text 13"/>
           <p:cNvSpPr/>
           <p:nvPr/>
         </p:nvSpPr>
@@ -15062,7 +15062,7 @@
       </p:sp>
       <p:sp>
         <p:nvSpPr>
-          <p:cNvPr id="498361137" name="Text 14"/>
+          <p:cNvPr id="65882582" name="Text 14"/>
           <p:cNvSpPr/>
           <p:nvPr/>
         </p:nvSpPr>
@@ -15120,7 +15120,7 @@
       </p:sp>
       <p:sp>
         <p:nvSpPr>
-          <p:cNvPr id="1820932082" name="Shape 15"/>
+          <p:cNvPr id="2042319028" name="Shape 15"/>
           <p:cNvSpPr/>
           <p:nvPr/>
         </p:nvSpPr>
@@ -15167,7 +15167,7 @@
       </p:sp>
       <p:sp>
         <p:nvSpPr>
-          <p:cNvPr id="1015306620" name="Text 16"/>
+          <p:cNvPr id="817929506" name="Text 16"/>
           <p:cNvSpPr/>
           <p:nvPr/>
         </p:nvSpPr>
@@ -15245,7 +15245,7 @@
       </p:sp>
       <p:pic>
         <p:nvPicPr>
-          <p:cNvPr id="503440574" name="Image 0" descr="preencoded.png"/>
+          <p:cNvPr id="1827540481" name="Image 0" descr="preencoded.png"/>
           <p:cNvPicPr/>
           <p:nvPr/>
         </p:nvPicPr>
@@ -15269,7 +15269,7 @@
       </p:pic>
       <p:sp>
         <p:nvSpPr>
-          <p:cNvPr id="705011173" name="Text 17"/>
+          <p:cNvPr id="1510223579" name="Text 17"/>
           <p:cNvSpPr/>
           <p:nvPr/>
         </p:nvSpPr>
@@ -15327,7 +15327,7 @@
       </p:sp>
       <p:sp>
         <p:nvSpPr>
-          <p:cNvPr id="171785448" name="Shape 18"/>
+          <p:cNvPr id="1361946055" name="Shape 18"/>
           <p:cNvSpPr/>
           <p:nvPr/>
         </p:nvSpPr>
@@ -15374,7 +15374,7 @@
       </p:sp>
       <p:sp>
         <p:nvSpPr>
-          <p:cNvPr id="544127312" name="Text 19"/>
+          <p:cNvPr id="1328152379" name="Text 19"/>
           <p:cNvSpPr/>
           <p:nvPr/>
         </p:nvSpPr>
@@ -15452,7 +15452,7 @@
       </p:sp>
       <p:pic>
         <p:nvPicPr>
-          <p:cNvPr id="555593218" name="Image 1" descr="preencoded.png"/>
+          <p:cNvPr id="302248481" name="Image 1" descr="preencoded.png"/>
           <p:cNvPicPr/>
           <p:nvPr/>
         </p:nvPicPr>
@@ -15476,7 +15476,7 @@
       </p:pic>
       <p:sp>
         <p:nvSpPr>
-          <p:cNvPr id="1136569274" name="Text 20"/>
+          <p:cNvPr id="702312345" name="Text 20"/>
           <p:cNvSpPr/>
           <p:nvPr/>
         </p:nvSpPr>
@@ -15534,7 +15534,7 @@
       </p:sp>
       <p:sp>
         <p:nvSpPr>
-          <p:cNvPr id="384048609" name="Text 21"/>
+          <p:cNvPr id="56479663" name="Text 21"/>
           <p:cNvSpPr/>
           <p:nvPr/>
         </p:nvSpPr>
@@ -15592,7 +15592,7 @@
       </p:sp>
       <p:sp>
         <p:nvSpPr>
-          <p:cNvPr id="907591184" name="Text 22"/>
+          <p:cNvPr id="1818124912" name="Text 22"/>
           <p:cNvSpPr/>
           <p:nvPr/>
         </p:nvSpPr>
@@ -15730,7 +15730,7 @@
       </p:grpSpPr>
       <p:sp>
         <p:nvSpPr>
-          <p:cNvPr id="1455134663" name="Shape 0"/>
+          <p:cNvPr id="236028453" name="Shape 0"/>
           <p:cNvSpPr/>
           <p:nvPr/>
         </p:nvSpPr>
@@ -15774,7 +15774,7 @@
       </p:sp>
       <p:sp>
         <p:nvSpPr>
-          <p:cNvPr id="1794342229" name="Text 1"/>
+          <p:cNvPr id="1633793987" name="Text 1"/>
           <p:cNvSpPr/>
           <p:nvPr/>
         </p:nvSpPr>
@@ -15832,7 +15832,7 @@
       </p:sp>
       <p:sp>
         <p:nvSpPr>
-          <p:cNvPr id="725415191" name="Text 2"/>
+          <p:cNvPr id="1213808859" name="Text 2"/>
           <p:cNvSpPr/>
           <p:nvPr/>
         </p:nvSpPr>
@@ -15890,7 +15890,7 @@
       </p:sp>
       <p:sp>
         <p:nvSpPr>
-          <p:cNvPr id="649015260" name="Text 3"/>
+          <p:cNvPr id="1746125775" name="Text 3"/>
           <p:cNvSpPr/>
           <p:nvPr/>
         </p:nvSpPr>
@@ -15968,7 +15968,7 @@
       </p:sp>
       <p:sp>
         <p:nvSpPr>
-          <p:cNvPr id="525908390" name="Text 4"/>
+          <p:cNvPr id="278640089" name="Text 4"/>
           <p:cNvSpPr/>
           <p:nvPr/>
         </p:nvSpPr>
@@ -16046,7 +16046,7 @@
       </p:sp>
       <p:sp>
         <p:nvSpPr>
-          <p:cNvPr id="362321185" name="Text 5"/>
+          <p:cNvPr id="2112157493" name="Text 5"/>
           <p:cNvSpPr/>
           <p:nvPr/>
         </p:nvSpPr>
@@ -16124,7 +16124,7 @@
       </p:sp>
       <p:sp>
         <p:nvSpPr>
-          <p:cNvPr id="2101199333" name="Shape 6"/>
+          <p:cNvPr id="238217539" name="Shape 6"/>
           <p:cNvSpPr/>
           <p:nvPr/>
         </p:nvSpPr>
@@ -16171,7 +16171,7 @@
       </p:sp>
       <p:pic>
         <p:nvPicPr>
-          <p:cNvPr id="1339350575" name="Image 0" descr="preencoded.png"/>
+          <p:cNvPr id="1090843728" name="Image 0" descr="preencoded.png"/>
           <p:cNvPicPr/>
           <p:nvPr/>
         </p:nvPicPr>
@@ -16195,7 +16195,7 @@
       </p:pic>
       <p:sp>
         <p:nvSpPr>
-          <p:cNvPr id="1013212979" name="Text 7"/>
+          <p:cNvPr id="1235186655" name="Text 7"/>
           <p:cNvSpPr/>
           <p:nvPr/>
         </p:nvSpPr>
@@ -16253,7 +16253,7 @@
       </p:sp>
       <p:sp>
         <p:nvSpPr>
-          <p:cNvPr id="1096581599" name="Text 8"/>
+          <p:cNvPr id="1815987519" name="Text 8"/>
           <p:cNvSpPr/>
           <p:nvPr/>
         </p:nvSpPr>
@@ -16411,7 +16411,7 @@
       </p:grpSpPr>
       <p:sp>
         <p:nvSpPr>
-          <p:cNvPr id="2048356476" name="Shape 0"/>
+          <p:cNvPr id="1393754872" name="Shape 0"/>
           <p:cNvSpPr/>
           <p:nvPr/>
         </p:nvSpPr>
@@ -16455,7 +16455,7 @@
       </p:sp>
       <p:sp>
         <p:nvSpPr>
-          <p:cNvPr id="497280334" name="Text 1"/>
+          <p:cNvPr id="69202372" name="Text 1"/>
           <p:cNvSpPr/>
           <p:nvPr/>
         </p:nvSpPr>
@@ -16513,7 +16513,7 @@
       </p:sp>
       <p:sp>
         <p:nvSpPr>
-          <p:cNvPr id="1617864630" name="Text 2"/>
+          <p:cNvPr id="1343480941" name="Text 2"/>
           <p:cNvSpPr/>
           <p:nvPr/>
         </p:nvSpPr>
@@ -16571,7 +16571,7 @@
       </p:sp>
       <p:sp>
         <p:nvSpPr>
-          <p:cNvPr id="899904238" name="Text 3"/>
+          <p:cNvPr id="1827101703" name="Text 3"/>
           <p:cNvSpPr/>
           <p:nvPr/>
         </p:nvSpPr>
@@ -16639,7 +16639,7 @@
       </p:sp>
       <p:sp>
         <p:nvSpPr>
-          <p:cNvPr id="208919990" name="Text 4"/>
+          <p:cNvPr id="2056517744" name="Text 4"/>
           <p:cNvSpPr/>
           <p:nvPr/>
         </p:nvSpPr>
@@ -16707,7 +16707,7 @@
       </p:sp>
       <p:sp>
         <p:nvSpPr>
-          <p:cNvPr id="1857490926" name="Text 5"/>
+          <p:cNvPr id="898822288" name="Text 5"/>
           <p:cNvSpPr/>
           <p:nvPr/>
         </p:nvSpPr>
@@ -16789,7 +16789,7 @@
       </p:sp>
       <p:sp>
         <p:nvSpPr>
-          <p:cNvPr id="790506815" name="Text 6"/>
+          <p:cNvPr id="905978517" name="Text 6"/>
           <p:cNvSpPr/>
           <p:nvPr/>
         </p:nvSpPr>
@@ -16847,7 +16847,7 @@
       </p:sp>
       <p:sp>
         <p:nvSpPr>
-          <p:cNvPr id="2107274469" name="Shape 7"/>
+          <p:cNvPr id="383643775" name="Shape 7"/>
           <p:cNvSpPr/>
           <p:nvPr/>
         </p:nvSpPr>
@@ -16893,7 +16893,7 @@
       </p:sp>
       <p:sp>
         <p:nvSpPr>
-          <p:cNvPr id="1511241397" name="Text 8"/>
+          <p:cNvPr id="682803266" name="Text 8"/>
           <p:cNvSpPr/>
           <p:nvPr/>
         </p:nvSpPr>
@@ -16951,7 +16951,7 @@
       </p:sp>
       <p:sp>
         <p:nvSpPr>
-          <p:cNvPr id="885585109" name="Text 9"/>
+          <p:cNvPr id="2006490503" name="Text 9"/>
           <p:cNvSpPr/>
           <p:nvPr/>
         </p:nvSpPr>
@@ -17009,7 +17009,7 @@
       </p:sp>
       <p:sp>
         <p:nvSpPr>
-          <p:cNvPr id="243308595" name="Text 10"/>
+          <p:cNvPr id="659972303" name="Text 10"/>
           <p:cNvSpPr/>
           <p:nvPr/>
         </p:nvSpPr>
@@ -17067,7 +17067,7 @@
       </p:sp>
       <p:sp>
         <p:nvSpPr>
-          <p:cNvPr id="22889132" name="Text 11"/>
+          <p:cNvPr id="282132659" name="Text 11"/>
           <p:cNvSpPr/>
           <p:nvPr/>
         </p:nvSpPr>
@@ -17135,7 +17135,7 @@
       </p:sp>
       <p:sp>
         <p:nvSpPr>
-          <p:cNvPr id="1566627860" name="Text 12"/>
+          <p:cNvPr id="1204635433" name="Text 12"/>
           <p:cNvSpPr/>
           <p:nvPr/>
         </p:nvSpPr>
@@ -17193,7 +17193,7 @@
       </p:sp>
       <p:sp>
         <p:nvSpPr>
-          <p:cNvPr id="1950995619" name="Text 13"/>
+          <p:cNvPr id="930360517" name="Text 13"/>
           <p:cNvSpPr/>
           <p:nvPr/>
         </p:nvSpPr>
@@ -17251,7 +17251,7 @@
       </p:sp>
       <p:sp>
         <p:nvSpPr>
-          <p:cNvPr id="871341328" name="Shape 14"/>
+          <p:cNvPr id="388455664" name="Shape 14"/>
           <p:cNvSpPr/>
           <p:nvPr/>
         </p:nvSpPr>
@@ -17298,7 +17298,7 @@
       </p:sp>
       <p:sp>
         <p:nvSpPr>
-          <p:cNvPr id="1689388071" name="Text 15"/>
+          <p:cNvPr id="1338083699" name="Text 15"/>
           <p:cNvSpPr/>
           <p:nvPr/>
         </p:nvSpPr>
@@ -17358,7 +17358,7 @@
       </p:sp>
       <p:pic>
         <p:nvPicPr>
-          <p:cNvPr id="424698534" name="Image 0" descr="preencoded.png"/>
+          <p:cNvPr id="986361131" name="Image 0" descr="preencoded.png"/>
           <p:cNvPicPr/>
           <p:nvPr/>
         </p:nvPicPr>
@@ -17382,7 +17382,7 @@
       </p:pic>
       <p:sp>
         <p:nvSpPr>
-          <p:cNvPr id="914017339" name="Text 16"/>
+          <p:cNvPr id="2084056285" name="Text 16"/>
           <p:cNvSpPr/>
           <p:nvPr/>
         </p:nvSpPr>
@@ -17440,7 +17440,7 @@
       </p:sp>
       <p:sp>
         <p:nvSpPr>
-          <p:cNvPr id="860260467" name="Text 17"/>
+          <p:cNvPr id="1342029099" name="Text 17"/>
           <p:cNvSpPr/>
           <p:nvPr/>
         </p:nvSpPr>
@@ -17598,7 +17598,7 @@
       </p:grpSpPr>
       <p:sp>
         <p:nvSpPr>
-          <p:cNvPr id="576507102" name="Shape 0"/>
+          <p:cNvPr id="953959685" name="Shape 0"/>
           <p:cNvSpPr/>
           <p:nvPr/>
         </p:nvSpPr>
@@ -17642,7 +17642,7 @@
       </p:sp>
       <p:sp>
         <p:nvSpPr>
-          <p:cNvPr id="1915541970" name="Text 1"/>
+          <p:cNvPr id="1588987794" name="Text 1"/>
           <p:cNvSpPr/>
           <p:nvPr/>
         </p:nvSpPr>
@@ -17700,7 +17700,7 @@
       </p:sp>
       <p:sp>
         <p:nvSpPr>
-          <p:cNvPr id="609599192" name="Text 2"/>
+          <p:cNvPr id="1656703744" name="Text 2"/>
           <p:cNvSpPr/>
           <p:nvPr/>
         </p:nvSpPr>
@@ -17760,7 +17760,7 @@
       </p:sp>
       <p:sp>
         <p:nvSpPr>
-          <p:cNvPr id="101138698" name="Text 3"/>
+          <p:cNvPr id="1067872066" name="Text 3"/>
           <p:cNvSpPr/>
           <p:nvPr/>
         </p:nvSpPr>
@@ -17832,7 +17832,7 @@
       </p:sp>
       <p:sp>
         <p:nvSpPr>
-          <p:cNvPr id="1878100107" name="Text 4"/>
+          <p:cNvPr id="1823166397" name="Text 4"/>
           <p:cNvSpPr/>
           <p:nvPr/>
         </p:nvSpPr>
@@ -17900,7 +17900,7 @@
       </p:sp>
       <p:sp>
         <p:nvSpPr>
-          <p:cNvPr id="1268904596" name="Text 5"/>
+          <p:cNvPr id="1264389786" name="Text 5"/>
           <p:cNvSpPr/>
           <p:nvPr/>
         </p:nvSpPr>
@@ -17960,7 +17960,7 @@
       </p:sp>
       <p:sp>
         <p:nvSpPr>
-          <p:cNvPr id="719346191" name="Shape 6"/>
+          <p:cNvPr id="1436440392" name="Shape 6"/>
           <p:cNvSpPr/>
           <p:nvPr/>
         </p:nvSpPr>
@@ -18004,7 +18004,7 @@
       </p:sp>
       <p:sp>
         <p:nvSpPr>
-          <p:cNvPr id="1884192920" name="Text 7"/>
+          <p:cNvPr id="262787581" name="Text 7"/>
           <p:cNvSpPr/>
           <p:nvPr/>
         </p:nvSpPr>
@@ -18064,7 +18064,7 @@
       </p:sp>
       <p:sp>
         <p:nvSpPr>
-          <p:cNvPr id="1057550619" name="Text 8"/>
+          <p:cNvPr id="1219936095" name="Text 8"/>
           <p:cNvSpPr/>
           <p:nvPr/>
         </p:nvSpPr>
@@ -18250,7 +18250,7 @@
       </p:sp>
       <p:sp>
         <p:nvSpPr>
-          <p:cNvPr id="557885163" name="Shape 9"/>
+          <p:cNvPr id="1096165120" name="Shape 9"/>
           <p:cNvSpPr/>
           <p:nvPr/>
         </p:nvSpPr>
@@ -18294,7 +18294,7 @@
       </p:sp>
       <p:sp>
         <p:nvSpPr>
-          <p:cNvPr id="804926757" name="Text 10"/>
+          <p:cNvPr id="1190279740" name="Text 10"/>
           <p:cNvSpPr/>
           <p:nvPr/>
         </p:nvSpPr>
@@ -18354,7 +18354,7 @@
       </p:sp>
       <p:sp>
         <p:nvSpPr>
-          <p:cNvPr id="1086110919" name="Text 11"/>
+          <p:cNvPr id="203484227" name="Text 11"/>
           <p:cNvSpPr/>
           <p:nvPr/>
         </p:nvSpPr>
@@ -18530,7 +18530,7 @@
       </p:sp>
       <p:sp>
         <p:nvSpPr>
-          <p:cNvPr id="144038349" name="Shape 12"/>
+          <p:cNvPr id="1063443184" name="Shape 12"/>
           <p:cNvSpPr/>
           <p:nvPr/>
         </p:nvSpPr>
@@ -18574,7 +18574,7 @@
       </p:sp>
       <p:sp>
         <p:nvSpPr>
-          <p:cNvPr id="620596687" name="Text 13"/>
+          <p:cNvPr id="1972699463" name="Text 13"/>
           <p:cNvSpPr/>
           <p:nvPr/>
         </p:nvSpPr>
@@ -18634,7 +18634,7 @@
       </p:sp>
       <p:sp>
         <p:nvSpPr>
-          <p:cNvPr id="1226263714" name="Text 14"/>
+          <p:cNvPr id="697564323" name="Text 14"/>
           <p:cNvSpPr/>
           <p:nvPr/>
         </p:nvSpPr>
@@ -18810,7 +18810,7 @@
       </p:sp>
       <p:sp>
         <p:nvSpPr>
-          <p:cNvPr id="1825288368" name="Text 15"/>
+          <p:cNvPr id="235913045" name="Text 15"/>
           <p:cNvSpPr/>
           <p:nvPr/>
         </p:nvSpPr>
@@ -18870,7 +18870,7 @@
       </p:sp>
       <p:sp>
         <p:nvSpPr>
-          <p:cNvPr id="1740805273" name="Text 16"/>
+          <p:cNvPr id="1134950762" name="Text 16"/>
           <p:cNvSpPr/>
           <p:nvPr/>
         </p:nvSpPr>
@@ -19018,7 +19018,7 @@
       </p:grpSpPr>
       <p:sp>
         <p:nvSpPr>
-          <p:cNvPr id="1758143046" name="Shape 0"/>
+          <p:cNvPr id="1688572215" name="Shape 0"/>
           <p:cNvSpPr/>
           <p:nvPr/>
         </p:nvSpPr>
@@ -19062,7 +19062,7 @@
       </p:sp>
       <p:sp>
         <p:nvSpPr>
-          <p:cNvPr id="2077290380" name="Text 1"/>
+          <p:cNvPr id="2108087472" name="Text 1"/>
           <p:cNvSpPr/>
           <p:nvPr/>
         </p:nvSpPr>
@@ -19120,7 +19120,7 @@
       </p:sp>
       <p:sp>
         <p:nvSpPr>
-          <p:cNvPr id="547814934" name="Text 2"/>
+          <p:cNvPr id="524111110" name="Text 2"/>
           <p:cNvSpPr/>
           <p:nvPr/>
         </p:nvSpPr>
@@ -19178,7 +19178,7 @@
       </p:sp>
       <p:sp>
         <p:nvSpPr>
-          <p:cNvPr id="1379526926" name="Text 3"/>
+          <p:cNvPr id="1244758089" name="Text 3"/>
           <p:cNvSpPr/>
           <p:nvPr/>
         </p:nvSpPr>
@@ -19286,7 +19286,7 @@
       </p:sp>
       <p:sp>
         <p:nvSpPr>
-          <p:cNvPr id="1559642411" name="Text 4"/>
+          <p:cNvPr id="1418798006" name="Text 4"/>
           <p:cNvSpPr/>
           <p:nvPr/>
         </p:nvSpPr>
@@ -19384,7 +19384,7 @@
       </p:sp>
       <p:sp>
         <p:nvSpPr>
-          <p:cNvPr id="1964139600" name="Text 5"/>
+          <p:cNvPr id="1577047204" name="Text 5"/>
           <p:cNvSpPr/>
           <p:nvPr/>
         </p:nvSpPr>
@@ -19462,7 +19462,7 @@
       </p:sp>
       <p:sp>
         <p:nvSpPr>
-          <p:cNvPr id="785425816" name="Text 6"/>
+          <p:cNvPr id="1111255037" name="Text 6"/>
           <p:cNvSpPr/>
           <p:nvPr/>
         </p:nvSpPr>
@@ -19560,7 +19560,7 @@
       </p:sp>
       <p:sp>
         <p:nvSpPr>
-          <p:cNvPr id="594998918" name="Shape 7"/>
+          <p:cNvPr id="2075674447" name="Shape 7"/>
           <p:cNvSpPr/>
           <p:nvPr/>
         </p:nvSpPr>
@@ -19606,7 +19606,7 @@
       </p:sp>
       <p:sp>
         <p:nvSpPr>
-          <p:cNvPr id="1063329633" name="Text 8"/>
+          <p:cNvPr id="1437831706" name="Text 8"/>
           <p:cNvSpPr/>
           <p:nvPr/>
         </p:nvSpPr>
@@ -19664,7 +19664,7 @@
       </p:sp>
       <p:sp>
         <p:nvSpPr>
-          <p:cNvPr id="371148390" name="Text 9"/>
+          <p:cNvPr id="948704298" name="Text 9"/>
           <p:cNvSpPr/>
           <p:nvPr/>
         </p:nvSpPr>
@@ -19722,7 +19722,7 @@
       </p:sp>
       <p:sp>
         <p:nvSpPr>
-          <p:cNvPr id="1723462849" name="Text 10"/>
+          <p:cNvPr id="1280645231" name="Text 10"/>
           <p:cNvSpPr/>
           <p:nvPr/>
         </p:nvSpPr>
@@ -19800,7 +19800,7 @@
       </p:sp>
       <p:sp>
         <p:nvSpPr>
-          <p:cNvPr id="1960020873" name="Text 11"/>
+          <p:cNvPr id="835297470" name="Text 11"/>
           <p:cNvSpPr/>
           <p:nvPr/>
         </p:nvSpPr>
@@ -19858,7 +19858,7 @@
       </p:sp>
       <p:sp>
         <p:nvSpPr>
-          <p:cNvPr id="1018719017" name="Text 12"/>
+          <p:cNvPr id="781981274" name="Text 12"/>
           <p:cNvSpPr/>
           <p:nvPr/>
         </p:nvSpPr>
@@ -19964,7 +19964,7 @@
       </p:sp>
       <p:sp>
         <p:nvSpPr>
-          <p:cNvPr id="24693780" name="Shape 13"/>
+          <p:cNvPr id="455024112" name="Shape 13"/>
           <p:cNvSpPr/>
           <p:nvPr/>
         </p:nvSpPr>
@@ -20011,7 +20011,7 @@
       </p:sp>
       <p:sp>
         <p:nvSpPr>
-          <p:cNvPr id="56391103" name="Text 14"/>
+          <p:cNvPr id="1073796200" name="Text 14"/>
           <p:cNvSpPr/>
           <p:nvPr/>
         </p:nvSpPr>
@@ -20069,7 +20069,7 @@
       </p:sp>
       <p:sp>
         <p:nvSpPr>
-          <p:cNvPr id="88658421" name="Text 15"/>
+          <p:cNvPr id="1013254589" name="Text 15"/>
           <p:cNvSpPr/>
           <p:nvPr/>
         </p:nvSpPr>
@@ -20340,7 +20340,7 @@
       </p:sp>
       <p:sp>
         <p:nvSpPr>
-          <p:cNvPr id="231876704" name="Shape 16"/>
+          <p:cNvPr id="2140284908" name="Shape 16"/>
           <p:cNvSpPr/>
           <p:nvPr/>
         </p:nvSpPr>
@@ -20387,7 +20387,7 @@
       </p:sp>
       <p:sp>
         <p:nvSpPr>
-          <p:cNvPr id="1057190693" name="Text 17"/>
+          <p:cNvPr id="256075205" name="Text 17"/>
           <p:cNvSpPr/>
           <p:nvPr/>
         </p:nvSpPr>
@@ -20445,7 +20445,7 @@
       </p:sp>
       <p:sp>
         <p:nvSpPr>
-          <p:cNvPr id="264466579" name="Text 18"/>
+          <p:cNvPr id="1375646596" name="Text 18"/>
           <p:cNvSpPr/>
           <p:nvPr/>
         </p:nvSpPr>
@@ -20604,7 +20604,7 @@
       </p:sp>
       <p:sp>
         <p:nvSpPr>
-          <p:cNvPr id="1131098155" name="Shape 19"/>
+          <p:cNvPr id="1878393752" name="Shape 19"/>
           <p:cNvSpPr/>
           <p:nvPr/>
         </p:nvSpPr>
@@ -20651,7 +20651,7 @@
       </p:sp>
       <p:sp>
         <p:nvSpPr>
-          <p:cNvPr id="336462265" name="Text 20"/>
+          <p:cNvPr id="1695801543" name="Text 20"/>
           <p:cNvSpPr/>
           <p:nvPr/>
         </p:nvSpPr>
@@ -20729,7 +20729,7 @@
       </p:sp>
       <p:sp>
         <p:nvSpPr>
-          <p:cNvPr id="1523828494" name="Text 21"/>
+          <p:cNvPr id="792040435" name="Text 21"/>
           <p:cNvSpPr/>
           <p:nvPr/>
         </p:nvSpPr>
@@ -20908,7 +20908,7 @@
       </p:sp>
       <p:sp>
         <p:nvSpPr>
-          <p:cNvPr id="1555567358" name="Text 22"/>
+          <p:cNvPr id="1776584651" name="Text 22"/>
           <p:cNvSpPr/>
           <p:nvPr/>
         </p:nvSpPr>
@@ -20966,7 +20966,7 @@
       </p:sp>
       <p:sp>
         <p:nvSpPr>
-          <p:cNvPr id="1057804698" name="Text 23"/>
+          <p:cNvPr id="1895352732" name="Text 23"/>
           <p:cNvSpPr/>
           <p:nvPr/>
         </p:nvSpPr>
@@ -21104,7 +21104,7 @@
       </p:sp>
       <p:sp>
         <p:nvSpPr>
-          <p:cNvPr id="1466648479" name="Text 11"/>
+          <p:cNvPr id="338205783" name="Text 11"/>
           <p:cNvSpPr/>
           <p:nvPr/>
         </p:nvSpPr>
@@ -21162,7 +21162,7 @@
       </p:sp>
       <p:sp>
         <p:nvSpPr>
-          <p:cNvPr id="1181559285" name="Text 12"/>
+          <p:cNvPr id="1467830058" name="Text 12"/>
           <p:cNvSpPr/>
           <p:nvPr/>
         </p:nvSpPr>

</xml_diff>

<commit_message>
docs: align all artifacts with village RE plan + 交付金 funding route
Roll the Mitsue Village RE Plan (御杖村再エネ導入最大化計画, Jan 2025) alignment through core docs, EVM/WBS, government/community, outreach, stakeholders, brochures, and presentations (EN+JP). Biomass CHP stays primary; the village-led 地域脱炭素移行・再エネ推進交付金 (2/3–3/4, via village) is added as a named gap-closer. Adds alignment docs (EN+JP), clean plan translation, and the Sonnet execution brief. OpenProject WPs updated separately via API; presentations' .pptx updated (PDF re-export pending PowerPoint).

Co-Authored-By: Claude Opus 4.8 <noreply@anthropic.com>
</commit_message>
<xml_diff>
--- a/Mitsue Project Presentation - 日本語.pptx
+++ b/Mitsue Project Presentation - 日本語.pptx
@@ -5,7 +5,7 @@
     <p:sldMasterId id="2147483648" r:id="rId1"/>
   </p:sldMasterIdLst>
   <p:notesMasterIdLst>
-    <p:notesMasterId r:id="rId15"/>
+    <p:notesMasterId r:id="rId16"/>
   </p:notesMasterIdLst>
   <p:sldIdLst>
     <p:sldId id="256" r:id="rId4"/>
@@ -19,6 +19,7 @@
     <p:sldId id="264" r:id="rId12"/>
     <p:sldId id="265" r:id="rId13"/>
     <p:sldId id="266" r:id="rId14"/>
+    <p:sldId id="267" r:id="rId15"/>
   </p:sldIdLst>
   <p:sldSz cx="18288000" cy="10287000"/>
   <p:notesSz cx="10287000" cy="18288000"/>
@@ -44,7 +45,7 @@
       </p:grpSpPr>
       <p:sp>
         <p:nvSpPr>
-          <p:cNvPr id="294604861" name="PlaceHolder 1"/>
+          <p:cNvPr id="474464368" name="PlaceHolder 1"/>
           <p:cNvSpPr>
             <a:spLocks noGrp="1"/>
           </p:cNvSpPr>
@@ -93,7 +94,7 @@
       </p:sp>
       <p:sp>
         <p:nvSpPr>
-          <p:cNvPr id="564233237" name="PlaceHolder 2"/>
+          <p:cNvPr id="1212008970" name="PlaceHolder 2"/>
           <p:cNvSpPr>
             <a:spLocks noGrp="1"/>
           </p:cNvSpPr>
@@ -143,7 +144,7 @@
       </p:sp>
       <p:sp>
         <p:nvSpPr>
-          <p:cNvPr id="477663182" name="PlaceHolder 3"/>
+          <p:cNvPr id="406563221" name="PlaceHolder 3"/>
           <p:cNvSpPr>
             <a:spLocks noGrp="1"/>
           </p:cNvSpPr>
@@ -193,7 +194,7 @@
       </p:sp>
       <p:sp>
         <p:nvSpPr>
-          <p:cNvPr id="437754593" name="PlaceHolder 4"/>
+          <p:cNvPr id="220124868" name="PlaceHolder 4"/>
           <p:cNvSpPr>
             <a:spLocks noGrp="1"/>
           </p:cNvSpPr>
@@ -254,7 +255,7 @@
       </p:sp>
       <p:sp>
         <p:nvSpPr>
-          <p:cNvPr id="99097040" name="PlaceHolder 5"/>
+          <p:cNvPr id="1271616834" name="PlaceHolder 5"/>
           <p:cNvSpPr>
             <a:spLocks noGrp="1"/>
           </p:cNvSpPr>
@@ -315,7 +316,7 @@
       </p:sp>
       <p:sp>
         <p:nvSpPr>
-          <p:cNvPr id="11205150" name="PlaceHolder 6"/>
+          <p:cNvPr id="566903743" name="PlaceHolder 6"/>
           <p:cNvSpPr>
             <a:spLocks noGrp="1"/>
           </p:cNvSpPr>
@@ -399,7 +400,7 @@
       </p:grpSpPr>
       <p:sp>
         <p:nvSpPr>
-          <p:cNvPr id="1644009152" name="PlaceHolder 1"/>
+          <p:cNvPr id="1148764543" name="PlaceHolder 1"/>
           <p:cNvSpPr>
             <a:spLocks noGrp="1"/>
           </p:cNvSpPr>
@@ -422,7 +423,7 @@
       </p:sp>
       <p:sp>
         <p:nvSpPr>
-          <p:cNvPr id="1351841254" name="PlaceHolder 2"/>
+          <p:cNvPr id="292579712" name="PlaceHolder 2"/>
           <p:cNvSpPr>
             <a:spLocks noGrp="1"/>
           </p:cNvSpPr>
@@ -529,7 +530,7 @@
       </p:sp>
       <p:sp>
         <p:nvSpPr>
-          <p:cNvPr id="33546514" name="PlaceHolder 3"/>
+          <p:cNvPr id="1223126254" name="PlaceHolder 3"/>
           <p:cNvSpPr>
             <a:spLocks noGrp="1"/>
           </p:cNvSpPr>
@@ -623,7 +624,7 @@
       </p:grpSpPr>
       <p:sp>
         <p:nvSpPr>
-          <p:cNvPr id="518145258" name="PlaceHolder 1"/>
+          <p:cNvPr id="1484771320" name="PlaceHolder 1"/>
           <p:cNvSpPr>
             <a:spLocks noGrp="1"/>
           </p:cNvSpPr>
@@ -646,7 +647,7 @@
       </p:sp>
       <p:sp>
         <p:nvSpPr>
-          <p:cNvPr id="84616943" name="PlaceHolder 2"/>
+          <p:cNvPr id="1728178874" name="PlaceHolder 2"/>
           <p:cNvSpPr>
             <a:spLocks noGrp="1"/>
           </p:cNvSpPr>
@@ -753,7 +754,7 @@
       </p:sp>
       <p:sp>
         <p:nvSpPr>
-          <p:cNvPr id="901081253" name="PlaceHolder 3"/>
+          <p:cNvPr id="1033826964" name="PlaceHolder 3"/>
           <p:cNvSpPr>
             <a:spLocks noGrp="1"/>
           </p:cNvSpPr>
@@ -847,7 +848,92 @@
       </p:grpSpPr>
       <p:sp>
         <p:nvSpPr>
-          <p:cNvPr id="2000092283" name="PlaceHolder 1"/>
+          <p:cNvPr id="2" name="Slide Image Placeholder 1"/>
+          <p:cNvSpPr>
+            <a:spLocks noChangeAspect="1" noGrp="1" noRot="1"/>
+          </p:cNvSpPr>
+          <p:nvPr>
+            <p:ph type="sldImg"/>
+          </p:nvPr>
+        </p:nvSpPr>
+        <p:spPr bwMode="auto"/>
+      </p:sp>
+      <p:sp>
+        <p:nvSpPr>
+          <p:cNvPr id="3" name="Notes Placeholder 2"/>
+          <p:cNvSpPr>
+            <a:spLocks noGrp="1"/>
+          </p:cNvSpPr>
+          <p:nvPr>
+            <p:ph type="body" idx="1"/>
+          </p:nvPr>
+        </p:nvSpPr>
+        <p:spPr bwMode="auto"/>
+        <p:txBody>
+          <a:bodyPr/>
+          <a:lstStyle/>
+          <a:p>
+            <a:pPr>
+              <a:defRPr/>
+            </a:pPr>
+            <a:endParaRPr/>
+          </a:p>
+        </p:txBody>
+      </p:sp>
+      <p:sp>
+        <p:nvSpPr>
+          <p:cNvPr id="4" name="Slide Number Placeholder 3"/>
+          <p:cNvSpPr>
+            <a:spLocks noGrp="1"/>
+          </p:cNvSpPr>
+          <p:nvPr>
+            <p:ph type="sldNum" sz="quarter" idx="10"/>
+          </p:nvPr>
+        </p:nvSpPr>
+        <p:spPr bwMode="auto"/>
+        <p:txBody>
+          <a:bodyPr/>
+          <a:lstStyle/>
+          <a:p>
+            <a:pPr>
+              <a:defRPr/>
+            </a:pPr>
+            <a:fld id="{AC3AF0FB-5DD0-D5F8-4FC6-3AFBDDD4867B}" type="slidenum">
+              <a:rPr/>
+              <a:t/>
+            </a:fld>
+            <a:endParaRPr/>
+          </a:p>
+        </p:txBody>
+      </p:sp>
+    </p:spTree>
+  </p:cSld>
+  <p:clrMapOvr>
+    <a:masterClrMapping/>
+  </p:clrMapOvr>
+</p:notes>
+</file>
+
+<file path=ppt/notesSlides/notesSlide12.xml><?xml version="1.0" encoding="utf-8"?>
+<p:notes xmlns:a="http://schemas.openxmlformats.org/drawingml/2006/main" xmlns:r="http://schemas.openxmlformats.org/officeDocument/2006/relationships" xmlns:p="http://schemas.openxmlformats.org/presentationml/2006/main" xmlns:m="http://schemas.openxmlformats.org/officeDocument/2006/math" xmlns:w="http://schemas.openxmlformats.org/wordprocessingml/2006/main">
+  <p:cSld name="">
+    <p:spTree>
+      <p:nvGrpSpPr>
+        <p:cNvPr id="1" name=""/>
+        <p:cNvGrpSpPr/>
+        <p:nvPr/>
+      </p:nvGrpSpPr>
+      <p:grpSpPr bwMode="auto">
+        <a:xfrm>
+          <a:off x="0" y="0"/>
+          <a:ext cx="0" cy="0"/>
+          <a:chOff x="0" y="0"/>
+          <a:chExt cx="0" cy="0"/>
+        </a:xfrm>
+      </p:grpSpPr>
+      <p:sp>
+        <p:nvSpPr>
+          <p:cNvPr id="2112575390" name="PlaceHolder 1"/>
           <p:cNvSpPr>
             <a:spLocks noGrp="1"/>
           </p:cNvSpPr>
@@ -870,7 +956,7 @@
       </p:sp>
       <p:sp>
         <p:nvSpPr>
-          <p:cNvPr id="1441880656" name="PlaceHolder 2"/>
+          <p:cNvPr id="144776969" name="PlaceHolder 2"/>
           <p:cNvSpPr>
             <a:spLocks noGrp="1"/>
           </p:cNvSpPr>
@@ -959,7 +1045,7 @@
       </p:sp>
       <p:sp>
         <p:nvSpPr>
-          <p:cNvPr id="421292214" name="PlaceHolder 3"/>
+          <p:cNvPr id="1653232828" name="PlaceHolder 3"/>
           <p:cNvSpPr>
             <a:spLocks noGrp="1"/>
           </p:cNvSpPr>
@@ -1053,7 +1139,7 @@
       </p:grpSpPr>
       <p:sp>
         <p:nvSpPr>
-          <p:cNvPr id="1675644118" name="PlaceHolder 1"/>
+          <p:cNvPr id="1683102921" name="PlaceHolder 1"/>
           <p:cNvSpPr>
             <a:spLocks noGrp="1"/>
           </p:cNvSpPr>
@@ -1076,7 +1162,7 @@
       </p:sp>
       <p:sp>
         <p:nvSpPr>
-          <p:cNvPr id="1612828889" name="PlaceHolder 2"/>
+          <p:cNvPr id="164072909" name="PlaceHolder 2"/>
           <p:cNvSpPr>
             <a:spLocks noGrp="1"/>
           </p:cNvSpPr>
@@ -1147,7 +1233,7 @@
       </p:sp>
       <p:sp>
         <p:nvSpPr>
-          <p:cNvPr id="1142676710" name="PlaceHolder 3"/>
+          <p:cNvPr id="540368441" name="PlaceHolder 3"/>
           <p:cNvSpPr>
             <a:spLocks noGrp="1"/>
           </p:cNvSpPr>
@@ -1241,7 +1327,7 @@
       </p:grpSpPr>
       <p:sp>
         <p:nvSpPr>
-          <p:cNvPr id="456172479" name="PlaceHolder 1"/>
+          <p:cNvPr id="114105337" name="PlaceHolder 1"/>
           <p:cNvSpPr>
             <a:spLocks noGrp="1"/>
           </p:cNvSpPr>
@@ -1264,7 +1350,7 @@
       </p:sp>
       <p:sp>
         <p:nvSpPr>
-          <p:cNvPr id="1437364269" name="PlaceHolder 2"/>
+          <p:cNvPr id="906915812" name="PlaceHolder 2"/>
           <p:cNvSpPr>
             <a:spLocks noGrp="1"/>
           </p:cNvSpPr>
@@ -1353,7 +1439,7 @@
       </p:sp>
       <p:sp>
         <p:nvSpPr>
-          <p:cNvPr id="1602422303" name="PlaceHolder 3"/>
+          <p:cNvPr id="90151720" name="PlaceHolder 3"/>
           <p:cNvSpPr>
             <a:spLocks noGrp="1"/>
           </p:cNvSpPr>
@@ -1447,7 +1533,7 @@
       </p:grpSpPr>
       <p:sp>
         <p:nvSpPr>
-          <p:cNvPr id="322539848" name="PlaceHolder 1"/>
+          <p:cNvPr id="1477472835" name="PlaceHolder 1"/>
           <p:cNvSpPr>
             <a:spLocks noGrp="1"/>
           </p:cNvSpPr>
@@ -1470,7 +1556,7 @@
       </p:sp>
       <p:sp>
         <p:nvSpPr>
-          <p:cNvPr id="1396194268" name="PlaceHolder 2"/>
+          <p:cNvPr id="866797242" name="PlaceHolder 2"/>
           <p:cNvSpPr>
             <a:spLocks noGrp="1"/>
           </p:cNvSpPr>
@@ -1559,7 +1645,7 @@
       </p:sp>
       <p:sp>
         <p:nvSpPr>
-          <p:cNvPr id="378677349" name="PlaceHolder 3"/>
+          <p:cNvPr id="1235559022" name="PlaceHolder 3"/>
           <p:cNvSpPr>
             <a:spLocks noGrp="1"/>
           </p:cNvSpPr>
@@ -1653,7 +1739,7 @@
       </p:grpSpPr>
       <p:sp>
         <p:nvSpPr>
-          <p:cNvPr id="1739135960" name="PlaceHolder 1"/>
+          <p:cNvPr id="1313190089" name="PlaceHolder 1"/>
           <p:cNvSpPr>
             <a:spLocks noGrp="1"/>
           </p:cNvSpPr>
@@ -1676,7 +1762,7 @@
       </p:sp>
       <p:sp>
         <p:nvSpPr>
-          <p:cNvPr id="2060867458" name="PlaceHolder 2"/>
+          <p:cNvPr id="1728347983" name="PlaceHolder 2"/>
           <p:cNvSpPr>
             <a:spLocks noGrp="1"/>
           </p:cNvSpPr>
@@ -1783,7 +1869,7 @@
       </p:sp>
       <p:sp>
         <p:nvSpPr>
-          <p:cNvPr id="970390403" name="PlaceHolder 3"/>
+          <p:cNvPr id="1611860891" name="PlaceHolder 3"/>
           <p:cNvSpPr>
             <a:spLocks noGrp="1"/>
           </p:cNvSpPr>
@@ -1877,7 +1963,7 @@
       </p:grpSpPr>
       <p:sp>
         <p:nvSpPr>
-          <p:cNvPr id="1256436520" name="PlaceHolder 1"/>
+          <p:cNvPr id="936556065" name="PlaceHolder 1"/>
           <p:cNvSpPr>
             <a:spLocks noGrp="1"/>
           </p:cNvSpPr>
@@ -1900,7 +1986,7 @@
       </p:sp>
       <p:sp>
         <p:nvSpPr>
-          <p:cNvPr id="2083170079" name="PlaceHolder 2"/>
+          <p:cNvPr id="1858776002" name="PlaceHolder 2"/>
           <p:cNvSpPr>
             <a:spLocks noGrp="1"/>
           </p:cNvSpPr>
@@ -1971,7 +2057,7 @@
       </p:sp>
       <p:sp>
         <p:nvSpPr>
-          <p:cNvPr id="72588911" name="PlaceHolder 3"/>
+          <p:cNvPr id="1736634144" name="PlaceHolder 3"/>
           <p:cNvSpPr>
             <a:spLocks noGrp="1"/>
           </p:cNvSpPr>
@@ -2065,7 +2151,7 @@
       </p:grpSpPr>
       <p:sp>
         <p:nvSpPr>
-          <p:cNvPr id="1502679641" name="PlaceHolder 1"/>
+          <p:cNvPr id="753684879" name="PlaceHolder 1"/>
           <p:cNvSpPr>
             <a:spLocks noGrp="1"/>
           </p:cNvSpPr>
@@ -2088,7 +2174,7 @@
       </p:sp>
       <p:sp>
         <p:nvSpPr>
-          <p:cNvPr id="745449383" name="PlaceHolder 2"/>
+          <p:cNvPr id="843157048" name="PlaceHolder 2"/>
           <p:cNvSpPr>
             <a:spLocks noGrp="1"/>
           </p:cNvSpPr>
@@ -2159,7 +2245,7 @@
       </p:sp>
       <p:sp>
         <p:nvSpPr>
-          <p:cNvPr id="1755066038" name="PlaceHolder 3"/>
+          <p:cNvPr id="725356437" name="PlaceHolder 3"/>
           <p:cNvSpPr>
             <a:spLocks noGrp="1"/>
           </p:cNvSpPr>
@@ -2253,7 +2339,7 @@
       </p:grpSpPr>
       <p:sp>
         <p:nvSpPr>
-          <p:cNvPr id="1706231782" name="PlaceHolder 1"/>
+          <p:cNvPr id="362995743" name="PlaceHolder 1"/>
           <p:cNvSpPr>
             <a:spLocks noGrp="1"/>
           </p:cNvSpPr>
@@ -2276,7 +2362,7 @@
       </p:sp>
       <p:sp>
         <p:nvSpPr>
-          <p:cNvPr id="1719961001" name="PlaceHolder 2"/>
+          <p:cNvPr id="413230053" name="PlaceHolder 2"/>
           <p:cNvSpPr>
             <a:spLocks noGrp="1"/>
           </p:cNvSpPr>
@@ -2347,7 +2433,7 @@
       </p:sp>
       <p:sp>
         <p:nvSpPr>
-          <p:cNvPr id="111054837" name="PlaceHolder 3"/>
+          <p:cNvPr id="1838084281" name="PlaceHolder 3"/>
           <p:cNvSpPr>
             <a:spLocks noGrp="1"/>
           </p:cNvSpPr>
@@ -2441,7 +2527,7 @@
       </p:grpSpPr>
       <p:sp>
         <p:nvSpPr>
-          <p:cNvPr id="1127562183" name="PlaceHolder 1"/>
+          <p:cNvPr id="1847243908" name="PlaceHolder 1"/>
           <p:cNvSpPr>
             <a:spLocks noGrp="1"/>
           </p:cNvSpPr>
@@ -2464,7 +2550,7 @@
       </p:sp>
       <p:sp>
         <p:nvSpPr>
-          <p:cNvPr id="564359513" name="PlaceHolder 2"/>
+          <p:cNvPr id="1190904952" name="PlaceHolder 2"/>
           <p:cNvSpPr>
             <a:spLocks noGrp="1"/>
           </p:cNvSpPr>
@@ -2589,7 +2675,7 @@
       </p:sp>
       <p:sp>
         <p:nvSpPr>
-          <p:cNvPr id="386954311" name="PlaceHolder 3"/>
+          <p:cNvPr id="975213600" name="PlaceHolder 3"/>
           <p:cNvSpPr>
             <a:spLocks noGrp="1"/>
           </p:cNvSpPr>
@@ -2715,7 +2801,7 @@
       </p:grpSpPr>
       <p:sp>
         <p:nvSpPr>
-          <p:cNvPr id="92704070" name="PlaceHolder 1"/>
+          <p:cNvPr id="942112972" name="PlaceHolder 1"/>
           <p:cNvSpPr>
             <a:spLocks noGrp="1"/>
           </p:cNvSpPr>
@@ -2785,7 +2871,7 @@
       </p:sp>
       <p:sp>
         <p:nvSpPr>
-          <p:cNvPr id="1761809761" name="PlaceHolder 2"/>
+          <p:cNvPr id="280821485" name="PlaceHolder 2"/>
           <p:cNvSpPr>
             <a:spLocks noGrp="1"/>
           </p:cNvSpPr>
@@ -3171,7 +3257,7 @@
       </p:grpSpPr>
       <p:sp>
         <p:nvSpPr>
-          <p:cNvPr id="1621578403" name="Shape 0"/>
+          <p:cNvPr id="2061980885" name="Shape 0"/>
           <p:cNvSpPr/>
           <p:nvPr/>
         </p:nvSpPr>
@@ -3215,7 +3301,7 @@
       </p:sp>
       <p:sp>
         <p:nvSpPr>
-          <p:cNvPr id="1721350262" name="Text 1"/>
+          <p:cNvPr id="1309409602" name="Text 1"/>
           <p:cNvSpPr/>
           <p:nvPr/>
         </p:nvSpPr>
@@ -3273,7 +3359,7 @@
       </p:sp>
       <p:sp>
         <p:nvSpPr>
-          <p:cNvPr id="1812411050" name="Text 2"/>
+          <p:cNvPr id="1207650316" name="Text 2"/>
           <p:cNvSpPr/>
           <p:nvPr/>
         </p:nvSpPr>
@@ -3331,7 +3417,7 @@
       </p:sp>
       <p:sp>
         <p:nvSpPr>
-          <p:cNvPr id="982168404" name="Text 3"/>
+          <p:cNvPr id="1462407034" name="Text 3"/>
           <p:cNvSpPr/>
           <p:nvPr/>
         </p:nvSpPr>
@@ -3469,7 +3555,7 @@
       </p:sp>
       <p:sp>
         <p:nvSpPr>
-          <p:cNvPr id="1089769332" name="Text 4"/>
+          <p:cNvPr id="1122683357" name="Text 4"/>
           <p:cNvSpPr/>
           <p:nvPr/>
         </p:nvSpPr>
@@ -3547,7 +3633,7 @@
       </p:sp>
       <p:sp>
         <p:nvSpPr>
-          <p:cNvPr id="339785271" name="Text 5"/>
+          <p:cNvPr id="1605923894" name="Text 5"/>
           <p:cNvSpPr/>
           <p:nvPr/>
         </p:nvSpPr>
@@ -3615,7 +3701,7 @@
       </p:sp>
       <p:sp>
         <p:nvSpPr>
-          <p:cNvPr id="1238795058" name="Text 6"/>
+          <p:cNvPr id="1812504890" name="Text 6"/>
           <p:cNvSpPr/>
           <p:nvPr/>
         </p:nvSpPr>
@@ -3673,7 +3759,7 @@
       </p:sp>
       <p:pic>
         <p:nvPicPr>
-          <p:cNvPr id="115836495" name="Image 0" descr="preencoded.png"/>
+          <p:cNvPr id="312189902" name="Image 0" descr="preencoded.png"/>
           <p:cNvPicPr/>
           <p:nvPr/>
         </p:nvPicPr>
@@ -3697,7 +3783,7 @@
       </p:pic>
       <p:sp>
         <p:nvSpPr>
-          <p:cNvPr id="1171554852" name="Text 7"/>
+          <p:cNvPr id="1518509703" name="Text 7"/>
           <p:cNvSpPr/>
           <p:nvPr/>
         </p:nvSpPr>
@@ -3755,7 +3841,7 @@
       </p:sp>
       <p:sp>
         <p:nvSpPr>
-          <p:cNvPr id="896286411" name="Text 8"/>
+          <p:cNvPr id="1392562113" name="Text 8"/>
           <p:cNvSpPr/>
           <p:nvPr/>
         </p:nvSpPr>
@@ -3883,7 +3969,7 @@
       </p:grpSpPr>
       <p:sp>
         <p:nvSpPr>
-          <p:cNvPr id="1168522280" name="Shape 0"/>
+          <p:cNvPr id="826795135" name="Shape 0"/>
           <p:cNvSpPr/>
           <p:nvPr/>
         </p:nvSpPr>
@@ -3927,7 +4013,7 @@
       </p:sp>
       <p:sp>
         <p:nvSpPr>
-          <p:cNvPr id="1956532926" name="Text 1"/>
+          <p:cNvPr id="1669995564" name="Text 1"/>
           <p:cNvSpPr/>
           <p:nvPr/>
         </p:nvSpPr>
@@ -3985,7 +4071,7 @@
       </p:sp>
       <p:sp>
         <p:nvSpPr>
-          <p:cNvPr id="847783222" name="Text 2"/>
+          <p:cNvPr id="1701677850" name="Text 2"/>
           <p:cNvSpPr/>
           <p:nvPr/>
         </p:nvSpPr>
@@ -4043,7 +4129,7 @@
       </p:sp>
       <p:sp>
         <p:nvSpPr>
-          <p:cNvPr id="992690375" name="Text 3"/>
+          <p:cNvPr id="106396219" name="Text 3"/>
           <p:cNvSpPr/>
           <p:nvPr/>
         </p:nvSpPr>
@@ -4111,7 +4197,7 @@
       </p:sp>
       <p:sp>
         <p:nvSpPr>
-          <p:cNvPr id="930047618" name="Text 4"/>
+          <p:cNvPr id="361156982" name="Text 4"/>
           <p:cNvSpPr/>
           <p:nvPr/>
         </p:nvSpPr>
@@ -4189,7 +4275,7 @@
       </p:sp>
       <p:sp>
         <p:nvSpPr>
-          <p:cNvPr id="871699349" name="Text 5"/>
+          <p:cNvPr id="771307319" name="Text 5"/>
           <p:cNvSpPr/>
           <p:nvPr/>
         </p:nvSpPr>
@@ -4247,7 +4333,7 @@
       </p:sp>
       <p:sp>
         <p:nvSpPr>
-          <p:cNvPr id="269950831" name="Shape 6"/>
+          <p:cNvPr id="216800741" name="Shape 6"/>
           <p:cNvSpPr/>
           <p:nvPr/>
         </p:nvSpPr>
@@ -4294,7 +4380,7 @@
       </p:sp>
       <p:sp>
         <p:nvSpPr>
-          <p:cNvPr id="739628669" name="Text 7"/>
+          <p:cNvPr id="1033510372" name="Text 7"/>
           <p:cNvSpPr/>
           <p:nvPr/>
         </p:nvSpPr>
@@ -4402,7 +4488,7 @@
       </p:sp>
       <p:sp>
         <p:nvSpPr>
-          <p:cNvPr id="2120340319" name="Text 8"/>
+          <p:cNvPr id="678180236" name="Text 8"/>
           <p:cNvSpPr/>
           <p:nvPr/>
         </p:nvSpPr>
@@ -4460,7 +4546,7 @@
       </p:sp>
       <p:sp>
         <p:nvSpPr>
-          <p:cNvPr id="569172326" name="Text 9"/>
+          <p:cNvPr id="1938946004" name="Text 9"/>
           <p:cNvSpPr/>
           <p:nvPr/>
         </p:nvSpPr>
@@ -4568,7 +4654,7 @@
       </p:sp>
       <p:sp>
         <p:nvSpPr>
-          <p:cNvPr id="1452356530" name="Shape 10"/>
+          <p:cNvPr id="1146355012" name="Shape 10"/>
           <p:cNvSpPr/>
           <p:nvPr/>
         </p:nvSpPr>
@@ -4615,7 +4701,7 @@
       </p:sp>
       <p:sp>
         <p:nvSpPr>
-          <p:cNvPr id="1756266922" name="Text 11"/>
+          <p:cNvPr id="622563737" name="Text 11"/>
           <p:cNvSpPr/>
           <p:nvPr/>
         </p:nvSpPr>
@@ -4693,7 +4779,7 @@
       </p:sp>
       <p:sp>
         <p:nvSpPr>
-          <p:cNvPr id="1201799498" name="Text 12"/>
+          <p:cNvPr id="1480112825" name="Text 12"/>
           <p:cNvSpPr/>
           <p:nvPr/>
         </p:nvSpPr>
@@ -4751,7 +4837,7 @@
       </p:sp>
       <p:sp>
         <p:nvSpPr>
-          <p:cNvPr id="932686163" name="Text 13"/>
+          <p:cNvPr id="156899430" name="Text 13"/>
           <p:cNvSpPr/>
           <p:nvPr/>
         </p:nvSpPr>
@@ -4849,7 +4935,7 @@
       </p:sp>
       <p:sp>
         <p:nvSpPr>
-          <p:cNvPr id="1702947435" name="Shape 14"/>
+          <p:cNvPr id="314553532" name="Shape 14"/>
           <p:cNvSpPr/>
           <p:nvPr/>
         </p:nvSpPr>
@@ -4896,7 +4982,7 @@
       </p:sp>
       <p:sp>
         <p:nvSpPr>
-          <p:cNvPr id="513126716" name="Text 15"/>
+          <p:cNvPr id="1255941100" name="Text 15"/>
           <p:cNvSpPr/>
           <p:nvPr/>
         </p:nvSpPr>
@@ -4974,7 +5060,7 @@
       </p:sp>
       <p:sp>
         <p:nvSpPr>
-          <p:cNvPr id="1416626192" name="Text 16"/>
+          <p:cNvPr id="2062826141" name="Text 16"/>
           <p:cNvSpPr/>
           <p:nvPr/>
         </p:nvSpPr>
@@ -5032,7 +5118,7 @@
       </p:sp>
       <p:sp>
         <p:nvSpPr>
-          <p:cNvPr id="1025559051" name="Text 17"/>
+          <p:cNvPr id="1107153712" name="Text 17"/>
           <p:cNvSpPr/>
           <p:nvPr/>
         </p:nvSpPr>
@@ -5130,7 +5216,7 @@
       </p:sp>
       <p:sp>
         <p:nvSpPr>
-          <p:cNvPr id="1216885097" name="Shape 18"/>
+          <p:cNvPr id="1472733376" name="Shape 18"/>
           <p:cNvSpPr/>
           <p:nvPr/>
         </p:nvSpPr>
@@ -5177,7 +5263,7 @@
       </p:sp>
       <p:sp>
         <p:nvSpPr>
-          <p:cNvPr id="2114946139" name="Text 19"/>
+          <p:cNvPr id="1142254478" name="Text 19"/>
           <p:cNvSpPr/>
           <p:nvPr/>
         </p:nvSpPr>
@@ -5255,7 +5341,7 @@
       </p:sp>
       <p:sp>
         <p:nvSpPr>
-          <p:cNvPr id="642712425" name="Text 20"/>
+          <p:cNvPr id="1570316932" name="Text 20"/>
           <p:cNvSpPr/>
           <p:nvPr/>
         </p:nvSpPr>
@@ -5313,7 +5399,7 @@
       </p:sp>
       <p:sp>
         <p:nvSpPr>
-          <p:cNvPr id="331462764" name="Text 21"/>
+          <p:cNvPr id="32413668" name="Text 21"/>
           <p:cNvSpPr/>
           <p:nvPr/>
         </p:nvSpPr>
@@ -5411,7 +5497,7 @@
       </p:sp>
       <p:sp>
         <p:nvSpPr>
-          <p:cNvPr id="2076120625" name="Shape 22"/>
+          <p:cNvPr id="42887861" name="Shape 22"/>
           <p:cNvSpPr/>
           <p:nvPr/>
         </p:nvSpPr>
@@ -5458,7 +5544,7 @@
       </p:sp>
       <p:sp>
         <p:nvSpPr>
-          <p:cNvPr id="326732685" name="Text 23"/>
+          <p:cNvPr id="158416612" name="Text 23"/>
           <p:cNvSpPr/>
           <p:nvPr/>
         </p:nvSpPr>
@@ -5536,7 +5622,7 @@
       </p:sp>
       <p:sp>
         <p:nvSpPr>
-          <p:cNvPr id="1682596808" name="Text 24"/>
+          <p:cNvPr id="1048764473" name="Text 24"/>
           <p:cNvSpPr/>
           <p:nvPr/>
         </p:nvSpPr>
@@ -5594,7 +5680,7 @@
       </p:sp>
       <p:sp>
         <p:nvSpPr>
-          <p:cNvPr id="1689171855" name="Text 25"/>
+          <p:cNvPr id="1250018482" name="Text 25"/>
           <p:cNvSpPr/>
           <p:nvPr/>
         </p:nvSpPr>
@@ -5662,7 +5748,7 @@
       </p:sp>
       <p:sp>
         <p:nvSpPr>
-          <p:cNvPr id="448649583" name="Text 26"/>
+          <p:cNvPr id="502625562" name="Text 26"/>
           <p:cNvSpPr/>
           <p:nvPr/>
         </p:nvSpPr>
@@ -5720,7 +5806,7 @@
       </p:sp>
       <p:sp>
         <p:nvSpPr>
-          <p:cNvPr id="1284850120" name="Text 27"/>
+          <p:cNvPr id="55536897" name="Text 27"/>
           <p:cNvSpPr/>
           <p:nvPr/>
         </p:nvSpPr>
@@ -5778,7 +5864,7 @@
       </p:sp>
       <p:sp>
         <p:nvSpPr>
-          <p:cNvPr id="441838751" name="Text 28"/>
+          <p:cNvPr id="160859227" name="Text 28"/>
           <p:cNvSpPr/>
           <p:nvPr/>
         </p:nvSpPr>
@@ -5836,7 +5922,7 @@
       </p:sp>
       <p:sp>
         <p:nvSpPr>
-          <p:cNvPr id="1024005534" name="Text 29"/>
+          <p:cNvPr id="1131552028" name="Text 29"/>
           <p:cNvSpPr/>
           <p:nvPr/>
         </p:nvSpPr>
@@ -5904,7 +5990,7 @@
       </p:sp>
       <p:sp>
         <p:nvSpPr>
-          <p:cNvPr id="1455515365" name="Text 30"/>
+          <p:cNvPr id="748534737" name="Text 30"/>
           <p:cNvSpPr/>
           <p:nvPr/>
         </p:nvSpPr>
@@ -5992,7 +6078,7 @@
       </p:sp>
       <p:sp>
         <p:nvSpPr>
-          <p:cNvPr id="739741437" name="Shape 31"/>
+          <p:cNvPr id="1911637998" name="Shape 31"/>
           <p:cNvSpPr/>
           <p:nvPr/>
         </p:nvSpPr>
@@ -6036,7 +6122,7 @@
       </p:sp>
       <p:sp>
         <p:nvSpPr>
-          <p:cNvPr id="1731245722" name="Text 32"/>
+          <p:cNvPr id="100224088" name="Text 32"/>
           <p:cNvSpPr/>
           <p:nvPr/>
         </p:nvSpPr>
@@ -6094,7 +6180,7 @@
       </p:sp>
       <p:sp>
         <p:nvSpPr>
-          <p:cNvPr id="1750879334" name="Text 33"/>
+          <p:cNvPr id="1174621260" name="Text 33"/>
           <p:cNvSpPr/>
           <p:nvPr/>
         </p:nvSpPr>
@@ -6152,7 +6238,7 @@
       </p:sp>
       <p:sp>
         <p:nvSpPr>
-          <p:cNvPr id="1736926084" name="Text 34"/>
+          <p:cNvPr id="1457054681" name="Text 34"/>
           <p:cNvSpPr/>
           <p:nvPr/>
         </p:nvSpPr>
@@ -6220,7 +6306,7 @@
       </p:sp>
       <p:sp>
         <p:nvSpPr>
-          <p:cNvPr id="973696983" name="Text 35"/>
+          <p:cNvPr id="1936047628" name="Text 35"/>
           <p:cNvSpPr/>
           <p:nvPr/>
         </p:nvSpPr>
@@ -6288,7 +6374,7 @@
       </p:sp>
       <p:sp>
         <p:nvSpPr>
-          <p:cNvPr id="110159385" name="Shape 36"/>
+          <p:cNvPr id="1930694332" name="Shape 36"/>
           <p:cNvSpPr/>
           <p:nvPr/>
         </p:nvSpPr>
@@ -6334,7 +6420,7 @@
       </p:sp>
       <p:sp>
         <p:nvSpPr>
-          <p:cNvPr id="1379994335" name="Text 37"/>
+          <p:cNvPr id="1004715848" name="Text 37"/>
           <p:cNvSpPr/>
           <p:nvPr/>
         </p:nvSpPr>
@@ -6392,7 +6478,7 @@
       </p:sp>
       <p:sp>
         <p:nvSpPr>
-          <p:cNvPr id="901924047" name="Text 38"/>
+          <p:cNvPr id="1246142409" name="Text 38"/>
           <p:cNvSpPr/>
           <p:nvPr/>
         </p:nvSpPr>
@@ -6450,7 +6536,7 @@
       </p:sp>
       <p:sp>
         <p:nvSpPr>
-          <p:cNvPr id="1388925597" name="Text 39"/>
+          <p:cNvPr id="230568050" name="Text 39"/>
           <p:cNvSpPr/>
           <p:nvPr/>
         </p:nvSpPr>
@@ -6508,7 +6594,7 @@
       </p:sp>
       <p:sp>
         <p:nvSpPr>
-          <p:cNvPr id="1350152330" name="Text 40"/>
+          <p:cNvPr id="277611462" name="Text 40"/>
           <p:cNvSpPr/>
           <p:nvPr/>
         </p:nvSpPr>
@@ -6566,7 +6652,7 @@
       </p:sp>
       <p:sp>
         <p:nvSpPr>
-          <p:cNvPr id="1855788583" name="Shape 41"/>
+          <p:cNvPr id="749544622" name="Shape 41"/>
           <p:cNvSpPr/>
           <p:nvPr/>
         </p:nvSpPr>
@@ -6612,7 +6698,7 @@
       </p:sp>
       <p:sp>
         <p:nvSpPr>
-          <p:cNvPr id="178675538" name="Text 42"/>
+          <p:cNvPr id="99077319" name="Text 42"/>
           <p:cNvSpPr/>
           <p:nvPr/>
         </p:nvSpPr>
@@ -6670,7 +6756,7 @@
       </p:sp>
       <p:sp>
         <p:nvSpPr>
-          <p:cNvPr id="903588724" name="Text 43"/>
+          <p:cNvPr id="1600832" name="Text 43"/>
           <p:cNvSpPr/>
           <p:nvPr/>
         </p:nvSpPr>
@@ -6728,7 +6814,7 @@
       </p:sp>
       <p:sp>
         <p:nvSpPr>
-          <p:cNvPr id="763527347" name="Text 44"/>
+          <p:cNvPr id="1599232697" name="Text 44"/>
           <p:cNvSpPr/>
           <p:nvPr/>
         </p:nvSpPr>
@@ -6786,7 +6872,7 @@
       </p:sp>
       <p:sp>
         <p:nvSpPr>
-          <p:cNvPr id="985522155" name="Text 45"/>
+          <p:cNvPr id="1407417103" name="Text 45"/>
           <p:cNvSpPr/>
           <p:nvPr/>
         </p:nvSpPr>
@@ -6844,7 +6930,7 @@
       </p:sp>
       <p:sp>
         <p:nvSpPr>
-          <p:cNvPr id="839946929" name="Shape 46"/>
+          <p:cNvPr id="1524137504" name="Shape 46"/>
           <p:cNvSpPr/>
           <p:nvPr/>
         </p:nvSpPr>
@@ -6890,7 +6976,7 @@
       </p:sp>
       <p:sp>
         <p:nvSpPr>
-          <p:cNvPr id="1016362202" name="Text 47"/>
+          <p:cNvPr id="1173607991" name="Text 47"/>
           <p:cNvSpPr/>
           <p:nvPr/>
         </p:nvSpPr>
@@ -6948,7 +7034,7 @@
       </p:sp>
       <p:sp>
         <p:nvSpPr>
-          <p:cNvPr id="1799256594" name="Text 48"/>
+          <p:cNvPr id="311598484" name="Text 48"/>
           <p:cNvSpPr/>
           <p:nvPr/>
         </p:nvSpPr>
@@ -7006,7 +7092,7 @@
       </p:sp>
       <p:sp>
         <p:nvSpPr>
-          <p:cNvPr id="1208826639" name="Text 49"/>
+          <p:cNvPr id="350821692" name="Text 49"/>
           <p:cNvSpPr/>
           <p:nvPr/>
         </p:nvSpPr>
@@ -7064,7 +7150,7 @@
       </p:sp>
       <p:sp>
         <p:nvSpPr>
-          <p:cNvPr id="515625587" name="Text 50"/>
+          <p:cNvPr id="2095228400" name="Text 50"/>
           <p:cNvSpPr/>
           <p:nvPr/>
         </p:nvSpPr>
@@ -7122,7 +7208,7 @@
       </p:sp>
       <p:sp>
         <p:nvSpPr>
-          <p:cNvPr id="978389807" name="Shape 51"/>
+          <p:cNvPr id="1651408859" name="Shape 51"/>
           <p:cNvSpPr/>
           <p:nvPr/>
         </p:nvSpPr>
@@ -7168,7 +7254,7 @@
       </p:sp>
       <p:sp>
         <p:nvSpPr>
-          <p:cNvPr id="685024993" name="Text 52"/>
+          <p:cNvPr id="2292662" name="Text 52"/>
           <p:cNvSpPr/>
           <p:nvPr/>
         </p:nvSpPr>
@@ -7226,7 +7312,7 @@
       </p:sp>
       <p:sp>
         <p:nvSpPr>
-          <p:cNvPr id="2018820869" name="Text 53"/>
+          <p:cNvPr id="1793508249" name="Text 53"/>
           <p:cNvSpPr/>
           <p:nvPr/>
         </p:nvSpPr>
@@ -7284,7 +7370,7 @@
       </p:sp>
       <p:sp>
         <p:nvSpPr>
-          <p:cNvPr id="922336134" name="Text 54"/>
+          <p:cNvPr id="723762752" name="Text 54"/>
           <p:cNvSpPr/>
           <p:nvPr/>
         </p:nvSpPr>
@@ -7342,7 +7428,7 @@
       </p:sp>
       <p:sp>
         <p:nvSpPr>
-          <p:cNvPr id="998811619" name="Text 55"/>
+          <p:cNvPr id="1460699497" name="Text 55"/>
           <p:cNvSpPr/>
           <p:nvPr/>
         </p:nvSpPr>
@@ -7400,7 +7486,7 @@
       </p:sp>
       <p:sp>
         <p:nvSpPr>
-          <p:cNvPr id="54790400" name="Shape 56"/>
+          <p:cNvPr id="680836660" name="Shape 56"/>
           <p:cNvSpPr/>
           <p:nvPr/>
         </p:nvSpPr>
@@ -7446,7 +7532,7 @@
       </p:sp>
       <p:sp>
         <p:nvSpPr>
-          <p:cNvPr id="1713836872" name="Text 57"/>
+          <p:cNvPr id="1659179315" name="Text 57"/>
           <p:cNvSpPr/>
           <p:nvPr/>
         </p:nvSpPr>
@@ -7504,7 +7590,7 @@
       </p:sp>
       <p:sp>
         <p:nvSpPr>
-          <p:cNvPr id="341303249" name="Text 58"/>
+          <p:cNvPr id="1242423806" name="Text 58"/>
           <p:cNvSpPr/>
           <p:nvPr/>
         </p:nvSpPr>
@@ -7562,7 +7648,7 @@
       </p:sp>
       <p:sp>
         <p:nvSpPr>
-          <p:cNvPr id="1762383823" name="Text 59"/>
+          <p:cNvPr id="783455090" name="Text 59"/>
           <p:cNvSpPr/>
           <p:nvPr/>
         </p:nvSpPr>
@@ -7620,7 +7706,7 @@
       </p:sp>
       <p:sp>
         <p:nvSpPr>
-          <p:cNvPr id="181491160" name="Text 60"/>
+          <p:cNvPr id="1623836511" name="Text 60"/>
           <p:cNvSpPr/>
           <p:nvPr/>
         </p:nvSpPr>
@@ -7678,7 +7764,7 @@
       </p:sp>
       <p:sp>
         <p:nvSpPr>
-          <p:cNvPr id="1852344475" name="Text 61"/>
+          <p:cNvPr id="703468444" name="Text 61"/>
           <p:cNvSpPr/>
           <p:nvPr/>
         </p:nvSpPr>
@@ -7736,7 +7822,7 @@
       </p:sp>
       <p:sp>
         <p:nvSpPr>
-          <p:cNvPr id="784009581" name="Text 62"/>
+          <p:cNvPr id="1405418278" name="Text 62"/>
           <p:cNvSpPr/>
           <p:nvPr/>
         </p:nvSpPr>
@@ -7794,7 +7880,7 @@
       </p:sp>
       <p:sp>
         <p:nvSpPr>
-          <p:cNvPr id="41677004" name="Text 63"/>
+          <p:cNvPr id="1938937128" name="Text 63"/>
           <p:cNvSpPr/>
           <p:nvPr/>
         </p:nvSpPr>
@@ -7852,7 +7938,7 @@
       </p:sp>
       <p:sp>
         <p:nvSpPr>
-          <p:cNvPr id="1893354768" name="Text 64"/>
+          <p:cNvPr id="511447950" name="Text 64"/>
           <p:cNvSpPr/>
           <p:nvPr/>
         </p:nvSpPr>
@@ -7910,7 +7996,7 @@
       </p:sp>
       <p:sp>
         <p:nvSpPr>
-          <p:cNvPr id="1145831762" name="Text 65"/>
+          <p:cNvPr id="819101004" name="Text 65"/>
           <p:cNvSpPr/>
           <p:nvPr/>
         </p:nvSpPr>
@@ -7968,7 +8054,7 @@
       </p:sp>
       <p:sp>
         <p:nvSpPr>
-          <p:cNvPr id="1449669377" name="Text 66"/>
+          <p:cNvPr id="852892146" name="Text 66"/>
           <p:cNvSpPr/>
           <p:nvPr/>
         </p:nvSpPr>
@@ -8036,7 +8122,7 @@
       </p:sp>
       <p:sp>
         <p:nvSpPr>
-          <p:cNvPr id="413677408" name="Text 67"/>
+          <p:cNvPr id="487553628" name="Text 67"/>
           <p:cNvSpPr/>
           <p:nvPr/>
         </p:nvSpPr>
@@ -8104,7 +8190,7 @@
       </p:sp>
       <p:sp>
         <p:nvSpPr>
-          <p:cNvPr id="631411145" name="Text 68"/>
+          <p:cNvPr id="917022969" name="Text 68"/>
           <p:cNvSpPr/>
           <p:nvPr/>
         </p:nvSpPr>
@@ -8172,7 +8258,7 @@
       </p:sp>
       <p:sp>
         <p:nvSpPr>
-          <p:cNvPr id="960034234" name="Text 69"/>
+          <p:cNvPr id="133425682" name="Text 69"/>
           <p:cNvSpPr/>
           <p:nvPr/>
         </p:nvSpPr>
@@ -8240,7 +8326,7 @@
       </p:sp>
       <p:sp>
         <p:nvSpPr>
-          <p:cNvPr id="1070260513" name="Text 70"/>
+          <p:cNvPr id="1296541281" name="Text 70"/>
           <p:cNvSpPr/>
           <p:nvPr/>
         </p:nvSpPr>
@@ -8308,7 +8394,7 @@
       </p:sp>
       <p:sp>
         <p:nvSpPr>
-          <p:cNvPr id="1957294692" name="Text 71"/>
+          <p:cNvPr id="269330140" name="Text 71"/>
           <p:cNvSpPr/>
           <p:nvPr/>
         </p:nvSpPr>
@@ -8376,7 +8462,7 @@
       </p:sp>
       <p:sp>
         <p:nvSpPr>
-          <p:cNvPr id="1289630489" name="Text 72"/>
+          <p:cNvPr id="2111889543" name="Text 72"/>
           <p:cNvSpPr/>
           <p:nvPr/>
         </p:nvSpPr>
@@ -8434,7 +8520,7 @@
       </p:sp>
       <p:sp>
         <p:nvSpPr>
-          <p:cNvPr id="745567176" name="Text 73"/>
+          <p:cNvPr id="294291845" name="Text 73"/>
           <p:cNvSpPr/>
           <p:nvPr/>
         </p:nvSpPr>
@@ -8562,7 +8648,7 @@
       </p:grpSpPr>
       <p:sp>
         <p:nvSpPr>
-          <p:cNvPr id="1485813197" name="Shape 0"/>
+          <p:cNvPr id="976203814" name="Shape 0"/>
           <p:cNvSpPr/>
           <p:nvPr/>
         </p:nvSpPr>
@@ -8606,7 +8692,7 @@
       </p:sp>
       <p:sp>
         <p:nvSpPr>
-          <p:cNvPr id="126183597" name="Text 1"/>
+          <p:cNvPr id="45025121" name="Text 1"/>
           <p:cNvSpPr/>
           <p:nvPr/>
         </p:nvSpPr>
@@ -8664,7 +8750,7 @@
       </p:sp>
       <p:sp>
         <p:nvSpPr>
-          <p:cNvPr id="491116623" name="Text 2"/>
+          <p:cNvPr id="870632659" name="Text 2"/>
           <p:cNvSpPr/>
           <p:nvPr/>
         </p:nvSpPr>
@@ -8724,14 +8810,14 @@
       </p:sp>
       <p:sp>
         <p:nvSpPr>
-          <p:cNvPr id="2038090585" name="Text 3"/>
-          <p:cNvSpPr/>
-          <p:nvPr/>
-        </p:nvSpPr>
-        <p:spPr bwMode="auto">
-          <a:xfrm>
-            <a:off x="13964760" y="762120"/>
-            <a:ext cx="3373560" cy="371160"/>
+          <p:cNvPr id="1223444559" name="Text 3"/>
+          <p:cNvSpPr/>
+          <p:nvPr/>
+        </p:nvSpPr>
+        <p:spPr bwMode="auto">
+          <a:xfrm>
+            <a:off x="15902640" y="762120"/>
+            <a:ext cx="1413360" cy="371160"/>
           </a:xfrm>
           <a:prstGeom prst="rect">
             <a:avLst/>
@@ -8771,10 +8857,58 @@
                 <a:latin typeface="Noto Sans JP"/>
                 <a:ea typeface="Noto Sans JP"/>
               </a:rPr>
-              <a:t>§ 10 · </a:t>
-            </a:r>
-            <a:r>
-              <a:rPr lang="zh-CN" sz="1800" b="0" u="none" strike="noStrike" spc="108">
+              <a:t>§ 11 · 村の再エネ計画</a:t>
+            </a:r>
+            <a:endParaRPr lang="en-US" sz="1800" b="0" u="none" strike="noStrike">
+              <a:solidFill>
+                <a:srgbClr val="FFFFFF"/>
+              </a:solidFill>
+              <a:latin typeface="Arial"/>
+            </a:endParaRPr>
+          </a:p>
+        </p:txBody>
+      </p:sp>
+      <p:sp>
+        <p:nvSpPr>
+          <p:cNvPr id="325786775" name="Text 4"/>
+          <p:cNvSpPr/>
+          <p:nvPr/>
+        </p:nvSpPr>
+        <p:spPr bwMode="auto">
+          <a:xfrm>
+            <a:off x="1047600" y="1383120"/>
+            <a:ext cx="16678079" cy="371160"/>
+          </a:xfrm>
+          <a:prstGeom prst="rect">
+            <a:avLst/>
+          </a:prstGeom>
+          <a:noFill/>
+          <a:ln w="0">
+            <a:noFill/>
+          </a:ln>
+        </p:spPr>
+        <p:style>
+          <a:lnRef idx="0"/>
+          <a:fillRef idx="0"/>
+          <a:effectRef idx="0"/>
+          <a:fontRef idx="minor"/>
+        </p:style>
+        <p:txBody>
+          <a:bodyPr lIns="25560" tIns="25560" rIns="25560" bIns="25560" anchor="t">
+            <a:normAutofit/>
+          </a:bodyPr>
+          <a:p>
+            <a:pPr defTabSz="914400">
+              <a:lnSpc>
+                <a:spcPct val="100000"/>
+              </a:lnSpc>
+              <a:tabLst>
+                <a:tab pos="0" algn="l"/>
+              </a:tabLst>
+              <a:defRPr/>
+            </a:pPr>
+            <a:r>
+              <a:rPr lang="zh-CN" sz="1800" b="0" u="none" strike="noStrike" spc="145">
                 <a:solidFill>
                   <a:srgbClr val="F3ECE0">
                     <a:alpha val="67000"/>
@@ -8783,7 +8917,7 @@
                 <a:latin typeface="Noto Sans JP"/>
                 <a:ea typeface="Noto Sans JP"/>
               </a:rPr>
-              <a:t>十年単位で考える方へ</a:t>
+              <a:t>御杖村再エネ導入最大化計画との整合</a:t>
             </a:r>
             <a:endParaRPr lang="en-US" sz="1800" b="0" u="none" strike="noStrike">
               <a:solidFill>
@@ -8796,14 +8930,92 @@
       </p:sp>
       <p:sp>
         <p:nvSpPr>
-          <p:cNvPr id="859157660" name="Text 4"/>
-          <p:cNvSpPr/>
-          <p:nvPr/>
-        </p:nvSpPr>
-        <p:spPr bwMode="auto">
-          <a:xfrm>
-            <a:off x="1047600" y="1769040"/>
-            <a:ext cx="8324640" cy="371160"/>
+          <p:cNvPr id="597741482" name="Text 5"/>
+          <p:cNvSpPr/>
+          <p:nvPr/>
+        </p:nvSpPr>
+        <p:spPr bwMode="auto">
+          <a:xfrm>
+            <a:off x="1047600" y="2383560"/>
+            <a:ext cx="15513480" cy="3078000"/>
+          </a:xfrm>
+          <a:prstGeom prst="rect">
+            <a:avLst/>
+          </a:prstGeom>
+          <a:noFill/>
+          <a:ln w="0">
+            <a:noFill/>
+          </a:ln>
+        </p:spPr>
+        <p:style>
+          <a:lnRef idx="0"/>
+          <a:fillRef idx="0"/>
+          <a:effectRef idx="0"/>
+          <a:fontRef idx="minor"/>
+        </p:style>
+        <p:txBody>
+          <a:bodyPr vertOverflow="overflow" horzOverflow="overflow" vert="horz" wrap="square" lIns="25560" tIns="25560" rIns="25560" bIns="25560" numCol="1" spcCol="0" rtlCol="0" fromWordArt="0" anchor="t" anchorCtr="0" forceAA="0" upright="0" compatLnSpc="0">
+            <a:normAutofit fontScale="95000" lnSpcReduction="1000"/>
+          </a:bodyPr>
+          <a:p>
+            <a:pPr defTabSz="914400">
+              <a:lnSpc>
+                <a:spcPct val="105000"/>
+              </a:lnSpc>
+              <a:tabLst>
+                <a:tab pos="0" algn="l"/>
+              </a:tabLst>
+              <a:defRPr/>
+            </a:pPr>
+            <a:r>
+              <a:rPr lang="zh-CN" sz="7200" b="1" u="none" strike="noStrike" spc="-57">
+                <a:solidFill>
+                  <a:srgbClr val="F3ECE0"/>
+                </a:solidFill>
+                <a:latin typeface="Noto Serif JP"/>
+                <a:ea typeface="Noto Serif JP"/>
+              </a:rPr>
+              <a:t>村に新しい構想を求めない。</a:t>
+            </a:r>
+            <a:r>
+              <a:rPr lang="zh-CN" sz="7200" b="1" i="1" u="none" strike="noStrike" spc="-56">
+                <a:solidFill>
+                  <a:srgbClr val="F3B486"/>
+                </a:solidFill>
+                <a:latin typeface="Noto Serif JP"/>
+                <a:ea typeface="Noto Serif JP"/>
+              </a:rPr>
+              <a:t>村がすでに書いた計画を、私たちが実行する</a:t>
+            </a:r>
+            <a:r>
+              <a:rPr lang="zh-CN" sz="8000" b="1" i="1" u="none" strike="noStrike" spc="-56">
+                <a:solidFill>
+                  <a:srgbClr val="F3B486"/>
+                </a:solidFill>
+                <a:latin typeface="Noto Serif JP"/>
+                <a:ea typeface="Noto Serif JP"/>
+              </a:rPr>
+              <a:t>。</a:t>
+            </a:r>
+            <a:endParaRPr lang="en-US" sz="11400" b="0" u="none" strike="noStrike">
+              <a:solidFill>
+                <a:srgbClr val="FFFFFF"/>
+              </a:solidFill>
+              <a:latin typeface="Arial"/>
+            </a:endParaRPr>
+          </a:p>
+        </p:txBody>
+      </p:sp>
+      <p:sp>
+        <p:nvSpPr>
+          <p:cNvPr id="401775374" name="Text 6"/>
+          <p:cNvSpPr/>
+          <p:nvPr/>
+        </p:nvSpPr>
+        <p:spPr bwMode="auto">
+          <a:xfrm>
+            <a:off x="1047599" y="4976279"/>
+            <a:ext cx="16678079" cy="485280"/>
           </a:xfrm>
           <a:prstGeom prst="rect">
             <a:avLst/>
@@ -8834,7 +9046,67 @@
               <a:defRPr/>
             </a:pPr>
             <a:r>
-              <a:rPr lang="zh-CN" sz="1800" b="0" u="none" strike="noStrike" spc="145">
+              <a:rPr lang="zh-CN" sz="2400" b="0" u="none" strike="noStrike">
+                <a:solidFill>
+                  <a:srgbClr val="F3ECE0">
+                    <a:alpha val="60000"/>
+                  </a:srgbClr>
+                </a:solidFill>
+                <a:latin typeface="Noto Serif JP"/>
+                <a:ea typeface="Noto Serif JP"/>
+              </a:rPr>
+              <a:t>御杖村再エネ導入最大化計画（2025年・環境省補助）の官民連携 運営体制として。</a:t>
+            </a:r>
+            <a:endParaRPr lang="en-US" sz="2400" b="0" u="none" strike="noStrike">
+              <a:solidFill>
+                <a:srgbClr val="FFFFFF"/>
+              </a:solidFill>
+              <a:latin typeface="Arial"/>
+            </a:endParaRPr>
+          </a:p>
+        </p:txBody>
+      </p:sp>
+      <p:sp>
+        <p:nvSpPr>
+          <p:cNvPr id="553533526" name="Text 7"/>
+          <p:cNvSpPr/>
+          <p:nvPr/>
+        </p:nvSpPr>
+        <p:spPr bwMode="auto">
+          <a:xfrm>
+            <a:off x="972358" y="5646060"/>
+            <a:ext cx="5166720" cy="371160"/>
+          </a:xfrm>
+          <a:prstGeom prst="rect">
+            <a:avLst/>
+          </a:prstGeom>
+          <a:noFill/>
+          <a:ln w="0">
+            <a:noFill/>
+          </a:ln>
+        </p:spPr>
+        <p:style>
+          <a:lnRef idx="0"/>
+          <a:fillRef idx="0"/>
+          <a:effectRef idx="0"/>
+          <a:fontRef idx="minor"/>
+        </p:style>
+        <p:txBody>
+          <a:bodyPr lIns="25560" tIns="25560" rIns="25560" bIns="25560" anchor="t">
+            <a:normAutofit/>
+          </a:bodyPr>
+          <a:p>
+            <a:pPr defTabSz="914400">
+              <a:lnSpc>
+                <a:spcPct val="100000"/>
+              </a:lnSpc>
+              <a:tabLst>
+                <a:tab pos="0" algn="l"/>
+              </a:tabLst>
+              <a:defRPr/>
+            </a:pPr>
+            <a:r>
+              <a:rPr lang="en-US" sz="1800" b="0" u="none" strike="noStrike" spc="145">
                 <a:solidFill>
                   <a:srgbClr val="F3ECE0">
                     <a:alpha val="67000"/>
@@ -8843,7 +9115,7 @@
                 <a:latin typeface="Noto Sans JP"/>
                 <a:ea typeface="Noto Sans JP"/>
               </a:rPr>
-              <a:t>あなたの時間軸が私たちと合うなら…</a:t>
+              <a:t>i</a:t>
             </a:r>
             <a:endParaRPr lang="en-US" sz="1800" b="0" u="none" strike="noStrike">
               <a:solidFill>
@@ -8856,14 +9128,72 @@
       </p:sp>
       <p:sp>
         <p:nvSpPr>
-          <p:cNvPr id="1712679557" name="Text 5"/>
-          <p:cNvSpPr/>
-          <p:nvPr/>
-        </p:nvSpPr>
-        <p:spPr bwMode="auto">
-          <a:xfrm>
-            <a:off x="1047600" y="2331000"/>
-            <a:ext cx="8324640" cy="5798520"/>
+          <p:cNvPr id="1644907204" name="Text 8"/>
+          <p:cNvSpPr/>
+          <p:nvPr/>
+        </p:nvSpPr>
+        <p:spPr bwMode="auto">
+          <a:xfrm>
+            <a:off x="972358" y="6055740"/>
+            <a:ext cx="5166720" cy="607320"/>
+          </a:xfrm>
+          <a:prstGeom prst="rect">
+            <a:avLst/>
+          </a:prstGeom>
+          <a:noFill/>
+          <a:ln w="0">
+            <a:noFill/>
+          </a:ln>
+        </p:spPr>
+        <p:style>
+          <a:lnRef idx="0"/>
+          <a:fillRef idx="0"/>
+          <a:effectRef idx="0"/>
+          <a:fontRef idx="minor"/>
+        </p:style>
+        <p:txBody>
+          <a:bodyPr lIns="25560" tIns="25560" rIns="25560" bIns="25560" anchor="t">
+            <a:normAutofit fontScale="85000"/>
+          </a:bodyPr>
+          <a:p>
+            <a:pPr defTabSz="914400">
+              <a:lnSpc>
+                <a:spcPct val="114999"/>
+              </a:lnSpc>
+              <a:tabLst>
+                <a:tab pos="0" algn="l"/>
+              </a:tabLst>
+              <a:defRPr/>
+            </a:pPr>
+            <a:r>
+              <a:rPr lang="zh-CN" sz="3900" b="1" u="none" strike="noStrike" spc="-20">
+                <a:solidFill>
+                  <a:srgbClr val="F3ECE0"/>
+                </a:solidFill>
+                <a:latin typeface="Noto Serif JP"/>
+                <a:ea typeface="Noto Serif JP"/>
+              </a:rPr>
+              <a:t>レジリエント1拠点</a:t>
+            </a:r>
+            <a:endParaRPr lang="en-US" sz="3900" b="0" u="none" strike="noStrike">
+              <a:solidFill>
+                <a:srgbClr val="FFFFFF"/>
+              </a:solidFill>
+              <a:latin typeface="Arial"/>
+            </a:endParaRPr>
+          </a:p>
+        </p:txBody>
+      </p:sp>
+      <p:sp>
+        <p:nvSpPr>
+          <p:cNvPr id="1891710512" name="Text 9"/>
+          <p:cNvSpPr/>
+          <p:nvPr/>
+        </p:nvSpPr>
+        <p:spPr bwMode="auto">
+          <a:xfrm>
+            <a:off x="972358" y="6758460"/>
+            <a:ext cx="5166720" cy="792000"/>
           </a:xfrm>
           <a:prstGeom prst="rect">
             <a:avLst/>
@@ -8886,34 +9216,26 @@
           <a:p>
             <a:pPr defTabSz="914400">
               <a:lnSpc>
-                <a:spcPct val="120000"/>
-              </a:lnSpc>
-              <a:tabLst>
-                <a:tab pos="0" algn="l"/>
-              </a:tabLst>
-              <a:defRPr/>
-            </a:pPr>
-            <a:r>
-              <a:rPr lang="zh-CN" sz="6300" b="1" u="none" strike="noStrike" spc="-31">
-                <a:solidFill>
-                  <a:srgbClr val="F3ECE0"/>
-                </a:solidFill>
-                <a:latin typeface="Noto Serif JP"/>
-                <a:ea typeface="Noto Serif JP"/>
-              </a:rPr>
-              <a:t>私たちが求めているのは、 忍耐強い資本、 率直なご批判、 そして数人の </a:t>
-            </a:r>
-            <a:r>
-              <a:rPr lang="zh-CN" sz="6300" b="1" u="none" strike="noStrike" spc="-31">
-                <a:solidFill>
-                  <a:srgbClr val="F3B486"/>
-                </a:solidFill>
-                <a:latin typeface="Noto Serif JP"/>
-                <a:ea typeface="Noto Serif JP"/>
-              </a:rPr>
-              <a:t>良き隣人。</a:t>
-            </a:r>
-            <a:endParaRPr lang="en-US" sz="6300" b="0" u="none" strike="noStrike">
+                <a:spcPct val="165000"/>
+              </a:lnSpc>
+              <a:tabLst>
+                <a:tab pos="0" algn="l"/>
+              </a:tabLst>
+              <a:defRPr/>
+            </a:pPr>
+            <a:r>
+              <a:rPr lang="zh-CN" sz="1800" b="0" u="none" strike="noStrike">
+                <a:solidFill>
+                  <a:srgbClr val="F3ECE0">
+                    <a:alpha val="85000"/>
+                  </a:srgbClr>
+                </a:solidFill>
+                <a:latin typeface="Noto Sans JP"/>
+                <a:ea typeface="Noto Sans JP"/>
+              </a:rPr>
+              <a:t>計画は再エネ＋蓄電池＋EVのレジリエント拠点を1つ（現状ゼロ）目標とする。我々のデータセンターがその拠点になる。</a:t>
+            </a:r>
+            <a:endParaRPr lang="en-US" sz="1800" b="0" u="none" strike="noStrike">
               <a:solidFill>
                 <a:srgbClr val="FFFFFF"/>
               </a:solidFill>
@@ -8924,14 +9246,14 @@
       </p:sp>
       <p:sp>
         <p:nvSpPr>
-          <p:cNvPr id="1882789491" name="Text 6"/>
-          <p:cNvSpPr/>
-          <p:nvPr/>
-        </p:nvSpPr>
-        <p:spPr bwMode="auto">
-          <a:xfrm>
-            <a:off x="9892440" y="1769040"/>
-            <a:ext cx="7567920" cy="371160"/>
+          <p:cNvPr id="1176841977" name="Text 10"/>
+          <p:cNvSpPr/>
+          <p:nvPr/>
+        </p:nvSpPr>
+        <p:spPr bwMode="auto">
+          <a:xfrm>
+            <a:off x="6560639" y="5646060"/>
+            <a:ext cx="5166720" cy="371160"/>
           </a:xfrm>
           <a:prstGeom prst="rect">
             <a:avLst/>
@@ -8962,7 +9284,7 @@
               <a:defRPr/>
             </a:pPr>
             <a:r>
-              <a:rPr lang="zh-CN" sz="1800" b="0" u="none" strike="noStrike" spc="145">
+              <a:rPr lang="en-US" sz="1800" b="0" u="none" strike="noStrike" spc="145">
                 <a:solidFill>
                   <a:srgbClr val="F3ECE0">
                     <a:alpha val="67000"/>
@@ -8971,6 +9293,884 @@
                 <a:latin typeface="Noto Sans JP"/>
                 <a:ea typeface="Noto Sans JP"/>
               </a:rPr>
+              <a:t>ii</a:t>
+            </a:r>
+            <a:endParaRPr lang="en-US" sz="1800" b="0" u="none" strike="noStrike">
+              <a:solidFill>
+                <a:srgbClr val="FFFFFF"/>
+              </a:solidFill>
+              <a:latin typeface="Arial"/>
+            </a:endParaRPr>
+          </a:p>
+        </p:txBody>
+      </p:sp>
+      <p:sp>
+        <p:nvSpPr>
+          <p:cNvPr id="250886971" name="Text 11"/>
+          <p:cNvSpPr/>
+          <p:nvPr/>
+        </p:nvSpPr>
+        <p:spPr bwMode="auto">
+          <a:xfrm>
+            <a:off x="6560639" y="6055740"/>
+            <a:ext cx="5166720" cy="607320"/>
+          </a:xfrm>
+          <a:prstGeom prst="rect">
+            <a:avLst/>
+          </a:prstGeom>
+          <a:noFill/>
+          <a:ln w="0">
+            <a:noFill/>
+          </a:ln>
+        </p:spPr>
+        <p:style>
+          <a:lnRef idx="0"/>
+          <a:fillRef idx="0"/>
+          <a:effectRef idx="0"/>
+          <a:fontRef idx="minor"/>
+        </p:style>
+        <p:txBody>
+          <a:bodyPr lIns="25560" tIns="25560" rIns="25560" bIns="25560" anchor="t">
+            <a:normAutofit fontScale="85000"/>
+          </a:bodyPr>
+          <a:p>
+            <a:pPr defTabSz="914400">
+              <a:lnSpc>
+                <a:spcPct val="114999"/>
+              </a:lnSpc>
+              <a:tabLst>
+                <a:tab pos="0" algn="l"/>
+              </a:tabLst>
+              <a:defRPr/>
+            </a:pPr>
+            <a:r>
+              <a:rPr lang="zh-CN" sz="3900" b="1" u="none" strike="noStrike" spc="-20">
+                <a:solidFill>
+                  <a:srgbClr val="F3ECE0"/>
+                </a:solidFill>
+                <a:latin typeface="Noto Serif JP"/>
+                <a:ea typeface="Noto Serif JP"/>
+              </a:rPr>
+              <a:t>EV充電の優先</a:t>
+            </a:r>
+            <a:endParaRPr lang="en-US" sz="3900" b="0" u="none" strike="noStrike">
+              <a:solidFill>
+                <a:srgbClr val="FFFFFF"/>
+              </a:solidFill>
+              <a:latin typeface="Arial"/>
+            </a:endParaRPr>
+          </a:p>
+        </p:txBody>
+      </p:sp>
+      <p:sp>
+        <p:nvSpPr>
+          <p:cNvPr id="1852600780" name="Text 12"/>
+          <p:cNvSpPr/>
+          <p:nvPr/>
+        </p:nvSpPr>
+        <p:spPr bwMode="auto">
+          <a:xfrm>
+            <a:off x="6560639" y="6758460"/>
+            <a:ext cx="5166720" cy="792000"/>
+          </a:xfrm>
+          <a:prstGeom prst="rect">
+            <a:avLst/>
+          </a:prstGeom>
+          <a:noFill/>
+          <a:ln w="0">
+            <a:noFill/>
+          </a:ln>
+        </p:spPr>
+        <p:style>
+          <a:lnRef idx="0"/>
+          <a:fillRef idx="0"/>
+          <a:effectRef idx="0"/>
+          <a:fontRef idx="minor"/>
+        </p:style>
+        <p:txBody>
+          <a:bodyPr lIns="25560" tIns="25560" rIns="25560" bIns="25560" anchor="t">
+            <a:normAutofit fontScale="85000"/>
+          </a:bodyPr>
+          <a:p>
+            <a:pPr defTabSz="914400">
+              <a:lnSpc>
+                <a:spcPct val="165000"/>
+              </a:lnSpc>
+              <a:tabLst>
+                <a:tab pos="0" algn="l"/>
+              </a:tabLst>
+              <a:defRPr/>
+            </a:pPr>
+            <a:r>
+              <a:rPr lang="zh-CN" sz="1800" b="0" u="none" strike="noStrike">
+                <a:solidFill>
+                  <a:srgbClr val="F3ECE0">
+                    <a:alpha val="85000"/>
+                  </a:srgbClr>
+                </a:solidFill>
+                <a:latin typeface="Noto Sans JP"/>
+                <a:ea typeface="Noto Sans JP"/>
+              </a:rPr>
+              <a:t>運輸が村の排出の46%。計画が掲げる公共施設へのEV充電優先を実現する。</a:t>
+            </a:r>
+            <a:endParaRPr lang="en-US" sz="1800" b="0" u="none" strike="noStrike">
+              <a:solidFill>
+                <a:srgbClr val="FFFFFF"/>
+              </a:solidFill>
+              <a:latin typeface="Arial"/>
+            </a:endParaRPr>
+          </a:p>
+        </p:txBody>
+      </p:sp>
+      <p:sp>
+        <p:nvSpPr>
+          <p:cNvPr id="780084112" name="Text 13"/>
+          <p:cNvSpPr/>
+          <p:nvPr/>
+        </p:nvSpPr>
+        <p:spPr bwMode="auto">
+          <a:xfrm>
+            <a:off x="12148560" y="5646060"/>
+            <a:ext cx="5166720" cy="371160"/>
+          </a:xfrm>
+          <a:prstGeom prst="rect">
+            <a:avLst/>
+          </a:prstGeom>
+          <a:noFill/>
+          <a:ln w="0">
+            <a:noFill/>
+          </a:ln>
+        </p:spPr>
+        <p:style>
+          <a:lnRef idx="0"/>
+          <a:fillRef idx="0"/>
+          <a:effectRef idx="0"/>
+          <a:fontRef idx="minor"/>
+        </p:style>
+        <p:txBody>
+          <a:bodyPr lIns="25560" tIns="25560" rIns="25560" bIns="25560" anchor="t">
+            <a:normAutofit/>
+          </a:bodyPr>
+          <a:p>
+            <a:pPr defTabSz="914400">
+              <a:lnSpc>
+                <a:spcPct val="100000"/>
+              </a:lnSpc>
+              <a:tabLst>
+                <a:tab pos="0" algn="l"/>
+              </a:tabLst>
+              <a:defRPr/>
+            </a:pPr>
+            <a:r>
+              <a:rPr lang="en-US" sz="1800" b="0" u="none" strike="noStrike" spc="145">
+                <a:solidFill>
+                  <a:srgbClr val="F3ECE0">
+                    <a:alpha val="67000"/>
+                  </a:srgbClr>
+                </a:solidFill>
+                <a:latin typeface="Noto Sans JP"/>
+                <a:ea typeface="Noto Sans JP"/>
+              </a:rPr>
+              <a:t>iii</a:t>
+            </a:r>
+            <a:endParaRPr lang="en-US" sz="1800" b="0" u="none" strike="noStrike">
+              <a:solidFill>
+                <a:srgbClr val="FFFFFF"/>
+              </a:solidFill>
+              <a:latin typeface="Arial"/>
+            </a:endParaRPr>
+          </a:p>
+        </p:txBody>
+      </p:sp>
+      <p:sp>
+        <p:nvSpPr>
+          <p:cNvPr id="1009733947" name="Text 14"/>
+          <p:cNvSpPr/>
+          <p:nvPr/>
+        </p:nvSpPr>
+        <p:spPr bwMode="auto">
+          <a:xfrm>
+            <a:off x="12148560" y="6055740"/>
+            <a:ext cx="5166720" cy="1176840"/>
+          </a:xfrm>
+          <a:prstGeom prst="rect">
+            <a:avLst/>
+          </a:prstGeom>
+          <a:noFill/>
+          <a:ln w="0">
+            <a:noFill/>
+          </a:ln>
+        </p:spPr>
+        <p:style>
+          <a:lnRef idx="0"/>
+          <a:fillRef idx="0"/>
+          <a:effectRef idx="0"/>
+          <a:fontRef idx="minor"/>
+        </p:style>
+        <p:txBody>
+          <a:bodyPr lIns="25560" tIns="25560" rIns="25560" bIns="25560" anchor="t">
+            <a:normAutofit fontScale="92500"/>
+          </a:bodyPr>
+          <a:p>
+            <a:pPr defTabSz="914400">
+              <a:lnSpc>
+                <a:spcPct val="114999"/>
+              </a:lnSpc>
+              <a:tabLst>
+                <a:tab pos="0" algn="l"/>
+              </a:tabLst>
+              <a:defRPr/>
+            </a:pPr>
+            <a:r>
+              <a:rPr lang="zh-CN" sz="3900" b="1" u="none" strike="noStrike" spc="-20">
+                <a:solidFill>
+                  <a:srgbClr val="F3ECE0"/>
+                </a:solidFill>
+                <a:latin typeface="Noto Serif JP"/>
+                <a:ea typeface="Noto Serif JP"/>
+              </a:rPr>
+              <a:t>森林J-クレジット + 交付金</a:t>
+            </a:r>
+            <a:endParaRPr lang="en-US" sz="3900" b="0" u="none" strike="noStrike">
+              <a:solidFill>
+                <a:srgbClr val="FFFFFF"/>
+              </a:solidFill>
+              <a:latin typeface="Arial"/>
+            </a:endParaRPr>
+          </a:p>
+        </p:txBody>
+      </p:sp>
+      <p:sp>
+        <p:nvSpPr>
+          <p:cNvPr id="208444932" name="Text 15"/>
+          <p:cNvSpPr/>
+          <p:nvPr/>
+        </p:nvSpPr>
+        <p:spPr bwMode="auto">
+          <a:xfrm>
+            <a:off x="12148560" y="6787977"/>
+            <a:ext cx="5166720" cy="415080"/>
+          </a:xfrm>
+          <a:prstGeom prst="rect">
+            <a:avLst/>
+          </a:prstGeom>
+          <a:noFill/>
+          <a:ln w="0">
+            <a:noFill/>
+          </a:ln>
+        </p:spPr>
+        <p:style>
+          <a:lnRef idx="0"/>
+          <a:fillRef idx="0"/>
+          <a:effectRef idx="0"/>
+          <a:fontRef idx="minor"/>
+        </p:style>
+        <p:txBody>
+          <a:bodyPr lIns="25560" tIns="25560" rIns="25560" bIns="25560" anchor="t">
+            <a:normAutofit fontScale="85000"/>
+          </a:bodyPr>
+          <a:p>
+            <a:pPr defTabSz="914400">
+              <a:lnSpc>
+                <a:spcPct val="165000"/>
+              </a:lnSpc>
+              <a:tabLst>
+                <a:tab pos="0" algn="l"/>
+              </a:tabLst>
+              <a:defRPr/>
+            </a:pPr>
+            <a:r>
+              <a:rPr lang="zh-CN" sz="1800" b="0" u="none" strike="noStrike">
+                <a:solidFill>
+                  <a:srgbClr val="F3ECE0">
+                    <a:alpha val="85000"/>
+                  </a:srgbClr>
+                </a:solidFill>
+                <a:latin typeface="Noto Sans JP"/>
+                <a:ea typeface="Noto Sans JP"/>
+              </a:rPr>
+              <a:t>バイオマスCHPが森林炭素／J-クレジット機構を供給。村主導の交付金（太陽光・蓄電池・EVの補助率2/3〜3/4、村経由）を引き出す。</a:t>
+            </a:r>
+            <a:endParaRPr lang="en-US" sz="1800" b="0" u="none" strike="noStrike">
+              <a:solidFill>
+                <a:srgbClr val="FFFFFF"/>
+              </a:solidFill>
+              <a:latin typeface="Arial"/>
+            </a:endParaRPr>
+          </a:p>
+        </p:txBody>
+      </p:sp>
+      <p:sp>
+        <p:nvSpPr>
+          <p:cNvPr id="704529689" name="Text 16"/>
+          <p:cNvSpPr/>
+          <p:nvPr/>
+        </p:nvSpPr>
+        <p:spPr bwMode="auto">
+          <a:xfrm flipH="0" flipV="0">
+            <a:off x="1047600" y="9191520"/>
+            <a:ext cx="1157087" cy="371160"/>
+          </a:xfrm>
+          <a:prstGeom prst="rect">
+            <a:avLst/>
+          </a:prstGeom>
+          <a:noFill/>
+          <a:ln w="0">
+            <a:noFill/>
+          </a:ln>
+        </p:spPr>
+        <p:style>
+          <a:lnRef idx="0"/>
+          <a:fillRef idx="0"/>
+          <a:effectRef idx="0"/>
+          <a:fontRef idx="minor"/>
+        </p:style>
+        <p:txBody>
+          <a:bodyPr lIns="25560" tIns="25560" rIns="25560" bIns="25560" anchor="t">
+            <a:normAutofit/>
+          </a:bodyPr>
+          <a:p>
+            <a:pPr defTabSz="914400">
+              <a:lnSpc>
+                <a:spcPct val="100000"/>
+              </a:lnSpc>
+              <a:tabLst>
+                <a:tab pos="0" algn="l"/>
+              </a:tabLst>
+              <a:defRPr/>
+            </a:pPr>
+            <a:r>
+              <a:rPr lang="en-US" sz="1800" b="0" u="none" strike="noStrike" spc="71">
+                <a:solidFill>
+                  <a:srgbClr val="F3ECE0">
+                    <a:alpha val="67000"/>
+                  </a:srgbClr>
+                </a:solidFill>
+                <a:latin typeface="Noto Sans JP"/>
+                <a:ea typeface="Noto Sans JP"/>
+              </a:rPr>
+              <a:t>12 / 12</a:t>
+            </a:r>
+            <a:endParaRPr lang="en-US" sz="1800" b="0" u="none" strike="noStrike">
+              <a:solidFill>
+                <a:srgbClr val="FFFFFF"/>
+              </a:solidFill>
+              <a:latin typeface="Arial"/>
+            </a:endParaRPr>
+          </a:p>
+        </p:txBody>
+      </p:sp>
+      <p:sp>
+        <p:nvSpPr>
+          <p:cNvPr id="1884024737" name="Text 17"/>
+          <p:cNvSpPr/>
+          <p:nvPr/>
+        </p:nvSpPr>
+        <p:spPr bwMode="auto">
+          <a:xfrm>
+            <a:off x="12153959" y="7289460"/>
+            <a:ext cx="5383440" cy="371160"/>
+          </a:xfrm>
+          <a:prstGeom prst="rect">
+            <a:avLst/>
+          </a:prstGeom>
+          <a:noFill/>
+          <a:ln w="0">
+            <a:noFill/>
+          </a:ln>
+        </p:spPr>
+        <p:style>
+          <a:lnRef idx="0"/>
+          <a:fillRef idx="0"/>
+          <a:effectRef idx="0"/>
+          <a:fontRef idx="minor"/>
+        </p:style>
+        <p:txBody>
+          <a:bodyPr lIns="25560" tIns="25560" rIns="25560" bIns="25560" anchor="t">
+            <a:normAutofit/>
+          </a:bodyPr>
+          <a:p>
+            <a:pPr defTabSz="914400">
+              <a:lnSpc>
+                <a:spcPct val="100000"/>
+              </a:lnSpc>
+              <a:tabLst>
+                <a:tab pos="0" algn="l"/>
+              </a:tabLst>
+              <a:defRPr/>
+            </a:pPr>
+            <a:r>
+              <a:rPr lang="zh-CN" sz="1800" b="0" u="none" strike="noStrike" spc="71">
+                <a:solidFill>
+                  <a:srgbClr val="F3ECE0">
+                    <a:alpha val="67000"/>
+                  </a:srgbClr>
+                </a:solidFill>
+                <a:latin typeface="Noto Sans JP"/>
+                <a:ea typeface="Noto Sans JP"/>
+              </a:rPr>
+              <a:t>バイオマスCHPが主軸 · 太陽光／蓄電池／EVは補完 · 資金は村を通じて流れる</a:t>
+            </a:r>
+            <a:endParaRPr lang="en-US" sz="1800" b="0" u="none" strike="noStrike">
+              <a:solidFill>
+                <a:srgbClr val="FFFFFF"/>
+              </a:solidFill>
+              <a:latin typeface="Arial"/>
+            </a:endParaRPr>
+          </a:p>
+        </p:txBody>
+      </p:sp>
+    </p:spTree>
+  </p:cSld>
+  <p:clrMapOvr>
+    <a:masterClrMapping/>
+  </p:clrMapOvr>
+  <mc:AlternateContent xmlns:mc="http://schemas.openxmlformats.org/markup-compatibility/2006">
+    <mc:Choice xmlns:p159="http://schemas.microsoft.com/office/powerpoint/2015/09/main" xmlns:p14="http://schemas.microsoft.com/office/powerpoint/2010/main" Requires="p159">
+      <p:transition p14:dur="500" advClick="1"/>
+    </mc:Choice>
+    <mc:Fallback>
+      <p:transition advClick="1"/>
+    </mc:Fallback>
+  </mc:AlternateContent>
+</p:sld>
+</file>
+
+<file path=ppt/slides/slide12.xml><?xml version="1.0" encoding="utf-8"?>
+<p:sld xmlns:a="http://schemas.openxmlformats.org/drawingml/2006/main" xmlns:r="http://schemas.openxmlformats.org/officeDocument/2006/relationships" xmlns:p="http://schemas.openxmlformats.org/presentationml/2006/main" xmlns:m="http://schemas.openxmlformats.org/officeDocument/2006/math" xmlns:w="http://schemas.openxmlformats.org/wordprocessingml/2006/main" xmlns:mc="http://schemas.openxmlformats.org/markup-compatibility/2006" showMasterPhAnim="0" showMasterSp="1" show="1">
+  <p:cSld name="">
+    <p:bg>
+      <p:bgPr shadeToTitle="0">
+        <a:solidFill>
+          <a:srgbClr val="2F4A37"/>
+        </a:solidFill>
+      </p:bgPr>
+    </p:bg>
+    <p:spTree>
+      <p:nvGrpSpPr>
+        <p:cNvPr id="1" name=""/>
+        <p:cNvGrpSpPr/>
+        <p:nvPr/>
+      </p:nvGrpSpPr>
+      <p:grpSpPr bwMode="auto">
+        <a:xfrm>
+          <a:off x="0" y="0"/>
+          <a:ext cx="0" cy="0"/>
+          <a:chOff x="0" y="0"/>
+          <a:chExt cx="0" cy="0"/>
+        </a:xfrm>
+      </p:grpSpPr>
+      <p:sp>
+        <p:nvSpPr>
+          <p:cNvPr id="497585160" name="Shape 0"/>
+          <p:cNvSpPr/>
+          <p:nvPr/>
+        </p:nvSpPr>
+        <p:spPr bwMode="auto">
+          <a:xfrm>
+            <a:off x="1047600" y="762120"/>
+            <a:ext cx="456840" cy="456840"/>
+          </a:xfrm>
+          <a:prstGeom prst="ellipse">
+            <a:avLst/>
+          </a:prstGeom>
+          <a:solidFill>
+            <a:srgbClr val="F3ECE0"/>
+          </a:solidFill>
+          <a:ln w="0">
+            <a:noFill/>
+          </a:ln>
+        </p:spPr>
+        <p:style>
+          <a:lnRef idx="0"/>
+          <a:fillRef idx="0"/>
+          <a:effectRef idx="0"/>
+          <a:fontRef idx="minor"/>
+        </p:style>
+        <p:txBody>
+          <a:bodyPr lIns="90000" tIns="45000" rIns="90000" bIns="45000" anchor="t">
+            <a:noAutofit/>
+          </a:bodyPr>
+          <a:p>
+            <a:pPr>
+              <a:defRPr/>
+            </a:pPr>
+            <a:endParaRPr lang="en-US" sz="1800" b="0" u="none" strike="noStrike">
+              <a:solidFill>
+                <a:srgbClr val="000000"/>
+              </a:solidFill>
+              <a:latin typeface="Arial"/>
+            </a:endParaRPr>
+          </a:p>
+        </p:txBody>
+      </p:sp>
+      <p:sp>
+        <p:nvSpPr>
+          <p:cNvPr id="1273975722" name="Text 1"/>
+          <p:cNvSpPr/>
+          <p:nvPr/>
+        </p:nvSpPr>
+        <p:spPr bwMode="auto">
+          <a:xfrm>
+            <a:off x="1047600" y="762120"/>
+            <a:ext cx="533160" cy="495000"/>
+          </a:xfrm>
+          <a:prstGeom prst="rect">
+            <a:avLst/>
+          </a:prstGeom>
+          <a:noFill/>
+          <a:ln w="0">
+            <a:noFill/>
+          </a:ln>
+        </p:spPr>
+        <p:style>
+          <a:lnRef idx="0"/>
+          <a:fillRef idx="0"/>
+          <a:effectRef idx="0"/>
+          <a:fontRef idx="minor"/>
+        </p:style>
+        <p:txBody>
+          <a:bodyPr lIns="25560" tIns="25560" rIns="25560" bIns="25560" anchor="t">
+            <a:normAutofit/>
+          </a:bodyPr>
+          <a:p>
+            <a:pPr defTabSz="914400">
+              <a:lnSpc>
+                <a:spcPct val="100000"/>
+              </a:lnSpc>
+              <a:tabLst>
+                <a:tab pos="0" algn="l"/>
+              </a:tabLst>
+              <a:defRPr/>
+            </a:pPr>
+            <a:r>
+              <a:rPr lang="zh-CN" sz="1950" b="1" u="none" strike="noStrike" spc="108">
+                <a:solidFill>
+                  <a:srgbClr val="2F4A37"/>
+                </a:solidFill>
+                <a:latin typeface="Noto Serif JP"/>
+                <a:ea typeface="Noto Serif JP"/>
+              </a:rPr>
+              <a:t>御</a:t>
+            </a:r>
+            <a:endParaRPr lang="en-US" sz="1950" b="0" u="none" strike="noStrike">
+              <a:solidFill>
+                <a:srgbClr val="FFFFFF"/>
+              </a:solidFill>
+              <a:latin typeface="Arial"/>
+            </a:endParaRPr>
+          </a:p>
+        </p:txBody>
+      </p:sp>
+      <p:sp>
+        <p:nvSpPr>
+          <p:cNvPr id="2115235084" name="Text 2"/>
+          <p:cNvSpPr/>
+          <p:nvPr/>
+        </p:nvSpPr>
+        <p:spPr bwMode="auto">
+          <a:xfrm>
+            <a:off x="1638360" y="824040"/>
+            <a:ext cx="2007000" cy="371160"/>
+          </a:xfrm>
+          <a:prstGeom prst="rect">
+            <a:avLst/>
+          </a:prstGeom>
+          <a:noFill/>
+          <a:ln w="0">
+            <a:noFill/>
+          </a:ln>
+        </p:spPr>
+        <p:style>
+          <a:lnRef idx="0"/>
+          <a:fillRef idx="0"/>
+          <a:effectRef idx="0"/>
+          <a:fontRef idx="minor"/>
+        </p:style>
+        <p:txBody>
+          <a:bodyPr lIns="25560" tIns="25560" rIns="25560" bIns="25560" anchor="t">
+            <a:normAutofit/>
+          </a:bodyPr>
+          <a:p>
+            <a:pPr defTabSz="914400">
+              <a:lnSpc>
+                <a:spcPct val="100000"/>
+              </a:lnSpc>
+              <a:tabLst>
+                <a:tab pos="0" algn="l"/>
+              </a:tabLst>
+              <a:defRPr/>
+            </a:pPr>
+            <a:r>
+              <a:rPr lang="zh-CN" sz="1800" b="0" u="none" strike="noStrike" spc="108">
+                <a:solidFill>
+                  <a:srgbClr val="F3ECE0">
+                    <a:alpha val="67000"/>
+                  </a:srgbClr>
+                </a:solidFill>
+                <a:latin typeface="Noto Sans JP"/>
+                <a:ea typeface="Noto Sans JP"/>
+              </a:rPr>
+              <a:t>御杖プロジェクト</a:t>
+            </a:r>
+            <a:endParaRPr lang="en-US" sz="1800" b="0" u="none" strike="noStrike">
+              <a:solidFill>
+                <a:srgbClr val="FFFFFF"/>
+              </a:solidFill>
+              <a:latin typeface="Arial"/>
+            </a:endParaRPr>
+          </a:p>
+        </p:txBody>
+      </p:sp>
+      <p:sp>
+        <p:nvSpPr>
+          <p:cNvPr id="394781238" name="Text 3"/>
+          <p:cNvSpPr/>
+          <p:nvPr/>
+        </p:nvSpPr>
+        <p:spPr bwMode="auto">
+          <a:xfrm>
+            <a:off x="13964760" y="762120"/>
+            <a:ext cx="3373560" cy="371160"/>
+          </a:xfrm>
+          <a:prstGeom prst="rect">
+            <a:avLst/>
+          </a:prstGeom>
+          <a:noFill/>
+          <a:ln w="0">
+            <a:noFill/>
+          </a:ln>
+        </p:spPr>
+        <p:style>
+          <a:lnRef idx="0"/>
+          <a:fillRef idx="0"/>
+          <a:effectRef idx="0"/>
+          <a:fontRef idx="minor"/>
+        </p:style>
+        <p:txBody>
+          <a:bodyPr lIns="25560" tIns="25560" rIns="25560" bIns="25560" anchor="t">
+            <a:normAutofit/>
+          </a:bodyPr>
+          <a:p>
+            <a:pPr defTabSz="914400">
+              <a:lnSpc>
+                <a:spcPct val="100000"/>
+              </a:lnSpc>
+              <a:tabLst>
+                <a:tab pos="0" algn="l"/>
+              </a:tabLst>
+              <a:defRPr/>
+            </a:pPr>
+            <a:r>
+              <a:rPr lang="en-US" sz="1800" b="0" u="none" strike="noStrike" spc="108">
+                <a:solidFill>
+                  <a:srgbClr val="F3ECE0">
+                    <a:alpha val="67000"/>
+                  </a:srgbClr>
+                </a:solidFill>
+                <a:latin typeface="Noto Sans JP"/>
+                <a:ea typeface="Noto Sans JP"/>
+              </a:rPr>
+              <a:t>§ 10 · </a:t>
+            </a:r>
+            <a:r>
+              <a:rPr lang="zh-CN" sz="1800" b="0" u="none" strike="noStrike" spc="108">
+                <a:solidFill>
+                  <a:srgbClr val="F3ECE0">
+                    <a:alpha val="67000"/>
+                  </a:srgbClr>
+                </a:solidFill>
+                <a:latin typeface="Noto Sans JP"/>
+                <a:ea typeface="Noto Sans JP"/>
+              </a:rPr>
+              <a:t>十年単位で考える方へ</a:t>
+            </a:r>
+            <a:endParaRPr lang="en-US" sz="1800" b="0" u="none" strike="noStrike">
+              <a:solidFill>
+                <a:srgbClr val="FFFFFF"/>
+              </a:solidFill>
+              <a:latin typeface="Arial"/>
+            </a:endParaRPr>
+          </a:p>
+        </p:txBody>
+      </p:sp>
+      <p:sp>
+        <p:nvSpPr>
+          <p:cNvPr id="15288104" name="Text 4"/>
+          <p:cNvSpPr/>
+          <p:nvPr/>
+        </p:nvSpPr>
+        <p:spPr bwMode="auto">
+          <a:xfrm>
+            <a:off x="1047600" y="1769040"/>
+            <a:ext cx="8324640" cy="371160"/>
+          </a:xfrm>
+          <a:prstGeom prst="rect">
+            <a:avLst/>
+          </a:prstGeom>
+          <a:noFill/>
+          <a:ln w="0">
+            <a:noFill/>
+          </a:ln>
+        </p:spPr>
+        <p:style>
+          <a:lnRef idx="0"/>
+          <a:fillRef idx="0"/>
+          <a:effectRef idx="0"/>
+          <a:fontRef idx="minor"/>
+        </p:style>
+        <p:txBody>
+          <a:bodyPr lIns="25560" tIns="25560" rIns="25560" bIns="25560" anchor="t">
+            <a:normAutofit/>
+          </a:bodyPr>
+          <a:p>
+            <a:pPr defTabSz="914400">
+              <a:lnSpc>
+                <a:spcPct val="100000"/>
+              </a:lnSpc>
+              <a:tabLst>
+                <a:tab pos="0" algn="l"/>
+              </a:tabLst>
+              <a:defRPr/>
+            </a:pPr>
+            <a:r>
+              <a:rPr lang="zh-CN" sz="1800" b="0" u="none" strike="noStrike" spc="145">
+                <a:solidFill>
+                  <a:srgbClr val="F3ECE0">
+                    <a:alpha val="67000"/>
+                  </a:srgbClr>
+                </a:solidFill>
+                <a:latin typeface="Noto Sans JP"/>
+                <a:ea typeface="Noto Sans JP"/>
+              </a:rPr>
+              <a:t>あなたの時間軸が私たちと合うなら…</a:t>
+            </a:r>
+            <a:endParaRPr lang="en-US" sz="1800" b="0" u="none" strike="noStrike">
+              <a:solidFill>
+                <a:srgbClr val="FFFFFF"/>
+              </a:solidFill>
+              <a:latin typeface="Arial"/>
+            </a:endParaRPr>
+          </a:p>
+        </p:txBody>
+      </p:sp>
+      <p:sp>
+        <p:nvSpPr>
+          <p:cNvPr id="1784087132" name="Text 5"/>
+          <p:cNvSpPr/>
+          <p:nvPr/>
+        </p:nvSpPr>
+        <p:spPr bwMode="auto">
+          <a:xfrm>
+            <a:off x="1047600" y="2331000"/>
+            <a:ext cx="8324640" cy="5798520"/>
+          </a:xfrm>
+          <a:prstGeom prst="rect">
+            <a:avLst/>
+          </a:prstGeom>
+          <a:noFill/>
+          <a:ln w="0">
+            <a:noFill/>
+          </a:ln>
+        </p:spPr>
+        <p:style>
+          <a:lnRef idx="0"/>
+          <a:fillRef idx="0"/>
+          <a:effectRef idx="0"/>
+          <a:fontRef idx="minor"/>
+        </p:style>
+        <p:txBody>
+          <a:bodyPr lIns="25560" tIns="25560" rIns="25560" bIns="25560" anchor="t">
+            <a:normAutofit/>
+          </a:bodyPr>
+          <a:p>
+            <a:pPr defTabSz="914400">
+              <a:lnSpc>
+                <a:spcPct val="120000"/>
+              </a:lnSpc>
+              <a:tabLst>
+                <a:tab pos="0" algn="l"/>
+              </a:tabLst>
+              <a:defRPr/>
+            </a:pPr>
+            <a:r>
+              <a:rPr lang="zh-CN" sz="6300" b="1" u="none" strike="noStrike" spc="-31">
+                <a:solidFill>
+                  <a:srgbClr val="F3ECE0"/>
+                </a:solidFill>
+                <a:latin typeface="Noto Serif JP"/>
+                <a:ea typeface="Noto Serif JP"/>
+              </a:rPr>
+              <a:t>私たちが求めているのは、 忍耐強い資本、 率直なご批判、 そして数人の </a:t>
+            </a:r>
+            <a:r>
+              <a:rPr lang="zh-CN" sz="6300" b="1" u="none" strike="noStrike" spc="-31">
+                <a:solidFill>
+                  <a:srgbClr val="F3B486"/>
+                </a:solidFill>
+                <a:latin typeface="Noto Serif JP"/>
+                <a:ea typeface="Noto Serif JP"/>
+              </a:rPr>
+              <a:t>良き隣人。</a:t>
+            </a:r>
+            <a:endParaRPr lang="en-US" sz="6300" b="0" u="none" strike="noStrike">
+              <a:solidFill>
+                <a:srgbClr val="FFFFFF"/>
+              </a:solidFill>
+              <a:latin typeface="Arial"/>
+            </a:endParaRPr>
+          </a:p>
+        </p:txBody>
+      </p:sp>
+      <p:sp>
+        <p:nvSpPr>
+          <p:cNvPr id="38890854" name="Text 6"/>
+          <p:cNvSpPr/>
+          <p:nvPr/>
+        </p:nvSpPr>
+        <p:spPr bwMode="auto">
+          <a:xfrm>
+            <a:off x="9892440" y="1769040"/>
+            <a:ext cx="7567920" cy="371160"/>
+          </a:xfrm>
+          <a:prstGeom prst="rect">
+            <a:avLst/>
+          </a:prstGeom>
+          <a:noFill/>
+          <a:ln w="0">
+            <a:noFill/>
+          </a:ln>
+        </p:spPr>
+        <p:style>
+          <a:lnRef idx="0"/>
+          <a:fillRef idx="0"/>
+          <a:effectRef idx="0"/>
+          <a:fontRef idx="minor"/>
+        </p:style>
+        <p:txBody>
+          <a:bodyPr lIns="25560" tIns="25560" rIns="25560" bIns="25560" anchor="t">
+            <a:normAutofit/>
+          </a:bodyPr>
+          <a:p>
+            <a:pPr defTabSz="914400">
+              <a:lnSpc>
+                <a:spcPct val="100000"/>
+              </a:lnSpc>
+              <a:tabLst>
+                <a:tab pos="0" algn="l"/>
+              </a:tabLst>
+              <a:defRPr/>
+            </a:pPr>
+            <a:r>
+              <a:rPr lang="zh-CN" sz="1800" b="0" u="none" strike="noStrike" spc="145">
+                <a:solidFill>
+                  <a:srgbClr val="F3ECE0">
+                    <a:alpha val="67000"/>
+                  </a:srgbClr>
+                </a:solidFill>
+                <a:latin typeface="Noto Sans JP"/>
+                <a:ea typeface="Noto Sans JP"/>
+              </a:rPr>
               <a:t>いま助かるご支援</a:t>
             </a:r>
             <a:endParaRPr lang="en-US" sz="1800" b="0" u="none" strike="noStrike">
@@ -8984,7 +10184,7 @@
       </p:sp>
       <p:sp>
         <p:nvSpPr>
-          <p:cNvPr id="1046136931" name="Text 7"/>
+          <p:cNvPr id="776678473" name="Text 7"/>
           <p:cNvSpPr/>
           <p:nvPr/>
         </p:nvSpPr>
@@ -9193,7 +10393,7 @@
       </p:sp>
       <p:sp>
         <p:nvSpPr>
-          <p:cNvPr id="763766825" name="Shape 8"/>
+          <p:cNvPr id="1738061953" name="Shape 8"/>
           <p:cNvSpPr/>
           <p:nvPr/>
         </p:nvSpPr>
@@ -9239,7 +10439,7 @@
       </p:sp>
       <p:sp>
         <p:nvSpPr>
-          <p:cNvPr id="122209668" name="Shape 9"/>
+          <p:cNvPr id="566256924" name="Shape 9"/>
           <p:cNvSpPr/>
           <p:nvPr/>
         </p:nvSpPr>
@@ -9283,7 +10483,7 @@
       </p:sp>
       <p:pic>
         <p:nvPicPr>
-          <p:cNvPr id="1086079359" name="Image 0" descr="preencoded.png"/>
+          <p:cNvPr id="1232097482" name="Image 0" descr="preencoded.png"/>
           <p:cNvPicPr/>
           <p:nvPr/>
         </p:nvPicPr>
@@ -9307,7 +10507,7 @@
       </p:pic>
       <p:sp>
         <p:nvSpPr>
-          <p:cNvPr id="502199151" name="Text 10"/>
+          <p:cNvPr id="551440068" name="Text 10"/>
           <p:cNvSpPr/>
           <p:nvPr/>
         </p:nvSpPr>
@@ -9379,7 +10579,7 @@
       </p:sp>
       <p:sp>
         <p:nvSpPr>
-          <p:cNvPr id="1871879999" name="Text 11"/>
+          <p:cNvPr id="1464254093" name="Text 11"/>
           <p:cNvSpPr/>
           <p:nvPr/>
         </p:nvSpPr>
@@ -9437,7 +10637,7 @@
       </p:sp>
       <p:sp>
         <p:nvSpPr>
-          <p:cNvPr id="1344086185" name="Text 12"/>
+          <p:cNvPr id="1746317551" name="Text 12"/>
           <p:cNvSpPr/>
           <p:nvPr/>
         </p:nvSpPr>
@@ -9497,7 +10697,7 @@
       </p:sp>
       <p:sp>
         <p:nvSpPr>
-          <p:cNvPr id="234159831" name="Text 13"/>
+          <p:cNvPr id="499236962" name="Text 13"/>
           <p:cNvSpPr/>
           <p:nvPr/>
         </p:nvSpPr>
@@ -9557,7 +10757,7 @@
       </p:sp>
       <p:sp>
         <p:nvSpPr>
-          <p:cNvPr id="1254156152" name="Shape 14"/>
+          <p:cNvPr id="2016785946" name="Shape 14"/>
           <p:cNvSpPr/>
           <p:nvPr/>
         </p:nvSpPr>
@@ -9603,7 +10803,7 @@
       </p:sp>
       <p:sp>
         <p:nvSpPr>
-          <p:cNvPr id="722196524" name="Text 15"/>
+          <p:cNvPr id="1548483166" name="Text 15"/>
           <p:cNvSpPr/>
           <p:nvPr/>
         </p:nvSpPr>
@@ -9663,7 +10863,7 @@
       </p:sp>
       <p:sp>
         <p:nvSpPr>
-          <p:cNvPr id="1711504522" name="Text 16"/>
+          <p:cNvPr id="315802802" name="Text 16"/>
           <p:cNvSpPr/>
           <p:nvPr/>
         </p:nvSpPr>
@@ -9721,7 +10921,7 @@
       </p:sp>
       <p:sp>
         <p:nvSpPr>
-          <p:cNvPr id="1233636420" name="Text 17"/>
+          <p:cNvPr id="100037860" name="Text 17"/>
           <p:cNvSpPr/>
           <p:nvPr/>
         </p:nvSpPr>
@@ -9793,7 +10993,7 @@
       </p:sp>
       <p:sp>
         <p:nvSpPr>
-          <p:cNvPr id="189316891" name="Text 18"/>
+          <p:cNvPr id="1536459792" name="Text 18"/>
           <p:cNvSpPr/>
           <p:nvPr/>
         </p:nvSpPr>
@@ -9853,7 +11053,7 @@
       </p:sp>
       <p:sp>
         <p:nvSpPr>
-          <p:cNvPr id="1627025328" name="Text 19"/>
+          <p:cNvPr id="1598488824" name="Text 19"/>
           <p:cNvSpPr/>
           <p:nvPr/>
         </p:nvSpPr>
@@ -9965,7 +11165,7 @@
       </p:grpSpPr>
       <p:sp>
         <p:nvSpPr>
-          <p:cNvPr id="1827540468" name="Shape 0"/>
+          <p:cNvPr id="163946065" name="Shape 0"/>
           <p:cNvSpPr/>
           <p:nvPr/>
         </p:nvSpPr>
@@ -10009,7 +11209,7 @@
       </p:sp>
       <p:sp>
         <p:nvSpPr>
-          <p:cNvPr id="1740670500" name="Text 1"/>
+          <p:cNvPr id="876504556" name="Text 1"/>
           <p:cNvSpPr/>
           <p:nvPr/>
         </p:nvSpPr>
@@ -10067,7 +11267,7 @@
       </p:sp>
       <p:sp>
         <p:nvSpPr>
-          <p:cNvPr id="433017871" name="Text 2"/>
+          <p:cNvPr id="1754068356" name="Text 2"/>
           <p:cNvSpPr/>
           <p:nvPr/>
         </p:nvSpPr>
@@ -10125,7 +11325,7 @@
       </p:sp>
       <p:sp>
         <p:nvSpPr>
-          <p:cNvPr id="326968851" name="Text 3"/>
+          <p:cNvPr id="91101785" name="Text 3"/>
           <p:cNvSpPr/>
           <p:nvPr/>
         </p:nvSpPr>
@@ -10193,7 +11393,7 @@
       </p:sp>
       <p:sp>
         <p:nvSpPr>
-          <p:cNvPr id="700605793" name="Text 4"/>
+          <p:cNvPr id="854993838" name="Text 4"/>
           <p:cNvSpPr/>
           <p:nvPr/>
         </p:nvSpPr>
@@ -10271,7 +11471,7 @@
       </p:sp>
       <p:sp>
         <p:nvSpPr>
-          <p:cNvPr id="583191558" name="Text 5"/>
+          <p:cNvPr id="157322666" name="Text 5"/>
           <p:cNvSpPr/>
           <p:nvPr/>
         </p:nvSpPr>
@@ -10349,7 +11549,7 @@
       </p:sp>
       <p:sp>
         <p:nvSpPr>
-          <p:cNvPr id="1068698757" name="Text 6"/>
+          <p:cNvPr id="884229624" name="Text 6"/>
           <p:cNvSpPr/>
           <p:nvPr/>
         </p:nvSpPr>
@@ -10407,7 +11607,7 @@
       </p:sp>
       <p:sp>
         <p:nvSpPr>
-          <p:cNvPr id="639770386" name="Text 7"/>
+          <p:cNvPr id="814436259" name="Text 7"/>
           <p:cNvSpPr/>
           <p:nvPr/>
         </p:nvSpPr>
@@ -10465,7 +11665,7 @@
       </p:sp>
       <p:sp>
         <p:nvSpPr>
-          <p:cNvPr id="696573992" name="Shape 8"/>
+          <p:cNvPr id="1605364375" name="Shape 8"/>
           <p:cNvSpPr/>
           <p:nvPr/>
         </p:nvSpPr>
@@ -10512,7 +11712,7 @@
       </p:sp>
       <p:sp>
         <p:nvSpPr>
-          <p:cNvPr id="2122322110" name="Text 9"/>
+          <p:cNvPr id="1281089210" name="Text 9"/>
           <p:cNvSpPr/>
           <p:nvPr/>
         </p:nvSpPr>
@@ -10570,7 +11770,7 @@
       </p:sp>
       <p:sp>
         <p:nvSpPr>
-          <p:cNvPr id="258385052" name="Text 10"/>
+          <p:cNvPr id="665331478" name="Text 10"/>
           <p:cNvSpPr/>
           <p:nvPr/>
         </p:nvSpPr>
@@ -10628,7 +11828,7 @@
       </p:sp>
       <p:sp>
         <p:nvSpPr>
-          <p:cNvPr id="1943101733" name="Shape 11"/>
+          <p:cNvPr id="1804574221" name="Shape 11"/>
           <p:cNvSpPr/>
           <p:nvPr/>
         </p:nvSpPr>
@@ -10674,7 +11874,7 @@
       </p:sp>
       <p:sp>
         <p:nvSpPr>
-          <p:cNvPr id="1000951783" name="Text 12"/>
+          <p:cNvPr id="936373100" name="Text 12"/>
           <p:cNvSpPr/>
           <p:nvPr/>
         </p:nvSpPr>
@@ -10732,7 +11932,7 @@
       </p:sp>
       <p:sp>
         <p:nvSpPr>
-          <p:cNvPr id="979017131" name="Text 13"/>
+          <p:cNvPr id="313513820" name="Text 13"/>
           <p:cNvSpPr/>
           <p:nvPr/>
         </p:nvSpPr>
@@ -10790,7 +11990,7 @@
       </p:sp>
       <p:sp>
         <p:nvSpPr>
-          <p:cNvPr id="1021000704" name="Text 14"/>
+          <p:cNvPr id="1279361816" name="Text 14"/>
           <p:cNvSpPr/>
           <p:nvPr/>
         </p:nvSpPr>
@@ -10848,7 +12048,7 @@
       </p:sp>
       <p:sp>
         <p:nvSpPr>
-          <p:cNvPr id="1703776994" name="Text 15"/>
+          <p:cNvPr id="1332794188" name="Text 15"/>
           <p:cNvSpPr/>
           <p:nvPr/>
         </p:nvSpPr>
@@ -10906,7 +12106,7 @@
       </p:sp>
       <p:sp>
         <p:nvSpPr>
-          <p:cNvPr id="1569192084" name="Text 16"/>
+          <p:cNvPr id="61394415" name="Text 16"/>
           <p:cNvSpPr/>
           <p:nvPr/>
         </p:nvSpPr>
@@ -10964,7 +12164,7 @@
       </p:sp>
       <p:sp>
         <p:nvSpPr>
-          <p:cNvPr id="780382702" name="Text 17"/>
+          <p:cNvPr id="1228003210" name="Text 17"/>
           <p:cNvSpPr/>
           <p:nvPr/>
         </p:nvSpPr>
@@ -11022,7 +12222,7 @@
       </p:sp>
       <p:sp>
         <p:nvSpPr>
-          <p:cNvPr id="1471515198" name="Text 18"/>
+          <p:cNvPr id="1349431965" name="Text 18"/>
           <p:cNvSpPr/>
           <p:nvPr/>
         </p:nvSpPr>
@@ -11080,7 +12280,7 @@
       </p:sp>
       <p:sp>
         <p:nvSpPr>
-          <p:cNvPr id="1062625837" name="Text 19"/>
+          <p:cNvPr id="2070680761" name="Text 19"/>
           <p:cNvSpPr/>
           <p:nvPr/>
         </p:nvSpPr>
@@ -11148,7 +12348,7 @@
       </p:sp>
       <p:sp>
         <p:nvSpPr>
-          <p:cNvPr id="613488834" name="Text 20"/>
+          <p:cNvPr id="198727331" name="Text 20"/>
           <p:cNvSpPr/>
           <p:nvPr/>
         </p:nvSpPr>
@@ -11206,7 +12406,7 @@
       </p:sp>
       <p:sp>
         <p:nvSpPr>
-          <p:cNvPr id="1960415673" name="Text 21"/>
+          <p:cNvPr id="1259874034" name="Text 21"/>
           <p:cNvSpPr/>
           <p:nvPr/>
         </p:nvSpPr>
@@ -11264,7 +12464,7 @@
       </p:sp>
       <p:sp>
         <p:nvSpPr>
-          <p:cNvPr id="1679633539" name="Text 22"/>
+          <p:cNvPr id="633760713" name="Text 22"/>
           <p:cNvSpPr/>
           <p:nvPr/>
         </p:nvSpPr>
@@ -11362,7 +12562,7 @@
       </p:grpSpPr>
       <p:sp>
         <p:nvSpPr>
-          <p:cNvPr id="417168171" name="Shape 0"/>
+          <p:cNvPr id="72645126" name="Shape 0"/>
           <p:cNvSpPr/>
           <p:nvPr/>
         </p:nvSpPr>
@@ -11406,7 +12606,7 @@
       </p:sp>
       <p:sp>
         <p:nvSpPr>
-          <p:cNvPr id="424393670" name="Text 1"/>
+          <p:cNvPr id="111810687" name="Text 1"/>
           <p:cNvSpPr/>
           <p:nvPr/>
         </p:nvSpPr>
@@ -11464,7 +12664,7 @@
       </p:sp>
       <p:sp>
         <p:nvSpPr>
-          <p:cNvPr id="1329309250" name="Text 2"/>
+          <p:cNvPr id="1250820864" name="Text 2"/>
           <p:cNvSpPr/>
           <p:nvPr/>
         </p:nvSpPr>
@@ -11522,7 +12722,7 @@
       </p:sp>
       <p:sp>
         <p:nvSpPr>
-          <p:cNvPr id="954057615" name="Text 3"/>
+          <p:cNvPr id="1579222887" name="Text 3"/>
           <p:cNvSpPr/>
           <p:nvPr/>
         </p:nvSpPr>
@@ -11590,7 +12790,7 @@
       </p:sp>
       <p:sp>
         <p:nvSpPr>
-          <p:cNvPr id="902210945" name="Text 4"/>
+          <p:cNvPr id="1663366400" name="Text 4"/>
           <p:cNvSpPr/>
           <p:nvPr/>
         </p:nvSpPr>
@@ -11658,7 +12858,7 @@
       </p:sp>
       <p:sp>
         <p:nvSpPr>
-          <p:cNvPr id="780894899" name="Text 5"/>
+          <p:cNvPr id="989978741" name="Text 5"/>
           <p:cNvSpPr/>
           <p:nvPr/>
         </p:nvSpPr>
@@ -11716,7 +12916,7 @@
       </p:sp>
       <p:sp>
         <p:nvSpPr>
-          <p:cNvPr id="809733056" name="Shape 6"/>
+          <p:cNvPr id="850849008" name="Shape 6"/>
           <p:cNvSpPr/>
           <p:nvPr/>
         </p:nvSpPr>
@@ -11760,7 +12960,7 @@
       </p:sp>
       <p:sp>
         <p:nvSpPr>
-          <p:cNvPr id="1801038945" name="Text 7"/>
+          <p:cNvPr id="1566980833" name="Text 7"/>
           <p:cNvSpPr/>
           <p:nvPr/>
         </p:nvSpPr>
@@ -11828,7 +13028,7 @@
       </p:sp>
       <p:pic>
         <p:nvPicPr>
-          <p:cNvPr id="495873561" name="Image 0" descr="preencoded.png"/>
+          <p:cNvPr id="149885599" name="Image 0" descr="preencoded.png"/>
           <p:cNvPicPr/>
           <p:nvPr/>
         </p:nvPicPr>
@@ -11852,7 +13052,7 @@
       </p:pic>
       <p:sp>
         <p:nvSpPr>
-          <p:cNvPr id="2042120519" name="Text 8"/>
+          <p:cNvPr id="1220743206" name="Text 8"/>
           <p:cNvSpPr/>
           <p:nvPr/>
         </p:nvSpPr>
@@ -11920,7 +13120,7 @@
       </p:sp>
       <p:sp>
         <p:nvSpPr>
-          <p:cNvPr id="1816951347" name="Text 9"/>
+          <p:cNvPr id="1993936146" name="Text 9"/>
           <p:cNvSpPr/>
           <p:nvPr/>
         </p:nvSpPr>
@@ -12018,7 +13218,7 @@
       </p:sp>
       <p:sp>
         <p:nvSpPr>
-          <p:cNvPr id="507023777" name="Shape 10"/>
+          <p:cNvPr id="1107575624" name="Shape 10"/>
           <p:cNvSpPr/>
           <p:nvPr/>
         </p:nvSpPr>
@@ -12062,7 +13262,7 @@
       </p:sp>
       <p:sp>
         <p:nvSpPr>
-          <p:cNvPr id="1031941457" name="Text 11"/>
+          <p:cNvPr id="1061056791" name="Text 11"/>
           <p:cNvSpPr/>
           <p:nvPr/>
         </p:nvSpPr>
@@ -12130,7 +13330,7 @@
       </p:sp>
       <p:pic>
         <p:nvPicPr>
-          <p:cNvPr id="756740304" name="Image 1" descr="preencoded.png"/>
+          <p:cNvPr id="137800266" name="Image 1" descr="preencoded.png"/>
           <p:cNvPicPr/>
           <p:nvPr/>
         </p:nvPicPr>
@@ -12154,7 +13354,7 @@
       </p:pic>
       <p:sp>
         <p:nvSpPr>
-          <p:cNvPr id="2070446161" name="Text 12"/>
+          <p:cNvPr id="1431782554" name="Text 12"/>
           <p:cNvSpPr/>
           <p:nvPr/>
         </p:nvSpPr>
@@ -12212,7 +13412,7 @@
       </p:sp>
       <p:sp>
         <p:nvSpPr>
-          <p:cNvPr id="2128951686" name="Text 13"/>
+          <p:cNvPr id="2016876432" name="Text 13"/>
           <p:cNvSpPr/>
           <p:nvPr/>
         </p:nvSpPr>
@@ -12270,7 +13470,7 @@
       </p:sp>
       <p:sp>
         <p:nvSpPr>
-          <p:cNvPr id="1101007532" name="Shape 14"/>
+          <p:cNvPr id="1747675216" name="Shape 14"/>
           <p:cNvSpPr/>
           <p:nvPr/>
         </p:nvSpPr>
@@ -12314,7 +13514,7 @@
       </p:sp>
       <p:sp>
         <p:nvSpPr>
-          <p:cNvPr id="43513260" name="Text 15"/>
+          <p:cNvPr id="1157956527" name="Text 15"/>
           <p:cNvSpPr/>
           <p:nvPr/>
         </p:nvSpPr>
@@ -12382,7 +13582,7 @@
       </p:sp>
       <p:pic>
         <p:nvPicPr>
-          <p:cNvPr id="1966734930" name="Image 2" descr="preencoded.png"/>
+          <p:cNvPr id="988641731" name="Image 2" descr="preencoded.png"/>
           <p:cNvPicPr/>
           <p:nvPr/>
         </p:nvPicPr>
@@ -12406,7 +13606,7 @@
       </p:pic>
       <p:sp>
         <p:nvSpPr>
-          <p:cNvPr id="1863705255" name="Text 16"/>
+          <p:cNvPr id="284981304" name="Text 16"/>
           <p:cNvSpPr/>
           <p:nvPr/>
         </p:nvSpPr>
@@ -12464,7 +13664,7 @@
       </p:sp>
       <p:sp>
         <p:nvSpPr>
-          <p:cNvPr id="497457230" name="Text 17"/>
+          <p:cNvPr id="594573343" name="Text 17"/>
           <p:cNvSpPr/>
           <p:nvPr/>
         </p:nvSpPr>
@@ -12522,7 +13722,7 @@
       </p:sp>
       <p:sp>
         <p:nvSpPr>
-          <p:cNvPr id="749563276" name="Shape 18"/>
+          <p:cNvPr id="1371807952" name="Shape 18"/>
           <p:cNvSpPr/>
           <p:nvPr/>
         </p:nvSpPr>
@@ -12566,7 +13766,7 @@
       </p:sp>
       <p:sp>
         <p:nvSpPr>
-          <p:cNvPr id="266867855" name="Text 19"/>
+          <p:cNvPr id="774004436" name="Text 19"/>
           <p:cNvSpPr/>
           <p:nvPr/>
         </p:nvSpPr>
@@ -12634,7 +13834,7 @@
       </p:sp>
       <p:pic>
         <p:nvPicPr>
-          <p:cNvPr id="2123372896" name="Image 3" descr="preencoded.png"/>
+          <p:cNvPr id="817399958" name="Image 3" descr="preencoded.png"/>
           <p:cNvPicPr/>
           <p:nvPr/>
         </p:nvPicPr>
@@ -12658,7 +13858,7 @@
       </p:pic>
       <p:sp>
         <p:nvSpPr>
-          <p:cNvPr id="2032484805" name="Text 20"/>
+          <p:cNvPr id="856619513" name="Text 20"/>
           <p:cNvSpPr/>
           <p:nvPr/>
         </p:nvSpPr>
@@ -12716,7 +13916,7 @@
       </p:sp>
       <p:sp>
         <p:nvSpPr>
-          <p:cNvPr id="1065262737" name="Text 21"/>
+          <p:cNvPr id="1485473882" name="Text 21"/>
           <p:cNvSpPr/>
           <p:nvPr/>
         </p:nvSpPr>
@@ -12774,7 +13974,7 @@
       </p:sp>
       <p:sp>
         <p:nvSpPr>
-          <p:cNvPr id="2016434406" name="Text 22"/>
+          <p:cNvPr id="151926755" name="Text 22"/>
           <p:cNvSpPr/>
           <p:nvPr/>
         </p:nvSpPr>
@@ -12832,7 +14032,7 @@
       </p:sp>
       <p:sp>
         <p:nvSpPr>
-          <p:cNvPr id="1905953678" name="Text 23"/>
+          <p:cNvPr id="1499560159" name="Text 23"/>
           <p:cNvSpPr/>
           <p:nvPr/>
         </p:nvSpPr>
@@ -12950,7 +14150,7 @@
       </p:grpSpPr>
       <p:sp>
         <p:nvSpPr>
-          <p:cNvPr id="1475801700" name="Shape 0"/>
+          <p:cNvPr id="268147039" name="Shape 0"/>
           <p:cNvSpPr/>
           <p:nvPr/>
         </p:nvSpPr>
@@ -12994,7 +14194,7 @@
       </p:sp>
       <p:sp>
         <p:nvSpPr>
-          <p:cNvPr id="608051111" name="Text 1"/>
+          <p:cNvPr id="2076315955" name="Text 1"/>
           <p:cNvSpPr/>
           <p:nvPr/>
         </p:nvSpPr>
@@ -13052,7 +14252,7 @@
       </p:sp>
       <p:sp>
         <p:nvSpPr>
-          <p:cNvPr id="2084527036" name="Text 2"/>
+          <p:cNvPr id="779295802" name="Text 2"/>
           <p:cNvSpPr/>
           <p:nvPr/>
         </p:nvSpPr>
@@ -13112,7 +14312,7 @@
       </p:sp>
       <p:sp>
         <p:nvSpPr>
-          <p:cNvPr id="295629945" name="Text 3"/>
+          <p:cNvPr id="1792094845" name="Text 3"/>
           <p:cNvSpPr/>
           <p:nvPr/>
         </p:nvSpPr>
@@ -13184,7 +14384,7 @@
       </p:sp>
       <p:sp>
         <p:nvSpPr>
-          <p:cNvPr id="1847968381" name="Text 4"/>
+          <p:cNvPr id="1946049994" name="Text 4"/>
           <p:cNvSpPr/>
           <p:nvPr/>
         </p:nvSpPr>
@@ -13268,7 +14468,7 @@
       </p:sp>
       <p:sp>
         <p:nvSpPr>
-          <p:cNvPr id="790161197" name="Text 5"/>
+          <p:cNvPr id="1721210376" name="Text 5"/>
           <p:cNvSpPr/>
           <p:nvPr/>
         </p:nvSpPr>
@@ -13336,7 +14536,7 @@
       </p:sp>
       <p:sp>
         <p:nvSpPr>
-          <p:cNvPr id="544780188" name="Text 6"/>
+          <p:cNvPr id="906273815" name="Text 6"/>
           <p:cNvSpPr/>
           <p:nvPr/>
         </p:nvSpPr>
@@ -13396,13 +14596,13 @@
       </p:sp>
       <p:sp>
         <p:nvSpPr>
-          <p:cNvPr id="1985837495" name="Text 7"/>
-          <p:cNvSpPr/>
-          <p:nvPr/>
-        </p:nvSpPr>
-        <p:spPr bwMode="auto">
-          <a:xfrm>
-            <a:off x="972359" y="5646060"/>
+          <p:cNvPr id="1626710457" name="Text 7"/>
+          <p:cNvSpPr/>
+          <p:nvPr/>
+        </p:nvSpPr>
+        <p:spPr bwMode="auto">
+          <a:xfrm>
+            <a:off x="972358" y="5646060"/>
             <a:ext cx="5166720" cy="371160"/>
           </a:xfrm>
           <a:prstGeom prst="rect">
@@ -13456,13 +14656,13 @@
       </p:sp>
       <p:sp>
         <p:nvSpPr>
-          <p:cNvPr id="1951952415" name="Text 8"/>
-          <p:cNvSpPr/>
-          <p:nvPr/>
-        </p:nvSpPr>
-        <p:spPr bwMode="auto">
-          <a:xfrm>
-            <a:off x="972359" y="6055740"/>
+          <p:cNvPr id="1192521255" name="Text 8"/>
+          <p:cNvSpPr/>
+          <p:nvPr/>
+        </p:nvSpPr>
+        <p:spPr bwMode="auto">
+          <a:xfrm>
+            <a:off x="972358" y="6055740"/>
             <a:ext cx="5166720" cy="607320"/>
           </a:xfrm>
           <a:prstGeom prst="rect">
@@ -13514,13 +14714,13 @@
       </p:sp>
       <p:sp>
         <p:nvSpPr>
-          <p:cNvPr id="936654664" name="Text 9"/>
-          <p:cNvSpPr/>
-          <p:nvPr/>
-        </p:nvSpPr>
-        <p:spPr bwMode="auto">
-          <a:xfrm>
-            <a:off x="972359" y="6758460"/>
+          <p:cNvPr id="1244615054" name="Text 9"/>
+          <p:cNvSpPr/>
+          <p:nvPr/>
+        </p:nvSpPr>
+        <p:spPr bwMode="auto">
+          <a:xfrm>
+            <a:off x="972358" y="6758460"/>
             <a:ext cx="5166720" cy="792000"/>
           </a:xfrm>
           <a:prstGeom prst="rect">
@@ -13574,7 +14774,7 @@
       </p:sp>
       <p:sp>
         <p:nvSpPr>
-          <p:cNvPr id="550911995" name="Text 10"/>
+          <p:cNvPr id="956808408" name="Text 10"/>
           <p:cNvSpPr/>
           <p:nvPr/>
         </p:nvSpPr>
@@ -13634,7 +14834,7 @@
       </p:sp>
       <p:sp>
         <p:nvSpPr>
-          <p:cNvPr id="301830645" name="Text 11"/>
+          <p:cNvPr id="166880362" name="Text 11"/>
           <p:cNvSpPr/>
           <p:nvPr/>
         </p:nvSpPr>
@@ -13702,7 +14902,7 @@
       </p:sp>
       <p:sp>
         <p:nvSpPr>
-          <p:cNvPr id="935103193" name="Text 12"/>
+          <p:cNvPr id="601447542" name="Text 12"/>
           <p:cNvSpPr/>
           <p:nvPr/>
         </p:nvSpPr>
@@ -13858,7 +15058,7 @@
       </p:sp>
       <p:sp>
         <p:nvSpPr>
-          <p:cNvPr id="1486320110" name="Text 13"/>
+          <p:cNvPr id="288520255" name="Text 13"/>
           <p:cNvSpPr/>
           <p:nvPr/>
         </p:nvSpPr>
@@ -13918,7 +15118,7 @@
       </p:sp>
       <p:sp>
         <p:nvSpPr>
-          <p:cNvPr id="334830274" name="Text 14"/>
+          <p:cNvPr id="1619535129" name="Text 14"/>
           <p:cNvSpPr/>
           <p:nvPr/>
         </p:nvSpPr>
@@ -13976,13 +15176,13 @@
       </p:sp>
       <p:sp>
         <p:nvSpPr>
-          <p:cNvPr id="1688969194" name="Text 15"/>
-          <p:cNvSpPr/>
-          <p:nvPr/>
-        </p:nvSpPr>
-        <p:spPr bwMode="auto">
-          <a:xfrm>
-            <a:off x="12148560" y="6787978"/>
+          <p:cNvPr id="1215957212" name="Text 15"/>
+          <p:cNvSpPr/>
+          <p:nvPr/>
+        </p:nvSpPr>
+        <p:spPr bwMode="auto">
+          <a:xfrm>
+            <a:off x="12148560" y="6787977"/>
             <a:ext cx="5166720" cy="415080"/>
           </a:xfrm>
           <a:prstGeom prst="rect">
@@ -14036,7 +15236,7 @@
       </p:sp>
       <p:sp>
         <p:nvSpPr>
-          <p:cNvPr id="201891272" name="Text 16"/>
+          <p:cNvPr id="1067184216" name="Text 16"/>
           <p:cNvSpPr/>
           <p:nvPr/>
         </p:nvSpPr>
@@ -14096,7 +15296,7 @@
       </p:sp>
       <p:sp>
         <p:nvSpPr>
-          <p:cNvPr id="2107547592" name="Text 17"/>
+          <p:cNvPr id="755744476" name="Text 17"/>
           <p:cNvSpPr/>
           <p:nvPr/>
         </p:nvSpPr>
@@ -14196,7 +15396,7 @@
       </p:grpSpPr>
       <p:sp>
         <p:nvSpPr>
-          <p:cNvPr id="981710343" name="Shape 0"/>
+          <p:cNvPr id="415777619" name="Shape 0"/>
           <p:cNvSpPr/>
           <p:nvPr/>
         </p:nvSpPr>
@@ -14240,7 +15440,7 @@
       </p:sp>
       <p:sp>
         <p:nvSpPr>
-          <p:cNvPr id="368715291" name="Text 1"/>
+          <p:cNvPr id="1149455217" name="Text 1"/>
           <p:cNvSpPr/>
           <p:nvPr/>
         </p:nvSpPr>
@@ -14298,7 +15498,7 @@
       </p:sp>
       <p:sp>
         <p:nvSpPr>
-          <p:cNvPr id="1012480395" name="Text 2"/>
+          <p:cNvPr id="983153714" name="Text 2"/>
           <p:cNvSpPr/>
           <p:nvPr/>
         </p:nvSpPr>
@@ -14356,7 +15556,7 @@
       </p:sp>
       <p:sp>
         <p:nvSpPr>
-          <p:cNvPr id="258905470" name="Text 3"/>
+          <p:cNvPr id="626030941" name="Text 3"/>
           <p:cNvSpPr/>
           <p:nvPr/>
         </p:nvSpPr>
@@ -14424,7 +15624,7 @@
       </p:sp>
       <p:sp>
         <p:nvSpPr>
-          <p:cNvPr id="1054583620" name="Text 4"/>
+          <p:cNvPr id="1345912445" name="Text 4"/>
           <p:cNvSpPr/>
           <p:nvPr/>
         </p:nvSpPr>
@@ -14492,7 +15692,7 @@
       </p:sp>
       <p:sp>
         <p:nvSpPr>
-          <p:cNvPr id="1959366808" name="Text 5"/>
+          <p:cNvPr id="1262703188" name="Text 5"/>
           <p:cNvSpPr/>
           <p:nvPr/>
         </p:nvSpPr>
@@ -14610,7 +15810,7 @@
       </p:sp>
       <p:sp>
         <p:nvSpPr>
-          <p:cNvPr id="622638716" name="Text 6"/>
+          <p:cNvPr id="47805541" name="Text 6"/>
           <p:cNvSpPr/>
           <p:nvPr/>
         </p:nvSpPr>
@@ -14668,7 +15868,7 @@
       </p:sp>
       <p:sp>
         <p:nvSpPr>
-          <p:cNvPr id="1507952935" name="Text 7"/>
+          <p:cNvPr id="321755152" name="Text 7"/>
           <p:cNvSpPr/>
           <p:nvPr/>
         </p:nvSpPr>
@@ -14726,7 +15926,7 @@
       </p:sp>
       <p:sp>
         <p:nvSpPr>
-          <p:cNvPr id="2117137047" name="Shape 8"/>
+          <p:cNvPr id="1634202786" name="Shape 8"/>
           <p:cNvSpPr/>
           <p:nvPr/>
         </p:nvSpPr>
@@ -14772,7 +15972,7 @@
       </p:sp>
       <p:sp>
         <p:nvSpPr>
-          <p:cNvPr id="365943872" name="Text 9"/>
+          <p:cNvPr id="1513766674" name="Text 9"/>
           <p:cNvSpPr/>
           <p:nvPr/>
         </p:nvSpPr>
@@ -14830,7 +16030,7 @@
       </p:sp>
       <p:sp>
         <p:nvSpPr>
-          <p:cNvPr id="762558139" name="Text 10"/>
+          <p:cNvPr id="1404525155" name="Text 10"/>
           <p:cNvSpPr/>
           <p:nvPr/>
         </p:nvSpPr>
@@ -14888,7 +16088,7 @@
       </p:sp>
       <p:sp>
         <p:nvSpPr>
-          <p:cNvPr id="1300366708" name="Text 11"/>
+          <p:cNvPr id="347704216" name="Text 11"/>
           <p:cNvSpPr/>
           <p:nvPr/>
         </p:nvSpPr>
@@ -14946,7 +16146,7 @@
       </p:sp>
       <p:sp>
         <p:nvSpPr>
-          <p:cNvPr id="1408805184" name="Text 12"/>
+          <p:cNvPr id="1736339511" name="Text 12"/>
           <p:cNvSpPr/>
           <p:nvPr/>
         </p:nvSpPr>
@@ -15004,7 +16204,7 @@
       </p:sp>
       <p:sp>
         <p:nvSpPr>
-          <p:cNvPr id="1391449506" name="Text 13"/>
+          <p:cNvPr id="1375884240" name="Text 13"/>
           <p:cNvSpPr/>
           <p:nvPr/>
         </p:nvSpPr>
@@ -15062,7 +16262,7 @@
       </p:sp>
       <p:sp>
         <p:nvSpPr>
-          <p:cNvPr id="65882582" name="Text 14"/>
+          <p:cNvPr id="1805161126" name="Text 14"/>
           <p:cNvSpPr/>
           <p:nvPr/>
         </p:nvSpPr>
@@ -15120,7 +16320,7 @@
       </p:sp>
       <p:sp>
         <p:nvSpPr>
-          <p:cNvPr id="2042319028" name="Shape 15"/>
+          <p:cNvPr id="1321597264" name="Shape 15"/>
           <p:cNvSpPr/>
           <p:nvPr/>
         </p:nvSpPr>
@@ -15167,7 +16367,7 @@
       </p:sp>
       <p:sp>
         <p:nvSpPr>
-          <p:cNvPr id="817929506" name="Text 16"/>
+          <p:cNvPr id="77348241" name="Text 16"/>
           <p:cNvSpPr/>
           <p:nvPr/>
         </p:nvSpPr>
@@ -15245,7 +16445,7 @@
       </p:sp>
       <p:pic>
         <p:nvPicPr>
-          <p:cNvPr id="1827540481" name="Image 0" descr="preencoded.png"/>
+          <p:cNvPr id="477708287" name="Image 0" descr="preencoded.png"/>
           <p:cNvPicPr/>
           <p:nvPr/>
         </p:nvPicPr>
@@ -15269,7 +16469,7 @@
       </p:pic>
       <p:sp>
         <p:nvSpPr>
-          <p:cNvPr id="1510223579" name="Text 17"/>
+          <p:cNvPr id="1960988230" name="Text 17"/>
           <p:cNvSpPr/>
           <p:nvPr/>
         </p:nvSpPr>
@@ -15327,7 +16527,7 @@
       </p:sp>
       <p:sp>
         <p:nvSpPr>
-          <p:cNvPr id="1361946055" name="Shape 18"/>
+          <p:cNvPr id="583360267" name="Shape 18"/>
           <p:cNvSpPr/>
           <p:nvPr/>
         </p:nvSpPr>
@@ -15374,7 +16574,7 @@
       </p:sp>
       <p:sp>
         <p:nvSpPr>
-          <p:cNvPr id="1328152379" name="Text 19"/>
+          <p:cNvPr id="985846433" name="Text 19"/>
           <p:cNvSpPr/>
           <p:nvPr/>
         </p:nvSpPr>
@@ -15452,7 +16652,7 @@
       </p:sp>
       <p:pic>
         <p:nvPicPr>
-          <p:cNvPr id="302248481" name="Image 1" descr="preencoded.png"/>
+          <p:cNvPr id="1758927447" name="Image 1" descr="preencoded.png"/>
           <p:cNvPicPr/>
           <p:nvPr/>
         </p:nvPicPr>
@@ -15476,7 +16676,7 @@
       </p:pic>
       <p:sp>
         <p:nvSpPr>
-          <p:cNvPr id="702312345" name="Text 20"/>
+          <p:cNvPr id="1499438591" name="Text 20"/>
           <p:cNvSpPr/>
           <p:nvPr/>
         </p:nvSpPr>
@@ -15534,7 +16734,7 @@
       </p:sp>
       <p:sp>
         <p:nvSpPr>
-          <p:cNvPr id="56479663" name="Text 21"/>
+          <p:cNvPr id="1345083187" name="Text 21"/>
           <p:cNvSpPr/>
           <p:nvPr/>
         </p:nvSpPr>
@@ -15592,7 +16792,7 @@
       </p:sp>
       <p:sp>
         <p:nvSpPr>
-          <p:cNvPr id="1818124912" name="Text 22"/>
+          <p:cNvPr id="13829883" name="Text 22"/>
           <p:cNvSpPr/>
           <p:nvPr/>
         </p:nvSpPr>
@@ -15730,7 +16930,7 @@
       </p:grpSpPr>
       <p:sp>
         <p:nvSpPr>
-          <p:cNvPr id="236028453" name="Shape 0"/>
+          <p:cNvPr id="44045953" name="Shape 0"/>
           <p:cNvSpPr/>
           <p:nvPr/>
         </p:nvSpPr>
@@ -15774,7 +16974,7 @@
       </p:sp>
       <p:sp>
         <p:nvSpPr>
-          <p:cNvPr id="1633793987" name="Text 1"/>
+          <p:cNvPr id="768576054" name="Text 1"/>
           <p:cNvSpPr/>
           <p:nvPr/>
         </p:nvSpPr>
@@ -15832,7 +17032,7 @@
       </p:sp>
       <p:sp>
         <p:nvSpPr>
-          <p:cNvPr id="1213808859" name="Text 2"/>
+          <p:cNvPr id="1410488727" name="Text 2"/>
           <p:cNvSpPr/>
           <p:nvPr/>
         </p:nvSpPr>
@@ -15890,7 +17090,7 @@
       </p:sp>
       <p:sp>
         <p:nvSpPr>
-          <p:cNvPr id="1746125775" name="Text 3"/>
+          <p:cNvPr id="1626892963" name="Text 3"/>
           <p:cNvSpPr/>
           <p:nvPr/>
         </p:nvSpPr>
@@ -15968,7 +17168,7 @@
       </p:sp>
       <p:sp>
         <p:nvSpPr>
-          <p:cNvPr id="278640089" name="Text 4"/>
+          <p:cNvPr id="1767802259" name="Text 4"/>
           <p:cNvSpPr/>
           <p:nvPr/>
         </p:nvSpPr>
@@ -16046,7 +17246,7 @@
       </p:sp>
       <p:sp>
         <p:nvSpPr>
-          <p:cNvPr id="2112157493" name="Text 5"/>
+          <p:cNvPr id="1601936927" name="Text 5"/>
           <p:cNvSpPr/>
           <p:nvPr/>
         </p:nvSpPr>
@@ -16124,7 +17324,7 @@
       </p:sp>
       <p:sp>
         <p:nvSpPr>
-          <p:cNvPr id="238217539" name="Shape 6"/>
+          <p:cNvPr id="1497600333" name="Shape 6"/>
           <p:cNvSpPr/>
           <p:nvPr/>
         </p:nvSpPr>
@@ -16171,7 +17371,7 @@
       </p:sp>
       <p:pic>
         <p:nvPicPr>
-          <p:cNvPr id="1090843728" name="Image 0" descr="preencoded.png"/>
+          <p:cNvPr id="448587723" name="Image 0" descr="preencoded.png"/>
           <p:cNvPicPr/>
           <p:nvPr/>
         </p:nvPicPr>
@@ -16195,7 +17395,7 @@
       </p:pic>
       <p:sp>
         <p:nvSpPr>
-          <p:cNvPr id="1235186655" name="Text 7"/>
+          <p:cNvPr id="1710030542" name="Text 7"/>
           <p:cNvSpPr/>
           <p:nvPr/>
         </p:nvSpPr>
@@ -16253,7 +17453,7 @@
       </p:sp>
       <p:sp>
         <p:nvSpPr>
-          <p:cNvPr id="1815987519" name="Text 8"/>
+          <p:cNvPr id="518620456" name="Text 8"/>
           <p:cNvSpPr/>
           <p:nvPr/>
         </p:nvSpPr>
@@ -16411,7 +17611,7 @@
       </p:grpSpPr>
       <p:sp>
         <p:nvSpPr>
-          <p:cNvPr id="1393754872" name="Shape 0"/>
+          <p:cNvPr id="2048959761" name="Shape 0"/>
           <p:cNvSpPr/>
           <p:nvPr/>
         </p:nvSpPr>
@@ -16455,7 +17655,7 @@
       </p:sp>
       <p:sp>
         <p:nvSpPr>
-          <p:cNvPr id="69202372" name="Text 1"/>
+          <p:cNvPr id="556148216" name="Text 1"/>
           <p:cNvSpPr/>
           <p:nvPr/>
         </p:nvSpPr>
@@ -16513,7 +17713,7 @@
       </p:sp>
       <p:sp>
         <p:nvSpPr>
-          <p:cNvPr id="1343480941" name="Text 2"/>
+          <p:cNvPr id="1268941680" name="Text 2"/>
           <p:cNvSpPr/>
           <p:nvPr/>
         </p:nvSpPr>
@@ -16571,7 +17771,7 @@
       </p:sp>
       <p:sp>
         <p:nvSpPr>
-          <p:cNvPr id="1827101703" name="Text 3"/>
+          <p:cNvPr id="527566350" name="Text 3"/>
           <p:cNvSpPr/>
           <p:nvPr/>
         </p:nvSpPr>
@@ -16639,7 +17839,7 @@
       </p:sp>
       <p:sp>
         <p:nvSpPr>
-          <p:cNvPr id="2056517744" name="Text 4"/>
+          <p:cNvPr id="1610970501" name="Text 4"/>
           <p:cNvSpPr/>
           <p:nvPr/>
         </p:nvSpPr>
@@ -16707,7 +17907,7 @@
       </p:sp>
       <p:sp>
         <p:nvSpPr>
-          <p:cNvPr id="898822288" name="Text 5"/>
+          <p:cNvPr id="1174528073" name="Text 5"/>
           <p:cNvSpPr/>
           <p:nvPr/>
         </p:nvSpPr>
@@ -16789,7 +17989,7 @@
       </p:sp>
       <p:sp>
         <p:nvSpPr>
-          <p:cNvPr id="905978517" name="Text 6"/>
+          <p:cNvPr id="556443406" name="Text 6"/>
           <p:cNvSpPr/>
           <p:nvPr/>
         </p:nvSpPr>
@@ -16847,7 +18047,7 @@
       </p:sp>
       <p:sp>
         <p:nvSpPr>
-          <p:cNvPr id="383643775" name="Shape 7"/>
+          <p:cNvPr id="2115986170" name="Shape 7"/>
           <p:cNvSpPr/>
           <p:nvPr/>
         </p:nvSpPr>
@@ -16893,7 +18093,7 @@
       </p:sp>
       <p:sp>
         <p:nvSpPr>
-          <p:cNvPr id="682803266" name="Text 8"/>
+          <p:cNvPr id="412787634" name="Text 8"/>
           <p:cNvSpPr/>
           <p:nvPr/>
         </p:nvSpPr>
@@ -16951,7 +18151,7 @@
       </p:sp>
       <p:sp>
         <p:nvSpPr>
-          <p:cNvPr id="2006490503" name="Text 9"/>
+          <p:cNvPr id="59073656" name="Text 9"/>
           <p:cNvSpPr/>
           <p:nvPr/>
         </p:nvSpPr>
@@ -17009,7 +18209,7 @@
       </p:sp>
       <p:sp>
         <p:nvSpPr>
-          <p:cNvPr id="659972303" name="Text 10"/>
+          <p:cNvPr id="1759304351" name="Text 10"/>
           <p:cNvSpPr/>
           <p:nvPr/>
         </p:nvSpPr>
@@ -17067,7 +18267,7 @@
       </p:sp>
       <p:sp>
         <p:nvSpPr>
-          <p:cNvPr id="282132659" name="Text 11"/>
+          <p:cNvPr id="2068246621" name="Text 11"/>
           <p:cNvSpPr/>
           <p:nvPr/>
         </p:nvSpPr>
@@ -17135,7 +18335,7 @@
       </p:sp>
       <p:sp>
         <p:nvSpPr>
-          <p:cNvPr id="1204635433" name="Text 12"/>
+          <p:cNvPr id="1871646867" name="Text 12"/>
           <p:cNvSpPr/>
           <p:nvPr/>
         </p:nvSpPr>
@@ -17193,7 +18393,7 @@
       </p:sp>
       <p:sp>
         <p:nvSpPr>
-          <p:cNvPr id="930360517" name="Text 13"/>
+          <p:cNvPr id="1978581539" name="Text 13"/>
           <p:cNvSpPr/>
           <p:nvPr/>
         </p:nvSpPr>
@@ -17251,7 +18451,7 @@
       </p:sp>
       <p:sp>
         <p:nvSpPr>
-          <p:cNvPr id="388455664" name="Shape 14"/>
+          <p:cNvPr id="876704677" name="Shape 14"/>
           <p:cNvSpPr/>
           <p:nvPr/>
         </p:nvSpPr>
@@ -17298,7 +18498,7 @@
       </p:sp>
       <p:sp>
         <p:nvSpPr>
-          <p:cNvPr id="1338083699" name="Text 15"/>
+          <p:cNvPr id="568903728" name="Text 15"/>
           <p:cNvSpPr/>
           <p:nvPr/>
         </p:nvSpPr>
@@ -17358,7 +18558,7 @@
       </p:sp>
       <p:pic>
         <p:nvPicPr>
-          <p:cNvPr id="986361131" name="Image 0" descr="preencoded.png"/>
+          <p:cNvPr id="816675061" name="Image 0" descr="preencoded.png"/>
           <p:cNvPicPr/>
           <p:nvPr/>
         </p:nvPicPr>
@@ -17382,7 +18582,7 @@
       </p:pic>
       <p:sp>
         <p:nvSpPr>
-          <p:cNvPr id="2084056285" name="Text 16"/>
+          <p:cNvPr id="1813400699" name="Text 16"/>
           <p:cNvSpPr/>
           <p:nvPr/>
         </p:nvSpPr>
@@ -17440,7 +18640,7 @@
       </p:sp>
       <p:sp>
         <p:nvSpPr>
-          <p:cNvPr id="1342029099" name="Text 17"/>
+          <p:cNvPr id="420159433" name="Text 17"/>
           <p:cNvSpPr/>
           <p:nvPr/>
         </p:nvSpPr>
@@ -17598,7 +18798,7 @@
       </p:grpSpPr>
       <p:sp>
         <p:nvSpPr>
-          <p:cNvPr id="953959685" name="Shape 0"/>
+          <p:cNvPr id="2085963964" name="Shape 0"/>
           <p:cNvSpPr/>
           <p:nvPr/>
         </p:nvSpPr>
@@ -17642,7 +18842,7 @@
       </p:sp>
       <p:sp>
         <p:nvSpPr>
-          <p:cNvPr id="1588987794" name="Text 1"/>
+          <p:cNvPr id="84566039" name="Text 1"/>
           <p:cNvSpPr/>
           <p:nvPr/>
         </p:nvSpPr>
@@ -17700,7 +18900,7 @@
       </p:sp>
       <p:sp>
         <p:nvSpPr>
-          <p:cNvPr id="1656703744" name="Text 2"/>
+          <p:cNvPr id="2124079595" name="Text 2"/>
           <p:cNvSpPr/>
           <p:nvPr/>
         </p:nvSpPr>
@@ -17760,7 +18960,7 @@
       </p:sp>
       <p:sp>
         <p:nvSpPr>
-          <p:cNvPr id="1067872066" name="Text 3"/>
+          <p:cNvPr id="2078471918" name="Text 3"/>
           <p:cNvSpPr/>
           <p:nvPr/>
         </p:nvSpPr>
@@ -17832,7 +19032,7 @@
       </p:sp>
       <p:sp>
         <p:nvSpPr>
-          <p:cNvPr id="1823166397" name="Text 4"/>
+          <p:cNvPr id="29811027" name="Text 4"/>
           <p:cNvSpPr/>
           <p:nvPr/>
         </p:nvSpPr>
@@ -17900,7 +19100,7 @@
       </p:sp>
       <p:sp>
         <p:nvSpPr>
-          <p:cNvPr id="1264389786" name="Text 5"/>
+          <p:cNvPr id="927535820" name="Text 5"/>
           <p:cNvSpPr/>
           <p:nvPr/>
         </p:nvSpPr>
@@ -17960,7 +19160,7 @@
       </p:sp>
       <p:sp>
         <p:nvSpPr>
-          <p:cNvPr id="1436440392" name="Shape 6"/>
+          <p:cNvPr id="915421381" name="Shape 6"/>
           <p:cNvSpPr/>
           <p:nvPr/>
         </p:nvSpPr>
@@ -18004,7 +19204,7 @@
       </p:sp>
       <p:sp>
         <p:nvSpPr>
-          <p:cNvPr id="262787581" name="Text 7"/>
+          <p:cNvPr id="723050229" name="Text 7"/>
           <p:cNvSpPr/>
           <p:nvPr/>
         </p:nvSpPr>
@@ -18064,7 +19264,7 @@
       </p:sp>
       <p:sp>
         <p:nvSpPr>
-          <p:cNvPr id="1219936095" name="Text 8"/>
+          <p:cNvPr id="907107940" name="Text 8"/>
           <p:cNvSpPr/>
           <p:nvPr/>
         </p:nvSpPr>
@@ -18250,7 +19450,7 @@
       </p:sp>
       <p:sp>
         <p:nvSpPr>
-          <p:cNvPr id="1096165120" name="Shape 9"/>
+          <p:cNvPr id="1364369321" name="Shape 9"/>
           <p:cNvSpPr/>
           <p:nvPr/>
         </p:nvSpPr>
@@ -18294,7 +19494,7 @@
       </p:sp>
       <p:sp>
         <p:nvSpPr>
-          <p:cNvPr id="1190279740" name="Text 10"/>
+          <p:cNvPr id="504087592" name="Text 10"/>
           <p:cNvSpPr/>
           <p:nvPr/>
         </p:nvSpPr>
@@ -18354,7 +19554,7 @@
       </p:sp>
       <p:sp>
         <p:nvSpPr>
-          <p:cNvPr id="203484227" name="Text 11"/>
+          <p:cNvPr id="527966327" name="Text 11"/>
           <p:cNvSpPr/>
           <p:nvPr/>
         </p:nvSpPr>
@@ -18530,7 +19730,7 @@
       </p:sp>
       <p:sp>
         <p:nvSpPr>
-          <p:cNvPr id="1063443184" name="Shape 12"/>
+          <p:cNvPr id="1863908537" name="Shape 12"/>
           <p:cNvSpPr/>
           <p:nvPr/>
         </p:nvSpPr>
@@ -18574,7 +19774,7 @@
       </p:sp>
       <p:sp>
         <p:nvSpPr>
-          <p:cNvPr id="1972699463" name="Text 13"/>
+          <p:cNvPr id="1398606677" name="Text 13"/>
           <p:cNvSpPr/>
           <p:nvPr/>
         </p:nvSpPr>
@@ -18634,7 +19834,7 @@
       </p:sp>
       <p:sp>
         <p:nvSpPr>
-          <p:cNvPr id="697564323" name="Text 14"/>
+          <p:cNvPr id="1253448254" name="Text 14"/>
           <p:cNvSpPr/>
           <p:nvPr/>
         </p:nvSpPr>
@@ -18810,7 +20010,7 @@
       </p:sp>
       <p:sp>
         <p:nvSpPr>
-          <p:cNvPr id="235913045" name="Text 15"/>
+          <p:cNvPr id="198275211" name="Text 15"/>
           <p:cNvSpPr/>
           <p:nvPr/>
         </p:nvSpPr>
@@ -18870,7 +20070,7 @@
       </p:sp>
       <p:sp>
         <p:nvSpPr>
-          <p:cNvPr id="1134950762" name="Text 16"/>
+          <p:cNvPr id="212288947" name="Text 16"/>
           <p:cNvSpPr/>
           <p:nvPr/>
         </p:nvSpPr>
@@ -19018,7 +20218,7 @@
       </p:grpSpPr>
       <p:sp>
         <p:nvSpPr>
-          <p:cNvPr id="1688572215" name="Shape 0"/>
+          <p:cNvPr id="276741254" name="Shape 0"/>
           <p:cNvSpPr/>
           <p:nvPr/>
         </p:nvSpPr>
@@ -19062,7 +20262,7 @@
       </p:sp>
       <p:sp>
         <p:nvSpPr>
-          <p:cNvPr id="2108087472" name="Text 1"/>
+          <p:cNvPr id="951421895" name="Text 1"/>
           <p:cNvSpPr/>
           <p:nvPr/>
         </p:nvSpPr>
@@ -19120,7 +20320,7 @@
       </p:sp>
       <p:sp>
         <p:nvSpPr>
-          <p:cNvPr id="524111110" name="Text 2"/>
+          <p:cNvPr id="824120452" name="Text 2"/>
           <p:cNvSpPr/>
           <p:nvPr/>
         </p:nvSpPr>
@@ -19178,7 +20378,7 @@
       </p:sp>
       <p:sp>
         <p:nvSpPr>
-          <p:cNvPr id="1244758089" name="Text 3"/>
+          <p:cNvPr id="573305236" name="Text 3"/>
           <p:cNvSpPr/>
           <p:nvPr/>
         </p:nvSpPr>
@@ -19286,7 +20486,7 @@
       </p:sp>
       <p:sp>
         <p:nvSpPr>
-          <p:cNvPr id="1418798006" name="Text 4"/>
+          <p:cNvPr id="2127023241" name="Text 4"/>
           <p:cNvSpPr/>
           <p:nvPr/>
         </p:nvSpPr>
@@ -19384,7 +20584,7 @@
       </p:sp>
       <p:sp>
         <p:nvSpPr>
-          <p:cNvPr id="1577047204" name="Text 5"/>
+          <p:cNvPr id="351453344" name="Text 5"/>
           <p:cNvSpPr/>
           <p:nvPr/>
         </p:nvSpPr>
@@ -19462,7 +20662,7 @@
       </p:sp>
       <p:sp>
         <p:nvSpPr>
-          <p:cNvPr id="1111255037" name="Text 6"/>
+          <p:cNvPr id="1112451007" name="Text 6"/>
           <p:cNvSpPr/>
           <p:nvPr/>
         </p:nvSpPr>
@@ -19560,7 +20760,7 @@
       </p:sp>
       <p:sp>
         <p:nvSpPr>
-          <p:cNvPr id="2075674447" name="Shape 7"/>
+          <p:cNvPr id="215387679" name="Shape 7"/>
           <p:cNvSpPr/>
           <p:nvPr/>
         </p:nvSpPr>
@@ -19606,7 +20806,7 @@
       </p:sp>
       <p:sp>
         <p:nvSpPr>
-          <p:cNvPr id="1437831706" name="Text 8"/>
+          <p:cNvPr id="120196269" name="Text 8"/>
           <p:cNvSpPr/>
           <p:nvPr/>
         </p:nvSpPr>
@@ -19664,7 +20864,7 @@
       </p:sp>
       <p:sp>
         <p:nvSpPr>
-          <p:cNvPr id="948704298" name="Text 9"/>
+          <p:cNvPr id="1908038359" name="Text 9"/>
           <p:cNvSpPr/>
           <p:nvPr/>
         </p:nvSpPr>
@@ -19722,7 +20922,7 @@
       </p:sp>
       <p:sp>
         <p:nvSpPr>
-          <p:cNvPr id="1280645231" name="Text 10"/>
+          <p:cNvPr id="1375902699" name="Text 10"/>
           <p:cNvSpPr/>
           <p:nvPr/>
         </p:nvSpPr>
@@ -19800,7 +21000,7 @@
       </p:sp>
       <p:sp>
         <p:nvSpPr>
-          <p:cNvPr id="835297470" name="Text 11"/>
+          <p:cNvPr id="1774237948" name="Text 11"/>
           <p:cNvSpPr/>
           <p:nvPr/>
         </p:nvSpPr>
@@ -19858,7 +21058,7 @@
       </p:sp>
       <p:sp>
         <p:nvSpPr>
-          <p:cNvPr id="781981274" name="Text 12"/>
+          <p:cNvPr id="1624500021" name="Text 12"/>
           <p:cNvSpPr/>
           <p:nvPr/>
         </p:nvSpPr>
@@ -19964,7 +21164,7 @@
       </p:sp>
       <p:sp>
         <p:nvSpPr>
-          <p:cNvPr id="455024112" name="Shape 13"/>
+          <p:cNvPr id="629734177" name="Shape 13"/>
           <p:cNvSpPr/>
           <p:nvPr/>
         </p:nvSpPr>
@@ -20011,7 +21211,7 @@
       </p:sp>
       <p:sp>
         <p:nvSpPr>
-          <p:cNvPr id="1073796200" name="Text 14"/>
+          <p:cNvPr id="743880845" name="Text 14"/>
           <p:cNvSpPr/>
           <p:nvPr/>
         </p:nvSpPr>
@@ -20069,7 +21269,7 @@
       </p:sp>
       <p:sp>
         <p:nvSpPr>
-          <p:cNvPr id="1013254589" name="Text 15"/>
+          <p:cNvPr id="683291472" name="Text 15"/>
           <p:cNvSpPr/>
           <p:nvPr/>
         </p:nvSpPr>
@@ -20340,7 +21540,7 @@
       </p:sp>
       <p:sp>
         <p:nvSpPr>
-          <p:cNvPr id="2140284908" name="Shape 16"/>
+          <p:cNvPr id="1485420518" name="Shape 16"/>
           <p:cNvSpPr/>
           <p:nvPr/>
         </p:nvSpPr>
@@ -20387,7 +21587,7 @@
       </p:sp>
       <p:sp>
         <p:nvSpPr>
-          <p:cNvPr id="256075205" name="Text 17"/>
+          <p:cNvPr id="1901562381" name="Text 17"/>
           <p:cNvSpPr/>
           <p:nvPr/>
         </p:nvSpPr>
@@ -20445,7 +21645,7 @@
       </p:sp>
       <p:sp>
         <p:nvSpPr>
-          <p:cNvPr id="1375646596" name="Text 18"/>
+          <p:cNvPr id="1511629660" name="Text 18"/>
           <p:cNvSpPr/>
           <p:nvPr/>
         </p:nvSpPr>
@@ -20604,7 +21804,7 @@
       </p:sp>
       <p:sp>
         <p:nvSpPr>
-          <p:cNvPr id="1878393752" name="Shape 19"/>
+          <p:cNvPr id="1878665095" name="Shape 19"/>
           <p:cNvSpPr/>
           <p:nvPr/>
         </p:nvSpPr>
@@ -20651,7 +21851,7 @@
       </p:sp>
       <p:sp>
         <p:nvSpPr>
-          <p:cNvPr id="1695801543" name="Text 20"/>
+          <p:cNvPr id="1731197746" name="Text 20"/>
           <p:cNvSpPr/>
           <p:nvPr/>
         </p:nvSpPr>
@@ -20729,7 +21929,7 @@
       </p:sp>
       <p:sp>
         <p:nvSpPr>
-          <p:cNvPr id="792040435" name="Text 21"/>
+          <p:cNvPr id="783263626" name="Text 21"/>
           <p:cNvSpPr/>
           <p:nvPr/>
         </p:nvSpPr>
@@ -20908,7 +22108,7 @@
       </p:sp>
       <p:sp>
         <p:nvSpPr>
-          <p:cNvPr id="1776584651" name="Text 22"/>
+          <p:cNvPr id="792268729" name="Text 22"/>
           <p:cNvSpPr/>
           <p:nvPr/>
         </p:nvSpPr>
@@ -20966,7 +22166,7 @@
       </p:sp>
       <p:sp>
         <p:nvSpPr>
-          <p:cNvPr id="1895352732" name="Text 23"/>
+          <p:cNvPr id="1930112550" name="Text 23"/>
           <p:cNvSpPr/>
           <p:nvPr/>
         </p:nvSpPr>
@@ -21104,7 +22304,7 @@
       </p:sp>
       <p:sp>
         <p:nvSpPr>
-          <p:cNvPr id="338205783" name="Text 11"/>
+          <p:cNvPr id="1412705059" name="Text 11"/>
           <p:cNvSpPr/>
           <p:nvPr/>
         </p:nvSpPr>
@@ -21162,7 +22362,7 @@
       </p:sp>
       <p:sp>
         <p:nvSpPr>
-          <p:cNvPr id="1467830058" name="Text 12"/>
+          <p:cNvPr id="207766948" name="Text 12"/>
           <p:cNvSpPr/>
           <p:nvPr/>
         </p:nvSpPr>

</xml_diff>

<commit_message>
docs: fix inaccurate EV-majority claim in EN + JP presentations (slide 3)
Replace 'EV cars are coming / near future passenger vehicles will be electric'
with Japan's actual 100%-electrified-by-2035 target (EV/PHEV/FCV mix).
JP slide: replace fragmented runs '約10年で日本の乗用車の大半がEVに' with
corrected single run aligned to METI FY2024 CEV subsidy paper.

Co-Authored-By: Claude Sonnet 4.6 <noreply@anthropic.com>
</commit_message>
<xml_diff>
--- a/Mitsue Project Presentation - 日本語.pptx
+++ b/Mitsue Project Presentation - 日本語.pptx
@@ -13679,74 +13679,6 @@
               <a:defRPr/>
             </a:pPr>
             <a:r>
-              <a:rPr lang="en-US" sz="2400" b="1" u="none" strike="noStrike" spc="-11">
-                <a:solidFill>
-                  <a:srgbClr val="1F2A24"/>
-                </a:solidFill>
-                <a:latin typeface="Noto Serif JP"/>
-                <a:ea typeface="Noto Serif JP"/>
-              </a:rPr>
-              <a:t>EV</a:t>
-            </a:r>
-            <a:r>
-              <a:rPr lang="zh-CN" sz="2400" b="1" u="none" strike="noStrike" spc="-11">
-                <a:solidFill>
-                  <a:srgbClr val="1F2A24"/>
-                </a:solidFill>
-                <a:latin typeface="Noto Serif JP"/>
-                <a:ea typeface="Noto Serif JP"/>
-              </a:rPr>
-              <a:t>時代が来る。</a:t>
-            </a:r>
-            <a:endParaRPr lang="en-US" sz="2400" b="0" u="none" strike="noStrike">
-              <a:solidFill>
-                <a:srgbClr val="000000"/>
-              </a:solidFill>
-              <a:latin typeface="Arial"/>
-            </a:endParaRPr>
-          </a:p>
-        </p:txBody>
-      </p:sp>
-      <p:sp>
-        <p:nvSpPr>
-          <p:cNvPr id="830559544" name="Text 9"/>
-          <p:cNvSpPr/>
-          <p:nvPr/>
-        </p:nvSpPr>
-        <p:spPr bwMode="auto">
-          <a:xfrm>
-            <a:off x="1047600" y="7080840"/>
-            <a:ext cx="3948120" cy="1454759"/>
-          </a:xfrm>
-          <a:prstGeom prst="rect">
-            <a:avLst/>
-          </a:prstGeom>
-          <a:noFill/>
-          <a:ln w="0">
-            <a:noFill/>
-          </a:ln>
-        </p:spPr>
-        <p:style>
-          <a:lnRef idx="0"/>
-          <a:fillRef idx="0"/>
-          <a:effectRef idx="0"/>
-          <a:fontRef idx="minor"/>
-        </p:style>
-        <p:txBody>
-          <a:bodyPr lIns="25560" tIns="25560" rIns="25560" bIns="25560" anchor="t">
-            <a:normAutofit fontScale="85000" lnSpcReduction="9999"/>
-          </a:bodyPr>
-          <a:p>
-            <a:pPr defTabSz="914400">
-              <a:lnSpc>
-                <a:spcPct val="155000"/>
-              </a:lnSpc>
-              <a:tabLst>
-                <a:tab pos="0" algn="l"/>
-              </a:tabLst>
-              <a:defRPr/>
-            </a:pPr>
-            <a:r>
               <a:rPr lang="zh-CN" sz="1800" b="0" u="none" strike="noStrike">
                 <a:solidFill>
                   <a:srgbClr val="4C554F"/>
@@ -13754,47 +13686,7 @@
                 <a:latin typeface="Noto Sans JP"/>
                 <a:ea typeface="Noto Sans JP"/>
               </a:rPr>
-              <a:t>約</a:t>
-            </a:r>
-            <a:r>
-              <a:rPr lang="en-US" sz="1800" b="0" u="none" strike="noStrike">
-                <a:solidFill>
-                  <a:srgbClr val="4C554F"/>
-                </a:solidFill>
-                <a:latin typeface="Noto Sans JP"/>
-                <a:ea typeface="Noto Sans JP"/>
-              </a:rPr>
-              <a:t>10</a:t>
-            </a:r>
-            <a:r>
-              <a:rPr lang="zh-CN" sz="1800" b="0" u="none" strike="noStrike">
-                <a:solidFill>
-                  <a:srgbClr val="4C554F"/>
-                </a:solidFill>
-                <a:latin typeface="Noto Sans JP"/>
-                <a:ea typeface="Noto Sans JP"/>
-              </a:rPr>
-              <a:t>年で日本の乗用車の大半が</a:t>
-            </a:r>
-            <a:r>
-              <a:rPr lang="en-US" sz="1800" b="0" u="none" strike="noStrike">
-                <a:solidFill>
-                  <a:srgbClr val="4C554F"/>
-                </a:solidFill>
-                <a:latin typeface="Noto Sans JP"/>
-                <a:ea typeface="Noto Sans JP"/>
-              </a:rPr>
-              <a:t>EV</a:t>
-            </a:r>
-            <a:r>
-              <a:rPr lang="zh-CN" sz="1800" b="0" u="none" strike="noStrike">
-                <a:solidFill>
-                  <a:srgbClr val="4C554F"/>
-                </a:solidFill>
-                <a:latin typeface="Noto Sans JP"/>
-                <a:ea typeface="Noto Sans JP"/>
-              </a:rPr>
-              <a:t>に。農村の電力網には新たな分散電源が必要。送電線の延伸は遅く、高コストです。</a:t>
+              <a:t>日本は2035年までに新車乗用車の100%を電動車（EV・PHEV・FCV）とすることを目標としています。農村部には分散型発電と充電インフラが必要であり、系統延伸は遅く高コストです。</a:t>
             </a:r>
             <a:endParaRPr lang="en-US" sz="1800" b="0" u="none" strike="noStrike">
               <a:solidFill>

</xml_diff>

<commit_message>
docs: remove Joi Ito as advisor across all documents
- Drop Joi Ito from advisory-board listings (stakeholders EN/JP, SONNET_TASK)
- Rewrite HIGHRESO intro, quantum-mesh, and Baker & McKenzie outreach as
  direct approaches (they were built on Joi Ito as the warm-referral premise)
- Remove Joi Ito text run from presentation slide 9 (EN/JP pptx)
- Regenerate all affected PDFs (charter, brochures, intro, stakeholders, etc.)
  so published documents match the corrected sources

Also flushes pending working-tree source edits captured during regeneration.

Co-Authored-By: Claude Opus 4.8 <noreply@anthropic.com>
</commit_message>
<xml_diff>
--- a/Mitsue Project Presentation - 日本語.pptx
+++ b/Mitsue Project Presentation - 日本語.pptx
@@ -45,7 +45,7 @@
       </p:grpSpPr>
       <p:sp>
         <p:nvSpPr>
-          <p:cNvPr id="197521761" name="PlaceHolder 1"/>
+          <p:cNvPr id="1295010890" name="PlaceHolder 1"/>
           <p:cNvSpPr>
             <a:spLocks noGrp="1"/>
           </p:cNvSpPr>
@@ -94,7 +94,7 @@
       </p:sp>
       <p:sp>
         <p:nvSpPr>
-          <p:cNvPr id="1161140028" name="PlaceHolder 2"/>
+          <p:cNvPr id="598061854" name="PlaceHolder 2"/>
           <p:cNvSpPr>
             <a:spLocks noGrp="1"/>
           </p:cNvSpPr>
@@ -153,7 +153,7 @@
       </p:sp>
       <p:sp>
         <p:nvSpPr>
-          <p:cNvPr id="675968359" name="PlaceHolder 3"/>
+          <p:cNvPr id="80086207" name="PlaceHolder 3"/>
           <p:cNvSpPr>
             <a:spLocks noGrp="1"/>
           </p:cNvSpPr>
@@ -203,7 +203,7 @@
       </p:sp>
       <p:sp>
         <p:nvSpPr>
-          <p:cNvPr id="223762684" name="PlaceHolder 4"/>
+          <p:cNvPr id="1124829099" name="PlaceHolder 4"/>
           <p:cNvSpPr>
             <a:spLocks noGrp="1"/>
           </p:cNvSpPr>
@@ -264,7 +264,7 @@
       </p:sp>
       <p:sp>
         <p:nvSpPr>
-          <p:cNvPr id="1713456373" name="PlaceHolder 5"/>
+          <p:cNvPr id="399878085" name="PlaceHolder 5"/>
           <p:cNvSpPr>
             <a:spLocks noGrp="1"/>
           </p:cNvSpPr>
@@ -325,7 +325,7 @@
       </p:sp>
       <p:sp>
         <p:nvSpPr>
-          <p:cNvPr id="404328435" name="PlaceHolder 6"/>
+          <p:cNvPr id="447818689" name="PlaceHolder 6"/>
           <p:cNvSpPr>
             <a:spLocks noGrp="1"/>
           </p:cNvSpPr>
@@ -409,7 +409,7 @@
       </p:grpSpPr>
       <p:sp>
         <p:nvSpPr>
-          <p:cNvPr id="2070466821" name="PlaceHolder 1"/>
+          <p:cNvPr id="1935554336" name="PlaceHolder 1"/>
           <p:cNvSpPr>
             <a:spLocks noGrp="1"/>
           </p:cNvSpPr>
@@ -432,7 +432,7 @@
       </p:sp>
       <p:sp>
         <p:nvSpPr>
-          <p:cNvPr id="657573335" name="PlaceHolder 2"/>
+          <p:cNvPr id="918611323" name="PlaceHolder 2"/>
           <p:cNvSpPr>
             <a:spLocks noGrp="1"/>
           </p:cNvSpPr>
@@ -542,7 +542,7 @@
       </p:sp>
       <p:sp>
         <p:nvSpPr>
-          <p:cNvPr id="1973146529" name="PlaceHolder 3"/>
+          <p:cNvPr id="1734448161" name="PlaceHolder 3"/>
           <p:cNvSpPr>
             <a:spLocks noGrp="1"/>
           </p:cNvSpPr>
@@ -642,7 +642,7 @@
       </p:grpSpPr>
       <p:sp>
         <p:nvSpPr>
-          <p:cNvPr id="998354088" name="PlaceHolder 1"/>
+          <p:cNvPr id="985808270" name="PlaceHolder 1"/>
           <p:cNvSpPr>
             <a:spLocks noGrp="1"/>
           </p:cNvSpPr>
@@ -665,7 +665,7 @@
       </p:sp>
       <p:sp>
         <p:nvSpPr>
-          <p:cNvPr id="769323852" name="PlaceHolder 2"/>
+          <p:cNvPr id="1994441286" name="PlaceHolder 2"/>
           <p:cNvSpPr>
             <a:spLocks noGrp="1"/>
           </p:cNvSpPr>
@@ -775,7 +775,7 @@
       </p:sp>
       <p:sp>
         <p:nvSpPr>
-          <p:cNvPr id="454070341" name="PlaceHolder 3"/>
+          <p:cNvPr id="815316954" name="PlaceHolder 3"/>
           <p:cNvSpPr>
             <a:spLocks noGrp="1"/>
           </p:cNvSpPr>
@@ -875,7 +875,7 @@
       </p:grpSpPr>
       <p:sp>
         <p:nvSpPr>
-          <p:cNvPr id="714226646" name="PlaceHolder 1"/>
+          <p:cNvPr id="692161728" name="PlaceHolder 1"/>
           <p:cNvSpPr>
             <a:spLocks noGrp="1"/>
           </p:cNvSpPr>
@@ -898,7 +898,7 @@
       </p:sp>
       <p:sp>
         <p:nvSpPr>
-          <p:cNvPr id="1774471380" name="PlaceHolder 2"/>
+          <p:cNvPr id="1107445288" name="PlaceHolder 2"/>
           <p:cNvSpPr>
             <a:spLocks noGrp="1"/>
           </p:cNvSpPr>
@@ -939,7 +939,7 @@
       </p:sp>
       <p:sp>
         <p:nvSpPr>
-          <p:cNvPr id="1086996805" name="PlaceHolder 3"/>
+          <p:cNvPr id="402694603" name="PlaceHolder 3"/>
           <p:cNvSpPr>
             <a:spLocks noGrp="1"/>
           </p:cNvSpPr>
@@ -1005,7 +1005,7 @@
       </p:grpSpPr>
       <p:sp>
         <p:nvSpPr>
-          <p:cNvPr id="221591703" name="PlaceHolder 1"/>
+          <p:cNvPr id="221184182" name="PlaceHolder 1"/>
           <p:cNvSpPr>
             <a:spLocks noGrp="1"/>
           </p:cNvSpPr>
@@ -1028,7 +1028,7 @@
       </p:sp>
       <p:sp>
         <p:nvSpPr>
-          <p:cNvPr id="1806948111" name="PlaceHolder 2"/>
+          <p:cNvPr id="1201981277" name="PlaceHolder 2"/>
           <p:cNvSpPr>
             <a:spLocks noGrp="1"/>
           </p:cNvSpPr>
@@ -1120,7 +1120,7 @@
       </p:sp>
       <p:sp>
         <p:nvSpPr>
-          <p:cNvPr id="542564143" name="PlaceHolder 3"/>
+          <p:cNvPr id="906682641" name="PlaceHolder 3"/>
           <p:cNvSpPr>
             <a:spLocks noGrp="1"/>
           </p:cNvSpPr>
@@ -1220,7 +1220,7 @@
       </p:grpSpPr>
       <p:sp>
         <p:nvSpPr>
-          <p:cNvPr id="1732338039" name="PlaceHolder 1"/>
+          <p:cNvPr id="1890801967" name="PlaceHolder 1"/>
           <p:cNvSpPr>
             <a:spLocks noGrp="1"/>
           </p:cNvSpPr>
@@ -1243,7 +1243,7 @@
       </p:sp>
       <p:sp>
         <p:nvSpPr>
-          <p:cNvPr id="823011282" name="PlaceHolder 2"/>
+          <p:cNvPr id="697243306" name="PlaceHolder 2"/>
           <p:cNvSpPr>
             <a:spLocks noGrp="1"/>
           </p:cNvSpPr>
@@ -1317,7 +1317,7 @@
       </p:sp>
       <p:sp>
         <p:nvSpPr>
-          <p:cNvPr id="1818907761" name="PlaceHolder 3"/>
+          <p:cNvPr id="221292236" name="PlaceHolder 3"/>
           <p:cNvSpPr>
             <a:spLocks noGrp="1"/>
           </p:cNvSpPr>
@@ -1417,7 +1417,7 @@
       </p:grpSpPr>
       <p:sp>
         <p:nvSpPr>
-          <p:cNvPr id="1703996283" name="PlaceHolder 1"/>
+          <p:cNvPr id="1074039612" name="PlaceHolder 1"/>
           <p:cNvSpPr>
             <a:spLocks noGrp="1"/>
           </p:cNvSpPr>
@@ -1440,7 +1440,7 @@
       </p:sp>
       <p:sp>
         <p:nvSpPr>
-          <p:cNvPr id="81778844" name="PlaceHolder 2"/>
+          <p:cNvPr id="784795310" name="PlaceHolder 2"/>
           <p:cNvSpPr>
             <a:spLocks noGrp="1"/>
           </p:cNvSpPr>
@@ -1532,7 +1532,7 @@
       </p:sp>
       <p:sp>
         <p:nvSpPr>
-          <p:cNvPr id="1334087116" name="PlaceHolder 3"/>
+          <p:cNvPr id="1338293597" name="PlaceHolder 3"/>
           <p:cNvSpPr>
             <a:spLocks noGrp="1"/>
           </p:cNvSpPr>
@@ -1632,7 +1632,7 @@
       </p:grpSpPr>
       <p:sp>
         <p:nvSpPr>
-          <p:cNvPr id="1381197871" name="PlaceHolder 1"/>
+          <p:cNvPr id="1963159720" name="PlaceHolder 1"/>
           <p:cNvSpPr>
             <a:spLocks noGrp="1"/>
           </p:cNvSpPr>
@@ -1655,7 +1655,7 @@
       </p:sp>
       <p:sp>
         <p:nvSpPr>
-          <p:cNvPr id="1296983903" name="PlaceHolder 2"/>
+          <p:cNvPr id="2049443482" name="PlaceHolder 2"/>
           <p:cNvSpPr>
             <a:spLocks noGrp="1"/>
           </p:cNvSpPr>
@@ -1747,7 +1747,7 @@
       </p:sp>
       <p:sp>
         <p:nvSpPr>
-          <p:cNvPr id="1590985176" name="PlaceHolder 3"/>
+          <p:cNvPr id="1795269428" name="PlaceHolder 3"/>
           <p:cNvSpPr>
             <a:spLocks noGrp="1"/>
           </p:cNvSpPr>
@@ -1847,7 +1847,7 @@
       </p:grpSpPr>
       <p:sp>
         <p:nvSpPr>
-          <p:cNvPr id="1925971757" name="PlaceHolder 1"/>
+          <p:cNvPr id="264088751" name="PlaceHolder 1"/>
           <p:cNvSpPr>
             <a:spLocks noGrp="1"/>
           </p:cNvSpPr>
@@ -1870,7 +1870,7 @@
       </p:sp>
       <p:sp>
         <p:nvSpPr>
-          <p:cNvPr id="1108150413" name="PlaceHolder 2"/>
+          <p:cNvPr id="922398208" name="PlaceHolder 2"/>
           <p:cNvSpPr>
             <a:spLocks noGrp="1"/>
           </p:cNvSpPr>
@@ -1980,7 +1980,7 @@
       </p:sp>
       <p:sp>
         <p:nvSpPr>
-          <p:cNvPr id="637787723" name="PlaceHolder 3"/>
+          <p:cNvPr id="617515806" name="PlaceHolder 3"/>
           <p:cNvSpPr>
             <a:spLocks noGrp="1"/>
           </p:cNvSpPr>
@@ -2080,7 +2080,7 @@
       </p:grpSpPr>
       <p:sp>
         <p:nvSpPr>
-          <p:cNvPr id="54200152" name="PlaceHolder 1"/>
+          <p:cNvPr id="288234193" name="PlaceHolder 1"/>
           <p:cNvSpPr>
             <a:spLocks noGrp="1"/>
           </p:cNvSpPr>
@@ -2103,7 +2103,7 @@
       </p:sp>
       <p:sp>
         <p:nvSpPr>
-          <p:cNvPr id="1549180338" name="PlaceHolder 2"/>
+          <p:cNvPr id="761902110" name="PlaceHolder 2"/>
           <p:cNvSpPr>
             <a:spLocks noGrp="1"/>
           </p:cNvSpPr>
@@ -2177,7 +2177,7 @@
       </p:sp>
       <p:sp>
         <p:nvSpPr>
-          <p:cNvPr id="1090692663" name="PlaceHolder 3"/>
+          <p:cNvPr id="74894366" name="PlaceHolder 3"/>
           <p:cNvSpPr>
             <a:spLocks noGrp="1"/>
           </p:cNvSpPr>
@@ -2277,7 +2277,7 @@
       </p:grpSpPr>
       <p:sp>
         <p:nvSpPr>
-          <p:cNvPr id="38869440" name="PlaceHolder 1"/>
+          <p:cNvPr id="1234068235" name="PlaceHolder 1"/>
           <p:cNvSpPr>
             <a:spLocks noGrp="1"/>
           </p:cNvSpPr>
@@ -2300,7 +2300,7 @@
       </p:sp>
       <p:sp>
         <p:nvSpPr>
-          <p:cNvPr id="351238449" name="PlaceHolder 2"/>
+          <p:cNvPr id="542521723" name="PlaceHolder 2"/>
           <p:cNvSpPr>
             <a:spLocks noGrp="1"/>
           </p:cNvSpPr>
@@ -2374,7 +2374,7 @@
       </p:sp>
       <p:sp>
         <p:nvSpPr>
-          <p:cNvPr id="1229542771" name="PlaceHolder 3"/>
+          <p:cNvPr id="1840666858" name="PlaceHolder 3"/>
           <p:cNvSpPr>
             <a:spLocks noGrp="1"/>
           </p:cNvSpPr>
@@ -2474,7 +2474,7 @@
       </p:grpSpPr>
       <p:sp>
         <p:nvSpPr>
-          <p:cNvPr id="167143458" name="PlaceHolder 1"/>
+          <p:cNvPr id="1249212763" name="PlaceHolder 1"/>
           <p:cNvSpPr>
             <a:spLocks noGrp="1"/>
           </p:cNvSpPr>
@@ -2497,7 +2497,7 @@
       </p:sp>
       <p:sp>
         <p:nvSpPr>
-          <p:cNvPr id="835747974" name="PlaceHolder 2"/>
+          <p:cNvPr id="17239314" name="PlaceHolder 2"/>
           <p:cNvSpPr>
             <a:spLocks noGrp="1"/>
           </p:cNvSpPr>
@@ -2571,7 +2571,7 @@
       </p:sp>
       <p:sp>
         <p:nvSpPr>
-          <p:cNvPr id="1935237026" name="PlaceHolder 3"/>
+          <p:cNvPr id="1142698913" name="PlaceHolder 3"/>
           <p:cNvSpPr>
             <a:spLocks noGrp="1"/>
           </p:cNvSpPr>
@@ -2671,7 +2671,7 @@
       </p:grpSpPr>
       <p:sp>
         <p:nvSpPr>
-          <p:cNvPr id="7030439" name="PlaceHolder 1"/>
+          <p:cNvPr id="799354073" name="PlaceHolder 1"/>
           <p:cNvSpPr>
             <a:spLocks noGrp="1"/>
           </p:cNvSpPr>
@@ -2694,7 +2694,7 @@
       </p:sp>
       <p:sp>
         <p:nvSpPr>
-          <p:cNvPr id="672501367" name="PlaceHolder 2"/>
+          <p:cNvPr id="1201683583" name="PlaceHolder 2"/>
           <p:cNvSpPr>
             <a:spLocks noGrp="1"/>
           </p:cNvSpPr>
@@ -2822,7 +2822,7 @@
       </p:sp>
       <p:sp>
         <p:nvSpPr>
-          <p:cNvPr id="2009324390" name="PlaceHolder 3"/>
+          <p:cNvPr id="680348723" name="PlaceHolder 3"/>
           <p:cNvSpPr>
             <a:spLocks noGrp="1"/>
           </p:cNvSpPr>
@@ -2954,7 +2954,7 @@
       </p:grpSpPr>
       <p:sp>
         <p:nvSpPr>
-          <p:cNvPr id="1265334319" name="PlaceHolder 1"/>
+          <p:cNvPr id="1617058404" name="PlaceHolder 1"/>
           <p:cNvSpPr>
             <a:spLocks noGrp="1"/>
           </p:cNvSpPr>
@@ -3021,7 +3021,7 @@
       </p:sp>
       <p:sp>
         <p:nvSpPr>
-          <p:cNvPr id="1763855193" name="PlaceHolder 2"/>
+          <p:cNvPr id="93503689" name="PlaceHolder 2"/>
           <p:cNvSpPr>
             <a:spLocks noGrp="1"/>
           </p:cNvSpPr>
@@ -3407,7 +3407,7 @@
       </p:grpSpPr>
       <p:sp>
         <p:nvSpPr>
-          <p:cNvPr id="2072692731" name="Shape 0"/>
+          <p:cNvPr id="1364222741" name="Shape 0"/>
           <p:cNvSpPr/>
           <p:nvPr/>
         </p:nvSpPr>
@@ -3451,7 +3451,7 @@
       </p:sp>
       <p:sp>
         <p:nvSpPr>
-          <p:cNvPr id="1504690407" name="Text 1"/>
+          <p:cNvPr id="214352486" name="Text 1"/>
           <p:cNvSpPr/>
           <p:nvPr/>
         </p:nvSpPr>
@@ -3509,7 +3509,7 @@
       </p:sp>
       <p:sp>
         <p:nvSpPr>
-          <p:cNvPr id="1396524534" name="Text 2"/>
+          <p:cNvPr id="468515036" name="Text 2"/>
           <p:cNvSpPr/>
           <p:nvPr/>
         </p:nvSpPr>
@@ -3567,7 +3567,7 @@
       </p:sp>
       <p:sp>
         <p:nvSpPr>
-          <p:cNvPr id="955633914" name="Text 3"/>
+          <p:cNvPr id="1933064868" name="Text 3"/>
           <p:cNvSpPr/>
           <p:nvPr/>
         </p:nvSpPr>
@@ -3705,7 +3705,7 @@
       </p:sp>
       <p:sp>
         <p:nvSpPr>
-          <p:cNvPr id="625245615" name="Text 4"/>
+          <p:cNvPr id="1957505602" name="Text 4"/>
           <p:cNvSpPr/>
           <p:nvPr/>
         </p:nvSpPr>
@@ -3783,7 +3783,7 @@
       </p:sp>
       <p:sp>
         <p:nvSpPr>
-          <p:cNvPr id="1120982806" name="Text 5"/>
+          <p:cNvPr id="1353798140" name="Text 5"/>
           <p:cNvSpPr/>
           <p:nvPr/>
         </p:nvSpPr>
@@ -3851,7 +3851,7 @@
       </p:sp>
       <p:sp>
         <p:nvSpPr>
-          <p:cNvPr id="301559107" name="Text 6"/>
+          <p:cNvPr id="1294681744" name="Text 6"/>
           <p:cNvSpPr/>
           <p:nvPr/>
         </p:nvSpPr>
@@ -3909,7 +3909,7 @@
       </p:sp>
       <p:pic>
         <p:nvPicPr>
-          <p:cNvPr id="1191744802" name="Image 0" descr="preencoded.png"/>
+          <p:cNvPr id="2057711889" name="Image 0" descr="preencoded.png"/>
           <p:cNvPicPr/>
           <p:nvPr/>
         </p:nvPicPr>
@@ -3933,7 +3933,7 @@
       </p:pic>
       <p:sp>
         <p:nvSpPr>
-          <p:cNvPr id="2081003020" name="Text 7"/>
+          <p:cNvPr id="1641739200" name="Text 7"/>
           <p:cNvSpPr/>
           <p:nvPr/>
         </p:nvSpPr>
@@ -3991,7 +3991,7 @@
       </p:sp>
       <p:sp>
         <p:nvSpPr>
-          <p:cNvPr id="1292790991" name="Text 8"/>
+          <p:cNvPr id="32996925" name="Text 8"/>
           <p:cNvSpPr/>
           <p:nvPr/>
         </p:nvSpPr>
@@ -4119,7 +4119,7 @@
       </p:grpSpPr>
       <p:sp>
         <p:nvSpPr>
-          <p:cNvPr id="1302528442" name="Shape 0"/>
+          <p:cNvPr id="1414857656" name="Shape 0"/>
           <p:cNvSpPr/>
           <p:nvPr/>
         </p:nvSpPr>
@@ -4163,7 +4163,7 @@
       </p:sp>
       <p:sp>
         <p:nvSpPr>
-          <p:cNvPr id="563098560" name="Text 1"/>
+          <p:cNvPr id="154020062" name="Text 1"/>
           <p:cNvSpPr/>
           <p:nvPr/>
         </p:nvSpPr>
@@ -4221,7 +4221,7 @@
       </p:sp>
       <p:sp>
         <p:nvSpPr>
-          <p:cNvPr id="758978899" name="Text 2"/>
+          <p:cNvPr id="506827802" name="Text 2"/>
           <p:cNvSpPr/>
           <p:nvPr/>
         </p:nvSpPr>
@@ -4279,7 +4279,7 @@
       </p:sp>
       <p:sp>
         <p:nvSpPr>
-          <p:cNvPr id="817776435" name="Text 3"/>
+          <p:cNvPr id="977052996" name="Text 3"/>
           <p:cNvSpPr/>
           <p:nvPr/>
         </p:nvSpPr>
@@ -4347,7 +4347,7 @@
       </p:sp>
       <p:sp>
         <p:nvSpPr>
-          <p:cNvPr id="461690870" name="Text 4"/>
+          <p:cNvPr id="458118551" name="Text 4"/>
           <p:cNvSpPr/>
           <p:nvPr/>
         </p:nvSpPr>
@@ -4425,7 +4425,7 @@
       </p:sp>
       <p:sp>
         <p:nvSpPr>
-          <p:cNvPr id="550954248" name="Text 5"/>
+          <p:cNvPr id="81426864" name="Text 5"/>
           <p:cNvSpPr/>
           <p:nvPr/>
         </p:nvSpPr>
@@ -4483,7 +4483,7 @@
       </p:sp>
       <p:sp>
         <p:nvSpPr>
-          <p:cNvPr id="1242127353" name="Shape 6"/>
+          <p:cNvPr id="1737768667" name="Shape 6"/>
           <p:cNvSpPr/>
           <p:nvPr/>
         </p:nvSpPr>
@@ -4530,7 +4530,7 @@
       </p:sp>
       <p:sp>
         <p:nvSpPr>
-          <p:cNvPr id="1435326794" name="Text 7"/>
+          <p:cNvPr id="56285513" name="Text 7"/>
           <p:cNvSpPr/>
           <p:nvPr/>
         </p:nvSpPr>
@@ -4638,7 +4638,7 @@
       </p:sp>
       <p:sp>
         <p:nvSpPr>
-          <p:cNvPr id="594898726" name="Text 8"/>
+          <p:cNvPr id="140827414" name="Text 8"/>
           <p:cNvSpPr/>
           <p:nvPr/>
         </p:nvSpPr>
@@ -4696,7 +4696,7 @@
       </p:sp>
       <p:sp>
         <p:nvSpPr>
-          <p:cNvPr id="583210919" name="Text 9"/>
+          <p:cNvPr id="1625050207" name="Text 9"/>
           <p:cNvSpPr/>
           <p:nvPr/>
         </p:nvSpPr>
@@ -4804,7 +4804,7 @@
       </p:sp>
       <p:sp>
         <p:nvSpPr>
-          <p:cNvPr id="584282451" name="Shape 10"/>
+          <p:cNvPr id="792982958" name="Shape 10"/>
           <p:cNvSpPr/>
           <p:nvPr/>
         </p:nvSpPr>
@@ -4851,7 +4851,7 @@
       </p:sp>
       <p:sp>
         <p:nvSpPr>
-          <p:cNvPr id="1162529583" name="Text 11"/>
+          <p:cNvPr id="1933328607" name="Text 11"/>
           <p:cNvSpPr/>
           <p:nvPr/>
         </p:nvSpPr>
@@ -4929,7 +4929,7 @@
       </p:sp>
       <p:sp>
         <p:nvSpPr>
-          <p:cNvPr id="1911095737" name="Text 12"/>
+          <p:cNvPr id="677918622" name="Text 12"/>
           <p:cNvSpPr/>
           <p:nvPr/>
         </p:nvSpPr>
@@ -4987,7 +4987,7 @@
       </p:sp>
       <p:sp>
         <p:nvSpPr>
-          <p:cNvPr id="1977555152" name="Text 13"/>
+          <p:cNvPr id="728271358" name="Text 13"/>
           <p:cNvSpPr/>
           <p:nvPr/>
         </p:nvSpPr>
@@ -5085,7 +5085,7 @@
       </p:sp>
       <p:sp>
         <p:nvSpPr>
-          <p:cNvPr id="2003717147" name="Shape 14"/>
+          <p:cNvPr id="232366483" name="Shape 14"/>
           <p:cNvSpPr/>
           <p:nvPr/>
         </p:nvSpPr>
@@ -5132,7 +5132,7 @@
       </p:sp>
       <p:sp>
         <p:nvSpPr>
-          <p:cNvPr id="1437493233" name="Text 15"/>
+          <p:cNvPr id="943976144" name="Text 15"/>
           <p:cNvSpPr/>
           <p:nvPr/>
         </p:nvSpPr>
@@ -5210,7 +5210,7 @@
       </p:sp>
       <p:sp>
         <p:nvSpPr>
-          <p:cNvPr id="1187233075" name="Text 16"/>
+          <p:cNvPr id="538597641" name="Text 16"/>
           <p:cNvSpPr/>
           <p:nvPr/>
         </p:nvSpPr>
@@ -5268,7 +5268,7 @@
       </p:sp>
       <p:sp>
         <p:nvSpPr>
-          <p:cNvPr id="446679214" name="Text 17"/>
+          <p:cNvPr id="724100809" name="Text 17"/>
           <p:cNvSpPr/>
           <p:nvPr/>
         </p:nvSpPr>
@@ -5366,7 +5366,7 @@
       </p:sp>
       <p:sp>
         <p:nvSpPr>
-          <p:cNvPr id="119151593" name="Shape 18"/>
+          <p:cNvPr id="1547593720" name="Shape 18"/>
           <p:cNvSpPr/>
           <p:nvPr/>
         </p:nvSpPr>
@@ -5413,7 +5413,7 @@
       </p:sp>
       <p:sp>
         <p:nvSpPr>
-          <p:cNvPr id="1227873246" name="Text 19"/>
+          <p:cNvPr id="763112808" name="Text 19"/>
           <p:cNvSpPr/>
           <p:nvPr/>
         </p:nvSpPr>
@@ -5491,7 +5491,7 @@
       </p:sp>
       <p:sp>
         <p:nvSpPr>
-          <p:cNvPr id="1308325009" name="Text 20"/>
+          <p:cNvPr id="1004687839" name="Text 20"/>
           <p:cNvSpPr/>
           <p:nvPr/>
         </p:nvSpPr>
@@ -5549,7 +5549,7 @@
       </p:sp>
       <p:sp>
         <p:nvSpPr>
-          <p:cNvPr id="1223907196" name="Text 21"/>
+          <p:cNvPr id="394265840" name="Text 21"/>
           <p:cNvSpPr/>
           <p:nvPr/>
         </p:nvSpPr>
@@ -5647,7 +5647,7 @@
       </p:sp>
       <p:sp>
         <p:nvSpPr>
-          <p:cNvPr id="1738569934" name="Shape 22"/>
+          <p:cNvPr id="301998778" name="Shape 22"/>
           <p:cNvSpPr/>
           <p:nvPr/>
         </p:nvSpPr>
@@ -5694,7 +5694,7 @@
       </p:sp>
       <p:sp>
         <p:nvSpPr>
-          <p:cNvPr id="978476624" name="Text 23"/>
+          <p:cNvPr id="403690338" name="Text 23"/>
           <p:cNvSpPr/>
           <p:nvPr/>
         </p:nvSpPr>
@@ -5772,7 +5772,7 @@
       </p:sp>
       <p:sp>
         <p:nvSpPr>
-          <p:cNvPr id="1467212826" name="Text 24"/>
+          <p:cNvPr id="810191533" name="Text 24"/>
           <p:cNvSpPr/>
           <p:nvPr/>
         </p:nvSpPr>
@@ -5830,7 +5830,7 @@
       </p:sp>
       <p:sp>
         <p:nvSpPr>
-          <p:cNvPr id="775156214" name="Text 25"/>
+          <p:cNvPr id="1002897070" name="Text 25"/>
           <p:cNvSpPr/>
           <p:nvPr/>
         </p:nvSpPr>
@@ -5898,7 +5898,7 @@
       </p:sp>
       <p:sp>
         <p:nvSpPr>
-          <p:cNvPr id="653658310" name="Text 26"/>
+          <p:cNvPr id="675833249" name="Text 26"/>
           <p:cNvSpPr/>
           <p:nvPr/>
         </p:nvSpPr>
@@ -5956,7 +5956,7 @@
       </p:sp>
       <p:sp>
         <p:nvSpPr>
-          <p:cNvPr id="1666185973" name="Text 27"/>
+          <p:cNvPr id="11883429" name="Text 27"/>
           <p:cNvSpPr/>
           <p:nvPr/>
         </p:nvSpPr>
@@ -6014,7 +6014,7 @@
       </p:sp>
       <p:sp>
         <p:nvSpPr>
-          <p:cNvPr id="1644046179" name="Text 28"/>
+          <p:cNvPr id="1354991134" name="Text 28"/>
           <p:cNvSpPr/>
           <p:nvPr/>
         </p:nvSpPr>
@@ -6072,7 +6072,7 @@
       </p:sp>
       <p:sp>
         <p:nvSpPr>
-          <p:cNvPr id="1555470949" name="Text 29"/>
+          <p:cNvPr id="1736743332" name="Text 29"/>
           <p:cNvSpPr/>
           <p:nvPr/>
         </p:nvSpPr>
@@ -6140,7 +6140,7 @@
       </p:sp>
       <p:sp>
         <p:nvSpPr>
-          <p:cNvPr id="1908469579" name="Text 30"/>
+          <p:cNvPr id="1564436347" name="Text 30"/>
           <p:cNvSpPr/>
           <p:nvPr/>
         </p:nvSpPr>
@@ -6228,7 +6228,7 @@
       </p:sp>
       <p:sp>
         <p:nvSpPr>
-          <p:cNvPr id="1612771972" name="Shape 31"/>
+          <p:cNvPr id="586083656" name="Shape 31"/>
           <p:cNvSpPr/>
           <p:nvPr/>
         </p:nvSpPr>
@@ -6272,7 +6272,7 @@
       </p:sp>
       <p:sp>
         <p:nvSpPr>
-          <p:cNvPr id="247592000" name="Text 32"/>
+          <p:cNvPr id="846951458" name="Text 32"/>
           <p:cNvSpPr/>
           <p:nvPr/>
         </p:nvSpPr>
@@ -6330,7 +6330,7 @@
       </p:sp>
       <p:sp>
         <p:nvSpPr>
-          <p:cNvPr id="111778396" name="Text 33"/>
+          <p:cNvPr id="1664287904" name="Text 33"/>
           <p:cNvSpPr/>
           <p:nvPr/>
         </p:nvSpPr>
@@ -6388,7 +6388,7 @@
       </p:sp>
       <p:sp>
         <p:nvSpPr>
-          <p:cNvPr id="1771778495" name="Text 34"/>
+          <p:cNvPr id="992472014" name="Text 34"/>
           <p:cNvSpPr/>
           <p:nvPr/>
         </p:nvSpPr>
@@ -6456,7 +6456,7 @@
       </p:sp>
       <p:sp>
         <p:nvSpPr>
-          <p:cNvPr id="1277639290" name="Text 35"/>
+          <p:cNvPr id="1784648041" name="Text 35"/>
           <p:cNvSpPr/>
           <p:nvPr/>
         </p:nvSpPr>
@@ -6524,7 +6524,7 @@
       </p:sp>
       <p:sp>
         <p:nvSpPr>
-          <p:cNvPr id="639453383" name="Shape 36"/>
+          <p:cNvPr id="410080827" name="Shape 36"/>
           <p:cNvSpPr/>
           <p:nvPr/>
         </p:nvSpPr>
@@ -6570,7 +6570,7 @@
       </p:sp>
       <p:sp>
         <p:nvSpPr>
-          <p:cNvPr id="2010682356" name="Text 37"/>
+          <p:cNvPr id="171605054" name="Text 37"/>
           <p:cNvSpPr/>
           <p:nvPr/>
         </p:nvSpPr>
@@ -6628,7 +6628,7 @@
       </p:sp>
       <p:sp>
         <p:nvSpPr>
-          <p:cNvPr id="310474170" name="Text 38"/>
+          <p:cNvPr id="1590498095" name="Text 38"/>
           <p:cNvSpPr/>
           <p:nvPr/>
         </p:nvSpPr>
@@ -6686,7 +6686,7 @@
       </p:sp>
       <p:sp>
         <p:nvSpPr>
-          <p:cNvPr id="1385663433" name="Text 39"/>
+          <p:cNvPr id="1749921468" name="Text 39"/>
           <p:cNvSpPr/>
           <p:nvPr/>
         </p:nvSpPr>
@@ -6744,7 +6744,7 @@
       </p:sp>
       <p:sp>
         <p:nvSpPr>
-          <p:cNvPr id="2135664210" name="Text 40"/>
+          <p:cNvPr id="969632699" name="Text 40"/>
           <p:cNvSpPr/>
           <p:nvPr/>
         </p:nvSpPr>
@@ -6802,7 +6802,7 @@
       </p:sp>
       <p:sp>
         <p:nvSpPr>
-          <p:cNvPr id="492990165" name="Shape 41"/>
+          <p:cNvPr id="1639719885" name="Shape 41"/>
           <p:cNvSpPr/>
           <p:nvPr/>
         </p:nvSpPr>
@@ -6848,7 +6848,7 @@
       </p:sp>
       <p:sp>
         <p:nvSpPr>
-          <p:cNvPr id="1882130583" name="Text 42"/>
+          <p:cNvPr id="1753220351" name="Text 42"/>
           <p:cNvSpPr/>
           <p:nvPr/>
         </p:nvSpPr>
@@ -6906,7 +6906,7 @@
       </p:sp>
       <p:sp>
         <p:nvSpPr>
-          <p:cNvPr id="1546788202" name="Text 43"/>
+          <p:cNvPr id="1501338999" name="Text 43"/>
           <p:cNvSpPr/>
           <p:nvPr/>
         </p:nvSpPr>
@@ -6964,7 +6964,7 @@
       </p:sp>
       <p:sp>
         <p:nvSpPr>
-          <p:cNvPr id="556266269" name="Text 44"/>
+          <p:cNvPr id="71100173" name="Text 44"/>
           <p:cNvSpPr/>
           <p:nvPr/>
         </p:nvSpPr>
@@ -7022,7 +7022,7 @@
       </p:sp>
       <p:sp>
         <p:nvSpPr>
-          <p:cNvPr id="380893645" name="Text 45"/>
+          <p:cNvPr id="1460055194" name="Text 45"/>
           <p:cNvSpPr/>
           <p:nvPr/>
         </p:nvSpPr>
@@ -7080,7 +7080,7 @@
       </p:sp>
       <p:sp>
         <p:nvSpPr>
-          <p:cNvPr id="1502126950" name="Shape 46"/>
+          <p:cNvPr id="1593770340" name="Shape 46"/>
           <p:cNvSpPr/>
           <p:nvPr/>
         </p:nvSpPr>
@@ -7126,7 +7126,7 @@
       </p:sp>
       <p:sp>
         <p:nvSpPr>
-          <p:cNvPr id="1348035176" name="Text 47"/>
+          <p:cNvPr id="1055738706" name="Text 47"/>
           <p:cNvSpPr/>
           <p:nvPr/>
         </p:nvSpPr>
@@ -7184,7 +7184,7 @@
       </p:sp>
       <p:sp>
         <p:nvSpPr>
-          <p:cNvPr id="881734692" name="Text 48"/>
+          <p:cNvPr id="907534924" name="Text 48"/>
           <p:cNvSpPr/>
           <p:nvPr/>
         </p:nvSpPr>
@@ -7242,7 +7242,7 @@
       </p:sp>
       <p:sp>
         <p:nvSpPr>
-          <p:cNvPr id="40637871" name="Text 49"/>
+          <p:cNvPr id="1967856192" name="Text 49"/>
           <p:cNvSpPr/>
           <p:nvPr/>
         </p:nvSpPr>
@@ -7300,7 +7300,7 @@
       </p:sp>
       <p:sp>
         <p:nvSpPr>
-          <p:cNvPr id="318023950" name="Text 50"/>
+          <p:cNvPr id="105921294" name="Text 50"/>
           <p:cNvSpPr/>
           <p:nvPr/>
         </p:nvSpPr>
@@ -7358,7 +7358,7 @@
       </p:sp>
       <p:sp>
         <p:nvSpPr>
-          <p:cNvPr id="181259984" name="Shape 51"/>
+          <p:cNvPr id="1115009943" name="Shape 51"/>
           <p:cNvSpPr/>
           <p:nvPr/>
         </p:nvSpPr>
@@ -7404,7 +7404,7 @@
       </p:sp>
       <p:sp>
         <p:nvSpPr>
-          <p:cNvPr id="1615680787" name="Text 52"/>
+          <p:cNvPr id="998650798" name="Text 52"/>
           <p:cNvSpPr/>
           <p:nvPr/>
         </p:nvSpPr>
@@ -7462,7 +7462,7 @@
       </p:sp>
       <p:sp>
         <p:nvSpPr>
-          <p:cNvPr id="1987785237" name="Text 53"/>
+          <p:cNvPr id="1719137075" name="Text 53"/>
           <p:cNvSpPr/>
           <p:nvPr/>
         </p:nvSpPr>
@@ -7520,7 +7520,7 @@
       </p:sp>
       <p:sp>
         <p:nvSpPr>
-          <p:cNvPr id="656351494" name="Text 54"/>
+          <p:cNvPr id="582073202" name="Text 54"/>
           <p:cNvSpPr/>
           <p:nvPr/>
         </p:nvSpPr>
@@ -7578,7 +7578,7 @@
       </p:sp>
       <p:sp>
         <p:nvSpPr>
-          <p:cNvPr id="1947954004" name="Text 55"/>
+          <p:cNvPr id="725049455" name="Text 55"/>
           <p:cNvSpPr/>
           <p:nvPr/>
         </p:nvSpPr>
@@ -7636,7 +7636,7 @@
       </p:sp>
       <p:sp>
         <p:nvSpPr>
-          <p:cNvPr id="247669085" name="Shape 56"/>
+          <p:cNvPr id="1753907322" name="Shape 56"/>
           <p:cNvSpPr/>
           <p:nvPr/>
         </p:nvSpPr>
@@ -7682,7 +7682,7 @@
       </p:sp>
       <p:sp>
         <p:nvSpPr>
-          <p:cNvPr id="1125515618" name="Text 57"/>
+          <p:cNvPr id="473164843" name="Text 57"/>
           <p:cNvSpPr/>
           <p:nvPr/>
         </p:nvSpPr>
@@ -7740,7 +7740,7 @@
       </p:sp>
       <p:sp>
         <p:nvSpPr>
-          <p:cNvPr id="792616168" name="Text 58"/>
+          <p:cNvPr id="1724856562" name="Text 58"/>
           <p:cNvSpPr/>
           <p:nvPr/>
         </p:nvSpPr>
@@ -7798,7 +7798,7 @@
       </p:sp>
       <p:sp>
         <p:nvSpPr>
-          <p:cNvPr id="1563449708" name="Text 59"/>
+          <p:cNvPr id="1330550955" name="Text 59"/>
           <p:cNvSpPr/>
           <p:nvPr/>
         </p:nvSpPr>
@@ -7856,7 +7856,7 @@
       </p:sp>
       <p:sp>
         <p:nvSpPr>
-          <p:cNvPr id="603849567" name="Text 60"/>
+          <p:cNvPr id="668739589" name="Text 60"/>
           <p:cNvSpPr/>
           <p:nvPr/>
         </p:nvSpPr>
@@ -7914,7 +7914,7 @@
       </p:sp>
       <p:sp>
         <p:nvSpPr>
-          <p:cNvPr id="131609376" name="Text 61"/>
+          <p:cNvPr id="62178628" name="Text 61"/>
           <p:cNvSpPr/>
           <p:nvPr/>
         </p:nvSpPr>
@@ -7972,7 +7972,7 @@
       </p:sp>
       <p:sp>
         <p:nvSpPr>
-          <p:cNvPr id="1706597462" name="Text 62"/>
+          <p:cNvPr id="1871383825" name="Text 62"/>
           <p:cNvSpPr/>
           <p:nvPr/>
         </p:nvSpPr>
@@ -8030,7 +8030,7 @@
       </p:sp>
       <p:sp>
         <p:nvSpPr>
-          <p:cNvPr id="1118253017" name="Text 63"/>
+          <p:cNvPr id="1145246726" name="Text 63"/>
           <p:cNvSpPr/>
           <p:nvPr/>
         </p:nvSpPr>
@@ -8088,7 +8088,7 @@
       </p:sp>
       <p:sp>
         <p:nvSpPr>
-          <p:cNvPr id="859466184" name="Text 64"/>
+          <p:cNvPr id="1058054260" name="Text 64"/>
           <p:cNvSpPr/>
           <p:nvPr/>
         </p:nvSpPr>
@@ -8146,7 +8146,7 @@
       </p:sp>
       <p:sp>
         <p:nvSpPr>
-          <p:cNvPr id="1028460194" name="Text 65"/>
+          <p:cNvPr id="293190604" name="Text 65"/>
           <p:cNvSpPr/>
           <p:nvPr/>
         </p:nvSpPr>
@@ -8204,7 +8204,7 @@
       </p:sp>
       <p:sp>
         <p:nvSpPr>
-          <p:cNvPr id="1152297472" name="Text 66"/>
+          <p:cNvPr id="1567620190" name="Text 66"/>
           <p:cNvSpPr/>
           <p:nvPr/>
         </p:nvSpPr>
@@ -8272,7 +8272,7 @@
       </p:sp>
       <p:sp>
         <p:nvSpPr>
-          <p:cNvPr id="2020677704" name="Text 67"/>
+          <p:cNvPr id="898219953" name="Text 67"/>
           <p:cNvSpPr/>
           <p:nvPr/>
         </p:nvSpPr>
@@ -8340,7 +8340,7 @@
       </p:sp>
       <p:sp>
         <p:nvSpPr>
-          <p:cNvPr id="638921680" name="Text 68"/>
+          <p:cNvPr id="11807216" name="Text 68"/>
           <p:cNvSpPr/>
           <p:nvPr/>
         </p:nvSpPr>
@@ -8408,7 +8408,7 @@
       </p:sp>
       <p:sp>
         <p:nvSpPr>
-          <p:cNvPr id="1709010642" name="Text 69"/>
+          <p:cNvPr id="493581599" name="Text 69"/>
           <p:cNvSpPr/>
           <p:nvPr/>
         </p:nvSpPr>
@@ -8476,7 +8476,7 @@
       </p:sp>
       <p:sp>
         <p:nvSpPr>
-          <p:cNvPr id="1641825011" name="Text 70"/>
+          <p:cNvPr id="1709487681" name="Text 70"/>
           <p:cNvSpPr/>
           <p:nvPr/>
         </p:nvSpPr>
@@ -8544,7 +8544,7 @@
       </p:sp>
       <p:sp>
         <p:nvSpPr>
-          <p:cNvPr id="1076684984" name="Text 71"/>
+          <p:cNvPr id="464364820" name="Text 71"/>
           <p:cNvSpPr/>
           <p:nvPr/>
         </p:nvSpPr>
@@ -8612,7 +8612,7 @@
       </p:sp>
       <p:sp>
         <p:nvSpPr>
-          <p:cNvPr id="78916431" name="Text 72"/>
+          <p:cNvPr id="191763102" name="Text 72"/>
           <p:cNvSpPr/>
           <p:nvPr/>
         </p:nvSpPr>
@@ -8670,7 +8670,7 @@
       </p:sp>
       <p:sp>
         <p:nvSpPr>
-          <p:cNvPr id="1170295199" name="Text 73"/>
+          <p:cNvPr id="1849630892" name="Text 73"/>
           <p:cNvSpPr/>
           <p:nvPr/>
         </p:nvSpPr>
@@ -8798,7 +8798,7 @@
       </p:grpSpPr>
       <p:sp>
         <p:nvSpPr>
-          <p:cNvPr id="2096440767" name="Shape 0"/>
+          <p:cNvPr id="389688511" name="Shape 0"/>
           <p:cNvSpPr/>
           <p:nvPr/>
         </p:nvSpPr>
@@ -8842,7 +8842,7 @@
       </p:sp>
       <p:sp>
         <p:nvSpPr>
-          <p:cNvPr id="1765142292" name="Text 1"/>
+          <p:cNvPr id="785890394" name="Text 1"/>
           <p:cNvSpPr/>
           <p:nvPr/>
         </p:nvSpPr>
@@ -8900,7 +8900,7 @@
       </p:sp>
       <p:sp>
         <p:nvSpPr>
-          <p:cNvPr id="1117617131" name="Text 2"/>
+          <p:cNvPr id="736161944" name="Text 2"/>
           <p:cNvSpPr/>
           <p:nvPr/>
         </p:nvSpPr>
@@ -8960,7 +8960,7 @@
       </p:sp>
       <p:sp>
         <p:nvSpPr>
-          <p:cNvPr id="1123202425" name="Text 3"/>
+          <p:cNvPr id="1622825803" name="Text 3"/>
           <p:cNvSpPr/>
           <p:nvPr/>
         </p:nvSpPr>
@@ -9032,7 +9032,7 @@
       </p:sp>
       <p:sp>
         <p:nvSpPr>
-          <p:cNvPr id="1219758003" name="Text 4"/>
+          <p:cNvPr id="705301510" name="Text 4"/>
           <p:cNvSpPr/>
           <p:nvPr/>
         </p:nvSpPr>
@@ -9092,7 +9092,7 @@
       </p:sp>
       <p:sp>
         <p:nvSpPr>
-          <p:cNvPr id="800895751" name="Text 5"/>
+          <p:cNvPr id="1413120437" name="Text 5"/>
           <p:cNvSpPr/>
           <p:nvPr/>
         </p:nvSpPr>
@@ -9170,7 +9170,7 @@
       </p:sp>
       <p:sp>
         <p:nvSpPr>
-          <p:cNvPr id="285609531" name="Text 6"/>
+          <p:cNvPr id="1438303711" name="Text 6"/>
           <p:cNvSpPr/>
           <p:nvPr/>
         </p:nvSpPr>
@@ -9254,7 +9254,7 @@
       </p:sp>
       <p:sp>
         <p:nvSpPr>
-          <p:cNvPr id="1658991284" name="Text 7"/>
+          <p:cNvPr id="892757980" name="Text 7"/>
           <p:cNvSpPr/>
           <p:nvPr/>
         </p:nvSpPr>
@@ -9314,7 +9314,7 @@
       </p:sp>
       <p:sp>
         <p:nvSpPr>
-          <p:cNvPr id="375502636" name="Text 8"/>
+          <p:cNvPr id="91018433" name="Text 8"/>
           <p:cNvSpPr/>
           <p:nvPr/>
         </p:nvSpPr>
@@ -9392,7 +9392,7 @@
       </p:sp>
       <p:sp>
         <p:nvSpPr>
-          <p:cNvPr id="1362828765" name="Text 9"/>
+          <p:cNvPr id="1064814305" name="Text 9"/>
           <p:cNvSpPr/>
           <p:nvPr/>
         </p:nvSpPr>
@@ -9500,7 +9500,7 @@
       </p:sp>
       <p:sp>
         <p:nvSpPr>
-          <p:cNvPr id="1212078520" name="Text 10"/>
+          <p:cNvPr id="968836545" name="Text 10"/>
           <p:cNvSpPr/>
           <p:nvPr/>
         </p:nvSpPr>
@@ -9560,7 +9560,7 @@
       </p:sp>
       <p:sp>
         <p:nvSpPr>
-          <p:cNvPr id="532904990" name="Text 11"/>
+          <p:cNvPr id="2021175142" name="Text 11"/>
           <p:cNvSpPr/>
           <p:nvPr/>
         </p:nvSpPr>
@@ -9628,7 +9628,7 @@
       </p:sp>
       <p:sp>
         <p:nvSpPr>
-          <p:cNvPr id="1483384686" name="Text 12"/>
+          <p:cNvPr id="1539300925" name="Text 12"/>
           <p:cNvSpPr/>
           <p:nvPr/>
         </p:nvSpPr>
@@ -9736,7 +9736,7 @@
       </p:sp>
       <p:sp>
         <p:nvSpPr>
-          <p:cNvPr id="352978677" name="Text 13"/>
+          <p:cNvPr id="1187353625" name="Text 13"/>
           <p:cNvSpPr/>
           <p:nvPr/>
         </p:nvSpPr>
@@ -9796,7 +9796,7 @@
       </p:sp>
       <p:sp>
         <p:nvSpPr>
-          <p:cNvPr id="1578325875" name="Text 14"/>
+          <p:cNvPr id="1383733685" name="Text 14"/>
           <p:cNvSpPr/>
           <p:nvPr/>
         </p:nvSpPr>
@@ -9894,7 +9894,7 @@
       </p:sp>
       <p:sp>
         <p:nvSpPr>
-          <p:cNvPr id="24657267" name="Text 15"/>
+          <p:cNvPr id="677448826" name="Text 15"/>
           <p:cNvSpPr/>
           <p:nvPr/>
         </p:nvSpPr>
@@ -10074,7 +10074,7 @@
       </p:sp>
       <p:sp>
         <p:nvSpPr>
-          <p:cNvPr id="1411695792" name="Text 16"/>
+          <p:cNvPr id="664636682" name="Text 16"/>
           <p:cNvSpPr/>
           <p:nvPr/>
         </p:nvSpPr>
@@ -10134,7 +10134,7 @@
       </p:sp>
       <p:sp>
         <p:nvSpPr>
-          <p:cNvPr id="660724384" name="Text 17"/>
+          <p:cNvPr id="1117464559" name="Text 17"/>
           <p:cNvSpPr/>
           <p:nvPr/>
         </p:nvSpPr>
@@ -10330,7 +10330,7 @@
       </p:grpSpPr>
       <p:sp>
         <p:nvSpPr>
-          <p:cNvPr id="1146781025" name="Shape 0"/>
+          <p:cNvPr id="2041742319" name="Shape 0"/>
           <p:cNvSpPr/>
           <p:nvPr/>
         </p:nvSpPr>
@@ -10374,7 +10374,7 @@
       </p:sp>
       <p:sp>
         <p:nvSpPr>
-          <p:cNvPr id="294357163" name="Text 1"/>
+          <p:cNvPr id="52905904" name="Text 1"/>
           <p:cNvSpPr/>
           <p:nvPr/>
         </p:nvSpPr>
@@ -10432,7 +10432,7 @@
       </p:sp>
       <p:sp>
         <p:nvSpPr>
-          <p:cNvPr id="1169121289" name="Text 2"/>
+          <p:cNvPr id="1466805166" name="Text 2"/>
           <p:cNvSpPr/>
           <p:nvPr/>
         </p:nvSpPr>
@@ -10492,7 +10492,7 @@
       </p:sp>
       <p:sp>
         <p:nvSpPr>
-          <p:cNvPr id="53509121" name="Text 3"/>
+          <p:cNvPr id="1858523615" name="Text 3"/>
           <p:cNvSpPr/>
           <p:nvPr/>
         </p:nvSpPr>
@@ -10564,7 +10564,7 @@
       </p:sp>
       <p:sp>
         <p:nvSpPr>
-          <p:cNvPr id="17793660" name="Text 4"/>
+          <p:cNvPr id="236619856" name="Text 4"/>
           <p:cNvSpPr/>
           <p:nvPr/>
         </p:nvSpPr>
@@ -10624,7 +10624,7 @@
       </p:sp>
       <p:sp>
         <p:nvSpPr>
-          <p:cNvPr id="65012790" name="Text 5"/>
+          <p:cNvPr id="621307711" name="Text 5"/>
           <p:cNvSpPr/>
           <p:nvPr/>
         </p:nvSpPr>
@@ -10692,7 +10692,7 @@
       </p:sp>
       <p:sp>
         <p:nvSpPr>
-          <p:cNvPr id="862404027" name="Text 6"/>
+          <p:cNvPr id="577656669" name="Text 6"/>
           <p:cNvSpPr/>
           <p:nvPr/>
         </p:nvSpPr>
@@ -10752,7 +10752,7 @@
       </p:sp>
       <p:sp>
         <p:nvSpPr>
-          <p:cNvPr id="891823406" name="Text 7"/>
+          <p:cNvPr id="2089015600" name="Text 7"/>
           <p:cNvSpPr/>
           <p:nvPr/>
         </p:nvSpPr>
@@ -10961,7 +10961,7 @@
       </p:sp>
       <p:sp>
         <p:nvSpPr>
-          <p:cNvPr id="45957080" name="Shape 8"/>
+          <p:cNvPr id="641881895" name="Shape 8"/>
           <p:cNvSpPr/>
           <p:nvPr/>
         </p:nvSpPr>
@@ -11007,7 +11007,7 @@
       </p:sp>
       <p:sp>
         <p:nvSpPr>
-          <p:cNvPr id="789567102" name="Shape 9"/>
+          <p:cNvPr id="1952312966" name="Shape 9"/>
           <p:cNvSpPr/>
           <p:nvPr/>
         </p:nvSpPr>
@@ -11051,7 +11051,7 @@
       </p:sp>
       <p:pic>
         <p:nvPicPr>
-          <p:cNvPr id="1543744633" name="Image 0" descr="preencoded.png"/>
+          <p:cNvPr id="2072395825" name="Image 0" descr="preencoded.png"/>
           <p:cNvPicPr/>
           <p:nvPr/>
         </p:nvPicPr>
@@ -11075,7 +11075,7 @@
       </p:pic>
       <p:sp>
         <p:nvSpPr>
-          <p:cNvPr id="147039443" name="Text 10"/>
+          <p:cNvPr id="487484641" name="Text 10"/>
           <p:cNvSpPr/>
           <p:nvPr/>
         </p:nvSpPr>
@@ -11147,7 +11147,7 @@
       </p:sp>
       <p:sp>
         <p:nvSpPr>
-          <p:cNvPr id="1360571044" name="Text 11"/>
+          <p:cNvPr id="167148866" name="Text 11"/>
           <p:cNvSpPr/>
           <p:nvPr/>
         </p:nvSpPr>
@@ -11205,7 +11205,7 @@
       </p:sp>
       <p:sp>
         <p:nvSpPr>
-          <p:cNvPr id="1419105235" name="Text 12"/>
+          <p:cNvPr id="21847613" name="Text 12"/>
           <p:cNvSpPr/>
           <p:nvPr/>
         </p:nvSpPr>
@@ -11265,7 +11265,7 @@
       </p:sp>
       <p:sp>
         <p:nvSpPr>
-          <p:cNvPr id="238606750" name="Text 13"/>
+          <p:cNvPr id="1239078231" name="Text 13"/>
           <p:cNvSpPr/>
           <p:nvPr/>
         </p:nvSpPr>
@@ -11325,7 +11325,7 @@
       </p:sp>
       <p:sp>
         <p:nvSpPr>
-          <p:cNvPr id="735514673" name="Shape 14"/>
+          <p:cNvPr id="1859284563" name="Shape 14"/>
           <p:cNvSpPr/>
           <p:nvPr/>
         </p:nvSpPr>
@@ -11371,7 +11371,7 @@
       </p:sp>
       <p:sp>
         <p:nvSpPr>
-          <p:cNvPr id="749582167" name="Text 15"/>
+          <p:cNvPr id="1917405616" name="Text 15"/>
           <p:cNvSpPr/>
           <p:nvPr/>
         </p:nvSpPr>
@@ -11431,7 +11431,7 @@
       </p:sp>
       <p:sp>
         <p:nvSpPr>
-          <p:cNvPr id="60770306" name="Text 16"/>
+          <p:cNvPr id="1307828907" name="Text 16"/>
           <p:cNvSpPr/>
           <p:nvPr/>
         </p:nvSpPr>
@@ -11490,7 +11490,7 @@
       </p:sp>
       <p:sp>
         <p:nvSpPr>
-          <p:cNvPr id="1381543553" name="Text 17"/>
+          <p:cNvPr id="1224991249" name="Text 17"/>
           <p:cNvSpPr/>
           <p:nvPr/>
         </p:nvSpPr>
@@ -11562,7 +11562,7 @@
       </p:sp>
       <p:sp>
         <p:nvSpPr>
-          <p:cNvPr id="1880962877" name="Text 18"/>
+          <p:cNvPr id="268651937" name="Text 18"/>
           <p:cNvSpPr/>
           <p:nvPr/>
         </p:nvSpPr>
@@ -11622,7 +11622,7 @@
       </p:sp>
       <p:sp>
         <p:nvSpPr>
-          <p:cNvPr id="1351181634" name="Text 19"/>
+          <p:cNvPr id="969194271" name="Text 19"/>
           <p:cNvSpPr/>
           <p:nvPr/>
         </p:nvSpPr>
@@ -11734,7 +11734,7 @@
       </p:grpSpPr>
       <p:sp>
         <p:nvSpPr>
-          <p:cNvPr id="1757485452" name="Shape 0"/>
+          <p:cNvPr id="1287866875" name="Shape 0"/>
           <p:cNvSpPr/>
           <p:nvPr/>
         </p:nvSpPr>
@@ -11778,7 +11778,7 @@
       </p:sp>
       <p:sp>
         <p:nvSpPr>
-          <p:cNvPr id="1510442751" name="Text 1"/>
+          <p:cNvPr id="1206102519" name="Text 1"/>
           <p:cNvSpPr/>
           <p:nvPr/>
         </p:nvSpPr>
@@ -11836,7 +11836,7 @@
       </p:sp>
       <p:sp>
         <p:nvSpPr>
-          <p:cNvPr id="881016858" name="Text 2"/>
+          <p:cNvPr id="1612426682" name="Text 2"/>
           <p:cNvSpPr/>
           <p:nvPr/>
         </p:nvSpPr>
@@ -11894,7 +11894,7 @@
       </p:sp>
       <p:sp>
         <p:nvSpPr>
-          <p:cNvPr id="1045216400" name="Text 3"/>
+          <p:cNvPr id="1315520820" name="Text 3"/>
           <p:cNvSpPr/>
           <p:nvPr/>
         </p:nvSpPr>
@@ -11962,7 +11962,7 @@
       </p:sp>
       <p:sp>
         <p:nvSpPr>
-          <p:cNvPr id="1555579060" name="Text 4"/>
+          <p:cNvPr id="2096218452" name="Text 4"/>
           <p:cNvSpPr/>
           <p:nvPr/>
         </p:nvSpPr>
@@ -12040,7 +12040,7 @@
       </p:sp>
       <p:sp>
         <p:nvSpPr>
-          <p:cNvPr id="2051421447" name="Text 5"/>
+          <p:cNvPr id="1114131113" name="Text 5"/>
           <p:cNvSpPr/>
           <p:nvPr/>
         </p:nvSpPr>
@@ -12118,7 +12118,7 @@
       </p:sp>
       <p:sp>
         <p:nvSpPr>
-          <p:cNvPr id="96705943" name="Text 6"/>
+          <p:cNvPr id="326210327" name="Text 6"/>
           <p:cNvSpPr/>
           <p:nvPr/>
         </p:nvSpPr>
@@ -12196,7 +12196,7 @@
       </p:sp>
       <p:sp>
         <p:nvSpPr>
-          <p:cNvPr id="768723745" name="Text 7"/>
+          <p:cNvPr id="620017736" name="Text 7"/>
           <p:cNvSpPr/>
           <p:nvPr/>
         </p:nvSpPr>
@@ -12254,7 +12254,7 @@
       </p:sp>
       <p:sp>
         <p:nvSpPr>
-          <p:cNvPr id="1126715287" name="Shape 8"/>
+          <p:cNvPr id="95907859" name="Shape 8"/>
           <p:cNvSpPr/>
           <p:nvPr/>
         </p:nvSpPr>
@@ -12301,7 +12301,7 @@
       </p:sp>
       <p:sp>
         <p:nvSpPr>
-          <p:cNvPr id="2021133949" name="Text 9"/>
+          <p:cNvPr id="1451134366" name="Text 9"/>
           <p:cNvSpPr/>
           <p:nvPr/>
         </p:nvSpPr>
@@ -12359,7 +12359,7 @@
       </p:sp>
       <p:sp>
         <p:nvSpPr>
-          <p:cNvPr id="529058563" name="Text 10"/>
+          <p:cNvPr id="2052995849" name="Text 10"/>
           <p:cNvSpPr/>
           <p:nvPr/>
         </p:nvSpPr>
@@ -12417,7 +12417,7 @@
       </p:sp>
       <p:sp>
         <p:nvSpPr>
-          <p:cNvPr id="200123778" name="Shape 11"/>
+          <p:cNvPr id="1680025036" name="Shape 11"/>
           <p:cNvSpPr/>
           <p:nvPr/>
         </p:nvSpPr>
@@ -12463,7 +12463,7 @@
       </p:sp>
       <p:sp>
         <p:nvSpPr>
-          <p:cNvPr id="405781641" name="Text 12"/>
+          <p:cNvPr id="1836652737" name="Text 12"/>
           <p:cNvSpPr/>
           <p:nvPr/>
         </p:nvSpPr>
@@ -12521,7 +12521,7 @@
       </p:sp>
       <p:sp>
         <p:nvSpPr>
-          <p:cNvPr id="1748294669" name="Text 13"/>
+          <p:cNvPr id="1535386778" name="Text 13"/>
           <p:cNvSpPr/>
           <p:nvPr/>
         </p:nvSpPr>
@@ -12579,7 +12579,7 @@
       </p:sp>
       <p:sp>
         <p:nvSpPr>
-          <p:cNvPr id="961358014" name="Text 14"/>
+          <p:cNvPr id="64339613" name="Text 14"/>
           <p:cNvSpPr/>
           <p:nvPr/>
         </p:nvSpPr>
@@ -12637,7 +12637,7 @@
       </p:sp>
       <p:sp>
         <p:nvSpPr>
-          <p:cNvPr id="2032672006" name="Text 15"/>
+          <p:cNvPr id="721640649" name="Text 15"/>
           <p:cNvSpPr/>
           <p:nvPr/>
         </p:nvSpPr>
@@ -12695,7 +12695,7 @@
       </p:sp>
       <p:sp>
         <p:nvSpPr>
-          <p:cNvPr id="21908726" name="Text 16"/>
+          <p:cNvPr id="29976743" name="Text 16"/>
           <p:cNvSpPr/>
           <p:nvPr/>
         </p:nvSpPr>
@@ -12753,7 +12753,7 @@
       </p:sp>
       <p:sp>
         <p:nvSpPr>
-          <p:cNvPr id="1239040994" name="Text 17"/>
+          <p:cNvPr id="656041353" name="Text 17"/>
           <p:cNvSpPr/>
           <p:nvPr/>
         </p:nvSpPr>
@@ -12811,7 +12811,7 @@
       </p:sp>
       <p:sp>
         <p:nvSpPr>
-          <p:cNvPr id="2134407834" name="Text 18"/>
+          <p:cNvPr id="1460617023" name="Text 18"/>
           <p:cNvSpPr/>
           <p:nvPr/>
         </p:nvSpPr>
@@ -12869,7 +12869,7 @@
       </p:sp>
       <p:sp>
         <p:nvSpPr>
-          <p:cNvPr id="1144363538" name="Text 19"/>
+          <p:cNvPr id="1432592293" name="Text 19"/>
           <p:cNvSpPr/>
           <p:nvPr/>
         </p:nvSpPr>
@@ -12937,7 +12937,7 @@
       </p:sp>
       <p:sp>
         <p:nvSpPr>
-          <p:cNvPr id="1346167971" name="Text 20"/>
+          <p:cNvPr id="385443418" name="Text 20"/>
           <p:cNvSpPr/>
           <p:nvPr/>
         </p:nvSpPr>
@@ -12995,7 +12995,7 @@
       </p:sp>
       <p:sp>
         <p:nvSpPr>
-          <p:cNvPr id="510247541" name="Text 21"/>
+          <p:cNvPr id="862015976" name="Text 21"/>
           <p:cNvSpPr/>
           <p:nvPr/>
         </p:nvSpPr>
@@ -13053,7 +13053,7 @@
       </p:sp>
       <p:sp>
         <p:nvSpPr>
-          <p:cNvPr id="1537247820" name="Text 22"/>
+          <p:cNvPr id="1739433619" name="Text 22"/>
           <p:cNvSpPr/>
           <p:nvPr/>
         </p:nvSpPr>
@@ -13151,7 +13151,7 @@
       </p:grpSpPr>
       <p:sp>
         <p:nvSpPr>
-          <p:cNvPr id="423428" name="Shape 0"/>
+          <p:cNvPr id="1660445605" name="Shape 0"/>
           <p:cNvSpPr/>
           <p:nvPr/>
         </p:nvSpPr>
@@ -13195,7 +13195,7 @@
       </p:sp>
       <p:sp>
         <p:nvSpPr>
-          <p:cNvPr id="551947034" name="Text 1"/>
+          <p:cNvPr id="1856287210" name="Text 1"/>
           <p:cNvSpPr/>
           <p:nvPr/>
         </p:nvSpPr>
@@ -13253,7 +13253,7 @@
       </p:sp>
       <p:sp>
         <p:nvSpPr>
-          <p:cNvPr id="794217966" name="Text 2"/>
+          <p:cNvPr id="200293727" name="Text 2"/>
           <p:cNvSpPr/>
           <p:nvPr/>
         </p:nvSpPr>
@@ -13311,7 +13311,7 @@
       </p:sp>
       <p:sp>
         <p:nvSpPr>
-          <p:cNvPr id="1635551528" name="Text 3"/>
+          <p:cNvPr id="1732016352" name="Text 3"/>
           <p:cNvSpPr/>
           <p:nvPr/>
         </p:nvSpPr>
@@ -13379,7 +13379,7 @@
       </p:sp>
       <p:sp>
         <p:nvSpPr>
-          <p:cNvPr id="1919873230" name="Text 4"/>
+          <p:cNvPr id="1900836413" name="Text 4"/>
           <p:cNvSpPr/>
           <p:nvPr/>
         </p:nvSpPr>
@@ -13447,7 +13447,7 @@
       </p:sp>
       <p:sp>
         <p:nvSpPr>
-          <p:cNvPr id="1906826658" name="Text 5"/>
+          <p:cNvPr id="1686262622" name="Text 5"/>
           <p:cNvSpPr/>
           <p:nvPr/>
         </p:nvSpPr>
@@ -13505,7 +13505,7 @@
       </p:sp>
       <p:sp>
         <p:nvSpPr>
-          <p:cNvPr id="1463153963" name="Shape 6"/>
+          <p:cNvPr id="51129904" name="Shape 6"/>
           <p:cNvSpPr/>
           <p:nvPr/>
         </p:nvSpPr>
@@ -13549,7 +13549,7 @@
       </p:sp>
       <p:sp>
         <p:nvSpPr>
-          <p:cNvPr id="1864519216" name="Text 7"/>
+          <p:cNvPr id="1401126924" name="Text 7"/>
           <p:cNvSpPr/>
           <p:nvPr/>
         </p:nvSpPr>
@@ -13617,7 +13617,7 @@
       </p:sp>
       <p:pic>
         <p:nvPicPr>
-          <p:cNvPr id="474918310" name="Image 0" descr="preencoded.png"/>
+          <p:cNvPr id="92173812" name="Image 0" descr="preencoded.png"/>
           <p:cNvPicPr/>
           <p:nvPr/>
         </p:nvPicPr>
@@ -13641,7 +13641,7 @@
       </p:pic>
       <p:sp>
         <p:nvSpPr>
-          <p:cNvPr id="1313810471" name="Text 8"/>
+          <p:cNvPr id="27488187" name="Text 8"/>
           <p:cNvSpPr/>
           <p:nvPr/>
         </p:nvSpPr>
@@ -13699,7 +13699,7 @@
       </p:sp>
       <p:sp>
         <p:nvSpPr>
-          <p:cNvPr id="711754606" name="Shape 10"/>
+          <p:cNvPr id="60127530" name="Shape 10"/>
           <p:cNvSpPr/>
           <p:nvPr/>
         </p:nvSpPr>
@@ -13743,7 +13743,7 @@
       </p:sp>
       <p:sp>
         <p:nvSpPr>
-          <p:cNvPr id="1950265914" name="Text 11"/>
+          <p:cNvPr id="766483232" name="Text 11"/>
           <p:cNvSpPr/>
           <p:nvPr/>
         </p:nvSpPr>
@@ -13811,7 +13811,7 @@
       </p:sp>
       <p:pic>
         <p:nvPicPr>
-          <p:cNvPr id="1020344471" name="Image 1" descr="preencoded.png"/>
+          <p:cNvPr id="1012825563" name="Image 1" descr="preencoded.png"/>
           <p:cNvPicPr/>
           <p:nvPr/>
         </p:nvPicPr>
@@ -13835,7 +13835,7 @@
       </p:pic>
       <p:sp>
         <p:nvSpPr>
-          <p:cNvPr id="2019124698" name="Text 12"/>
+          <p:cNvPr id="1514996577" name="Text 12"/>
           <p:cNvSpPr/>
           <p:nvPr/>
         </p:nvSpPr>
@@ -13893,7 +13893,7 @@
       </p:sp>
       <p:sp>
         <p:nvSpPr>
-          <p:cNvPr id="1081132991" name="Text 13"/>
+          <p:cNvPr id="1529780369" name="Text 13"/>
           <p:cNvSpPr/>
           <p:nvPr/>
         </p:nvSpPr>
@@ -13951,7 +13951,7 @@
       </p:sp>
       <p:sp>
         <p:nvSpPr>
-          <p:cNvPr id="1073571589" name="Shape 14"/>
+          <p:cNvPr id="156471252" name="Shape 14"/>
           <p:cNvSpPr/>
           <p:nvPr/>
         </p:nvSpPr>
@@ -13995,7 +13995,7 @@
       </p:sp>
       <p:sp>
         <p:nvSpPr>
-          <p:cNvPr id="574024337" name="Text 15"/>
+          <p:cNvPr id="1950048983" name="Text 15"/>
           <p:cNvSpPr/>
           <p:nvPr/>
         </p:nvSpPr>
@@ -14063,7 +14063,7 @@
       </p:sp>
       <p:pic>
         <p:nvPicPr>
-          <p:cNvPr id="1835591501" name="Image 2" descr="preencoded.png"/>
+          <p:cNvPr id="444475236" name="Image 2" descr="preencoded.png"/>
           <p:cNvPicPr/>
           <p:nvPr/>
         </p:nvPicPr>
@@ -14087,7 +14087,7 @@
       </p:pic>
       <p:sp>
         <p:nvSpPr>
-          <p:cNvPr id="668857301" name="Text 16"/>
+          <p:cNvPr id="122410797" name="Text 16"/>
           <p:cNvSpPr/>
           <p:nvPr/>
         </p:nvSpPr>
@@ -14145,7 +14145,7 @@
       </p:sp>
       <p:sp>
         <p:nvSpPr>
-          <p:cNvPr id="979782493" name="Text 17"/>
+          <p:cNvPr id="1210181510" name="Text 17"/>
           <p:cNvSpPr/>
           <p:nvPr/>
         </p:nvSpPr>
@@ -14203,7 +14203,7 @@
       </p:sp>
       <p:sp>
         <p:nvSpPr>
-          <p:cNvPr id="1500516061" name="Shape 18"/>
+          <p:cNvPr id="267048276" name="Shape 18"/>
           <p:cNvSpPr/>
           <p:nvPr/>
         </p:nvSpPr>
@@ -14247,7 +14247,7 @@
       </p:sp>
       <p:sp>
         <p:nvSpPr>
-          <p:cNvPr id="888371213" name="Text 19"/>
+          <p:cNvPr id="909548507" name="Text 19"/>
           <p:cNvSpPr/>
           <p:nvPr/>
         </p:nvSpPr>
@@ -14315,7 +14315,7 @@
       </p:sp>
       <p:pic>
         <p:nvPicPr>
-          <p:cNvPr id="1459174361" name="Image 3" descr="preencoded.png"/>
+          <p:cNvPr id="1757261292" name="Image 3" descr="preencoded.png"/>
           <p:cNvPicPr/>
           <p:nvPr/>
         </p:nvPicPr>
@@ -14339,7 +14339,7 @@
       </p:pic>
       <p:sp>
         <p:nvSpPr>
-          <p:cNvPr id="1271691229" name="Text 20"/>
+          <p:cNvPr id="425916187" name="Text 20"/>
           <p:cNvSpPr/>
           <p:nvPr/>
         </p:nvSpPr>
@@ -14397,7 +14397,7 @@
       </p:sp>
       <p:sp>
         <p:nvSpPr>
-          <p:cNvPr id="937422431" name="Text 21"/>
+          <p:cNvPr id="1660112326" name="Text 21"/>
           <p:cNvSpPr/>
           <p:nvPr/>
         </p:nvSpPr>
@@ -14455,7 +14455,7 @@
       </p:sp>
       <p:sp>
         <p:nvSpPr>
-          <p:cNvPr id="10074061" name="Text 22"/>
+          <p:cNvPr id="856596209" name="Text 22"/>
           <p:cNvSpPr/>
           <p:nvPr/>
         </p:nvSpPr>
@@ -14513,7 +14513,7 @@
       </p:sp>
       <p:sp>
         <p:nvSpPr>
-          <p:cNvPr id="483128124" name="Text 23"/>
+          <p:cNvPr id="512733001" name="Text 23"/>
           <p:cNvSpPr/>
           <p:nvPr/>
         </p:nvSpPr>
@@ -14631,7 +14631,7 @@
       </p:grpSpPr>
       <p:sp>
         <p:nvSpPr>
-          <p:cNvPr id="2129301496" name="Shape 0"/>
+          <p:cNvPr id="59391222" name="Shape 0"/>
           <p:cNvSpPr/>
           <p:nvPr/>
         </p:nvSpPr>
@@ -14675,7 +14675,7 @@
       </p:sp>
       <p:sp>
         <p:nvSpPr>
-          <p:cNvPr id="430638121" name="Text 1"/>
+          <p:cNvPr id="557195684" name="Text 1"/>
           <p:cNvSpPr/>
           <p:nvPr/>
         </p:nvSpPr>
@@ -14733,7 +14733,7 @@
       </p:sp>
       <p:sp>
         <p:nvSpPr>
-          <p:cNvPr id="1369387662" name="Text 2"/>
+          <p:cNvPr id="913885141" name="Text 2"/>
           <p:cNvSpPr/>
           <p:nvPr/>
         </p:nvSpPr>
@@ -14793,7 +14793,7 @@
       </p:sp>
       <p:sp>
         <p:nvSpPr>
-          <p:cNvPr id="463139444" name="Text 3"/>
+          <p:cNvPr id="2135852896" name="Text 3"/>
           <p:cNvSpPr/>
           <p:nvPr/>
         </p:nvSpPr>
@@ -14865,7 +14865,7 @@
       </p:sp>
       <p:sp>
         <p:nvSpPr>
-          <p:cNvPr id="491486150" name="Text 4"/>
+          <p:cNvPr id="1610280703" name="Text 4"/>
           <p:cNvSpPr/>
           <p:nvPr/>
         </p:nvSpPr>
@@ -14949,7 +14949,7 @@
       </p:sp>
       <p:sp>
         <p:nvSpPr>
-          <p:cNvPr id="627323599" name="Text 5"/>
+          <p:cNvPr id="581988788" name="Text 5"/>
           <p:cNvSpPr/>
           <p:nvPr/>
         </p:nvSpPr>
@@ -15017,7 +15017,7 @@
       </p:sp>
       <p:sp>
         <p:nvSpPr>
-          <p:cNvPr id="645229335" name="Text 6"/>
+          <p:cNvPr id="1417866298" name="Text 6"/>
           <p:cNvSpPr/>
           <p:nvPr/>
         </p:nvSpPr>
@@ -15077,7 +15077,7 @@
       </p:sp>
       <p:sp>
         <p:nvSpPr>
-          <p:cNvPr id="451439063" name="Text 7"/>
+          <p:cNvPr id="1800624719" name="Text 7"/>
           <p:cNvSpPr/>
           <p:nvPr/>
         </p:nvSpPr>
@@ -15137,7 +15137,7 @@
       </p:sp>
       <p:sp>
         <p:nvSpPr>
-          <p:cNvPr id="478332216" name="Text 8"/>
+          <p:cNvPr id="1929416015" name="Text 8"/>
           <p:cNvSpPr/>
           <p:nvPr/>
         </p:nvSpPr>
@@ -15195,7 +15195,7 @@
       </p:sp>
       <p:sp>
         <p:nvSpPr>
-          <p:cNvPr id="1308845884" name="Text 9"/>
+          <p:cNvPr id="508452049" name="Text 9"/>
           <p:cNvSpPr/>
           <p:nvPr/>
         </p:nvSpPr>
@@ -15255,7 +15255,7 @@
       </p:sp>
       <p:sp>
         <p:nvSpPr>
-          <p:cNvPr id="259314870" name="Text 10"/>
+          <p:cNvPr id="1009064709" name="Text 10"/>
           <p:cNvSpPr/>
           <p:nvPr/>
         </p:nvSpPr>
@@ -15315,7 +15315,7 @@
       </p:sp>
       <p:sp>
         <p:nvSpPr>
-          <p:cNvPr id="972643582" name="Text 11"/>
+          <p:cNvPr id="384797365" name="Text 11"/>
           <p:cNvSpPr/>
           <p:nvPr/>
         </p:nvSpPr>
@@ -15383,7 +15383,7 @@
       </p:sp>
       <p:sp>
         <p:nvSpPr>
-          <p:cNvPr id="843303412" name="Text 12"/>
+          <p:cNvPr id="1806563976" name="Text 12"/>
           <p:cNvSpPr/>
           <p:nvPr/>
         </p:nvSpPr>
@@ -15539,7 +15539,7 @@
       </p:sp>
       <p:sp>
         <p:nvSpPr>
-          <p:cNvPr id="742793685" name="Text 13"/>
+          <p:cNvPr id="1133739914" name="Text 13"/>
           <p:cNvSpPr/>
           <p:nvPr/>
         </p:nvSpPr>
@@ -15599,7 +15599,7 @@
       </p:sp>
       <p:sp>
         <p:nvSpPr>
-          <p:cNvPr id="1841536695" name="Text 14"/>
+          <p:cNvPr id="1983976638" name="Text 14"/>
           <p:cNvSpPr/>
           <p:nvPr/>
         </p:nvSpPr>
@@ -15657,7 +15657,7 @@
       </p:sp>
       <p:sp>
         <p:nvSpPr>
-          <p:cNvPr id="728336914" name="Text 15"/>
+          <p:cNvPr id="965883876" name="Text 15"/>
           <p:cNvSpPr/>
           <p:nvPr/>
         </p:nvSpPr>
@@ -15717,7 +15717,7 @@
       </p:sp>
       <p:sp>
         <p:nvSpPr>
-          <p:cNvPr id="1398174203" name="Text 16"/>
+          <p:cNvPr id="2083527223" name="Text 16"/>
           <p:cNvSpPr/>
           <p:nvPr/>
         </p:nvSpPr>
@@ -15777,7 +15777,7 @@
       </p:sp>
       <p:sp>
         <p:nvSpPr>
-          <p:cNvPr id="568347197" name="Text 17"/>
+          <p:cNvPr id="334869604" name="Text 17"/>
           <p:cNvSpPr/>
           <p:nvPr/>
         </p:nvSpPr>
@@ -15877,7 +15877,7 @@
       </p:grpSpPr>
       <p:sp>
         <p:nvSpPr>
-          <p:cNvPr id="1993077772" name="Shape 0"/>
+          <p:cNvPr id="1977880252" name="Shape 0"/>
           <p:cNvSpPr/>
           <p:nvPr/>
         </p:nvSpPr>
@@ -15921,7 +15921,7 @@
       </p:sp>
       <p:sp>
         <p:nvSpPr>
-          <p:cNvPr id="474964564" name="Text 1"/>
+          <p:cNvPr id="1605318297" name="Text 1"/>
           <p:cNvSpPr/>
           <p:nvPr/>
         </p:nvSpPr>
@@ -15979,7 +15979,7 @@
       </p:sp>
       <p:sp>
         <p:nvSpPr>
-          <p:cNvPr id="23513926" name="Text 2"/>
+          <p:cNvPr id="1530681077" name="Text 2"/>
           <p:cNvSpPr/>
           <p:nvPr/>
         </p:nvSpPr>
@@ -16037,7 +16037,7 @@
       </p:sp>
       <p:sp>
         <p:nvSpPr>
-          <p:cNvPr id="208163897" name="Text 3"/>
+          <p:cNvPr id="1259767069" name="Text 3"/>
           <p:cNvSpPr/>
           <p:nvPr/>
         </p:nvSpPr>
@@ -16105,7 +16105,7 @@
       </p:sp>
       <p:sp>
         <p:nvSpPr>
-          <p:cNvPr id="435528367" name="Text 4"/>
+          <p:cNvPr id="1204977788" name="Text 4"/>
           <p:cNvSpPr/>
           <p:nvPr/>
         </p:nvSpPr>
@@ -16173,7 +16173,7 @@
       </p:sp>
       <p:sp>
         <p:nvSpPr>
-          <p:cNvPr id="1134753968" name="Text 5"/>
+          <p:cNvPr id="838257782" name="Text 5"/>
           <p:cNvSpPr/>
           <p:nvPr/>
         </p:nvSpPr>
@@ -16291,7 +16291,7 @@
       </p:sp>
       <p:sp>
         <p:nvSpPr>
-          <p:cNvPr id="190792066" name="Text 6"/>
+          <p:cNvPr id="2122379911" name="Text 6"/>
           <p:cNvSpPr/>
           <p:nvPr/>
         </p:nvSpPr>
@@ -16349,7 +16349,7 @@
       </p:sp>
       <p:sp>
         <p:nvSpPr>
-          <p:cNvPr id="562020537" name="Text 7"/>
+          <p:cNvPr id="801553266" name="Text 7"/>
           <p:cNvSpPr/>
           <p:nvPr/>
         </p:nvSpPr>
@@ -16407,7 +16407,7 @@
       </p:sp>
       <p:sp>
         <p:nvSpPr>
-          <p:cNvPr id="694194913" name="Shape 8"/>
+          <p:cNvPr id="1833340192" name="Shape 8"/>
           <p:cNvSpPr/>
           <p:nvPr/>
         </p:nvSpPr>
@@ -16453,7 +16453,7 @@
       </p:sp>
       <p:sp>
         <p:nvSpPr>
-          <p:cNvPr id="222332095" name="Text 9"/>
+          <p:cNvPr id="411757293" name="Text 9"/>
           <p:cNvSpPr/>
           <p:nvPr/>
         </p:nvSpPr>
@@ -16511,7 +16511,7 @@
       </p:sp>
       <p:sp>
         <p:nvSpPr>
-          <p:cNvPr id="1729793275" name="Text 10"/>
+          <p:cNvPr id="1134156434" name="Text 10"/>
           <p:cNvSpPr/>
           <p:nvPr/>
         </p:nvSpPr>
@@ -16569,7 +16569,7 @@
       </p:sp>
       <p:sp>
         <p:nvSpPr>
-          <p:cNvPr id="1559022566" name="Text 11"/>
+          <p:cNvPr id="1127708519" name="Text 11"/>
           <p:cNvSpPr/>
           <p:nvPr/>
         </p:nvSpPr>
@@ -16627,7 +16627,7 @@
       </p:sp>
       <p:sp>
         <p:nvSpPr>
-          <p:cNvPr id="1941237536" name="Text 12"/>
+          <p:cNvPr id="1699575869" name="Text 12"/>
           <p:cNvSpPr/>
           <p:nvPr/>
         </p:nvSpPr>
@@ -16685,7 +16685,7 @@
       </p:sp>
       <p:sp>
         <p:nvSpPr>
-          <p:cNvPr id="96698536" name="Text 13"/>
+          <p:cNvPr id="1003409485" name="Text 13"/>
           <p:cNvSpPr/>
           <p:nvPr/>
         </p:nvSpPr>
@@ -16743,7 +16743,7 @@
       </p:sp>
       <p:sp>
         <p:nvSpPr>
-          <p:cNvPr id="342860826" name="Text 14"/>
+          <p:cNvPr id="1947939478" name="Text 14"/>
           <p:cNvSpPr/>
           <p:nvPr/>
         </p:nvSpPr>
@@ -16801,7 +16801,7 @@
       </p:sp>
       <p:sp>
         <p:nvSpPr>
-          <p:cNvPr id="1238120779" name="Shape 15"/>
+          <p:cNvPr id="73796191" name="Shape 15"/>
           <p:cNvSpPr/>
           <p:nvPr/>
         </p:nvSpPr>
@@ -16848,7 +16848,7 @@
       </p:sp>
       <p:sp>
         <p:nvSpPr>
-          <p:cNvPr id="732143810" name="Text 16"/>
+          <p:cNvPr id="1366585285" name="Text 16"/>
           <p:cNvSpPr/>
           <p:nvPr/>
         </p:nvSpPr>
@@ -16926,7 +16926,7 @@
       </p:sp>
       <p:pic>
         <p:nvPicPr>
-          <p:cNvPr id="982359470" name="Image 0" descr="preencoded.png"/>
+          <p:cNvPr id="1346883949" name="Image 0" descr="preencoded.png"/>
           <p:cNvPicPr/>
           <p:nvPr/>
         </p:nvPicPr>
@@ -16950,7 +16950,7 @@
       </p:pic>
       <p:sp>
         <p:nvSpPr>
-          <p:cNvPr id="231595781" name="Text 17"/>
+          <p:cNvPr id="124265424" name="Text 17"/>
           <p:cNvSpPr/>
           <p:nvPr/>
         </p:nvSpPr>
@@ -17008,7 +17008,7 @@
       </p:sp>
       <p:sp>
         <p:nvSpPr>
-          <p:cNvPr id="2069567218" name="Shape 18"/>
+          <p:cNvPr id="1397987447" name="Shape 18"/>
           <p:cNvSpPr/>
           <p:nvPr/>
         </p:nvSpPr>
@@ -17055,7 +17055,7 @@
       </p:sp>
       <p:sp>
         <p:nvSpPr>
-          <p:cNvPr id="2034994015" name="Text 19"/>
+          <p:cNvPr id="318876634" name="Text 19"/>
           <p:cNvSpPr/>
           <p:nvPr/>
         </p:nvSpPr>
@@ -17133,7 +17133,7 @@
       </p:sp>
       <p:pic>
         <p:nvPicPr>
-          <p:cNvPr id="129358333" name="Image 1" descr="preencoded.png"/>
+          <p:cNvPr id="2119610802" name="Image 1" descr="preencoded.png"/>
           <p:cNvPicPr/>
           <p:nvPr/>
         </p:nvPicPr>
@@ -17157,7 +17157,7 @@
       </p:pic>
       <p:sp>
         <p:nvSpPr>
-          <p:cNvPr id="63087475" name="Text 20"/>
+          <p:cNvPr id="35441932" name="Text 20"/>
           <p:cNvSpPr/>
           <p:nvPr/>
         </p:nvSpPr>
@@ -17215,7 +17215,7 @@
       </p:sp>
       <p:sp>
         <p:nvSpPr>
-          <p:cNvPr id="1134224184" name="Text 21"/>
+          <p:cNvPr id="630825889" name="Text 21"/>
           <p:cNvSpPr/>
           <p:nvPr/>
         </p:nvSpPr>
@@ -17273,7 +17273,7 @@
       </p:sp>
       <p:sp>
         <p:nvSpPr>
-          <p:cNvPr id="300727393" name="Text 22"/>
+          <p:cNvPr id="1825487958" name="Text 22"/>
           <p:cNvSpPr/>
           <p:nvPr/>
         </p:nvSpPr>
@@ -17411,7 +17411,7 @@
       </p:grpSpPr>
       <p:sp>
         <p:nvSpPr>
-          <p:cNvPr id="1245463289" name="Shape 0"/>
+          <p:cNvPr id="2011452840" name="Shape 0"/>
           <p:cNvSpPr/>
           <p:nvPr/>
         </p:nvSpPr>
@@ -17455,7 +17455,7 @@
       </p:sp>
       <p:sp>
         <p:nvSpPr>
-          <p:cNvPr id="1494648394" name="Text 1"/>
+          <p:cNvPr id="1602557829" name="Text 1"/>
           <p:cNvSpPr/>
           <p:nvPr/>
         </p:nvSpPr>
@@ -17513,7 +17513,7 @@
       </p:sp>
       <p:sp>
         <p:nvSpPr>
-          <p:cNvPr id="1852268820" name="Text 2"/>
+          <p:cNvPr id="100909371" name="Text 2"/>
           <p:cNvSpPr/>
           <p:nvPr/>
         </p:nvSpPr>
@@ -17571,7 +17571,7 @@
       </p:sp>
       <p:sp>
         <p:nvSpPr>
-          <p:cNvPr id="1446324329" name="Text 3"/>
+          <p:cNvPr id="2106867549" name="Text 3"/>
           <p:cNvSpPr/>
           <p:nvPr/>
         </p:nvSpPr>
@@ -17649,7 +17649,7 @@
       </p:sp>
       <p:sp>
         <p:nvSpPr>
-          <p:cNvPr id="886413495" name="Text 4"/>
+          <p:cNvPr id="1956160284" name="Text 4"/>
           <p:cNvSpPr/>
           <p:nvPr/>
         </p:nvSpPr>
@@ -17727,7 +17727,7 @@
       </p:sp>
       <p:sp>
         <p:nvSpPr>
-          <p:cNvPr id="947402038" name="Text 5"/>
+          <p:cNvPr id="961787094" name="Text 5"/>
           <p:cNvSpPr/>
           <p:nvPr/>
         </p:nvSpPr>
@@ -17805,7 +17805,7 @@
       </p:sp>
       <p:sp>
         <p:nvSpPr>
-          <p:cNvPr id="799371116" name="Shape 6"/>
+          <p:cNvPr id="754615848" name="Shape 6"/>
           <p:cNvSpPr/>
           <p:nvPr/>
         </p:nvSpPr>
@@ -17852,7 +17852,7 @@
       </p:sp>
       <p:pic>
         <p:nvPicPr>
-          <p:cNvPr id="960713727" name="Image 0" descr="preencoded.png"/>
+          <p:cNvPr id="985435574" name="Image 0" descr="preencoded.png"/>
           <p:cNvPicPr/>
           <p:nvPr/>
         </p:nvPicPr>
@@ -17876,7 +17876,7 @@
       </p:pic>
       <p:sp>
         <p:nvSpPr>
-          <p:cNvPr id="1155353699" name="Text 7"/>
+          <p:cNvPr id="123458386" name="Text 7"/>
           <p:cNvSpPr/>
           <p:nvPr/>
         </p:nvSpPr>
@@ -17934,7 +17934,7 @@
       </p:sp>
       <p:sp>
         <p:nvSpPr>
-          <p:cNvPr id="1378951163" name="Text 8"/>
+          <p:cNvPr id="470462273" name="Text 8"/>
           <p:cNvSpPr/>
           <p:nvPr/>
         </p:nvSpPr>
@@ -18092,7 +18092,7 @@
       </p:grpSpPr>
       <p:sp>
         <p:nvSpPr>
-          <p:cNvPr id="785406660" name="Shape 0"/>
+          <p:cNvPr id="652587292" name="Shape 0"/>
           <p:cNvSpPr/>
           <p:nvPr/>
         </p:nvSpPr>
@@ -18136,7 +18136,7 @@
       </p:sp>
       <p:sp>
         <p:nvSpPr>
-          <p:cNvPr id="1032449588" name="Text 1"/>
+          <p:cNvPr id="1990869241" name="Text 1"/>
           <p:cNvSpPr/>
           <p:nvPr/>
         </p:nvSpPr>
@@ -18194,7 +18194,7 @@
       </p:sp>
       <p:sp>
         <p:nvSpPr>
-          <p:cNvPr id="1097712535" name="Text 2"/>
+          <p:cNvPr id="298267421" name="Text 2"/>
           <p:cNvSpPr/>
           <p:nvPr/>
         </p:nvSpPr>
@@ -18252,7 +18252,7 @@
       </p:sp>
       <p:sp>
         <p:nvSpPr>
-          <p:cNvPr id="40439513" name="Text 3"/>
+          <p:cNvPr id="586924568" name="Text 3"/>
           <p:cNvSpPr/>
           <p:nvPr/>
         </p:nvSpPr>
@@ -18320,7 +18320,7 @@
       </p:sp>
       <p:sp>
         <p:nvSpPr>
-          <p:cNvPr id="1060134820" name="Text 4"/>
+          <p:cNvPr id="1799639985" name="Text 4"/>
           <p:cNvSpPr/>
           <p:nvPr/>
         </p:nvSpPr>
@@ -18388,7 +18388,7 @@
       </p:sp>
       <p:sp>
         <p:nvSpPr>
-          <p:cNvPr id="1689295725" name="Text 5"/>
+          <p:cNvPr id="838126193" name="Text 5"/>
           <p:cNvSpPr/>
           <p:nvPr/>
         </p:nvSpPr>
@@ -18550,7 +18550,7 @@
       </p:sp>
       <p:sp>
         <p:nvSpPr>
-          <p:cNvPr id="1644209276" name="Text 6"/>
+          <p:cNvPr id="1458142003" name="Text 6"/>
           <p:cNvSpPr/>
           <p:nvPr/>
         </p:nvSpPr>
@@ -18608,7 +18608,7 @@
       </p:sp>
       <p:sp>
         <p:nvSpPr>
-          <p:cNvPr id="1104232442" name="Shape 7"/>
+          <p:cNvPr id="631910805" name="Shape 7"/>
           <p:cNvSpPr/>
           <p:nvPr/>
         </p:nvSpPr>
@@ -18654,7 +18654,7 @@
       </p:sp>
       <p:sp>
         <p:nvSpPr>
-          <p:cNvPr id="1476814984" name="Text 8"/>
+          <p:cNvPr id="1243008045" name="Text 8"/>
           <p:cNvSpPr/>
           <p:nvPr/>
         </p:nvSpPr>
@@ -18712,7 +18712,7 @@
       </p:sp>
       <p:sp>
         <p:nvSpPr>
-          <p:cNvPr id="181401618" name="Text 9"/>
+          <p:cNvPr id="1841001831" name="Text 9"/>
           <p:cNvSpPr/>
           <p:nvPr/>
         </p:nvSpPr>
@@ -18770,7 +18770,7 @@
       </p:sp>
       <p:sp>
         <p:nvSpPr>
-          <p:cNvPr id="1034888500" name="Text 10"/>
+          <p:cNvPr id="1327431244" name="Text 10"/>
           <p:cNvSpPr/>
           <p:nvPr/>
         </p:nvSpPr>
@@ -18828,7 +18828,7 @@
       </p:sp>
       <p:sp>
         <p:nvSpPr>
-          <p:cNvPr id="1431052227" name="Text 11"/>
+          <p:cNvPr id="1499488718" name="Text 11"/>
           <p:cNvSpPr/>
           <p:nvPr/>
         </p:nvSpPr>
@@ -18896,7 +18896,7 @@
       </p:sp>
       <p:sp>
         <p:nvSpPr>
-          <p:cNvPr id="1001050027" name="Text 12"/>
+          <p:cNvPr id="150576007" name="Text 12"/>
           <p:cNvSpPr/>
           <p:nvPr/>
         </p:nvSpPr>
@@ -18954,7 +18954,7 @@
       </p:sp>
       <p:sp>
         <p:nvSpPr>
-          <p:cNvPr id="2126731221" name="Text 13"/>
+          <p:cNvPr id="1171153813" name="Text 13"/>
           <p:cNvSpPr/>
           <p:nvPr/>
         </p:nvSpPr>
@@ -19012,7 +19012,7 @@
       </p:sp>
       <p:sp>
         <p:nvSpPr>
-          <p:cNvPr id="499124861" name="Shape 14"/>
+          <p:cNvPr id="1033123634" name="Shape 14"/>
           <p:cNvSpPr/>
           <p:nvPr/>
         </p:nvSpPr>
@@ -19059,7 +19059,7 @@
       </p:sp>
       <p:sp>
         <p:nvSpPr>
-          <p:cNvPr id="1802764802" name="Text 15"/>
+          <p:cNvPr id="1443571858" name="Text 15"/>
           <p:cNvSpPr/>
           <p:nvPr/>
         </p:nvSpPr>
@@ -19119,7 +19119,7 @@
       </p:sp>
       <p:pic>
         <p:nvPicPr>
-          <p:cNvPr id="103098106" name="Image 0" descr="preencoded.png"/>
+          <p:cNvPr id="1229112061" name="Image 0" descr="preencoded.png"/>
           <p:cNvPicPr/>
           <p:nvPr/>
         </p:nvPicPr>
@@ -19143,7 +19143,7 @@
       </p:pic>
       <p:sp>
         <p:nvSpPr>
-          <p:cNvPr id="391402228" name="Text 16"/>
+          <p:cNvPr id="1428936093" name="Text 16"/>
           <p:cNvSpPr/>
           <p:nvPr/>
         </p:nvSpPr>
@@ -19201,7 +19201,7 @@
       </p:sp>
       <p:sp>
         <p:nvSpPr>
-          <p:cNvPr id="440651942" name="Text 17"/>
+          <p:cNvPr id="1750980943" name="Text 17"/>
           <p:cNvSpPr/>
           <p:nvPr/>
         </p:nvSpPr>
@@ -19359,7 +19359,7 @@
       </p:grpSpPr>
       <p:sp>
         <p:nvSpPr>
-          <p:cNvPr id="149746884" name="Shape 0"/>
+          <p:cNvPr id="1010947714" name="Shape 0"/>
           <p:cNvSpPr/>
           <p:nvPr/>
         </p:nvSpPr>
@@ -19403,7 +19403,7 @@
       </p:sp>
       <p:sp>
         <p:nvSpPr>
-          <p:cNvPr id="111895282" name="Text 1"/>
+          <p:cNvPr id="427653097" name="Text 1"/>
           <p:cNvSpPr/>
           <p:nvPr/>
         </p:nvSpPr>
@@ -19461,7 +19461,7 @@
       </p:sp>
       <p:sp>
         <p:nvSpPr>
-          <p:cNvPr id="908056198" name="Text 2"/>
+          <p:cNvPr id="1835903993" name="Text 2"/>
           <p:cNvSpPr/>
           <p:nvPr/>
         </p:nvSpPr>
@@ -19521,7 +19521,7 @@
       </p:sp>
       <p:sp>
         <p:nvSpPr>
-          <p:cNvPr id="1176715778" name="Text 3"/>
+          <p:cNvPr id="1164152954" name="Text 3"/>
           <p:cNvSpPr/>
           <p:nvPr/>
         </p:nvSpPr>
@@ -19593,7 +19593,7 @@
       </p:sp>
       <p:sp>
         <p:nvSpPr>
-          <p:cNvPr id="1542238695" name="Text 4"/>
+          <p:cNvPr id="165928310" name="Text 4"/>
           <p:cNvSpPr/>
           <p:nvPr/>
         </p:nvSpPr>
@@ -19661,7 +19661,7 @@
       </p:sp>
       <p:sp>
         <p:nvSpPr>
-          <p:cNvPr id="450416562" name="Text 5"/>
+          <p:cNvPr id="1529594465" name="Text 5"/>
           <p:cNvSpPr/>
           <p:nvPr/>
         </p:nvSpPr>
@@ -19721,7 +19721,7 @@
       </p:sp>
       <p:sp>
         <p:nvSpPr>
-          <p:cNvPr id="1823866933" name="Shape 6"/>
+          <p:cNvPr id="577429002" name="Shape 6"/>
           <p:cNvSpPr/>
           <p:nvPr/>
         </p:nvSpPr>
@@ -19765,7 +19765,7 @@
       </p:sp>
       <p:sp>
         <p:nvSpPr>
-          <p:cNvPr id="842990211" name="Text 7"/>
+          <p:cNvPr id="941751401" name="Text 7"/>
           <p:cNvSpPr/>
           <p:nvPr/>
         </p:nvSpPr>
@@ -19825,7 +19825,7 @@
       </p:sp>
       <p:sp>
         <p:nvSpPr>
-          <p:cNvPr id="485358175" name="Text 8"/>
+          <p:cNvPr id="1342879390" name="Text 8"/>
           <p:cNvSpPr/>
           <p:nvPr/>
         </p:nvSpPr>
@@ -20011,7 +20011,7 @@
       </p:sp>
       <p:sp>
         <p:nvSpPr>
-          <p:cNvPr id="1067310002" name="Shape 9"/>
+          <p:cNvPr id="1289684471" name="Shape 9"/>
           <p:cNvSpPr/>
           <p:nvPr/>
         </p:nvSpPr>
@@ -20055,7 +20055,7 @@
       </p:sp>
       <p:sp>
         <p:nvSpPr>
-          <p:cNvPr id="1554804390" name="Text 10"/>
+          <p:cNvPr id="200067932" name="Text 10"/>
           <p:cNvSpPr/>
           <p:nvPr/>
         </p:nvSpPr>
@@ -20115,7 +20115,7 @@
       </p:sp>
       <p:sp>
         <p:nvSpPr>
-          <p:cNvPr id="914748122" name="Text 11"/>
+          <p:cNvPr id="792407" name="Text 11"/>
           <p:cNvSpPr/>
           <p:nvPr/>
         </p:nvSpPr>
@@ -20291,7 +20291,7 @@
       </p:sp>
       <p:sp>
         <p:nvSpPr>
-          <p:cNvPr id="1848708041" name="Shape 12"/>
+          <p:cNvPr id="2051376604" name="Shape 12"/>
           <p:cNvSpPr/>
           <p:nvPr/>
         </p:nvSpPr>
@@ -20335,7 +20335,7 @@
       </p:sp>
       <p:sp>
         <p:nvSpPr>
-          <p:cNvPr id="139916386" name="Text 13"/>
+          <p:cNvPr id="1919822435" name="Text 13"/>
           <p:cNvSpPr/>
           <p:nvPr/>
         </p:nvSpPr>
@@ -20395,7 +20395,7 @@
       </p:sp>
       <p:sp>
         <p:nvSpPr>
-          <p:cNvPr id="423603956" name="Text 14"/>
+          <p:cNvPr id="175803777" name="Text 14"/>
           <p:cNvSpPr/>
           <p:nvPr/>
         </p:nvSpPr>
@@ -20571,7 +20571,7 @@
       </p:sp>
       <p:sp>
         <p:nvSpPr>
-          <p:cNvPr id="2086836060" name="Text 15"/>
+          <p:cNvPr id="284970709" name="Text 15"/>
           <p:cNvSpPr/>
           <p:nvPr/>
         </p:nvSpPr>
@@ -20631,7 +20631,7 @@
       </p:sp>
       <p:sp>
         <p:nvSpPr>
-          <p:cNvPr id="242843278" name="Text 16"/>
+          <p:cNvPr id="1381887433" name="Text 16"/>
           <p:cNvSpPr/>
           <p:nvPr/>
         </p:nvSpPr>
@@ -20779,7 +20779,7 @@
       </p:grpSpPr>
       <p:sp>
         <p:nvSpPr>
-          <p:cNvPr id="144003489" name="Shape 0"/>
+          <p:cNvPr id="1548777111" name="Shape 0"/>
           <p:cNvSpPr/>
           <p:nvPr/>
         </p:nvSpPr>
@@ -20823,7 +20823,7 @@
       </p:sp>
       <p:sp>
         <p:nvSpPr>
-          <p:cNvPr id="1174825575" name="Text 1"/>
+          <p:cNvPr id="1998504101" name="Text 1"/>
           <p:cNvSpPr/>
           <p:nvPr/>
         </p:nvSpPr>
@@ -20881,7 +20881,7 @@
       </p:sp>
       <p:sp>
         <p:nvSpPr>
-          <p:cNvPr id="684929902" name="Text 2"/>
+          <p:cNvPr id="1478516142" name="Text 2"/>
           <p:cNvSpPr/>
           <p:nvPr/>
         </p:nvSpPr>
@@ -20939,7 +20939,7 @@
       </p:sp>
       <p:sp>
         <p:nvSpPr>
-          <p:cNvPr id="1266471479" name="Text 3"/>
+          <p:cNvPr id="1550505196" name="Text 3"/>
           <p:cNvSpPr/>
           <p:nvPr/>
         </p:nvSpPr>
@@ -21047,7 +21047,7 @@
       </p:sp>
       <p:sp>
         <p:nvSpPr>
-          <p:cNvPr id="1817059530" name="Text 4"/>
+          <p:cNvPr id="1030818060" name="Text 4"/>
           <p:cNvSpPr/>
           <p:nvPr/>
         </p:nvSpPr>
@@ -21145,7 +21145,7 @@
       </p:sp>
       <p:sp>
         <p:nvSpPr>
-          <p:cNvPr id="949320431" name="Text 5"/>
+          <p:cNvPr id="2018547039" name="Text 5"/>
           <p:cNvSpPr/>
           <p:nvPr/>
         </p:nvSpPr>
@@ -21223,7 +21223,7 @@
       </p:sp>
       <p:sp>
         <p:nvSpPr>
-          <p:cNvPr id="469874499" name="Text 6"/>
+          <p:cNvPr id="1392724523" name="Text 6"/>
           <p:cNvSpPr/>
           <p:nvPr/>
         </p:nvSpPr>
@@ -21321,7 +21321,7 @@
       </p:sp>
       <p:sp>
         <p:nvSpPr>
-          <p:cNvPr id="296423648" name="Shape 7"/>
+          <p:cNvPr id="1773764865" name="Shape 7"/>
           <p:cNvSpPr/>
           <p:nvPr/>
         </p:nvSpPr>
@@ -21367,7 +21367,7 @@
       </p:sp>
       <p:sp>
         <p:nvSpPr>
-          <p:cNvPr id="1357524329" name="Text 8"/>
+          <p:cNvPr id="536025197" name="Text 8"/>
           <p:cNvSpPr/>
           <p:nvPr/>
         </p:nvSpPr>
@@ -21425,32 +21425,32 @@
       </p:sp>
       <p:sp>
         <p:nvSpPr>
-          <p:cNvPr id="1139539299" name="Text 9"/>
-          <p:cNvSpPr/>
-          <p:nvPr/>
-        </p:nvSpPr>
-        <p:spPr bwMode="auto">
-          <a:xfrm>
-            <a:off x="1047600" y="8195400"/>
-            <a:ext cx="2522519" cy="498240"/>
-          </a:xfrm>
-          <a:prstGeom prst="rect">
-            <a:avLst/>
-          </a:prstGeom>
-          <a:noFill/>
-          <a:ln w="0">
-            <a:noFill/>
-          </a:ln>
-        </p:spPr>
-        <p:style>
-          <a:lnRef idx="0"/>
-          <a:fillRef idx="0"/>
-          <a:effectRef idx="0"/>
-          <a:fontRef idx="minor"/>
-        </p:style>
-        <p:txBody>
-          <a:bodyPr lIns="25560" tIns="25560" rIns="25560" bIns="25560" anchor="t">
-            <a:normAutofit fontScale="85000" lnSpcReduction="9999"/>
+          <p:cNvPr id="905714767" name="Text 11"/>
+          <p:cNvSpPr/>
+          <p:nvPr/>
+        </p:nvSpPr>
+        <p:spPr bwMode="auto">
+          <a:xfrm>
+            <a:off x="1120955" y="8156880"/>
+            <a:ext cx="4329000" cy="575280"/>
+          </a:xfrm>
+          <a:prstGeom prst="rect">
+            <a:avLst/>
+          </a:prstGeom>
+          <a:noFill/>
+          <a:ln w="0">
+            <a:noFill/>
+          </a:ln>
+        </p:spPr>
+        <p:style>
+          <a:lnRef idx="0"/>
+          <a:fillRef idx="0"/>
+          <a:effectRef idx="0"/>
+          <a:fontRef idx="minor"/>
+        </p:style>
+        <p:txBody>
+          <a:bodyPr horzOverflow="overflow" lIns="25560" tIns="25560" rIns="25560" bIns="25560" numCol="1" spcCol="0" anchor="t">
+            <a:normAutofit lnSpcReduction="9999"/>
           </a:bodyPr>
           <a:p>
             <a:pPr defTabSz="914400">
@@ -21470,7 +21470,7 @@
                 <a:latin typeface="Noto Serif JP"/>
                 <a:ea typeface="Noto Serif JP"/>
               </a:rPr>
-              <a:t>伊藤穰一</a:t>
+              <a:t>レイ・オジー</a:t>
             </a:r>
             <a:endParaRPr lang="en-US" sz="3300" b="0" u="none" strike="noStrike">
               <a:solidFill>
@@ -21483,149 +21483,13 @@
       </p:sp>
       <p:sp>
         <p:nvSpPr>
-          <p:cNvPr id="134756765" name="Text 10"/>
-          <p:cNvSpPr/>
-          <p:nvPr/>
-        </p:nvSpPr>
-        <p:spPr bwMode="auto">
-          <a:xfrm>
-            <a:off x="1047600" y="8656200"/>
-            <a:ext cx="2522519" cy="414720"/>
-          </a:xfrm>
-          <a:prstGeom prst="rect">
-            <a:avLst/>
-          </a:prstGeom>
-          <a:noFill/>
-          <a:ln w="0">
-            <a:noFill/>
-          </a:ln>
-        </p:spPr>
-        <p:style>
-          <a:lnRef idx="0"/>
-          <a:fillRef idx="0"/>
-          <a:effectRef idx="0"/>
-          <a:fontRef idx="minor"/>
-        </p:style>
-        <p:txBody>
-          <a:bodyPr lIns="25560" tIns="25560" rIns="25560" bIns="25560" anchor="t">
-            <a:normAutofit fontScale="85000" lnSpcReduction="9999"/>
-          </a:bodyPr>
-          <a:p>
-            <a:pPr defTabSz="914400">
-              <a:lnSpc>
-                <a:spcPct val="165000"/>
-              </a:lnSpc>
-              <a:tabLst>
-                <a:tab pos="0" algn="l"/>
-              </a:tabLst>
-              <a:defRPr/>
-            </a:pPr>
-            <a:r>
-              <a:rPr lang="zh-CN" sz="1800" b="0" u="none" strike="noStrike">
-                <a:solidFill>
-                  <a:srgbClr val="4C554F"/>
-                </a:solidFill>
-                <a:latin typeface="Noto Sans JP"/>
-                <a:ea typeface="Noto Sans JP"/>
-              </a:rPr>
-              <a:t>元</a:t>
-            </a:r>
-            <a:r>
-              <a:rPr lang="en-US" sz="1800" b="0" u="none" strike="noStrike">
-                <a:solidFill>
-                  <a:srgbClr val="4C554F"/>
-                </a:solidFill>
-                <a:latin typeface="Noto Sans JP"/>
-                <a:ea typeface="Noto Sans JP"/>
-              </a:rPr>
-              <a:t>MIT</a:t>
-            </a:r>
-            <a:r>
-              <a:rPr lang="zh-CN" sz="1800" b="0" u="none" strike="noStrike">
-                <a:solidFill>
-                  <a:srgbClr val="4C554F"/>
-                </a:solidFill>
-                <a:latin typeface="Noto Sans JP"/>
-                <a:ea typeface="Noto Sans JP"/>
-              </a:rPr>
-              <a:t>メディアラボ所長</a:t>
-            </a:r>
-            <a:endParaRPr lang="en-US" sz="1800" b="0" u="none" strike="noStrike">
-              <a:solidFill>
-                <a:srgbClr val="000000"/>
-              </a:solidFill>
-              <a:latin typeface="Arial"/>
-            </a:endParaRPr>
-          </a:p>
-        </p:txBody>
-      </p:sp>
-      <p:sp>
-        <p:nvSpPr>
-          <p:cNvPr id="2056877570" name="Text 11"/>
-          <p:cNvSpPr/>
-          <p:nvPr/>
-        </p:nvSpPr>
-        <p:spPr bwMode="auto">
-          <a:xfrm>
-            <a:off x="3421800" y="8156880"/>
-            <a:ext cx="4329000" cy="575280"/>
-          </a:xfrm>
-          <a:prstGeom prst="rect">
-            <a:avLst/>
-          </a:prstGeom>
-          <a:noFill/>
-          <a:ln w="0">
-            <a:noFill/>
-          </a:ln>
-        </p:spPr>
-        <p:style>
-          <a:lnRef idx="0"/>
-          <a:fillRef idx="0"/>
-          <a:effectRef idx="0"/>
-          <a:fontRef idx="minor"/>
-        </p:style>
-        <p:txBody>
-          <a:bodyPr horzOverflow="overflow" lIns="25560" tIns="25560" rIns="25560" bIns="25560" numCol="1" spcCol="0" anchor="t">
-            <a:normAutofit lnSpcReduction="9999"/>
-          </a:bodyPr>
-          <a:p>
-            <a:pPr defTabSz="914400">
-              <a:lnSpc>
-                <a:spcPct val="110000"/>
-              </a:lnSpc>
-              <a:tabLst>
-                <a:tab pos="0" algn="l"/>
-              </a:tabLst>
-              <a:defRPr/>
-            </a:pPr>
-            <a:r>
-              <a:rPr lang="zh-CN" sz="3300" b="1" u="none" strike="noStrike" spc="-17">
-                <a:solidFill>
-                  <a:srgbClr val="1F2A24"/>
-                </a:solidFill>
-                <a:latin typeface="Noto Serif JP"/>
-                <a:ea typeface="Noto Serif JP"/>
-              </a:rPr>
-              <a:t>レイ・オジー</a:t>
-            </a:r>
-            <a:endParaRPr lang="en-US" sz="3300" b="0" u="none" strike="noStrike">
-              <a:solidFill>
-                <a:srgbClr val="000000"/>
-              </a:solidFill>
-              <a:latin typeface="Arial"/>
-            </a:endParaRPr>
-          </a:p>
-        </p:txBody>
-      </p:sp>
-      <p:sp>
-        <p:nvSpPr>
-          <p:cNvPr id="2047730026" name="Text 12"/>
-          <p:cNvSpPr/>
-          <p:nvPr/>
-        </p:nvSpPr>
-        <p:spPr bwMode="auto">
-          <a:xfrm>
-            <a:off x="3421800" y="8656200"/>
+          <p:cNvPr id="1101886664" name="Text 12"/>
+          <p:cNvSpPr/>
+          <p:nvPr/>
+        </p:nvSpPr>
+        <p:spPr bwMode="auto">
+          <a:xfrm>
+            <a:off x="1120955" y="8656200"/>
             <a:ext cx="4329000" cy="728280"/>
           </a:xfrm>
           <a:prstGeom prst="rect">
@@ -21724,7 +21588,7 @@
       </p:sp>
       <p:sp>
         <p:nvSpPr>
-          <p:cNvPr id="1920316379" name="Shape 13"/>
+          <p:cNvPr id="474636508" name="Shape 13"/>
           <p:cNvSpPr/>
           <p:nvPr/>
         </p:nvSpPr>
@@ -21771,7 +21635,7 @@
       </p:sp>
       <p:sp>
         <p:nvSpPr>
-          <p:cNvPr id="2085703316" name="Text 14"/>
+          <p:cNvPr id="1199825270" name="Text 14"/>
           <p:cNvSpPr/>
           <p:nvPr/>
         </p:nvSpPr>
@@ -21829,7 +21693,7 @@
       </p:sp>
       <p:sp>
         <p:nvSpPr>
-          <p:cNvPr id="1005908593" name="Text 15"/>
+          <p:cNvPr id="1518491008" name="Text 15"/>
           <p:cNvSpPr/>
           <p:nvPr/>
         </p:nvSpPr>
@@ -22087,20 +21951,20 @@
                 <a:latin typeface="Noto Sans JP"/>
                 <a:ea typeface="Noto Sans JP"/>
               </a:rPr>
-              <a:t>伊藤穰一、レイ・オジー、堂目卓生</a:t>
-            </a:r>
-            <a:endParaRPr lang="en-US" sz="1800" b="0" u="none" strike="noStrike">
-              <a:solidFill>
-                <a:srgbClr val="000000"/>
-              </a:solidFill>
-              <a:latin typeface="Arial"/>
-            </a:endParaRPr>
-          </a:p>
-        </p:txBody>
-      </p:sp>
-      <p:sp>
-        <p:nvSpPr>
-          <p:cNvPr id="1568408932" name="Shape 16"/>
+              <a:t>レイ・オジー、堂目卓生</a:t>
+            </a:r>
+            <a:endParaRPr lang="en-US" sz="1800" b="0" u="none" strike="noStrike">
+              <a:solidFill>
+                <a:srgbClr val="000000"/>
+              </a:solidFill>
+              <a:latin typeface="Arial"/>
+            </a:endParaRPr>
+          </a:p>
+        </p:txBody>
+      </p:sp>
+      <p:sp>
+        <p:nvSpPr>
+          <p:cNvPr id="670161464" name="Shape 16"/>
           <p:cNvSpPr/>
           <p:nvPr/>
         </p:nvSpPr>
@@ -22147,7 +22011,7 @@
       </p:sp>
       <p:sp>
         <p:nvSpPr>
-          <p:cNvPr id="1104310412" name="Text 17"/>
+          <p:cNvPr id="314190796" name="Text 17"/>
           <p:cNvSpPr/>
           <p:nvPr/>
         </p:nvSpPr>
@@ -22205,7 +22069,7 @@
       </p:sp>
       <p:sp>
         <p:nvSpPr>
-          <p:cNvPr id="83375133" name="Text 18"/>
+          <p:cNvPr id="1671069591" name="Text 18"/>
           <p:cNvSpPr/>
           <p:nvPr/>
         </p:nvSpPr>
@@ -22364,7 +22228,7 @@
       </p:sp>
       <p:sp>
         <p:nvSpPr>
-          <p:cNvPr id="1659564511" name="Shape 19"/>
+          <p:cNvPr id="835615478" name="Shape 19"/>
           <p:cNvSpPr/>
           <p:nvPr/>
         </p:nvSpPr>
@@ -22411,7 +22275,7 @@
       </p:sp>
       <p:sp>
         <p:nvSpPr>
-          <p:cNvPr id="404673071" name="Text 20"/>
+          <p:cNvPr id="103242283" name="Text 20"/>
           <p:cNvSpPr/>
           <p:nvPr/>
         </p:nvSpPr>
@@ -22489,7 +22353,7 @@
       </p:sp>
       <p:sp>
         <p:nvSpPr>
-          <p:cNvPr id="1131084399" name="Text 21"/>
+          <p:cNvPr id="1972385429" name="Text 21"/>
           <p:cNvSpPr/>
           <p:nvPr/>
         </p:nvSpPr>
@@ -22668,7 +22532,7 @@
       </p:sp>
       <p:sp>
         <p:nvSpPr>
-          <p:cNvPr id="1243589086" name="Text 22"/>
+          <p:cNvPr id="913796730" name="Text 22"/>
           <p:cNvSpPr/>
           <p:nvPr/>
         </p:nvSpPr>
@@ -22726,7 +22590,7 @@
       </p:sp>
       <p:sp>
         <p:nvSpPr>
-          <p:cNvPr id="204039878" name="Text 23"/>
+          <p:cNvPr id="1102843968" name="Text 23"/>
           <p:cNvSpPr/>
           <p:nvPr/>
         </p:nvSpPr>
@@ -22864,13 +22728,13 @@
       </p:sp>
       <p:sp>
         <p:nvSpPr>
-          <p:cNvPr id="674363299" name="Text 11"/>
-          <p:cNvSpPr/>
-          <p:nvPr/>
-        </p:nvSpPr>
-        <p:spPr bwMode="auto">
-          <a:xfrm>
-            <a:off x="6553800" y="8195400"/>
+          <p:cNvPr id="407574252" name="Text 11"/>
+          <p:cNvSpPr/>
+          <p:nvPr/>
+        </p:nvSpPr>
+        <p:spPr bwMode="auto">
+          <a:xfrm>
+            <a:off x="4815000" y="8149500"/>
             <a:ext cx="4329000" cy="498240"/>
           </a:xfrm>
           <a:prstGeom prst="rect">
@@ -22922,13 +22786,13 @@
       </p:sp>
       <p:sp>
         <p:nvSpPr>
-          <p:cNvPr id="937200662" name="Text 12"/>
-          <p:cNvSpPr/>
-          <p:nvPr/>
-        </p:nvSpPr>
-        <p:spPr bwMode="auto">
-          <a:xfrm>
-            <a:off x="6553800" y="8656200"/>
+          <p:cNvPr id="1231718346" name="Text 12"/>
+          <p:cNvSpPr/>
+          <p:nvPr/>
+        </p:nvSpPr>
+        <p:spPr bwMode="auto">
+          <a:xfrm>
+            <a:off x="4874820" y="8610300"/>
             <a:ext cx="4329000" cy="669960"/>
           </a:xfrm>
           <a:prstGeom prst="rect">

</xml_diff>

<commit_message>
docs: regenerate all stale PDFs and auto-add missing version headers
- Regenerated 49 stale PDFs across root, NGO setup, Bidding info, NPO setup, and Docs extra
- Auto-injected <!-- Version: v1.0 | Last modified: 2026-06-23 --> into 10 files that were missing version headers (script's ensureHeader feature)
- All PDFs now match their .md source timestamps

Co-Authored-By: Claude Sonnet 4.6 <noreply@anthropic.com>
</commit_message>
<xml_diff>
--- a/Mitsue Project Presentation - 日本語.pptx
+++ b/Mitsue Project Presentation - 日本語.pptx
@@ -4074,6 +4074,40 @@
               </a:solidFill>
               <a:latin typeface="Arial"/>
             </a:endParaRPr>
+          </a:p>
+        </p:txBody>
+      </p:sp>
+      <p:sp>
+        <p:nvSpPr>
+          <p:cNvPr id="2057711890" name="TextBox 2057711889"/>
+          <p:cNvSpPr txBox="1"/>
+          <p:nvPr/>
+        </p:nvSpPr>
+        <p:spPr>
+          <a:xfrm>
+            <a:off x="0" y="8987000"/>
+            <a:ext cx="18288000" cy="1100000"/>
+          </a:xfrm>
+          <a:prstGeom prst="rect">
+            <a:avLst/>
+          </a:prstGeom>
+          <a:noFill/>
+        </p:spPr>
+        <p:txBody>
+          <a:bodyPr wrap="square">
+            <a:spAutoFit/>
+          </a:bodyPr>
+          <a:lstStyle/>
+          <a:p>
+            <a:pPr algn="ctr"/>
+            <a:r>
+              <a:rPr i="1" sz="1300">
+                <a:solidFill>
+                  <a:srgbClr val="3A7A5A"/>
+                </a:solidFill>
+              </a:rPr>
+              <a:t>先人が植えた森が、今、村に豊かさをもたらす。</a:t>
+            </a:r>
           </a:p>
         </p:txBody>
       </p:sp>

</xml_diff>